<commit_message>
Regenerate RouteSignal pitch artifacts
Update the generated pitch layout JSON, preview images, contact sheet, manifest, and PowerPoint after slide layout polish.

Also surface route matches in compact Wizard recipe cards so cards and workbench both connect recipe steps to captured routes or explicit gaps.

Timestamp: 2026-05-21T04:11:05Z
</commit_message>
<xml_diff>
--- a/pitch/routesignal-hackathon-pitch.pptx
+++ b/pitch/routesignal-hackathon-pitch.pptx
@@ -2,20 +2,20 @@
 <file path=ppt/presentation.xml><?xml version="1.0" encoding="utf-8"?>
 <p:presentation xmlns:p="http://schemas.openxmlformats.org/presentationml/2006/main">
   <p:sldMasterIdLst>
-    <p:sldMasterId xmlns:r="http://schemas.openxmlformats.org/officeDocument/2006/relationships" id="2147483648" r:id="R7d039925b3cb4970"/>
+    <p:sldMasterId xmlns:r="http://schemas.openxmlformats.org/officeDocument/2006/relationships" id="2147483648" r:id="R11c0ef667ef04f59"/>
   </p:sldMasterIdLst>
   <p:notesMasterIdLst>
-    <p:notesMasterId xmlns:r="http://schemas.openxmlformats.org/officeDocument/2006/relationships" r:id="R557fae539e554b15"/>
+    <p:notesMasterId xmlns:r="http://schemas.openxmlformats.org/officeDocument/2006/relationships" r:id="R8dd81e4fd9844cd1"/>
   </p:notesMasterIdLst>
   <p:sldIdLst>
-    <p:sldId xmlns:r="http://schemas.openxmlformats.org/officeDocument/2006/relationships" id="256" r:id="Rdfc9f50b00c348a9"/>
-    <p:sldId xmlns:r="http://schemas.openxmlformats.org/officeDocument/2006/relationships" id="257" r:id="R96db5870792b4480"/>
-    <p:sldId xmlns:r="http://schemas.openxmlformats.org/officeDocument/2006/relationships" id="258" r:id="R84239fcc54c24ebe"/>
-    <p:sldId xmlns:r="http://schemas.openxmlformats.org/officeDocument/2006/relationships" id="259" r:id="R8ce6ecce39444614"/>
-    <p:sldId xmlns:r="http://schemas.openxmlformats.org/officeDocument/2006/relationships" id="260" r:id="R28fc52f0dfdd4936"/>
-    <p:sldId xmlns:r="http://schemas.openxmlformats.org/officeDocument/2006/relationships" id="261" r:id="Rf82769f797484d02"/>
-    <p:sldId xmlns:r="http://schemas.openxmlformats.org/officeDocument/2006/relationships" id="262" r:id="Radae91d81a1843f2"/>
-    <p:sldId xmlns:r="http://schemas.openxmlformats.org/officeDocument/2006/relationships" id="263" r:id="R27256378f4b34941"/>
+    <p:sldId xmlns:r="http://schemas.openxmlformats.org/officeDocument/2006/relationships" id="256" r:id="Rcb894ee1e90d4e6c"/>
+    <p:sldId xmlns:r="http://schemas.openxmlformats.org/officeDocument/2006/relationships" id="257" r:id="R0b454a5993b245df"/>
+    <p:sldId xmlns:r="http://schemas.openxmlformats.org/officeDocument/2006/relationships" id="258" r:id="Re0778b2fcf314996"/>
+    <p:sldId xmlns:r="http://schemas.openxmlformats.org/officeDocument/2006/relationships" id="259" r:id="Re8c2160a96514d23"/>
+    <p:sldId xmlns:r="http://schemas.openxmlformats.org/officeDocument/2006/relationships" id="260" r:id="R6a94fdcb2fa24efb"/>
+    <p:sldId xmlns:r="http://schemas.openxmlformats.org/officeDocument/2006/relationships" id="261" r:id="R500dfd2d29754535"/>
+    <p:sldId xmlns:r="http://schemas.openxmlformats.org/officeDocument/2006/relationships" id="262" r:id="Rccb556179dda4e0c"/>
+    <p:sldId xmlns:r="http://schemas.openxmlformats.org/officeDocument/2006/relationships" id="263" r:id="R35f5a9d9717a494b"/>
   </p:sldIdLst>
   <p:sldSz cx="12192000" cy="6858000"/>
   <p:notesSz cx="6858000" cy="9144000"/>
@@ -1024,7 +1024,7 @@
   </p:cSld>
   <p:clrMap bg1="lt1" tx1="dk1" bg2="lt2" tx2="dk2" accent1="accent1" accent2="accent2" accent3="accent3" accent4="accent4" accent5="accent5" accent6="accent6" hlink="hlink" folHlink="folHlink"/>
   <p:sldLayoutIdLst>
-    <p:sldLayoutId xmlns:r="http://schemas.openxmlformats.org/officeDocument/2006/relationships" id="2147483649" r:id="R1bf35f229ed84f40"/>
+    <p:sldLayoutId xmlns:r="http://schemas.openxmlformats.org/officeDocument/2006/relationships" id="2147483649" r:id="Rd3a687b170af4c32"/>
   </p:sldLayoutIdLst>
   <p:txStyles>
     <p:titleStyle>
@@ -1334,7 +1334,7 @@
           <p:nvPr/>
         </p:nvPicPr>
         <p:blipFill>
-          <a:blip xmlns:r="http://schemas.openxmlformats.org/officeDocument/2006/relationships" xmlns:a="http://schemas.openxmlformats.org/drawingml/2006/main" r:embed="R707aa8ae8cb143b6"/>
+          <a:blip xmlns:r="http://schemas.openxmlformats.org/officeDocument/2006/relationships" xmlns:a="http://schemas.openxmlformats.org/drawingml/2006/main" r:embed="Rf593bb4497d142ca"/>
           <a:srcRect xmlns:a="http://schemas.openxmlformats.org/drawingml/2006/main" l="23814" t="0" r="23814" b="0"/>
           <a:stretch xmlns:a="http://schemas.openxmlformats.org/drawingml/2006/main">
             <a:fillRect l="0" t="0" r="0" b="0"/>
@@ -1355,7 +1355,7 @@
           <p:cNvPr id="2" name="">
             <a:extLst xmlns:a="http://schemas.openxmlformats.org/drawingml/2006/main">
               <a:ext uri="{FF2B5EF4-FFF2-40B4-BE49-F238E27FC236}">
-                <a16:creationId xmlns:a16="http://schemas.microsoft.com/office/drawing/2014/main" id="{8B326C4D-BAAA-44D7-AFA5-3183FAEBA265}"/>
+                <a16:creationId xmlns:a16="http://schemas.microsoft.com/office/drawing/2014/main" id="{955C4E98-0E2E-43B1-B7A1-4871B6829D7F}"/>
               </a:ext>
             </a:extLst>
           </p:cNvPr>
@@ -1391,7 +1391,7 @@
           <p:cNvPr id="3" name="">
             <a:extLst xmlns:a="http://schemas.openxmlformats.org/drawingml/2006/main">
               <a:ext uri="{FF2B5EF4-FFF2-40B4-BE49-F238E27FC236}">
-                <a16:creationId xmlns:a16="http://schemas.microsoft.com/office/drawing/2014/main" id="{C557E160-2446-442A-9B1F-28F6827F76D7}"/>
+                <a16:creationId xmlns:a16="http://schemas.microsoft.com/office/drawing/2014/main" id="{87715C3F-794C-4AE3-B9E0-CAC3135018EB}"/>
               </a:ext>
             </a:extLst>
           </p:cNvPr>
@@ -1423,7 +1423,7 @@
           <p:cNvPr id="4" name="">
             <a:extLst xmlns:a="http://schemas.openxmlformats.org/drawingml/2006/main">
               <a:ext uri="{FF2B5EF4-FFF2-40B4-BE49-F238E27FC236}">
-                <a16:creationId xmlns:a16="http://schemas.microsoft.com/office/drawing/2014/main" id="{53BB588F-6B04-488C-B9DE-B0EB03D35B6B}"/>
+                <a16:creationId xmlns:a16="http://schemas.microsoft.com/office/drawing/2014/main" id="{97BF86B7-AA53-4D59-A405-54BF52A2CA45}"/>
               </a:ext>
             </a:extLst>
           </p:cNvPr>
@@ -1486,7 +1486,7 @@
           <p:cNvPr id="5" name="">
             <a:extLst xmlns:a="http://schemas.openxmlformats.org/drawingml/2006/main">
               <a:ext uri="{FF2B5EF4-FFF2-40B4-BE49-F238E27FC236}">
-                <a16:creationId xmlns:a16="http://schemas.microsoft.com/office/drawing/2014/main" id="{27604184-5798-46CE-B538-BE72AB0A7A5B}"/>
+                <a16:creationId xmlns:a16="http://schemas.microsoft.com/office/drawing/2014/main" id="{68D7D5B7-AF99-4183-B135-B7DDB6FCEA3C}"/>
               </a:ext>
             </a:extLst>
           </p:cNvPr>
@@ -1553,7 +1553,7 @@
           <p:cNvPr id="6" name="">
             <a:extLst xmlns:a="http://schemas.openxmlformats.org/drawingml/2006/main">
               <a:ext uri="{FF2B5EF4-FFF2-40B4-BE49-F238E27FC236}">
-                <a16:creationId xmlns:a16="http://schemas.microsoft.com/office/drawing/2014/main" id="{0094A1A5-4917-4247-A0B8-E4AD5B4DA2C5}"/>
+                <a16:creationId xmlns:a16="http://schemas.microsoft.com/office/drawing/2014/main" id="{34C9ED30-4536-4306-8F6D-85631D2385B6}"/>
               </a:ext>
             </a:extLst>
           </p:cNvPr>
@@ -1620,7 +1620,7 @@
           <p:cNvPr id="7" name="">
             <a:extLst xmlns:a="http://schemas.openxmlformats.org/drawingml/2006/main">
               <a:ext uri="{FF2B5EF4-FFF2-40B4-BE49-F238E27FC236}">
-                <a16:creationId xmlns:a16="http://schemas.microsoft.com/office/drawing/2014/main" id="{6164A07E-10A8-4489-BCA2-27F3082D29A8}"/>
+                <a16:creationId xmlns:a16="http://schemas.microsoft.com/office/drawing/2014/main" id="{064A4A85-7075-482E-AC70-49C6CB6D6A05}"/>
               </a:ext>
             </a:extLst>
           </p:cNvPr>
@@ -1687,7 +1687,7 @@
           <p:cNvPr id="8" name="">
             <a:extLst xmlns:a="http://schemas.openxmlformats.org/drawingml/2006/main">
               <a:ext uri="{FF2B5EF4-FFF2-40B4-BE49-F238E27FC236}">
-                <a16:creationId xmlns:a16="http://schemas.microsoft.com/office/drawing/2014/main" id="{5D4C8126-DE17-40A3-8269-CA8F47B06829}"/>
+                <a16:creationId xmlns:a16="http://schemas.microsoft.com/office/drawing/2014/main" id="{926154C2-E80E-4E56-8497-1D5DC2A15608}"/>
               </a:ext>
             </a:extLst>
           </p:cNvPr>
@@ -1750,7 +1750,7 @@
           <p:cNvPr id="9" name="">
             <a:extLst xmlns:a="http://schemas.openxmlformats.org/drawingml/2006/main">
               <a:ext uri="{FF2B5EF4-FFF2-40B4-BE49-F238E27FC236}">
-                <a16:creationId xmlns:a16="http://schemas.microsoft.com/office/drawing/2014/main" id="{171E162B-0499-45DD-9CF8-333CFDE6B5E4}"/>
+                <a16:creationId xmlns:a16="http://schemas.microsoft.com/office/drawing/2014/main" id="{55F1720D-C129-4609-B99F-358572946F5F}"/>
               </a:ext>
             </a:extLst>
           </p:cNvPr>
@@ -1817,7 +1817,7 @@
           <p:cNvPr id="10" name="">
             <a:extLst xmlns:a="http://schemas.openxmlformats.org/drawingml/2006/main">
               <a:ext uri="{FF2B5EF4-FFF2-40B4-BE49-F238E27FC236}">
-                <a16:creationId xmlns:a16="http://schemas.microsoft.com/office/drawing/2014/main" id="{78F3BE71-D979-4253-8FC3-263579DDC51B}"/>
+                <a16:creationId xmlns:a16="http://schemas.microsoft.com/office/drawing/2014/main" id="{A89650A4-0019-4861-AE17-1D78D74055D8}"/>
               </a:ext>
             </a:extLst>
           </p:cNvPr>
@@ -1880,7 +1880,7 @@
           <p:cNvPr id="11" name="">
             <a:extLst xmlns:a="http://schemas.openxmlformats.org/drawingml/2006/main">
               <a:ext uri="{FF2B5EF4-FFF2-40B4-BE49-F238E27FC236}">
-                <a16:creationId xmlns:a16="http://schemas.microsoft.com/office/drawing/2014/main" id="{B9F08DFF-A315-4BD9-BFDA-C62EEF35FD51}"/>
+                <a16:creationId xmlns:a16="http://schemas.microsoft.com/office/drawing/2014/main" id="{42F8EC8F-12D6-4ECF-8696-9BF3B89F2455}"/>
               </a:ext>
             </a:extLst>
           </p:cNvPr>
@@ -1947,7 +1947,7 @@
           <p:cNvPr id="12" name="">
             <a:extLst xmlns:a="http://schemas.openxmlformats.org/drawingml/2006/main">
               <a:ext uri="{FF2B5EF4-FFF2-40B4-BE49-F238E27FC236}">
-                <a16:creationId xmlns:a16="http://schemas.microsoft.com/office/drawing/2014/main" id="{7726DB85-1E29-48F4-A062-EC4E1536F296}"/>
+                <a16:creationId xmlns:a16="http://schemas.microsoft.com/office/drawing/2014/main" id="{8CD6F7FC-2505-4E22-A6C9-96B21A1BC98E}"/>
               </a:ext>
             </a:extLst>
           </p:cNvPr>
@@ -2010,7 +2010,7 @@
           <p:cNvPr id="13" name="">
             <a:extLst xmlns:a="http://schemas.openxmlformats.org/drawingml/2006/main">
               <a:ext uri="{FF2B5EF4-FFF2-40B4-BE49-F238E27FC236}">
-                <a16:creationId xmlns:a16="http://schemas.microsoft.com/office/drawing/2014/main" id="{041EDA54-3EA4-45F3-878E-F1A981F719CA}"/>
+                <a16:creationId xmlns:a16="http://schemas.microsoft.com/office/drawing/2014/main" id="{0877BF8E-C379-431A-BD19-E1F3D8B40DB5}"/>
               </a:ext>
             </a:extLst>
           </p:cNvPr>
@@ -2077,7 +2077,7 @@
           <p:cNvPr id="14" name="">
             <a:extLst xmlns:a="http://schemas.openxmlformats.org/drawingml/2006/main">
               <a:ext uri="{FF2B5EF4-FFF2-40B4-BE49-F238E27FC236}">
-                <a16:creationId xmlns:a16="http://schemas.microsoft.com/office/drawing/2014/main" id="{5C0930A8-10B9-48C5-B373-2CF1CB0A9B5D}"/>
+                <a16:creationId xmlns:a16="http://schemas.microsoft.com/office/drawing/2014/main" id="{28B45F79-5FFC-46D7-B38B-5303DB271B40}"/>
               </a:ext>
             </a:extLst>
           </p:cNvPr>
@@ -2109,7 +2109,7 @@
           <p:cNvPr id="15" name="">
             <a:extLst xmlns:a="http://schemas.openxmlformats.org/drawingml/2006/main">
               <a:ext uri="{FF2B5EF4-FFF2-40B4-BE49-F238E27FC236}">
-                <a16:creationId xmlns:a16="http://schemas.microsoft.com/office/drawing/2014/main" id="{452068E9-E416-411A-B863-BCE150158B8F}"/>
+                <a16:creationId xmlns:a16="http://schemas.microsoft.com/office/drawing/2014/main" id="{DD530DCE-77AD-4D0C-8411-A2E4659B2136}"/>
               </a:ext>
             </a:extLst>
           </p:cNvPr>
@@ -2172,7 +2172,7 @@
           <p:cNvPr id="16" name="">
             <a:extLst xmlns:a="http://schemas.openxmlformats.org/drawingml/2006/main">
               <a:ext uri="{FF2B5EF4-FFF2-40B4-BE49-F238E27FC236}">
-                <a16:creationId xmlns:a16="http://schemas.microsoft.com/office/drawing/2014/main" id="{ABD89EFA-C50F-47B5-8251-543F2EE27E81}"/>
+                <a16:creationId xmlns:a16="http://schemas.microsoft.com/office/drawing/2014/main" id="{17341A16-C8F7-4BB5-98F9-0D57204A984F}"/>
               </a:ext>
             </a:extLst>
           </p:cNvPr>
@@ -2233,7 +2233,7 @@
     </p:spTree>
     <p:extLst>
       <p:ext uri="{BB962C8B-B14F-4D97-AF65-F5344CB8AC3E}">
-        <p14:creationId xmlns:p14="http://schemas.microsoft.com/office/powerpoint/2010/main" val="2135877381"/>
+        <p14:creationId xmlns:p14="http://schemas.microsoft.com/office/powerpoint/2010/main" val="1543227665"/>
       </p:ext>
     </p:extLst>
   </p:cSld>
@@ -2264,7 +2264,7 @@
           <p:cNvPr id="1" name="">
             <a:extLst xmlns:a="http://schemas.openxmlformats.org/drawingml/2006/main">
               <a:ext uri="{FF2B5EF4-FFF2-40B4-BE49-F238E27FC236}">
-                <a16:creationId xmlns:a16="http://schemas.microsoft.com/office/drawing/2014/main" id="{D90B87BA-A528-4C98-956C-D253A6EFA781}"/>
+                <a16:creationId xmlns:a16="http://schemas.microsoft.com/office/drawing/2014/main" id="{7E06280A-2C87-4922-BBA1-17395B82162C}"/>
               </a:ext>
             </a:extLst>
           </p:cNvPr>
@@ -2327,7 +2327,7 @@
           <p:cNvPr id="2" name="">
             <a:extLst xmlns:a="http://schemas.openxmlformats.org/drawingml/2006/main">
               <a:ext uri="{FF2B5EF4-FFF2-40B4-BE49-F238E27FC236}">
-                <a16:creationId xmlns:a16="http://schemas.microsoft.com/office/drawing/2014/main" id="{7E85E226-6EE8-4CD2-94D0-E9B8402074A1}"/>
+                <a16:creationId xmlns:a16="http://schemas.microsoft.com/office/drawing/2014/main" id="{D3EF07DE-CEF2-4C0B-A1C5-D11F67DB833A}"/>
               </a:ext>
             </a:extLst>
           </p:cNvPr>
@@ -2394,7 +2394,7 @@
           <p:cNvPr id="3" name="">
             <a:extLst xmlns:a="http://schemas.openxmlformats.org/drawingml/2006/main">
               <a:ext uri="{FF2B5EF4-FFF2-40B4-BE49-F238E27FC236}">
-                <a16:creationId xmlns:a16="http://schemas.microsoft.com/office/drawing/2014/main" id="{45A77D2C-F81C-409E-B98F-6BEE878029FA}"/>
+                <a16:creationId xmlns:a16="http://schemas.microsoft.com/office/drawing/2014/main" id="{B3C96CCF-B821-4BAC-91F6-B7FFF7769EF1}"/>
               </a:ext>
             </a:extLst>
           </p:cNvPr>
@@ -2461,7 +2461,7 @@
           <p:cNvPr id="4" name="">
             <a:extLst xmlns:a="http://schemas.openxmlformats.org/drawingml/2006/main">
               <a:ext uri="{FF2B5EF4-FFF2-40B4-BE49-F238E27FC236}">
-                <a16:creationId xmlns:a16="http://schemas.microsoft.com/office/drawing/2014/main" id="{2844F322-4E01-4D62-A47B-6CD71DA4334E}"/>
+                <a16:creationId xmlns:a16="http://schemas.microsoft.com/office/drawing/2014/main" id="{B9A4366A-7909-4DAD-BB47-4657A65DAA6C}"/>
               </a:ext>
             </a:extLst>
           </p:cNvPr>
@@ -2495,7 +2495,7 @@
           <p:cNvPr id="5" name="">
             <a:extLst xmlns:a="http://schemas.openxmlformats.org/drawingml/2006/main">
               <a:ext uri="{FF2B5EF4-FFF2-40B4-BE49-F238E27FC236}">
-                <a16:creationId xmlns:a16="http://schemas.microsoft.com/office/drawing/2014/main" id="{467B50AD-F034-444F-BF62-F19E7CF87270}"/>
+                <a16:creationId xmlns:a16="http://schemas.microsoft.com/office/drawing/2014/main" id="{D21240EF-1F82-46F2-AA5D-DF1E662709F1}"/>
               </a:ext>
             </a:extLst>
           </p:cNvPr>
@@ -2529,7 +2529,7 @@
           <p:cNvPr id="6" name="">
             <a:extLst xmlns:a="http://schemas.openxmlformats.org/drawingml/2006/main">
               <a:ext uri="{FF2B5EF4-FFF2-40B4-BE49-F238E27FC236}">
-                <a16:creationId xmlns:a16="http://schemas.microsoft.com/office/drawing/2014/main" id="{359F9712-020F-4F69-AF17-45911142454E}"/>
+                <a16:creationId xmlns:a16="http://schemas.microsoft.com/office/drawing/2014/main" id="{64B3B270-CE01-429E-A5C4-A792DE5B2E7F}"/>
               </a:ext>
             </a:extLst>
           </p:cNvPr>
@@ -2563,7 +2563,7 @@
           <p:cNvPr id="7" name="">
             <a:extLst xmlns:a="http://schemas.openxmlformats.org/drawingml/2006/main">
               <a:ext uri="{FF2B5EF4-FFF2-40B4-BE49-F238E27FC236}">
-                <a16:creationId xmlns:a16="http://schemas.microsoft.com/office/drawing/2014/main" id="{804FE434-AB8D-47B7-82C1-A60ACC13FE38}"/>
+                <a16:creationId xmlns:a16="http://schemas.microsoft.com/office/drawing/2014/main" id="{E0977D2B-1997-468F-AAF8-F65A1DFDB3AB}"/>
               </a:ext>
             </a:extLst>
           </p:cNvPr>
@@ -2597,7 +2597,7 @@
           <p:cNvPr id="8" name="">
             <a:extLst xmlns:a="http://schemas.openxmlformats.org/drawingml/2006/main">
               <a:ext uri="{FF2B5EF4-FFF2-40B4-BE49-F238E27FC236}">
-                <a16:creationId xmlns:a16="http://schemas.microsoft.com/office/drawing/2014/main" id="{AF3A91E0-1B00-4A52-A93D-AA2A90724750}"/>
+                <a16:creationId xmlns:a16="http://schemas.microsoft.com/office/drawing/2014/main" id="{E278BC12-1E23-465C-89FB-F0B4F5A4A046}"/>
               </a:ext>
             </a:extLst>
           </p:cNvPr>
@@ -2631,7 +2631,7 @@
           <p:cNvPr id="9" name="">
             <a:extLst xmlns:a="http://schemas.openxmlformats.org/drawingml/2006/main">
               <a:ext uri="{FF2B5EF4-FFF2-40B4-BE49-F238E27FC236}">
-                <a16:creationId xmlns:a16="http://schemas.microsoft.com/office/drawing/2014/main" id="{57E7613F-9FB4-4ABF-B309-A7987F56BE73}"/>
+                <a16:creationId xmlns:a16="http://schemas.microsoft.com/office/drawing/2014/main" id="{02325945-6097-4985-9526-5F349B3F5CA2}"/>
               </a:ext>
             </a:extLst>
           </p:cNvPr>
@@ -2665,7 +2665,7 @@
           <p:cNvPr id="10" name="">
             <a:extLst xmlns:a="http://schemas.openxmlformats.org/drawingml/2006/main">
               <a:ext uri="{FF2B5EF4-FFF2-40B4-BE49-F238E27FC236}">
-                <a16:creationId xmlns:a16="http://schemas.microsoft.com/office/drawing/2014/main" id="{F193F623-BE4F-48A4-989C-70FA8DA2571E}"/>
+                <a16:creationId xmlns:a16="http://schemas.microsoft.com/office/drawing/2014/main" id="{B3A4EBAE-C020-4213-946C-F506EC119EB9}"/>
               </a:ext>
             </a:extLst>
           </p:cNvPr>
@@ -2699,7 +2699,7 @@
           <p:cNvPr id="11" name="">
             <a:extLst xmlns:a="http://schemas.openxmlformats.org/drawingml/2006/main">
               <a:ext uri="{FF2B5EF4-FFF2-40B4-BE49-F238E27FC236}">
-                <a16:creationId xmlns:a16="http://schemas.microsoft.com/office/drawing/2014/main" id="{98BC5449-C0D5-4671-9178-67319FE28996}"/>
+                <a16:creationId xmlns:a16="http://schemas.microsoft.com/office/drawing/2014/main" id="{DD901E1C-DF42-44BB-8472-435C3E2187BA}"/>
               </a:ext>
             </a:extLst>
           </p:cNvPr>
@@ -2733,7 +2733,7 @@
           <p:cNvPr id="12" name="">
             <a:extLst xmlns:a="http://schemas.openxmlformats.org/drawingml/2006/main">
               <a:ext uri="{FF2B5EF4-FFF2-40B4-BE49-F238E27FC236}">
-                <a16:creationId xmlns:a16="http://schemas.microsoft.com/office/drawing/2014/main" id="{EE7A35F1-D6ED-4807-A677-FD47C9E4B1C2}"/>
+                <a16:creationId xmlns:a16="http://schemas.microsoft.com/office/drawing/2014/main" id="{D9572B43-EDA8-4E5C-9AD5-6B8BA5AB1953}"/>
               </a:ext>
             </a:extLst>
           </p:cNvPr>
@@ -2767,7 +2767,7 @@
           <p:cNvPr id="13" name="">
             <a:extLst xmlns:a="http://schemas.openxmlformats.org/drawingml/2006/main">
               <a:ext uri="{FF2B5EF4-FFF2-40B4-BE49-F238E27FC236}">
-                <a16:creationId xmlns:a16="http://schemas.microsoft.com/office/drawing/2014/main" id="{D586F213-D8EB-49D7-9AF6-8F9B4F0E396F}"/>
+                <a16:creationId xmlns:a16="http://schemas.microsoft.com/office/drawing/2014/main" id="{9BA190C8-4A3D-4F8A-8A7B-535605B4AA97}"/>
               </a:ext>
             </a:extLst>
           </p:cNvPr>
@@ -2801,7 +2801,7 @@
           <p:cNvPr id="14" name="">
             <a:extLst xmlns:a="http://schemas.openxmlformats.org/drawingml/2006/main">
               <a:ext uri="{FF2B5EF4-FFF2-40B4-BE49-F238E27FC236}">
-                <a16:creationId xmlns:a16="http://schemas.microsoft.com/office/drawing/2014/main" id="{0E403C63-189C-4EC7-ADF1-22B5D87AD170}"/>
+                <a16:creationId xmlns:a16="http://schemas.microsoft.com/office/drawing/2014/main" id="{3091E2DC-D8B0-4C5F-82A9-923732403204}"/>
               </a:ext>
             </a:extLst>
           </p:cNvPr>
@@ -2835,7 +2835,7 @@
           <p:cNvPr id="15" name="">
             <a:extLst xmlns:a="http://schemas.openxmlformats.org/drawingml/2006/main">
               <a:ext uri="{FF2B5EF4-FFF2-40B4-BE49-F238E27FC236}">
-                <a16:creationId xmlns:a16="http://schemas.microsoft.com/office/drawing/2014/main" id="{3D5C8622-18DD-4211-AFFF-A525E6AA06B4}"/>
+                <a16:creationId xmlns:a16="http://schemas.microsoft.com/office/drawing/2014/main" id="{7C67AED0-B7BA-4CF9-B5C1-1B111053FF86}"/>
               </a:ext>
             </a:extLst>
           </p:cNvPr>
@@ -2869,7 +2869,7 @@
           <p:cNvPr id="16" name="">
             <a:extLst xmlns:a="http://schemas.openxmlformats.org/drawingml/2006/main">
               <a:ext uri="{FF2B5EF4-FFF2-40B4-BE49-F238E27FC236}">
-                <a16:creationId xmlns:a16="http://schemas.microsoft.com/office/drawing/2014/main" id="{0C7B9F0B-E466-437A-9E6E-538652C9E63A}"/>
+                <a16:creationId xmlns:a16="http://schemas.microsoft.com/office/drawing/2014/main" id="{3E990B68-B8A9-418F-A424-88AD9A5AA310}"/>
               </a:ext>
             </a:extLst>
           </p:cNvPr>
@@ -2903,7 +2903,7 @@
           <p:cNvPr id="17" name="">
             <a:extLst xmlns:a="http://schemas.openxmlformats.org/drawingml/2006/main">
               <a:ext uri="{FF2B5EF4-FFF2-40B4-BE49-F238E27FC236}">
-                <a16:creationId xmlns:a16="http://schemas.microsoft.com/office/drawing/2014/main" id="{EA235E05-82C8-4650-A837-BEBED14B6EAB}"/>
+                <a16:creationId xmlns:a16="http://schemas.microsoft.com/office/drawing/2014/main" id="{5CD0BDBC-3F16-40D1-B060-AC504DC7EE78}"/>
               </a:ext>
             </a:extLst>
           </p:cNvPr>
@@ -2937,7 +2937,7 @@
           <p:cNvPr id="18" name="">
             <a:extLst xmlns:a="http://schemas.openxmlformats.org/drawingml/2006/main">
               <a:ext uri="{FF2B5EF4-FFF2-40B4-BE49-F238E27FC236}">
-                <a16:creationId xmlns:a16="http://schemas.microsoft.com/office/drawing/2014/main" id="{CD6EA462-8AE2-461D-A2A4-99196C71AC3B}"/>
+                <a16:creationId xmlns:a16="http://schemas.microsoft.com/office/drawing/2014/main" id="{5D6502B3-DBF1-41A6-B30F-7B566E0EACDF}"/>
               </a:ext>
             </a:extLst>
           </p:cNvPr>
@@ -2971,7 +2971,7 @@
           <p:cNvPr id="19" name="">
             <a:extLst xmlns:a="http://schemas.openxmlformats.org/drawingml/2006/main">
               <a:ext uri="{FF2B5EF4-FFF2-40B4-BE49-F238E27FC236}">
-                <a16:creationId xmlns:a16="http://schemas.microsoft.com/office/drawing/2014/main" id="{1C738044-6360-4752-8735-5E4FC7C1BB28}"/>
+                <a16:creationId xmlns:a16="http://schemas.microsoft.com/office/drawing/2014/main" id="{1190D16F-B28E-48EE-B7F2-4204A0645E13}"/>
               </a:ext>
             </a:extLst>
           </p:cNvPr>
@@ -3005,7 +3005,7 @@
           <p:cNvPr id="20" name="">
             <a:extLst xmlns:a="http://schemas.openxmlformats.org/drawingml/2006/main">
               <a:ext uri="{FF2B5EF4-FFF2-40B4-BE49-F238E27FC236}">
-                <a16:creationId xmlns:a16="http://schemas.microsoft.com/office/drawing/2014/main" id="{89AC5579-3A3A-4625-9D13-6DE99665B93D}"/>
+                <a16:creationId xmlns:a16="http://schemas.microsoft.com/office/drawing/2014/main" id="{E1C87DB9-1D12-46ED-B2F0-13F0120D90C3}"/>
               </a:ext>
             </a:extLst>
           </p:cNvPr>
@@ -3039,7 +3039,7 @@
           <p:cNvPr id="21" name="">
             <a:extLst xmlns:a="http://schemas.openxmlformats.org/drawingml/2006/main">
               <a:ext uri="{FF2B5EF4-FFF2-40B4-BE49-F238E27FC236}">
-                <a16:creationId xmlns:a16="http://schemas.microsoft.com/office/drawing/2014/main" id="{1E6F7FF2-70E1-4E25-BFA9-59D2369472DB}"/>
+                <a16:creationId xmlns:a16="http://schemas.microsoft.com/office/drawing/2014/main" id="{8370DD99-0214-4599-9F63-BEDBD848343F}"/>
               </a:ext>
             </a:extLst>
           </p:cNvPr>
@@ -3073,7 +3073,7 @@
           <p:cNvPr id="22" name="">
             <a:extLst xmlns:a="http://schemas.openxmlformats.org/drawingml/2006/main">
               <a:ext uri="{FF2B5EF4-FFF2-40B4-BE49-F238E27FC236}">
-                <a16:creationId xmlns:a16="http://schemas.microsoft.com/office/drawing/2014/main" id="{FD4FC91A-FE8A-4635-91C4-C99BE37FD9B4}"/>
+                <a16:creationId xmlns:a16="http://schemas.microsoft.com/office/drawing/2014/main" id="{42BC0F0D-2545-4EAC-8429-56F969356AEF}"/>
               </a:ext>
             </a:extLst>
           </p:cNvPr>
@@ -3107,7 +3107,7 @@
           <p:cNvPr id="23" name="">
             <a:extLst xmlns:a="http://schemas.openxmlformats.org/drawingml/2006/main">
               <a:ext uri="{FF2B5EF4-FFF2-40B4-BE49-F238E27FC236}">
-                <a16:creationId xmlns:a16="http://schemas.microsoft.com/office/drawing/2014/main" id="{746B48B0-0963-4A0A-8B51-83F8BA799C63}"/>
+                <a16:creationId xmlns:a16="http://schemas.microsoft.com/office/drawing/2014/main" id="{DBCAD59F-2EA1-4F07-B8EC-4E5C692FFB8D}"/>
               </a:ext>
             </a:extLst>
           </p:cNvPr>
@@ -3141,7 +3141,7 @@
           <p:cNvPr id="24" name="">
             <a:extLst xmlns:a="http://schemas.openxmlformats.org/drawingml/2006/main">
               <a:ext uri="{FF2B5EF4-FFF2-40B4-BE49-F238E27FC236}">
-                <a16:creationId xmlns:a16="http://schemas.microsoft.com/office/drawing/2014/main" id="{D88F7024-C209-478F-B882-AA092A6375E2}"/>
+                <a16:creationId xmlns:a16="http://schemas.microsoft.com/office/drawing/2014/main" id="{982FA721-515A-4E4F-ACE2-C8EF185AAB61}"/>
               </a:ext>
             </a:extLst>
           </p:cNvPr>
@@ -3175,7 +3175,7 @@
           <p:cNvPr id="25" name="">
             <a:extLst xmlns:a="http://schemas.openxmlformats.org/drawingml/2006/main">
               <a:ext uri="{FF2B5EF4-FFF2-40B4-BE49-F238E27FC236}">
-                <a16:creationId xmlns:a16="http://schemas.microsoft.com/office/drawing/2014/main" id="{5F441E6B-46EE-4B2F-BD4B-130008486B74}"/>
+                <a16:creationId xmlns:a16="http://schemas.microsoft.com/office/drawing/2014/main" id="{7AAC41C3-BE1D-4B90-B448-4461E7B1D1D1}"/>
               </a:ext>
             </a:extLst>
           </p:cNvPr>
@@ -3209,7 +3209,7 @@
           <p:cNvPr id="26" name="">
             <a:extLst xmlns:a="http://schemas.openxmlformats.org/drawingml/2006/main">
               <a:ext uri="{FF2B5EF4-FFF2-40B4-BE49-F238E27FC236}">
-                <a16:creationId xmlns:a16="http://schemas.microsoft.com/office/drawing/2014/main" id="{BA09374B-4000-4B51-92BD-630F623728CB}"/>
+                <a16:creationId xmlns:a16="http://schemas.microsoft.com/office/drawing/2014/main" id="{080C4B3D-6F43-409F-8946-785CD6AE5FCA}"/>
               </a:ext>
             </a:extLst>
           </p:cNvPr>
@@ -3243,7 +3243,7 @@
           <p:cNvPr id="27" name="">
             <a:extLst xmlns:a="http://schemas.openxmlformats.org/drawingml/2006/main">
               <a:ext uri="{FF2B5EF4-FFF2-40B4-BE49-F238E27FC236}">
-                <a16:creationId xmlns:a16="http://schemas.microsoft.com/office/drawing/2014/main" id="{331991E1-9A25-4FA9-BD06-E534A1A0D25D}"/>
+                <a16:creationId xmlns:a16="http://schemas.microsoft.com/office/drawing/2014/main" id="{4AD55E3A-90F4-4EB2-8F66-70B159CCFDFF}"/>
               </a:ext>
             </a:extLst>
           </p:cNvPr>
@@ -3277,7 +3277,7 @@
           <p:cNvPr id="28" name="">
             <a:extLst xmlns:a="http://schemas.openxmlformats.org/drawingml/2006/main">
               <a:ext uri="{FF2B5EF4-FFF2-40B4-BE49-F238E27FC236}">
-                <a16:creationId xmlns:a16="http://schemas.microsoft.com/office/drawing/2014/main" id="{198A1916-C0F5-42CF-A26D-57457CAA8C5E}"/>
+                <a16:creationId xmlns:a16="http://schemas.microsoft.com/office/drawing/2014/main" id="{1D37AC29-6E7E-4935-9C34-C4389F1076E1}"/>
               </a:ext>
             </a:extLst>
           </p:cNvPr>
@@ -3311,7 +3311,7 @@
           <p:cNvPr id="29" name="">
             <a:extLst xmlns:a="http://schemas.openxmlformats.org/drawingml/2006/main">
               <a:ext uri="{FF2B5EF4-FFF2-40B4-BE49-F238E27FC236}">
-                <a16:creationId xmlns:a16="http://schemas.microsoft.com/office/drawing/2014/main" id="{F583954A-AE28-45C7-B3D0-3F0CA817AD30}"/>
+                <a16:creationId xmlns:a16="http://schemas.microsoft.com/office/drawing/2014/main" id="{F66C3B70-338B-4354-8517-7AE451DFE5AE}"/>
               </a:ext>
             </a:extLst>
           </p:cNvPr>
@@ -3345,7 +3345,7 @@
           <p:cNvPr id="30" name="">
             <a:extLst xmlns:a="http://schemas.openxmlformats.org/drawingml/2006/main">
               <a:ext uri="{FF2B5EF4-FFF2-40B4-BE49-F238E27FC236}">
-                <a16:creationId xmlns:a16="http://schemas.microsoft.com/office/drawing/2014/main" id="{DCCD953C-C3FA-4E24-B18F-CE7C90B77AB9}"/>
+                <a16:creationId xmlns:a16="http://schemas.microsoft.com/office/drawing/2014/main" id="{F4AD8120-8CF4-471A-8F91-DD18C41478E6}"/>
               </a:ext>
             </a:extLst>
           </p:cNvPr>
@@ -3379,7 +3379,7 @@
           <p:cNvPr id="31" name="">
             <a:extLst xmlns:a="http://schemas.openxmlformats.org/drawingml/2006/main">
               <a:ext uri="{FF2B5EF4-FFF2-40B4-BE49-F238E27FC236}">
-                <a16:creationId xmlns:a16="http://schemas.microsoft.com/office/drawing/2014/main" id="{CC87CCBC-4383-48F0-B594-E86A9EE4CD3B}"/>
+                <a16:creationId xmlns:a16="http://schemas.microsoft.com/office/drawing/2014/main" id="{633BFAB1-196E-4C2E-9253-84C43D6B982E}"/>
               </a:ext>
             </a:extLst>
           </p:cNvPr>
@@ -3413,7 +3413,7 @@
           <p:cNvPr id="32" name="">
             <a:extLst xmlns:a="http://schemas.openxmlformats.org/drawingml/2006/main">
               <a:ext uri="{FF2B5EF4-FFF2-40B4-BE49-F238E27FC236}">
-                <a16:creationId xmlns:a16="http://schemas.microsoft.com/office/drawing/2014/main" id="{166462A7-A2F3-4949-8496-1E28F1DD3DAC}"/>
+                <a16:creationId xmlns:a16="http://schemas.microsoft.com/office/drawing/2014/main" id="{E834D057-9D85-42DD-A286-28B7817D26B9}"/>
               </a:ext>
             </a:extLst>
           </p:cNvPr>
@@ -3447,7 +3447,7 @@
           <p:cNvPr id="33" name="">
             <a:extLst xmlns:a="http://schemas.openxmlformats.org/drawingml/2006/main">
               <a:ext uri="{FF2B5EF4-FFF2-40B4-BE49-F238E27FC236}">
-                <a16:creationId xmlns:a16="http://schemas.microsoft.com/office/drawing/2014/main" id="{65D5DB6C-E3A9-4E3B-AEE0-8EAC2796CE05}"/>
+                <a16:creationId xmlns:a16="http://schemas.microsoft.com/office/drawing/2014/main" id="{0DEA1797-6743-4841-A8B3-4ABCBA210FCE}"/>
               </a:ext>
             </a:extLst>
           </p:cNvPr>
@@ -3481,7 +3481,7 @@
           <p:cNvPr id="34" name="">
             <a:extLst xmlns:a="http://schemas.openxmlformats.org/drawingml/2006/main">
               <a:ext uri="{FF2B5EF4-FFF2-40B4-BE49-F238E27FC236}">
-                <a16:creationId xmlns:a16="http://schemas.microsoft.com/office/drawing/2014/main" id="{1B5E4AF8-B6BB-412D-BDEF-5F45A60363AA}"/>
+                <a16:creationId xmlns:a16="http://schemas.microsoft.com/office/drawing/2014/main" id="{5732F7EA-AE59-4B35-94A2-B1A32658B701}"/>
               </a:ext>
             </a:extLst>
           </p:cNvPr>
@@ -3515,7 +3515,7 @@
           <p:cNvPr id="35" name="">
             <a:extLst xmlns:a="http://schemas.openxmlformats.org/drawingml/2006/main">
               <a:ext uri="{FF2B5EF4-FFF2-40B4-BE49-F238E27FC236}">
-                <a16:creationId xmlns:a16="http://schemas.microsoft.com/office/drawing/2014/main" id="{85542FB8-45BA-4B14-8230-773F21473DF4}"/>
+                <a16:creationId xmlns:a16="http://schemas.microsoft.com/office/drawing/2014/main" id="{0E7A29EB-E695-4EDC-AFD6-9C30B63CDC39}"/>
               </a:ext>
             </a:extLst>
           </p:cNvPr>
@@ -3549,7 +3549,7 @@
           <p:cNvPr id="36" name="">
             <a:extLst xmlns:a="http://schemas.openxmlformats.org/drawingml/2006/main">
               <a:ext uri="{FF2B5EF4-FFF2-40B4-BE49-F238E27FC236}">
-                <a16:creationId xmlns:a16="http://schemas.microsoft.com/office/drawing/2014/main" id="{645215AA-3A39-433E-A0F5-A723740621E4}"/>
+                <a16:creationId xmlns:a16="http://schemas.microsoft.com/office/drawing/2014/main" id="{290710D2-2717-46E1-9130-3FF1D9F25CD6}"/>
               </a:ext>
             </a:extLst>
           </p:cNvPr>
@@ -3583,7 +3583,7 @@
           <p:cNvPr id="37" name="">
             <a:extLst xmlns:a="http://schemas.openxmlformats.org/drawingml/2006/main">
               <a:ext uri="{FF2B5EF4-FFF2-40B4-BE49-F238E27FC236}">
-                <a16:creationId xmlns:a16="http://schemas.microsoft.com/office/drawing/2014/main" id="{5CA90B09-4063-4CAD-9FB3-7C490E075B2F}"/>
+                <a16:creationId xmlns:a16="http://schemas.microsoft.com/office/drawing/2014/main" id="{A7CE8725-D0AE-4A13-8B55-158ACDE80ABC}"/>
               </a:ext>
             </a:extLst>
           </p:cNvPr>
@@ -3617,7 +3617,7 @@
           <p:cNvPr id="38" name="">
             <a:extLst xmlns:a="http://schemas.openxmlformats.org/drawingml/2006/main">
               <a:ext uri="{FF2B5EF4-FFF2-40B4-BE49-F238E27FC236}">
-                <a16:creationId xmlns:a16="http://schemas.microsoft.com/office/drawing/2014/main" id="{3B80EFEC-C0FE-4E2C-BEE7-6374A427B9E5}"/>
+                <a16:creationId xmlns:a16="http://schemas.microsoft.com/office/drawing/2014/main" id="{444A1C59-6D3C-42AB-AC05-551157F8E08E}"/>
               </a:ext>
             </a:extLst>
           </p:cNvPr>
@@ -3651,7 +3651,7 @@
           <p:cNvPr id="39" name="">
             <a:extLst xmlns:a="http://schemas.openxmlformats.org/drawingml/2006/main">
               <a:ext uri="{FF2B5EF4-FFF2-40B4-BE49-F238E27FC236}">
-                <a16:creationId xmlns:a16="http://schemas.microsoft.com/office/drawing/2014/main" id="{D9658E04-2C8C-450A-B59D-C1DB3491DEE8}"/>
+                <a16:creationId xmlns:a16="http://schemas.microsoft.com/office/drawing/2014/main" id="{FB66F15F-0884-4DBD-83D8-93BC35342C09}"/>
               </a:ext>
             </a:extLst>
           </p:cNvPr>
@@ -3685,7 +3685,7 @@
           <p:cNvPr id="40" name="">
             <a:extLst xmlns:a="http://schemas.openxmlformats.org/drawingml/2006/main">
               <a:ext uri="{FF2B5EF4-FFF2-40B4-BE49-F238E27FC236}">
-                <a16:creationId xmlns:a16="http://schemas.microsoft.com/office/drawing/2014/main" id="{C76AA5A6-1720-478F-9CC4-69B0D8CBA1F1}"/>
+                <a16:creationId xmlns:a16="http://schemas.microsoft.com/office/drawing/2014/main" id="{1CF3EBE9-38A1-45F8-BC85-4A33F3A8B991}"/>
               </a:ext>
             </a:extLst>
           </p:cNvPr>
@@ -3719,7 +3719,7 @@
           <p:cNvPr id="41" name="">
             <a:extLst xmlns:a="http://schemas.openxmlformats.org/drawingml/2006/main">
               <a:ext uri="{FF2B5EF4-FFF2-40B4-BE49-F238E27FC236}">
-                <a16:creationId xmlns:a16="http://schemas.microsoft.com/office/drawing/2014/main" id="{2DE5481C-5730-4A1A-B04E-863F57A0EDD3}"/>
+                <a16:creationId xmlns:a16="http://schemas.microsoft.com/office/drawing/2014/main" id="{E372AD63-90E1-43D8-82D8-CB08A65A6CA2}"/>
               </a:ext>
             </a:extLst>
           </p:cNvPr>
@@ -3753,7 +3753,7 @@
           <p:cNvPr id="42" name="">
             <a:extLst xmlns:a="http://schemas.openxmlformats.org/drawingml/2006/main">
               <a:ext uri="{FF2B5EF4-FFF2-40B4-BE49-F238E27FC236}">
-                <a16:creationId xmlns:a16="http://schemas.microsoft.com/office/drawing/2014/main" id="{F37AA6BF-23C0-4355-A7BF-682EBEEC3C09}"/>
+                <a16:creationId xmlns:a16="http://schemas.microsoft.com/office/drawing/2014/main" id="{6D2E87F6-A3CC-466C-999D-56EAE848BE00}"/>
               </a:ext>
             </a:extLst>
           </p:cNvPr>
@@ -3787,7 +3787,7 @@
           <p:cNvPr id="43" name="">
             <a:extLst xmlns:a="http://schemas.openxmlformats.org/drawingml/2006/main">
               <a:ext uri="{FF2B5EF4-FFF2-40B4-BE49-F238E27FC236}">
-                <a16:creationId xmlns:a16="http://schemas.microsoft.com/office/drawing/2014/main" id="{15596EA9-6735-4096-B81C-634FCC635988}"/>
+                <a16:creationId xmlns:a16="http://schemas.microsoft.com/office/drawing/2014/main" id="{22D01BD6-3681-47BC-AB0B-362AAEE67587}"/>
               </a:ext>
             </a:extLst>
           </p:cNvPr>
@@ -3821,7 +3821,7 @@
           <p:cNvPr id="44" name="">
             <a:extLst xmlns:a="http://schemas.openxmlformats.org/drawingml/2006/main">
               <a:ext uri="{FF2B5EF4-FFF2-40B4-BE49-F238E27FC236}">
-                <a16:creationId xmlns:a16="http://schemas.microsoft.com/office/drawing/2014/main" id="{B4850C8B-733F-4F24-B877-24FABC34F08D}"/>
+                <a16:creationId xmlns:a16="http://schemas.microsoft.com/office/drawing/2014/main" id="{3E2BD45F-7385-4A5D-989F-64A982B19B2F}"/>
               </a:ext>
             </a:extLst>
           </p:cNvPr>
@@ -3855,7 +3855,7 @@
           <p:cNvPr id="45" name="">
             <a:extLst xmlns:a="http://schemas.openxmlformats.org/drawingml/2006/main">
               <a:ext uri="{FF2B5EF4-FFF2-40B4-BE49-F238E27FC236}">
-                <a16:creationId xmlns:a16="http://schemas.microsoft.com/office/drawing/2014/main" id="{CE7CC566-607C-46B0-A25D-F51D5356635A}"/>
+                <a16:creationId xmlns:a16="http://schemas.microsoft.com/office/drawing/2014/main" id="{4F27EAA4-A1B5-4252-8875-278296E7D4D1}"/>
               </a:ext>
             </a:extLst>
           </p:cNvPr>
@@ -3889,7 +3889,7 @@
           <p:cNvPr id="46" name="">
             <a:extLst xmlns:a="http://schemas.openxmlformats.org/drawingml/2006/main">
               <a:ext uri="{FF2B5EF4-FFF2-40B4-BE49-F238E27FC236}">
-                <a16:creationId xmlns:a16="http://schemas.microsoft.com/office/drawing/2014/main" id="{DF361BBC-7850-4218-B3C7-66D40D79B996}"/>
+                <a16:creationId xmlns:a16="http://schemas.microsoft.com/office/drawing/2014/main" id="{AAFCBE49-3F1F-46D2-9110-252DBDF1B189}"/>
               </a:ext>
             </a:extLst>
           </p:cNvPr>
@@ -3923,7 +3923,7 @@
           <p:cNvPr id="47" name="">
             <a:extLst xmlns:a="http://schemas.openxmlformats.org/drawingml/2006/main">
               <a:ext uri="{FF2B5EF4-FFF2-40B4-BE49-F238E27FC236}">
-                <a16:creationId xmlns:a16="http://schemas.microsoft.com/office/drawing/2014/main" id="{5D51A589-992D-4F7A-AC0F-3CDB0D936FF7}"/>
+                <a16:creationId xmlns:a16="http://schemas.microsoft.com/office/drawing/2014/main" id="{0CB510D3-115E-4433-BFA0-36D8F0C3E0CF}"/>
               </a:ext>
             </a:extLst>
           </p:cNvPr>
@@ -3957,7 +3957,7 @@
           <p:cNvPr id="48" name="">
             <a:extLst xmlns:a="http://schemas.openxmlformats.org/drawingml/2006/main">
               <a:ext uri="{FF2B5EF4-FFF2-40B4-BE49-F238E27FC236}">
-                <a16:creationId xmlns:a16="http://schemas.microsoft.com/office/drawing/2014/main" id="{BCB6D2C6-1B5F-4DB7-80B8-45709E5359B2}"/>
+                <a16:creationId xmlns:a16="http://schemas.microsoft.com/office/drawing/2014/main" id="{A9D23018-6D48-4725-93EA-773F1101D459}"/>
               </a:ext>
             </a:extLst>
           </p:cNvPr>
@@ -3991,7 +3991,7 @@
           <p:cNvPr id="49" name="">
             <a:extLst xmlns:a="http://schemas.openxmlformats.org/drawingml/2006/main">
               <a:ext uri="{FF2B5EF4-FFF2-40B4-BE49-F238E27FC236}">
-                <a16:creationId xmlns:a16="http://schemas.microsoft.com/office/drawing/2014/main" id="{80ED47F0-00F3-4D6A-B594-818CB0D2C4E9}"/>
+                <a16:creationId xmlns:a16="http://schemas.microsoft.com/office/drawing/2014/main" id="{5A470371-E85F-4199-8F1D-0F347EAD1B00}"/>
               </a:ext>
             </a:extLst>
           </p:cNvPr>
@@ -4025,7 +4025,7 @@
           <p:cNvPr id="50" name="">
             <a:extLst xmlns:a="http://schemas.openxmlformats.org/drawingml/2006/main">
               <a:ext uri="{FF2B5EF4-FFF2-40B4-BE49-F238E27FC236}">
-                <a16:creationId xmlns:a16="http://schemas.microsoft.com/office/drawing/2014/main" id="{4AA5CAA6-E5A6-4EE3-827D-557FADC13E96}"/>
+                <a16:creationId xmlns:a16="http://schemas.microsoft.com/office/drawing/2014/main" id="{F6468DB0-0C44-4D8B-9DF2-0933D197B5E7}"/>
               </a:ext>
             </a:extLst>
           </p:cNvPr>
@@ -4059,7 +4059,7 @@
           <p:cNvPr id="51" name="">
             <a:extLst xmlns:a="http://schemas.openxmlformats.org/drawingml/2006/main">
               <a:ext uri="{FF2B5EF4-FFF2-40B4-BE49-F238E27FC236}">
-                <a16:creationId xmlns:a16="http://schemas.microsoft.com/office/drawing/2014/main" id="{B301DAE6-6B8B-4C16-B5B2-B6B5960A9F77}"/>
+                <a16:creationId xmlns:a16="http://schemas.microsoft.com/office/drawing/2014/main" id="{565FB5C9-1306-4C1C-AFB5-E3D26925C4B6}"/>
               </a:ext>
             </a:extLst>
           </p:cNvPr>
@@ -4093,7 +4093,7 @@
           <p:cNvPr id="52" name="">
             <a:extLst xmlns:a="http://schemas.openxmlformats.org/drawingml/2006/main">
               <a:ext uri="{FF2B5EF4-FFF2-40B4-BE49-F238E27FC236}">
-                <a16:creationId xmlns:a16="http://schemas.microsoft.com/office/drawing/2014/main" id="{9FA1A8E3-D866-4FF8-83C7-CDFCD84C0787}"/>
+                <a16:creationId xmlns:a16="http://schemas.microsoft.com/office/drawing/2014/main" id="{6F45A012-673E-4CAD-B22A-7CFDBA0144FE}"/>
               </a:ext>
             </a:extLst>
           </p:cNvPr>
@@ -4127,7 +4127,7 @@
           <p:cNvPr id="53" name="">
             <a:extLst xmlns:a="http://schemas.openxmlformats.org/drawingml/2006/main">
               <a:ext uri="{FF2B5EF4-FFF2-40B4-BE49-F238E27FC236}">
-                <a16:creationId xmlns:a16="http://schemas.microsoft.com/office/drawing/2014/main" id="{68A28DE0-E4DA-4EA0-A40C-2CED59C54EEF}"/>
+                <a16:creationId xmlns:a16="http://schemas.microsoft.com/office/drawing/2014/main" id="{0688FBCB-2C92-41FA-9C53-49C15FA99889}"/>
               </a:ext>
             </a:extLst>
           </p:cNvPr>
@@ -4161,7 +4161,7 @@
           <p:cNvPr id="54" name="">
             <a:extLst xmlns:a="http://schemas.openxmlformats.org/drawingml/2006/main">
               <a:ext uri="{FF2B5EF4-FFF2-40B4-BE49-F238E27FC236}">
-                <a16:creationId xmlns:a16="http://schemas.microsoft.com/office/drawing/2014/main" id="{F7F73305-C5C9-4855-95BE-01A7A7499A44}"/>
+                <a16:creationId xmlns:a16="http://schemas.microsoft.com/office/drawing/2014/main" id="{6E7E27B7-7C0E-42CD-A787-6D136E15DB0E}"/>
               </a:ext>
             </a:extLst>
           </p:cNvPr>
@@ -4195,7 +4195,7 @@
           <p:cNvPr id="55" name="">
             <a:extLst xmlns:a="http://schemas.openxmlformats.org/drawingml/2006/main">
               <a:ext uri="{FF2B5EF4-FFF2-40B4-BE49-F238E27FC236}">
-                <a16:creationId xmlns:a16="http://schemas.microsoft.com/office/drawing/2014/main" id="{3EFFC005-AFE1-416B-940F-56B36E38DBD9}"/>
+                <a16:creationId xmlns:a16="http://schemas.microsoft.com/office/drawing/2014/main" id="{C6175563-C851-484A-B005-DA615E84F366}"/>
               </a:ext>
             </a:extLst>
           </p:cNvPr>
@@ -4229,7 +4229,7 @@
           <p:cNvPr id="56" name="">
             <a:extLst xmlns:a="http://schemas.openxmlformats.org/drawingml/2006/main">
               <a:ext uri="{FF2B5EF4-FFF2-40B4-BE49-F238E27FC236}">
-                <a16:creationId xmlns:a16="http://schemas.microsoft.com/office/drawing/2014/main" id="{7A0DF304-3AC7-4189-995C-1D11FA7292B2}"/>
+                <a16:creationId xmlns:a16="http://schemas.microsoft.com/office/drawing/2014/main" id="{570F51BF-7908-4AC3-8203-15395F335CE0}"/>
               </a:ext>
             </a:extLst>
           </p:cNvPr>
@@ -4263,7 +4263,7 @@
           <p:cNvPr id="57" name="">
             <a:extLst xmlns:a="http://schemas.openxmlformats.org/drawingml/2006/main">
               <a:ext uri="{FF2B5EF4-FFF2-40B4-BE49-F238E27FC236}">
-                <a16:creationId xmlns:a16="http://schemas.microsoft.com/office/drawing/2014/main" id="{726CB07A-D662-4E90-A578-C8C04AC2FA70}"/>
+                <a16:creationId xmlns:a16="http://schemas.microsoft.com/office/drawing/2014/main" id="{A0FDDBAF-89D6-4CFF-921E-295B3AD7F52C}"/>
               </a:ext>
             </a:extLst>
           </p:cNvPr>
@@ -4297,7 +4297,7 @@
           <p:cNvPr id="58" name="">
             <a:extLst xmlns:a="http://schemas.openxmlformats.org/drawingml/2006/main">
               <a:ext uri="{FF2B5EF4-FFF2-40B4-BE49-F238E27FC236}">
-                <a16:creationId xmlns:a16="http://schemas.microsoft.com/office/drawing/2014/main" id="{DE128EBF-AA7A-4790-8A80-CDF0308C58E4}"/>
+                <a16:creationId xmlns:a16="http://schemas.microsoft.com/office/drawing/2014/main" id="{31174D9C-5B31-4366-A90A-63DE8F7F4EB1}"/>
               </a:ext>
             </a:extLst>
           </p:cNvPr>
@@ -4331,7 +4331,7 @@
           <p:cNvPr id="59" name="">
             <a:extLst xmlns:a="http://schemas.openxmlformats.org/drawingml/2006/main">
               <a:ext uri="{FF2B5EF4-FFF2-40B4-BE49-F238E27FC236}">
-                <a16:creationId xmlns:a16="http://schemas.microsoft.com/office/drawing/2014/main" id="{23243FEF-3EA0-4829-92FF-2861BE2CAE0D}"/>
+                <a16:creationId xmlns:a16="http://schemas.microsoft.com/office/drawing/2014/main" id="{465671A5-0828-4A9D-8ACA-8DC455D4CA5E}"/>
               </a:ext>
             </a:extLst>
           </p:cNvPr>
@@ -4365,7 +4365,7 @@
           <p:cNvPr id="60" name="">
             <a:extLst xmlns:a="http://schemas.openxmlformats.org/drawingml/2006/main">
               <a:ext uri="{FF2B5EF4-FFF2-40B4-BE49-F238E27FC236}">
-                <a16:creationId xmlns:a16="http://schemas.microsoft.com/office/drawing/2014/main" id="{47A21EED-F4EA-4ED3-AF6E-CD570B3136DA}"/>
+                <a16:creationId xmlns:a16="http://schemas.microsoft.com/office/drawing/2014/main" id="{CB213283-18E5-4F92-9C87-D60B556F2086}"/>
               </a:ext>
             </a:extLst>
           </p:cNvPr>
@@ -4399,7 +4399,7 @@
           <p:cNvPr id="61" name="">
             <a:extLst xmlns:a="http://schemas.openxmlformats.org/drawingml/2006/main">
               <a:ext uri="{FF2B5EF4-FFF2-40B4-BE49-F238E27FC236}">
-                <a16:creationId xmlns:a16="http://schemas.microsoft.com/office/drawing/2014/main" id="{7593574D-2045-44FC-B639-3E5B751245FB}"/>
+                <a16:creationId xmlns:a16="http://schemas.microsoft.com/office/drawing/2014/main" id="{01B90540-CCE5-4B5C-A3E1-99845C444B70}"/>
               </a:ext>
             </a:extLst>
           </p:cNvPr>
@@ -4433,7 +4433,7 @@
           <p:cNvPr id="62" name="">
             <a:extLst xmlns:a="http://schemas.openxmlformats.org/drawingml/2006/main">
               <a:ext uri="{FF2B5EF4-FFF2-40B4-BE49-F238E27FC236}">
-                <a16:creationId xmlns:a16="http://schemas.microsoft.com/office/drawing/2014/main" id="{A809AE53-FB57-429B-BDBE-9E87BB226C42}"/>
+                <a16:creationId xmlns:a16="http://schemas.microsoft.com/office/drawing/2014/main" id="{D6973122-5E96-4D06-9F6B-011C591AD16C}"/>
               </a:ext>
             </a:extLst>
           </p:cNvPr>
@@ -4467,7 +4467,7 @@
           <p:cNvPr id="63" name="">
             <a:extLst xmlns:a="http://schemas.openxmlformats.org/drawingml/2006/main">
               <a:ext uri="{FF2B5EF4-FFF2-40B4-BE49-F238E27FC236}">
-                <a16:creationId xmlns:a16="http://schemas.microsoft.com/office/drawing/2014/main" id="{9C389874-88A9-4412-ACBC-2DC34D290083}"/>
+                <a16:creationId xmlns:a16="http://schemas.microsoft.com/office/drawing/2014/main" id="{F50405AF-9AA0-44CB-9E8C-2B29A6C2C302}"/>
               </a:ext>
             </a:extLst>
           </p:cNvPr>
@@ -4501,7 +4501,7 @@
           <p:cNvPr id="64" name="">
             <a:extLst xmlns:a="http://schemas.openxmlformats.org/drawingml/2006/main">
               <a:ext uri="{FF2B5EF4-FFF2-40B4-BE49-F238E27FC236}">
-                <a16:creationId xmlns:a16="http://schemas.microsoft.com/office/drawing/2014/main" id="{D8BF6C5A-50FE-42BD-AB0D-4ED55FC4AE95}"/>
+                <a16:creationId xmlns:a16="http://schemas.microsoft.com/office/drawing/2014/main" id="{810A1D8B-B3FE-46B3-A096-71B7D49BB4BC}"/>
               </a:ext>
             </a:extLst>
           </p:cNvPr>
@@ -4535,7 +4535,7 @@
           <p:cNvPr id="65" name="">
             <a:extLst xmlns:a="http://schemas.openxmlformats.org/drawingml/2006/main">
               <a:ext uri="{FF2B5EF4-FFF2-40B4-BE49-F238E27FC236}">
-                <a16:creationId xmlns:a16="http://schemas.microsoft.com/office/drawing/2014/main" id="{FDEBBFCA-C3C3-4FF3-95E5-1B26BA0FE69B}"/>
+                <a16:creationId xmlns:a16="http://schemas.microsoft.com/office/drawing/2014/main" id="{9BD0506C-C26B-4E4F-89C8-744EFB87D03B}"/>
               </a:ext>
             </a:extLst>
           </p:cNvPr>
@@ -4569,7 +4569,7 @@
           <p:cNvPr id="66" name="">
             <a:extLst xmlns:a="http://schemas.openxmlformats.org/drawingml/2006/main">
               <a:ext uri="{FF2B5EF4-FFF2-40B4-BE49-F238E27FC236}">
-                <a16:creationId xmlns:a16="http://schemas.microsoft.com/office/drawing/2014/main" id="{1F10388C-74C7-4F5B-BCE0-A532C8EF77D1}"/>
+                <a16:creationId xmlns:a16="http://schemas.microsoft.com/office/drawing/2014/main" id="{FEDAB8AD-73ED-417C-A109-ADF55314D92F}"/>
               </a:ext>
             </a:extLst>
           </p:cNvPr>
@@ -4603,7 +4603,7 @@
           <p:cNvPr id="67" name="">
             <a:extLst xmlns:a="http://schemas.openxmlformats.org/drawingml/2006/main">
               <a:ext uri="{FF2B5EF4-FFF2-40B4-BE49-F238E27FC236}">
-                <a16:creationId xmlns:a16="http://schemas.microsoft.com/office/drawing/2014/main" id="{CAB0B428-35B8-4241-8BB1-E9320ECD3780}"/>
+                <a16:creationId xmlns:a16="http://schemas.microsoft.com/office/drawing/2014/main" id="{775DBF11-2F58-4E10-B867-05A4D30BEF12}"/>
               </a:ext>
             </a:extLst>
           </p:cNvPr>
@@ -4637,7 +4637,7 @@
           <p:cNvPr id="68" name="">
             <a:extLst xmlns:a="http://schemas.openxmlformats.org/drawingml/2006/main">
               <a:ext uri="{FF2B5EF4-FFF2-40B4-BE49-F238E27FC236}">
-                <a16:creationId xmlns:a16="http://schemas.microsoft.com/office/drawing/2014/main" id="{A4EE9C0C-6B03-436B-9303-1AF71E588EA2}"/>
+                <a16:creationId xmlns:a16="http://schemas.microsoft.com/office/drawing/2014/main" id="{DCB47729-5652-4176-B3C9-EE41241A999F}"/>
               </a:ext>
             </a:extLst>
           </p:cNvPr>
@@ -4671,7 +4671,7 @@
           <p:cNvPr id="69" name="">
             <a:extLst xmlns:a="http://schemas.openxmlformats.org/drawingml/2006/main">
               <a:ext uri="{FF2B5EF4-FFF2-40B4-BE49-F238E27FC236}">
-                <a16:creationId xmlns:a16="http://schemas.microsoft.com/office/drawing/2014/main" id="{76F78367-C5D5-406A-B560-B932F2619758}"/>
+                <a16:creationId xmlns:a16="http://schemas.microsoft.com/office/drawing/2014/main" id="{67F53D6C-8F02-456C-A7D7-3EEAB7BB2908}"/>
               </a:ext>
             </a:extLst>
           </p:cNvPr>
@@ -4705,7 +4705,7 @@
           <p:cNvPr id="70" name="">
             <a:extLst xmlns:a="http://schemas.openxmlformats.org/drawingml/2006/main">
               <a:ext uri="{FF2B5EF4-FFF2-40B4-BE49-F238E27FC236}">
-                <a16:creationId xmlns:a16="http://schemas.microsoft.com/office/drawing/2014/main" id="{BB39E129-4A57-4C2E-A41A-D14187F0D87E}"/>
+                <a16:creationId xmlns:a16="http://schemas.microsoft.com/office/drawing/2014/main" id="{9CD45085-A338-41A6-A3A4-52211EA20AA7}"/>
               </a:ext>
             </a:extLst>
           </p:cNvPr>
@@ -4739,7 +4739,7 @@
           <p:cNvPr id="71" name="">
             <a:extLst xmlns:a="http://schemas.openxmlformats.org/drawingml/2006/main">
               <a:ext uri="{FF2B5EF4-FFF2-40B4-BE49-F238E27FC236}">
-                <a16:creationId xmlns:a16="http://schemas.microsoft.com/office/drawing/2014/main" id="{E3CB149B-87FC-4F2A-ADFD-3E6F2FD86A6A}"/>
+                <a16:creationId xmlns:a16="http://schemas.microsoft.com/office/drawing/2014/main" id="{BE62C9C0-3310-4237-888D-D99DA7E86808}"/>
               </a:ext>
             </a:extLst>
           </p:cNvPr>
@@ -4773,7 +4773,7 @@
           <p:cNvPr id="72" name="">
             <a:extLst xmlns:a="http://schemas.openxmlformats.org/drawingml/2006/main">
               <a:ext uri="{FF2B5EF4-FFF2-40B4-BE49-F238E27FC236}">
-                <a16:creationId xmlns:a16="http://schemas.microsoft.com/office/drawing/2014/main" id="{1DACEC01-671B-40B4-B3C0-0EE3D61FBFE7}"/>
+                <a16:creationId xmlns:a16="http://schemas.microsoft.com/office/drawing/2014/main" id="{EA88F51E-C671-4FC3-9B39-CFE0DDBD8E13}"/>
               </a:ext>
             </a:extLst>
           </p:cNvPr>
@@ -4807,7 +4807,7 @@
           <p:cNvPr id="73" name="">
             <a:extLst xmlns:a="http://schemas.openxmlformats.org/drawingml/2006/main">
               <a:ext uri="{FF2B5EF4-FFF2-40B4-BE49-F238E27FC236}">
-                <a16:creationId xmlns:a16="http://schemas.microsoft.com/office/drawing/2014/main" id="{A1F9F9E0-A21A-4269-89D9-75AAEA9D4753}"/>
+                <a16:creationId xmlns:a16="http://schemas.microsoft.com/office/drawing/2014/main" id="{2002BF9A-A5E7-46E2-B482-F60A20DF07C2}"/>
               </a:ext>
             </a:extLst>
           </p:cNvPr>
@@ -4841,7 +4841,7 @@
           <p:cNvPr id="74" name="">
             <a:extLst xmlns:a="http://schemas.openxmlformats.org/drawingml/2006/main">
               <a:ext uri="{FF2B5EF4-FFF2-40B4-BE49-F238E27FC236}">
-                <a16:creationId xmlns:a16="http://schemas.microsoft.com/office/drawing/2014/main" id="{69730B60-EF8A-4720-AD0D-73807292E5CB}"/>
+                <a16:creationId xmlns:a16="http://schemas.microsoft.com/office/drawing/2014/main" id="{76B599B1-7740-4F8D-9EA9-09604DDF0C45}"/>
               </a:ext>
             </a:extLst>
           </p:cNvPr>
@@ -4875,7 +4875,7 @@
           <p:cNvPr id="75" name="">
             <a:extLst xmlns:a="http://schemas.openxmlformats.org/drawingml/2006/main">
               <a:ext uri="{FF2B5EF4-FFF2-40B4-BE49-F238E27FC236}">
-                <a16:creationId xmlns:a16="http://schemas.microsoft.com/office/drawing/2014/main" id="{32B3AA4F-1327-4E2D-A509-3804A0845907}"/>
+                <a16:creationId xmlns:a16="http://schemas.microsoft.com/office/drawing/2014/main" id="{6B993998-3922-453A-8FC1-517D6003AFDE}"/>
               </a:ext>
             </a:extLst>
           </p:cNvPr>
@@ -4909,7 +4909,7 @@
           <p:cNvPr id="76" name="">
             <a:extLst xmlns:a="http://schemas.openxmlformats.org/drawingml/2006/main">
               <a:ext uri="{FF2B5EF4-FFF2-40B4-BE49-F238E27FC236}">
-                <a16:creationId xmlns:a16="http://schemas.microsoft.com/office/drawing/2014/main" id="{515AA9A3-20A6-4AFB-95F3-7D34EE1CF660}"/>
+                <a16:creationId xmlns:a16="http://schemas.microsoft.com/office/drawing/2014/main" id="{E1AACCE1-5230-4C45-86F9-029E76377175}"/>
               </a:ext>
             </a:extLst>
           </p:cNvPr>
@@ -4943,7 +4943,7 @@
           <p:cNvPr id="77" name="">
             <a:extLst xmlns:a="http://schemas.openxmlformats.org/drawingml/2006/main">
               <a:ext uri="{FF2B5EF4-FFF2-40B4-BE49-F238E27FC236}">
-                <a16:creationId xmlns:a16="http://schemas.microsoft.com/office/drawing/2014/main" id="{656EEADC-B4E4-4BCA-8962-86DD9AC707D4}"/>
+                <a16:creationId xmlns:a16="http://schemas.microsoft.com/office/drawing/2014/main" id="{17C6BA69-B5AB-4BC8-9232-0A40387DB229}"/>
               </a:ext>
             </a:extLst>
           </p:cNvPr>
@@ -4977,7 +4977,7 @@
           <p:cNvPr id="78" name="">
             <a:extLst xmlns:a="http://schemas.openxmlformats.org/drawingml/2006/main">
               <a:ext uri="{FF2B5EF4-FFF2-40B4-BE49-F238E27FC236}">
-                <a16:creationId xmlns:a16="http://schemas.microsoft.com/office/drawing/2014/main" id="{ACFC89C8-FFBA-4019-933B-E18B43ADC092}"/>
+                <a16:creationId xmlns:a16="http://schemas.microsoft.com/office/drawing/2014/main" id="{6823F967-0FBF-480F-96C9-E4AA909EE860}"/>
               </a:ext>
             </a:extLst>
           </p:cNvPr>
@@ -5011,7 +5011,7 @@
           <p:cNvPr id="79" name="">
             <a:extLst xmlns:a="http://schemas.openxmlformats.org/drawingml/2006/main">
               <a:ext uri="{FF2B5EF4-FFF2-40B4-BE49-F238E27FC236}">
-                <a16:creationId xmlns:a16="http://schemas.microsoft.com/office/drawing/2014/main" id="{DC4128F8-4454-4BCE-9E31-58D6293AE26A}"/>
+                <a16:creationId xmlns:a16="http://schemas.microsoft.com/office/drawing/2014/main" id="{FAF7F706-AC37-455D-AA56-A6109EFFE190}"/>
               </a:ext>
             </a:extLst>
           </p:cNvPr>
@@ -5045,7 +5045,7 @@
           <p:cNvPr id="80" name="">
             <a:extLst xmlns:a="http://schemas.openxmlformats.org/drawingml/2006/main">
               <a:ext uri="{FF2B5EF4-FFF2-40B4-BE49-F238E27FC236}">
-                <a16:creationId xmlns:a16="http://schemas.microsoft.com/office/drawing/2014/main" id="{8303B494-09D8-4A5D-926A-B43215E54981}"/>
+                <a16:creationId xmlns:a16="http://schemas.microsoft.com/office/drawing/2014/main" id="{C6416DF6-D545-45E8-A20A-24788BFCA547}"/>
               </a:ext>
             </a:extLst>
           </p:cNvPr>
@@ -5079,7 +5079,7 @@
           <p:cNvPr id="81" name="">
             <a:extLst xmlns:a="http://schemas.openxmlformats.org/drawingml/2006/main">
               <a:ext uri="{FF2B5EF4-FFF2-40B4-BE49-F238E27FC236}">
-                <a16:creationId xmlns:a16="http://schemas.microsoft.com/office/drawing/2014/main" id="{7FD582D6-68C9-4D6C-8186-40151DFD42D4}"/>
+                <a16:creationId xmlns:a16="http://schemas.microsoft.com/office/drawing/2014/main" id="{B36ACEC1-C819-4445-9CAD-CCBCF61CFA53}"/>
               </a:ext>
             </a:extLst>
           </p:cNvPr>
@@ -5113,7 +5113,7 @@
           <p:cNvPr id="82" name="">
             <a:extLst xmlns:a="http://schemas.openxmlformats.org/drawingml/2006/main">
               <a:ext uri="{FF2B5EF4-FFF2-40B4-BE49-F238E27FC236}">
-                <a16:creationId xmlns:a16="http://schemas.microsoft.com/office/drawing/2014/main" id="{412AA338-EE1D-41D7-93EA-E604E00BE5BB}"/>
+                <a16:creationId xmlns:a16="http://schemas.microsoft.com/office/drawing/2014/main" id="{686F336C-C54A-47F9-8481-42DF5B891393}"/>
               </a:ext>
             </a:extLst>
           </p:cNvPr>
@@ -5147,7 +5147,7 @@
           <p:cNvPr id="83" name="">
             <a:extLst xmlns:a="http://schemas.openxmlformats.org/drawingml/2006/main">
               <a:ext uri="{FF2B5EF4-FFF2-40B4-BE49-F238E27FC236}">
-                <a16:creationId xmlns:a16="http://schemas.microsoft.com/office/drawing/2014/main" id="{511683FB-EB05-4541-B338-B60FD1B13C02}"/>
+                <a16:creationId xmlns:a16="http://schemas.microsoft.com/office/drawing/2014/main" id="{E630886B-3C88-48D9-834B-7EA2091695A0}"/>
               </a:ext>
             </a:extLst>
           </p:cNvPr>
@@ -5181,7 +5181,7 @@
           <p:cNvPr id="84" name="">
             <a:extLst xmlns:a="http://schemas.openxmlformats.org/drawingml/2006/main">
               <a:ext uri="{FF2B5EF4-FFF2-40B4-BE49-F238E27FC236}">
-                <a16:creationId xmlns:a16="http://schemas.microsoft.com/office/drawing/2014/main" id="{A777310E-46B4-4ABA-9E69-9ABFA7ECA1B6}"/>
+                <a16:creationId xmlns:a16="http://schemas.microsoft.com/office/drawing/2014/main" id="{6B3E07DC-124A-4ACF-A67D-0ABBC0529125}"/>
               </a:ext>
             </a:extLst>
           </p:cNvPr>
@@ -5215,7 +5215,7 @@
           <p:cNvPr id="85" name="">
             <a:extLst xmlns:a="http://schemas.openxmlformats.org/drawingml/2006/main">
               <a:ext uri="{FF2B5EF4-FFF2-40B4-BE49-F238E27FC236}">
-                <a16:creationId xmlns:a16="http://schemas.microsoft.com/office/drawing/2014/main" id="{F55111F3-7A95-4866-BC6F-332F3943C77A}"/>
+                <a16:creationId xmlns:a16="http://schemas.microsoft.com/office/drawing/2014/main" id="{5947CF18-0A74-4158-AAE7-399149ADBF24}"/>
               </a:ext>
             </a:extLst>
           </p:cNvPr>
@@ -5249,7 +5249,7 @@
           <p:cNvPr id="86" name="">
             <a:extLst xmlns:a="http://schemas.openxmlformats.org/drawingml/2006/main">
               <a:ext uri="{FF2B5EF4-FFF2-40B4-BE49-F238E27FC236}">
-                <a16:creationId xmlns:a16="http://schemas.microsoft.com/office/drawing/2014/main" id="{3F8D18D9-B731-4A68-B67F-7D7D0BF1366F}"/>
+                <a16:creationId xmlns:a16="http://schemas.microsoft.com/office/drawing/2014/main" id="{B7B21D53-346D-447F-AD44-56CA0AFA3A48}"/>
               </a:ext>
             </a:extLst>
           </p:cNvPr>
@@ -5283,7 +5283,7 @@
           <p:cNvPr id="87" name="">
             <a:extLst xmlns:a="http://schemas.openxmlformats.org/drawingml/2006/main">
               <a:ext uri="{FF2B5EF4-FFF2-40B4-BE49-F238E27FC236}">
-                <a16:creationId xmlns:a16="http://schemas.microsoft.com/office/drawing/2014/main" id="{5D3C4328-12AE-423F-895A-07CAAA5E80B2}"/>
+                <a16:creationId xmlns:a16="http://schemas.microsoft.com/office/drawing/2014/main" id="{4D6F9D32-7A8A-4680-AC17-DC27746B2B7D}"/>
               </a:ext>
             </a:extLst>
           </p:cNvPr>
@@ -5317,7 +5317,7 @@
           <p:cNvPr id="88" name="">
             <a:extLst xmlns:a="http://schemas.openxmlformats.org/drawingml/2006/main">
               <a:ext uri="{FF2B5EF4-FFF2-40B4-BE49-F238E27FC236}">
-                <a16:creationId xmlns:a16="http://schemas.microsoft.com/office/drawing/2014/main" id="{11A3A927-D460-4267-AC24-1EB654142C89}"/>
+                <a16:creationId xmlns:a16="http://schemas.microsoft.com/office/drawing/2014/main" id="{D395AAA1-5E10-4CF2-835D-69A3F0C876CB}"/>
               </a:ext>
             </a:extLst>
           </p:cNvPr>
@@ -5351,7 +5351,7 @@
           <p:cNvPr id="89" name="">
             <a:extLst xmlns:a="http://schemas.openxmlformats.org/drawingml/2006/main">
               <a:ext uri="{FF2B5EF4-FFF2-40B4-BE49-F238E27FC236}">
-                <a16:creationId xmlns:a16="http://schemas.microsoft.com/office/drawing/2014/main" id="{E576BD91-BC29-4CB7-A038-6BCFA8FB87A5}"/>
+                <a16:creationId xmlns:a16="http://schemas.microsoft.com/office/drawing/2014/main" id="{23D5AB63-E68F-4D62-BEF1-D6628701F44C}"/>
               </a:ext>
             </a:extLst>
           </p:cNvPr>
@@ -5385,7 +5385,7 @@
           <p:cNvPr id="90" name="">
             <a:extLst xmlns:a="http://schemas.openxmlformats.org/drawingml/2006/main">
               <a:ext uri="{FF2B5EF4-FFF2-40B4-BE49-F238E27FC236}">
-                <a16:creationId xmlns:a16="http://schemas.microsoft.com/office/drawing/2014/main" id="{3E407A15-AD90-438B-B045-79A118F7A7A1}"/>
+                <a16:creationId xmlns:a16="http://schemas.microsoft.com/office/drawing/2014/main" id="{646E9301-886B-439A-938B-297D49636AC1}"/>
               </a:ext>
             </a:extLst>
           </p:cNvPr>
@@ -5419,7 +5419,7 @@
           <p:cNvPr id="91" name="">
             <a:extLst xmlns:a="http://schemas.openxmlformats.org/drawingml/2006/main">
               <a:ext uri="{FF2B5EF4-FFF2-40B4-BE49-F238E27FC236}">
-                <a16:creationId xmlns:a16="http://schemas.microsoft.com/office/drawing/2014/main" id="{9F56E727-EE96-4140-AF8C-856D747A5C51}"/>
+                <a16:creationId xmlns:a16="http://schemas.microsoft.com/office/drawing/2014/main" id="{6C441074-50E7-430F-ABEA-8DC458E7DE46}"/>
               </a:ext>
             </a:extLst>
           </p:cNvPr>
@@ -5453,7 +5453,7 @@
           <p:cNvPr id="92" name="">
             <a:extLst xmlns:a="http://schemas.openxmlformats.org/drawingml/2006/main">
               <a:ext uri="{FF2B5EF4-FFF2-40B4-BE49-F238E27FC236}">
-                <a16:creationId xmlns:a16="http://schemas.microsoft.com/office/drawing/2014/main" id="{269139EE-483E-4843-9148-C18E10F97875}"/>
+                <a16:creationId xmlns:a16="http://schemas.microsoft.com/office/drawing/2014/main" id="{1E24916B-1B38-4C91-AF2D-5E35C0D1F1DB}"/>
               </a:ext>
             </a:extLst>
           </p:cNvPr>
@@ -5487,7 +5487,7 @@
           <p:cNvPr id="93" name="">
             <a:extLst xmlns:a="http://schemas.openxmlformats.org/drawingml/2006/main">
               <a:ext uri="{FF2B5EF4-FFF2-40B4-BE49-F238E27FC236}">
-                <a16:creationId xmlns:a16="http://schemas.microsoft.com/office/drawing/2014/main" id="{32A7EF5F-E0F8-4457-A452-1E39C2791275}"/>
+                <a16:creationId xmlns:a16="http://schemas.microsoft.com/office/drawing/2014/main" id="{ADB3069E-7FC6-43FE-B97F-5E5A37CDFAA5}"/>
               </a:ext>
             </a:extLst>
           </p:cNvPr>
@@ -5521,7 +5521,7 @@
           <p:cNvPr id="94" name="">
             <a:extLst xmlns:a="http://schemas.openxmlformats.org/drawingml/2006/main">
               <a:ext uri="{FF2B5EF4-FFF2-40B4-BE49-F238E27FC236}">
-                <a16:creationId xmlns:a16="http://schemas.microsoft.com/office/drawing/2014/main" id="{C863FD6D-80BC-4C87-9714-56B7DA629359}"/>
+                <a16:creationId xmlns:a16="http://schemas.microsoft.com/office/drawing/2014/main" id="{DA4BE8A6-C458-4C4B-A86A-935F15C6CC55}"/>
               </a:ext>
             </a:extLst>
           </p:cNvPr>
@@ -5555,7 +5555,7 @@
           <p:cNvPr id="95" name="">
             <a:extLst xmlns:a="http://schemas.openxmlformats.org/drawingml/2006/main">
               <a:ext uri="{FF2B5EF4-FFF2-40B4-BE49-F238E27FC236}">
-                <a16:creationId xmlns:a16="http://schemas.microsoft.com/office/drawing/2014/main" id="{EEC1D288-A6AB-4957-83EB-6771B092D817}"/>
+                <a16:creationId xmlns:a16="http://schemas.microsoft.com/office/drawing/2014/main" id="{75E8520D-072F-45C4-B1C2-77FF6F2BF632}"/>
               </a:ext>
             </a:extLst>
           </p:cNvPr>
@@ -5589,7 +5589,7 @@
           <p:cNvPr id="96" name="">
             <a:extLst xmlns:a="http://schemas.openxmlformats.org/drawingml/2006/main">
               <a:ext uri="{FF2B5EF4-FFF2-40B4-BE49-F238E27FC236}">
-                <a16:creationId xmlns:a16="http://schemas.microsoft.com/office/drawing/2014/main" id="{A62DD1B6-8165-4F0B-A97D-6AD16079643A}"/>
+                <a16:creationId xmlns:a16="http://schemas.microsoft.com/office/drawing/2014/main" id="{F16EB392-5727-4882-B004-18CC6474781D}"/>
               </a:ext>
             </a:extLst>
           </p:cNvPr>
@@ -5623,7 +5623,7 @@
           <p:cNvPr id="97" name="">
             <a:extLst xmlns:a="http://schemas.openxmlformats.org/drawingml/2006/main">
               <a:ext uri="{FF2B5EF4-FFF2-40B4-BE49-F238E27FC236}">
-                <a16:creationId xmlns:a16="http://schemas.microsoft.com/office/drawing/2014/main" id="{3D0E3546-90D6-4390-B86C-71FDEE4391FC}"/>
+                <a16:creationId xmlns:a16="http://schemas.microsoft.com/office/drawing/2014/main" id="{8E375C43-BF55-43B3-A0E5-D9D7AD3F32BB}"/>
               </a:ext>
             </a:extLst>
           </p:cNvPr>
@@ -5657,7 +5657,7 @@
           <p:cNvPr id="98" name="">
             <a:extLst xmlns:a="http://schemas.openxmlformats.org/drawingml/2006/main">
               <a:ext uri="{FF2B5EF4-FFF2-40B4-BE49-F238E27FC236}">
-                <a16:creationId xmlns:a16="http://schemas.microsoft.com/office/drawing/2014/main" id="{3063DDA1-2AB3-4089-B207-327C582036F1}"/>
+                <a16:creationId xmlns:a16="http://schemas.microsoft.com/office/drawing/2014/main" id="{F8E72EF1-4086-4E8B-ABAA-3D27019498A9}"/>
               </a:ext>
             </a:extLst>
           </p:cNvPr>
@@ -5691,7 +5691,7 @@
           <p:cNvPr id="99" name="">
             <a:extLst xmlns:a="http://schemas.openxmlformats.org/drawingml/2006/main">
               <a:ext uri="{FF2B5EF4-FFF2-40B4-BE49-F238E27FC236}">
-                <a16:creationId xmlns:a16="http://schemas.microsoft.com/office/drawing/2014/main" id="{CC1EC05C-C1C3-40D6-AB07-71EB7EFBBD06}"/>
+                <a16:creationId xmlns:a16="http://schemas.microsoft.com/office/drawing/2014/main" id="{DDE52B24-0D02-4299-A531-6A912DF3A898}"/>
               </a:ext>
             </a:extLst>
           </p:cNvPr>
@@ -5725,7 +5725,7 @@
           <p:cNvPr id="100" name="">
             <a:extLst xmlns:a="http://schemas.openxmlformats.org/drawingml/2006/main">
               <a:ext uri="{FF2B5EF4-FFF2-40B4-BE49-F238E27FC236}">
-                <a16:creationId xmlns:a16="http://schemas.microsoft.com/office/drawing/2014/main" id="{77A42126-C543-4747-8545-7A596E530E0F}"/>
+                <a16:creationId xmlns:a16="http://schemas.microsoft.com/office/drawing/2014/main" id="{1024582D-91F9-448F-B642-B6A17D1A9AC6}"/>
               </a:ext>
             </a:extLst>
           </p:cNvPr>
@@ -5757,7 +5757,7 @@
           <p:cNvPr id="101" name="">
             <a:extLst xmlns:a="http://schemas.openxmlformats.org/drawingml/2006/main">
               <a:ext uri="{FF2B5EF4-FFF2-40B4-BE49-F238E27FC236}">
-                <a16:creationId xmlns:a16="http://schemas.microsoft.com/office/drawing/2014/main" id="{357294BA-BDFA-402B-BC8A-A1E820C98C96}"/>
+                <a16:creationId xmlns:a16="http://schemas.microsoft.com/office/drawing/2014/main" id="{74B33431-ADD5-4876-83CF-5BD97718D73E}"/>
               </a:ext>
             </a:extLst>
           </p:cNvPr>
@@ -5791,7 +5791,7 @@
           <p:cNvPr id="102" name="">
             <a:extLst xmlns:a="http://schemas.openxmlformats.org/drawingml/2006/main">
               <a:ext uri="{FF2B5EF4-FFF2-40B4-BE49-F238E27FC236}">
-                <a16:creationId xmlns:a16="http://schemas.microsoft.com/office/drawing/2014/main" id="{CB55B94E-8745-4F4A-B1E9-9B2880C600FD}"/>
+                <a16:creationId xmlns:a16="http://schemas.microsoft.com/office/drawing/2014/main" id="{8375F5BC-1D9D-4843-ABFC-AB4264A7A859}"/>
               </a:ext>
             </a:extLst>
           </p:cNvPr>
@@ -5825,7 +5825,7 @@
           <p:cNvPr id="103" name="">
             <a:extLst xmlns:a="http://schemas.openxmlformats.org/drawingml/2006/main">
               <a:ext uri="{FF2B5EF4-FFF2-40B4-BE49-F238E27FC236}">
-                <a16:creationId xmlns:a16="http://schemas.microsoft.com/office/drawing/2014/main" id="{63113BE9-A26A-41C8-98ED-21B4ACDCEE1E}"/>
+                <a16:creationId xmlns:a16="http://schemas.microsoft.com/office/drawing/2014/main" id="{2DCCE72C-8336-484D-B8D1-B53BCEA6188E}"/>
               </a:ext>
             </a:extLst>
           </p:cNvPr>
@@ -5859,7 +5859,7 @@
           <p:cNvPr id="104" name="">
             <a:extLst xmlns:a="http://schemas.openxmlformats.org/drawingml/2006/main">
               <a:ext uri="{FF2B5EF4-FFF2-40B4-BE49-F238E27FC236}">
-                <a16:creationId xmlns:a16="http://schemas.microsoft.com/office/drawing/2014/main" id="{2E5ACE8E-9353-469E-AEE9-8F0794BB1768}"/>
+                <a16:creationId xmlns:a16="http://schemas.microsoft.com/office/drawing/2014/main" id="{C8E86DCF-E9D4-4DB9-B289-1C7DF914B93E}"/>
               </a:ext>
             </a:extLst>
           </p:cNvPr>
@@ -5893,7 +5893,7 @@
           <p:cNvPr id="105" name="">
             <a:extLst xmlns:a="http://schemas.openxmlformats.org/drawingml/2006/main">
               <a:ext uri="{FF2B5EF4-FFF2-40B4-BE49-F238E27FC236}">
-                <a16:creationId xmlns:a16="http://schemas.microsoft.com/office/drawing/2014/main" id="{5B255429-9022-4F96-91C4-5518534DDE64}"/>
+                <a16:creationId xmlns:a16="http://schemas.microsoft.com/office/drawing/2014/main" id="{BFFC6BE3-9911-4C6C-952C-FC7FB5B1F4CB}"/>
               </a:ext>
             </a:extLst>
           </p:cNvPr>
@@ -5927,7 +5927,7 @@
           <p:cNvPr id="106" name="">
             <a:extLst xmlns:a="http://schemas.openxmlformats.org/drawingml/2006/main">
               <a:ext uri="{FF2B5EF4-FFF2-40B4-BE49-F238E27FC236}">
-                <a16:creationId xmlns:a16="http://schemas.microsoft.com/office/drawing/2014/main" id="{D3005DFB-6F52-4087-9B5D-52FE8E5C9672}"/>
+                <a16:creationId xmlns:a16="http://schemas.microsoft.com/office/drawing/2014/main" id="{1B3A242A-D4A0-4055-BE63-54267CF826F0}"/>
               </a:ext>
             </a:extLst>
           </p:cNvPr>
@@ -5961,7 +5961,7 @@
           <p:cNvPr id="107" name="">
             <a:extLst xmlns:a="http://schemas.openxmlformats.org/drawingml/2006/main">
               <a:ext uri="{FF2B5EF4-FFF2-40B4-BE49-F238E27FC236}">
-                <a16:creationId xmlns:a16="http://schemas.microsoft.com/office/drawing/2014/main" id="{FC273D54-AE22-42D3-B098-142E21673BF7}"/>
+                <a16:creationId xmlns:a16="http://schemas.microsoft.com/office/drawing/2014/main" id="{A06E75F0-7506-41CC-B1CF-F849DC5106C0}"/>
               </a:ext>
             </a:extLst>
           </p:cNvPr>
@@ -5995,7 +5995,7 @@
           <p:cNvPr id="108" name="">
             <a:extLst xmlns:a="http://schemas.openxmlformats.org/drawingml/2006/main">
               <a:ext uri="{FF2B5EF4-FFF2-40B4-BE49-F238E27FC236}">
-                <a16:creationId xmlns:a16="http://schemas.microsoft.com/office/drawing/2014/main" id="{AFBC4E29-5391-469B-A1B4-2C458038671C}"/>
+                <a16:creationId xmlns:a16="http://schemas.microsoft.com/office/drawing/2014/main" id="{5B92CDC7-9052-480A-ACDE-AF7912B6C3F5}"/>
               </a:ext>
             </a:extLst>
           </p:cNvPr>
@@ -6029,7 +6029,7 @@
           <p:cNvPr id="109" name="">
             <a:extLst xmlns:a="http://schemas.openxmlformats.org/drawingml/2006/main">
               <a:ext uri="{FF2B5EF4-FFF2-40B4-BE49-F238E27FC236}">
-                <a16:creationId xmlns:a16="http://schemas.microsoft.com/office/drawing/2014/main" id="{4DA436E7-D40A-4946-AAD9-BE0D57936078}"/>
+                <a16:creationId xmlns:a16="http://schemas.microsoft.com/office/drawing/2014/main" id="{A28B2001-39B2-41C0-9A27-348609D1AD6E}"/>
               </a:ext>
             </a:extLst>
           </p:cNvPr>
@@ -6063,7 +6063,7 @@
           <p:cNvPr id="110" name="">
             <a:extLst xmlns:a="http://schemas.openxmlformats.org/drawingml/2006/main">
               <a:ext uri="{FF2B5EF4-FFF2-40B4-BE49-F238E27FC236}">
-                <a16:creationId xmlns:a16="http://schemas.microsoft.com/office/drawing/2014/main" id="{F65953AE-32CD-4735-8CE7-8FA7B4EF4792}"/>
+                <a16:creationId xmlns:a16="http://schemas.microsoft.com/office/drawing/2014/main" id="{95C250A1-8397-4BAF-8C2F-65E6DA8B4906}"/>
               </a:ext>
             </a:extLst>
           </p:cNvPr>
@@ -6097,7 +6097,7 @@
           <p:cNvPr id="111" name="">
             <a:extLst xmlns:a="http://schemas.openxmlformats.org/drawingml/2006/main">
               <a:ext uri="{FF2B5EF4-FFF2-40B4-BE49-F238E27FC236}">
-                <a16:creationId xmlns:a16="http://schemas.microsoft.com/office/drawing/2014/main" id="{A750F0A7-2408-458E-93CD-48D075ABE61C}"/>
+                <a16:creationId xmlns:a16="http://schemas.microsoft.com/office/drawing/2014/main" id="{FF5A2BD9-4D92-448D-BD8D-0AF8806BF1EC}"/>
               </a:ext>
             </a:extLst>
           </p:cNvPr>
@@ -6131,7 +6131,7 @@
           <p:cNvPr id="112" name="">
             <a:extLst xmlns:a="http://schemas.openxmlformats.org/drawingml/2006/main">
               <a:ext uri="{FF2B5EF4-FFF2-40B4-BE49-F238E27FC236}">
-                <a16:creationId xmlns:a16="http://schemas.microsoft.com/office/drawing/2014/main" id="{E0A27A55-3739-439A-9DC9-6ABC25B605DB}"/>
+                <a16:creationId xmlns:a16="http://schemas.microsoft.com/office/drawing/2014/main" id="{2FD0ECD2-540B-4575-ACC9-3EA0AAB29BED}"/>
               </a:ext>
             </a:extLst>
           </p:cNvPr>
@@ -6165,7 +6165,7 @@
           <p:cNvPr id="113" name="">
             <a:extLst xmlns:a="http://schemas.openxmlformats.org/drawingml/2006/main">
               <a:ext uri="{FF2B5EF4-FFF2-40B4-BE49-F238E27FC236}">
-                <a16:creationId xmlns:a16="http://schemas.microsoft.com/office/drawing/2014/main" id="{897A895D-F365-4C4E-86B5-B0A5A8C624F7}"/>
+                <a16:creationId xmlns:a16="http://schemas.microsoft.com/office/drawing/2014/main" id="{5E957B8A-80E8-4EE5-8178-4D632D935B79}"/>
               </a:ext>
             </a:extLst>
           </p:cNvPr>
@@ -6199,7 +6199,7 @@
           <p:cNvPr id="114" name="">
             <a:extLst xmlns:a="http://schemas.openxmlformats.org/drawingml/2006/main">
               <a:ext uri="{FF2B5EF4-FFF2-40B4-BE49-F238E27FC236}">
-                <a16:creationId xmlns:a16="http://schemas.microsoft.com/office/drawing/2014/main" id="{B7D15151-A981-4A2D-AA23-8370758FFA90}"/>
+                <a16:creationId xmlns:a16="http://schemas.microsoft.com/office/drawing/2014/main" id="{37181BF4-6224-43B9-B1C0-FB80DCE79277}"/>
               </a:ext>
             </a:extLst>
           </p:cNvPr>
@@ -6262,7 +6262,7 @@
           <p:cNvPr id="115" name="">
             <a:extLst xmlns:a="http://schemas.openxmlformats.org/drawingml/2006/main">
               <a:ext uri="{FF2B5EF4-FFF2-40B4-BE49-F238E27FC236}">
-                <a16:creationId xmlns:a16="http://schemas.microsoft.com/office/drawing/2014/main" id="{DBC49F1A-7DE7-4256-9B9F-4EC35292C902}"/>
+                <a16:creationId xmlns:a16="http://schemas.microsoft.com/office/drawing/2014/main" id="{57854300-DEED-447E-9DAD-312505C3B17F}"/>
               </a:ext>
             </a:extLst>
           </p:cNvPr>
@@ -6294,7 +6294,7 @@
           <p:cNvPr id="116" name="">
             <a:extLst xmlns:a="http://schemas.openxmlformats.org/drawingml/2006/main">
               <a:ext uri="{FF2B5EF4-FFF2-40B4-BE49-F238E27FC236}">
-                <a16:creationId xmlns:a16="http://schemas.microsoft.com/office/drawing/2014/main" id="{91302C51-71DC-49B4-A7D1-9BBAC066C702}"/>
+                <a16:creationId xmlns:a16="http://schemas.microsoft.com/office/drawing/2014/main" id="{30A659E7-40EA-4CD3-BFFB-473E0DC0A30B}"/>
               </a:ext>
             </a:extLst>
           </p:cNvPr>
@@ -6326,7 +6326,7 @@
           <p:cNvPr id="117" name="">
             <a:extLst xmlns:a="http://schemas.openxmlformats.org/drawingml/2006/main">
               <a:ext uri="{FF2B5EF4-FFF2-40B4-BE49-F238E27FC236}">
-                <a16:creationId xmlns:a16="http://schemas.microsoft.com/office/drawing/2014/main" id="{76984B30-587E-44C1-831C-5ADFB0E2BC23}"/>
+                <a16:creationId xmlns:a16="http://schemas.microsoft.com/office/drawing/2014/main" id="{22BA769A-5D70-44B3-A509-CB847E8AF766}"/>
               </a:ext>
             </a:extLst>
           </p:cNvPr>
@@ -6389,7 +6389,7 @@
           <p:cNvPr id="118" name="">
             <a:extLst xmlns:a="http://schemas.openxmlformats.org/drawingml/2006/main">
               <a:ext uri="{FF2B5EF4-FFF2-40B4-BE49-F238E27FC236}">
-                <a16:creationId xmlns:a16="http://schemas.microsoft.com/office/drawing/2014/main" id="{DCB11B5C-6F4D-4D95-8FDE-879889EE732B}"/>
+                <a16:creationId xmlns:a16="http://schemas.microsoft.com/office/drawing/2014/main" id="{401AA6F7-4AC5-40F6-9E3F-4A839544E4E0}"/>
               </a:ext>
             </a:extLst>
           </p:cNvPr>
@@ -6421,7 +6421,7 @@
           <p:cNvPr id="119" name="">
             <a:extLst xmlns:a="http://schemas.openxmlformats.org/drawingml/2006/main">
               <a:ext uri="{FF2B5EF4-FFF2-40B4-BE49-F238E27FC236}">
-                <a16:creationId xmlns:a16="http://schemas.microsoft.com/office/drawing/2014/main" id="{AD5E849B-2B15-4239-8472-A41C5BF88DB9}"/>
+                <a16:creationId xmlns:a16="http://schemas.microsoft.com/office/drawing/2014/main" id="{17C9A6C5-0833-43F6-8D6F-0447AC9B3DE0}"/>
               </a:ext>
             </a:extLst>
           </p:cNvPr>
@@ -6453,7 +6453,7 @@
           <p:cNvPr id="120" name="">
             <a:extLst xmlns:a="http://schemas.openxmlformats.org/drawingml/2006/main">
               <a:ext uri="{FF2B5EF4-FFF2-40B4-BE49-F238E27FC236}">
-                <a16:creationId xmlns:a16="http://schemas.microsoft.com/office/drawing/2014/main" id="{1651E290-8C6D-4D49-9483-A0D01CF73FDC}"/>
+                <a16:creationId xmlns:a16="http://schemas.microsoft.com/office/drawing/2014/main" id="{A4F22F63-3B68-497E-BF4F-6AB36BEB521C}"/>
               </a:ext>
             </a:extLst>
           </p:cNvPr>
@@ -6516,7 +6516,7 @@
           <p:cNvPr id="121" name="">
             <a:extLst xmlns:a="http://schemas.openxmlformats.org/drawingml/2006/main">
               <a:ext uri="{FF2B5EF4-FFF2-40B4-BE49-F238E27FC236}">
-                <a16:creationId xmlns:a16="http://schemas.microsoft.com/office/drawing/2014/main" id="{E8547B03-77B0-4F6E-97A9-F8ED45D0F6BD}"/>
+                <a16:creationId xmlns:a16="http://schemas.microsoft.com/office/drawing/2014/main" id="{7E21BE7F-58FF-41F5-8B6E-B7B89EEE4685}"/>
               </a:ext>
             </a:extLst>
           </p:cNvPr>
@@ -6548,7 +6548,7 @@
           <p:cNvPr id="122" name="">
             <a:extLst xmlns:a="http://schemas.openxmlformats.org/drawingml/2006/main">
               <a:ext uri="{FF2B5EF4-FFF2-40B4-BE49-F238E27FC236}">
-                <a16:creationId xmlns:a16="http://schemas.microsoft.com/office/drawing/2014/main" id="{8577556A-9981-4042-9171-4DD3BB6AF467}"/>
+                <a16:creationId xmlns:a16="http://schemas.microsoft.com/office/drawing/2014/main" id="{E0CD0E48-C8F0-4B4F-BE8D-E3AEF0D8892A}"/>
               </a:ext>
             </a:extLst>
           </p:cNvPr>
@@ -6580,7 +6580,7 @@
           <p:cNvPr id="123" name="">
             <a:extLst xmlns:a="http://schemas.openxmlformats.org/drawingml/2006/main">
               <a:ext uri="{FF2B5EF4-FFF2-40B4-BE49-F238E27FC236}">
-                <a16:creationId xmlns:a16="http://schemas.microsoft.com/office/drawing/2014/main" id="{A0199B2F-0955-45B1-9843-E177F1BBA110}"/>
+                <a16:creationId xmlns:a16="http://schemas.microsoft.com/office/drawing/2014/main" id="{E0BC1AFC-A827-4136-BB5A-9E02923E0A0A}"/>
               </a:ext>
             </a:extLst>
           </p:cNvPr>
@@ -6643,19 +6643,19 @@
           <p:cNvPr id="124" name="">
             <a:extLst xmlns:a="http://schemas.openxmlformats.org/drawingml/2006/main">
               <a:ext uri="{FF2B5EF4-FFF2-40B4-BE49-F238E27FC236}">
-                <a16:creationId xmlns:a16="http://schemas.microsoft.com/office/drawing/2014/main" id="{C5675E6E-AFB4-4B31-94D3-43E83BBE0F0F}"/>
-              </a:ext>
-            </a:extLst>
-          </p:cNvPr>
-          <p:cNvSpPr>
-            <a:spLocks xmlns:a="http://schemas.openxmlformats.org/drawingml/2006/main" noGrp="1"/>
-          </p:cNvSpPr>
-          <p:nvPr/>
-        </p:nvSpPr>
-        <p:spPr>
-          <a:xfrm xmlns:a="http://schemas.openxmlformats.org/drawingml/2006/main">
-            <a:off x="7000875" y="5105400"/>
-            <a:ext cx="4095750" cy="685800"/>
+                <a16:creationId xmlns:a16="http://schemas.microsoft.com/office/drawing/2014/main" id="{EB724EB0-E899-4DB6-9D91-658CF9E6421F}"/>
+              </a:ext>
+            </a:extLst>
+          </p:cNvPr>
+          <p:cNvSpPr>
+            <a:spLocks xmlns:a="http://schemas.openxmlformats.org/drawingml/2006/main" noGrp="1"/>
+          </p:cNvSpPr>
+          <p:nvPr/>
+        </p:nvSpPr>
+        <p:spPr>
+          <a:xfrm xmlns:a="http://schemas.openxmlformats.org/drawingml/2006/main">
+            <a:off x="7000875" y="5010150"/>
+            <a:ext cx="4095750" cy="590550"/>
           </a:xfrm>
           <a:prstGeom xmlns:a="http://schemas.openxmlformats.org/drawingml/2006/main" prst="rect">
             <a:avLst/>
@@ -6675,19 +6675,19 @@
           <p:cNvPr id="125" name="">
             <a:extLst xmlns:a="http://schemas.openxmlformats.org/drawingml/2006/main">
               <a:ext uri="{FF2B5EF4-FFF2-40B4-BE49-F238E27FC236}">
-                <a16:creationId xmlns:a16="http://schemas.microsoft.com/office/drawing/2014/main" id="{08BFF380-21D8-4154-BC83-8D376D5903CB}"/>
-              </a:ext>
-            </a:extLst>
-          </p:cNvPr>
-          <p:cNvSpPr>
-            <a:spLocks xmlns:a="http://schemas.openxmlformats.org/drawingml/2006/main" noGrp="1"/>
-          </p:cNvSpPr>
-          <p:nvPr/>
-        </p:nvSpPr>
-        <p:spPr>
-          <a:xfrm xmlns:a="http://schemas.openxmlformats.org/drawingml/2006/main">
-            <a:off x="7000875" y="5105400"/>
-            <a:ext cx="47625" cy="685800"/>
+                <a16:creationId xmlns:a16="http://schemas.microsoft.com/office/drawing/2014/main" id="{F15C74D9-ACD1-49A3-9892-3A1F1773A7A9}"/>
+              </a:ext>
+            </a:extLst>
+          </p:cNvPr>
+          <p:cNvSpPr>
+            <a:spLocks xmlns:a="http://schemas.openxmlformats.org/drawingml/2006/main" noGrp="1"/>
+          </p:cNvSpPr>
+          <p:nvPr/>
+        </p:nvSpPr>
+        <p:spPr>
+          <a:xfrm xmlns:a="http://schemas.openxmlformats.org/drawingml/2006/main">
+            <a:off x="7000875" y="5010150"/>
+            <a:ext cx="47625" cy="590550"/>
           </a:xfrm>
           <a:prstGeom xmlns:a="http://schemas.openxmlformats.org/drawingml/2006/main" prst="rect">
             <a:avLst/>
@@ -6707,19 +6707,19 @@
           <p:cNvPr id="126" name="">
             <a:extLst xmlns:a="http://schemas.openxmlformats.org/drawingml/2006/main">
               <a:ext uri="{FF2B5EF4-FFF2-40B4-BE49-F238E27FC236}">
-                <a16:creationId xmlns:a16="http://schemas.microsoft.com/office/drawing/2014/main" id="{0A6F4B34-1D1B-4C97-95C0-3F7DB10670E9}"/>
-              </a:ext>
-            </a:extLst>
-          </p:cNvPr>
-          <p:cNvSpPr>
-            <a:spLocks xmlns:a="http://schemas.openxmlformats.org/drawingml/2006/main" noGrp="1"/>
-          </p:cNvSpPr>
-          <p:nvPr/>
-        </p:nvSpPr>
-        <p:spPr>
-          <a:xfrm xmlns:a="http://schemas.openxmlformats.org/drawingml/2006/main">
-            <a:off x="7267575" y="5314950"/>
-            <a:ext cx="3333750" cy="266700"/>
+                <a16:creationId xmlns:a16="http://schemas.microsoft.com/office/drawing/2014/main" id="{01538746-28F5-4CCB-845E-BC840216C582}"/>
+              </a:ext>
+            </a:extLst>
+          </p:cNvPr>
+          <p:cNvSpPr>
+            <a:spLocks xmlns:a="http://schemas.openxmlformats.org/drawingml/2006/main" noGrp="1"/>
+          </p:cNvSpPr>
+          <p:nvPr/>
+        </p:nvSpPr>
+        <p:spPr>
+          <a:xfrm xmlns:a="http://schemas.openxmlformats.org/drawingml/2006/main">
+            <a:off x="7267575" y="5191125"/>
+            <a:ext cx="3333750" cy="247650"/>
           </a:xfrm>
           <a:prstGeom xmlns:a="http://schemas.openxmlformats.org/drawingml/2006/main" prst="rect">
             <a:avLst/>
@@ -6742,7 +6742,7 @@
           <a:lstStyle xmlns:a="http://schemas.openxmlformats.org/drawingml/2006/main"/>
           <a:p xmlns:a="http://schemas.openxmlformats.org/drawingml/2006/main">
             <a:pPr algn="l">
-              <a:defRPr sz="1425" b="1">
+              <a:defRPr sz="1350" b="1">
                 <a:solidFill>
                   <a:srgbClr val="10202A"/>
                 </a:solidFill>
@@ -6752,7 +6752,7 @@
               </a:defRPr>
             </a:pPr>
             <a:r>
-              <a:rPr sz="1425" b="1">
+              <a:rPr sz="1350" b="1">
                 <a:solidFill>
                   <a:srgbClr val="10202A"/>
                 </a:solidFill>
@@ -6770,18 +6770,18 @@
           <p:cNvPr id="127" name="">
             <a:extLst xmlns:a="http://schemas.openxmlformats.org/drawingml/2006/main">
               <a:ext uri="{FF2B5EF4-FFF2-40B4-BE49-F238E27FC236}">
-                <a16:creationId xmlns:a16="http://schemas.microsoft.com/office/drawing/2014/main" id="{65EAE2A0-9577-445C-933F-BB5CC7657660}"/>
-              </a:ext>
-            </a:extLst>
-          </p:cNvPr>
-          <p:cNvSpPr>
-            <a:spLocks xmlns:a="http://schemas.openxmlformats.org/drawingml/2006/main" noGrp="1"/>
-          </p:cNvSpPr>
-          <p:nvPr/>
-        </p:nvSpPr>
-        <p:spPr>
-          <a:xfrm xmlns:a="http://schemas.openxmlformats.org/drawingml/2006/main">
-            <a:off x="876300" y="5657850"/>
+                <a16:creationId xmlns:a16="http://schemas.microsoft.com/office/drawing/2014/main" id="{EC808D9F-BD07-47E9-AC46-A8A11CEE2A32}"/>
+              </a:ext>
+            </a:extLst>
+          </p:cNvPr>
+          <p:cNvSpPr>
+            <a:spLocks xmlns:a="http://schemas.openxmlformats.org/drawingml/2006/main" noGrp="1"/>
+          </p:cNvSpPr>
+          <p:nvPr/>
+        </p:nvSpPr>
+        <p:spPr>
+          <a:xfrm xmlns:a="http://schemas.openxmlformats.org/drawingml/2006/main">
+            <a:off x="876300" y="5848350"/>
             <a:ext cx="1600200" cy="266700"/>
           </a:xfrm>
           <a:prstGeom xmlns:a="http://schemas.openxmlformats.org/drawingml/2006/main" prst="rect">
@@ -6802,18 +6802,18 @@
           <p:cNvPr id="128" name="">
             <a:extLst xmlns:a="http://schemas.openxmlformats.org/drawingml/2006/main">
               <a:ext uri="{FF2B5EF4-FFF2-40B4-BE49-F238E27FC236}">
-                <a16:creationId xmlns:a16="http://schemas.microsoft.com/office/drawing/2014/main" id="{79F9139E-384A-49B4-BEB3-8D6522E94BA2}"/>
-              </a:ext>
-            </a:extLst>
-          </p:cNvPr>
-          <p:cNvSpPr>
-            <a:spLocks xmlns:a="http://schemas.openxmlformats.org/drawingml/2006/main" noGrp="1"/>
-          </p:cNvSpPr>
-          <p:nvPr/>
-        </p:nvSpPr>
-        <p:spPr>
-          <a:xfrm xmlns:a="http://schemas.openxmlformats.org/drawingml/2006/main">
-            <a:off x="971550" y="5715000"/>
+                <a16:creationId xmlns:a16="http://schemas.microsoft.com/office/drawing/2014/main" id="{E828E894-7E9A-4B1D-BCD5-633B8C47406F}"/>
+              </a:ext>
+            </a:extLst>
+          </p:cNvPr>
+          <p:cNvSpPr>
+            <a:spLocks xmlns:a="http://schemas.openxmlformats.org/drawingml/2006/main" noGrp="1"/>
+          </p:cNvSpPr>
+          <p:nvPr/>
+        </p:nvSpPr>
+        <p:spPr>
+          <a:xfrm xmlns:a="http://schemas.openxmlformats.org/drawingml/2006/main">
+            <a:off x="971550" y="5905500"/>
             <a:ext cx="1409700" cy="171450"/>
           </a:xfrm>
           <a:prstGeom xmlns:a="http://schemas.openxmlformats.org/drawingml/2006/main" prst="rect">
@@ -6865,18 +6865,18 @@
           <p:cNvPr id="129" name="">
             <a:extLst xmlns:a="http://schemas.openxmlformats.org/drawingml/2006/main">
               <a:ext uri="{FF2B5EF4-FFF2-40B4-BE49-F238E27FC236}">
-                <a16:creationId xmlns:a16="http://schemas.microsoft.com/office/drawing/2014/main" id="{101C5966-53E1-4016-A59D-5D20AB3E0399}"/>
-              </a:ext>
-            </a:extLst>
-          </p:cNvPr>
-          <p:cNvSpPr>
-            <a:spLocks xmlns:a="http://schemas.openxmlformats.org/drawingml/2006/main" noGrp="1"/>
-          </p:cNvSpPr>
-          <p:nvPr/>
-        </p:nvSpPr>
-        <p:spPr>
-          <a:xfrm xmlns:a="http://schemas.openxmlformats.org/drawingml/2006/main">
-            <a:off x="8858250" y="5657850"/>
+                <a16:creationId xmlns:a16="http://schemas.microsoft.com/office/drawing/2014/main" id="{0D765698-8B21-47F4-901E-E5D797BE23FC}"/>
+              </a:ext>
+            </a:extLst>
+          </p:cNvPr>
+          <p:cNvSpPr>
+            <a:spLocks xmlns:a="http://schemas.openxmlformats.org/drawingml/2006/main" noGrp="1"/>
+          </p:cNvSpPr>
+          <p:nvPr/>
+        </p:nvSpPr>
+        <p:spPr>
+          <a:xfrm xmlns:a="http://schemas.openxmlformats.org/drawingml/2006/main">
+            <a:off x="8858250" y="5848350"/>
             <a:ext cx="2000250" cy="266700"/>
           </a:xfrm>
           <a:prstGeom xmlns:a="http://schemas.openxmlformats.org/drawingml/2006/main" prst="rect">
@@ -6897,18 +6897,18 @@
           <p:cNvPr id="130" name="">
             <a:extLst xmlns:a="http://schemas.openxmlformats.org/drawingml/2006/main">
               <a:ext uri="{FF2B5EF4-FFF2-40B4-BE49-F238E27FC236}">
-                <a16:creationId xmlns:a16="http://schemas.microsoft.com/office/drawing/2014/main" id="{B5434954-9787-4DE0-8382-9F5716E7609E}"/>
-              </a:ext>
-            </a:extLst>
-          </p:cNvPr>
-          <p:cNvSpPr>
-            <a:spLocks xmlns:a="http://schemas.openxmlformats.org/drawingml/2006/main" noGrp="1"/>
-          </p:cNvSpPr>
-          <p:nvPr/>
-        </p:nvSpPr>
-        <p:spPr>
-          <a:xfrm xmlns:a="http://schemas.openxmlformats.org/drawingml/2006/main">
-            <a:off x="8953500" y="5715000"/>
+                <a16:creationId xmlns:a16="http://schemas.microsoft.com/office/drawing/2014/main" id="{6BEE59BD-0397-4384-9CAA-D3B0DCB091B9}"/>
+              </a:ext>
+            </a:extLst>
+          </p:cNvPr>
+          <p:cNvSpPr>
+            <a:spLocks xmlns:a="http://schemas.openxmlformats.org/drawingml/2006/main" noGrp="1"/>
+          </p:cNvSpPr>
+          <p:nvPr/>
+        </p:nvSpPr>
+        <p:spPr>
+          <a:xfrm xmlns:a="http://schemas.openxmlformats.org/drawingml/2006/main">
+            <a:off x="8953500" y="5905500"/>
             <a:ext cx="1809750" cy="171450"/>
           </a:xfrm>
           <a:prstGeom xmlns:a="http://schemas.openxmlformats.org/drawingml/2006/main" prst="rect">
@@ -6960,7 +6960,7 @@
           <p:cNvPr id="131" name="">
             <a:extLst xmlns:a="http://schemas.openxmlformats.org/drawingml/2006/main">
               <a:ext uri="{FF2B5EF4-FFF2-40B4-BE49-F238E27FC236}">
-                <a16:creationId xmlns:a16="http://schemas.microsoft.com/office/drawing/2014/main" id="{AA883A8D-1053-406B-964D-5448F13A365A}"/>
+                <a16:creationId xmlns:a16="http://schemas.microsoft.com/office/drawing/2014/main" id="{01F29113-84C6-4571-BDB6-2E0C3541B442}"/>
               </a:ext>
             </a:extLst>
           </p:cNvPr>
@@ -6992,7 +6992,7 @@
           <p:cNvPr id="132" name="">
             <a:extLst xmlns:a="http://schemas.openxmlformats.org/drawingml/2006/main">
               <a:ext uri="{FF2B5EF4-FFF2-40B4-BE49-F238E27FC236}">
-                <a16:creationId xmlns:a16="http://schemas.microsoft.com/office/drawing/2014/main" id="{4F19C877-4790-4309-BFD9-FD0CB8B66BD8}"/>
+                <a16:creationId xmlns:a16="http://schemas.microsoft.com/office/drawing/2014/main" id="{1056A67C-05B2-40FE-94B5-DF0A5C752A1F}"/>
               </a:ext>
             </a:extLst>
           </p:cNvPr>
@@ -7055,7 +7055,7 @@
           <p:cNvPr id="133" name="">
             <a:extLst xmlns:a="http://schemas.openxmlformats.org/drawingml/2006/main">
               <a:ext uri="{FF2B5EF4-FFF2-40B4-BE49-F238E27FC236}">
-                <a16:creationId xmlns:a16="http://schemas.microsoft.com/office/drawing/2014/main" id="{55E9DFA7-9148-4DEF-9EA5-1F6B407EE01D}"/>
+                <a16:creationId xmlns:a16="http://schemas.microsoft.com/office/drawing/2014/main" id="{381657C3-E278-422F-A2E9-ED42134ABD1B}"/>
               </a:ext>
             </a:extLst>
           </p:cNvPr>
@@ -7116,7 +7116,7 @@
     </p:spTree>
     <p:extLst>
       <p:ext uri="{BB962C8B-B14F-4D97-AF65-F5344CB8AC3E}">
-        <p14:creationId xmlns:p14="http://schemas.microsoft.com/office/powerpoint/2010/main" val="1085448211"/>
+        <p14:creationId xmlns:p14="http://schemas.microsoft.com/office/powerpoint/2010/main" val="40265662"/>
       </p:ext>
     </p:extLst>
   </p:cSld>
@@ -7147,7 +7147,7 @@
           <p:cNvPr id="1" name="">
             <a:extLst xmlns:a="http://schemas.openxmlformats.org/drawingml/2006/main">
               <a:ext uri="{FF2B5EF4-FFF2-40B4-BE49-F238E27FC236}">
-                <a16:creationId xmlns:a16="http://schemas.microsoft.com/office/drawing/2014/main" id="{0351C407-4BE0-4394-9823-EC52EC93F13A}"/>
+                <a16:creationId xmlns:a16="http://schemas.microsoft.com/office/drawing/2014/main" id="{C82D00C0-825C-432D-B7C8-42338A6AD800}"/>
               </a:ext>
             </a:extLst>
           </p:cNvPr>
@@ -7210,7 +7210,7 @@
           <p:cNvPr id="2" name="">
             <a:extLst xmlns:a="http://schemas.openxmlformats.org/drawingml/2006/main">
               <a:ext uri="{FF2B5EF4-FFF2-40B4-BE49-F238E27FC236}">
-                <a16:creationId xmlns:a16="http://schemas.microsoft.com/office/drawing/2014/main" id="{22AC6580-6054-49C5-80FD-EC1EBCE57F3D}"/>
+                <a16:creationId xmlns:a16="http://schemas.microsoft.com/office/drawing/2014/main" id="{2406EF05-D790-4AA1-94A2-A7A5C8D17CAC}"/>
               </a:ext>
             </a:extLst>
           </p:cNvPr>
@@ -7277,7 +7277,7 @@
           <p:cNvPr id="3" name="">
             <a:extLst xmlns:a="http://schemas.openxmlformats.org/drawingml/2006/main">
               <a:ext uri="{FF2B5EF4-FFF2-40B4-BE49-F238E27FC236}">
-                <a16:creationId xmlns:a16="http://schemas.microsoft.com/office/drawing/2014/main" id="{BE928C05-F287-48DA-A117-4AD9AED5D977}"/>
+                <a16:creationId xmlns:a16="http://schemas.microsoft.com/office/drawing/2014/main" id="{B38B1ACB-C4A8-44C9-9BCD-9086BB214459}"/>
               </a:ext>
             </a:extLst>
           </p:cNvPr>
@@ -7344,7 +7344,7 @@
           <p:cNvPr id="4" name="">
             <a:extLst xmlns:a="http://schemas.openxmlformats.org/drawingml/2006/main">
               <a:ext uri="{FF2B5EF4-FFF2-40B4-BE49-F238E27FC236}">
-                <a16:creationId xmlns:a16="http://schemas.microsoft.com/office/drawing/2014/main" id="{F71D10B7-4E51-4D7B-895D-5D1E4DB9CB02}"/>
+                <a16:creationId xmlns:a16="http://schemas.microsoft.com/office/drawing/2014/main" id="{B204AEC4-250E-46EB-A20E-1FA9694A4A8D}"/>
               </a:ext>
             </a:extLst>
           </p:cNvPr>
@@ -7407,7 +7407,7 @@
           <p:cNvPr id="5" name="">
             <a:extLst xmlns:a="http://schemas.openxmlformats.org/drawingml/2006/main">
               <a:ext uri="{FF2B5EF4-FFF2-40B4-BE49-F238E27FC236}">
-                <a16:creationId xmlns:a16="http://schemas.microsoft.com/office/drawing/2014/main" id="{91981E1B-E2F9-486E-9EA8-C94AADA17CDB}"/>
+                <a16:creationId xmlns:a16="http://schemas.microsoft.com/office/drawing/2014/main" id="{184DE7AB-EA3B-41F3-A08B-27A564CA97DF}"/>
               </a:ext>
             </a:extLst>
           </p:cNvPr>
@@ -7474,7 +7474,7 @@
           <p:cNvPr id="6" name="">
             <a:extLst xmlns:a="http://schemas.openxmlformats.org/drawingml/2006/main">
               <a:ext uri="{FF2B5EF4-FFF2-40B4-BE49-F238E27FC236}">
-                <a16:creationId xmlns:a16="http://schemas.microsoft.com/office/drawing/2014/main" id="{99047BC3-F456-4928-A261-142A7A72C412}"/>
+                <a16:creationId xmlns:a16="http://schemas.microsoft.com/office/drawing/2014/main" id="{18FD7856-4D79-459D-A312-F947C15B0019}"/>
               </a:ext>
             </a:extLst>
           </p:cNvPr>
@@ -7537,7 +7537,7 @@
           <p:cNvPr id="7" name="">
             <a:extLst xmlns:a="http://schemas.openxmlformats.org/drawingml/2006/main">
               <a:ext uri="{FF2B5EF4-FFF2-40B4-BE49-F238E27FC236}">
-                <a16:creationId xmlns:a16="http://schemas.microsoft.com/office/drawing/2014/main" id="{537706F1-AFD5-44FF-9464-02A66F41C22B}"/>
+                <a16:creationId xmlns:a16="http://schemas.microsoft.com/office/drawing/2014/main" id="{5739EB67-5C9D-4E35-B467-326ED1911E7B}"/>
               </a:ext>
             </a:extLst>
           </p:cNvPr>
@@ -7604,7 +7604,7 @@
           <p:cNvPr id="8" name="">
             <a:extLst xmlns:a="http://schemas.openxmlformats.org/drawingml/2006/main">
               <a:ext uri="{FF2B5EF4-FFF2-40B4-BE49-F238E27FC236}">
-                <a16:creationId xmlns:a16="http://schemas.microsoft.com/office/drawing/2014/main" id="{42C62731-2C5F-42D0-9BD6-F392DE314013}"/>
+                <a16:creationId xmlns:a16="http://schemas.microsoft.com/office/drawing/2014/main" id="{B45E81CC-B169-42E4-8C1B-11B23710F433}"/>
               </a:ext>
             </a:extLst>
           </p:cNvPr>
@@ -7667,7 +7667,7 @@
           <p:cNvPr id="9" name="">
             <a:extLst xmlns:a="http://schemas.openxmlformats.org/drawingml/2006/main">
               <a:ext uri="{FF2B5EF4-FFF2-40B4-BE49-F238E27FC236}">
-                <a16:creationId xmlns:a16="http://schemas.microsoft.com/office/drawing/2014/main" id="{82C2299B-C1C1-4E39-A6A2-1DCBBDE1B0DB}"/>
+                <a16:creationId xmlns:a16="http://schemas.microsoft.com/office/drawing/2014/main" id="{0B2F75F6-F82A-47EA-A803-73D5252456EE}"/>
               </a:ext>
             </a:extLst>
           </p:cNvPr>
@@ -7734,7 +7734,7 @@
           <p:cNvPr id="10" name="">
             <a:extLst xmlns:a="http://schemas.openxmlformats.org/drawingml/2006/main">
               <a:ext uri="{FF2B5EF4-FFF2-40B4-BE49-F238E27FC236}">
-                <a16:creationId xmlns:a16="http://schemas.microsoft.com/office/drawing/2014/main" id="{94B23B9D-CF5C-4742-ACCE-76FBB22C1502}"/>
+                <a16:creationId xmlns:a16="http://schemas.microsoft.com/office/drawing/2014/main" id="{225FBCC1-37A7-4171-9683-12CAA2CFACDD}"/>
               </a:ext>
             </a:extLst>
           </p:cNvPr>
@@ -7797,7 +7797,7 @@
           <p:cNvPr id="11" name="">
             <a:extLst xmlns:a="http://schemas.openxmlformats.org/drawingml/2006/main">
               <a:ext uri="{FF2B5EF4-FFF2-40B4-BE49-F238E27FC236}">
-                <a16:creationId xmlns:a16="http://schemas.microsoft.com/office/drawing/2014/main" id="{5D3FE6AD-902E-4EFD-8792-88F8D6FDB52D}"/>
+                <a16:creationId xmlns:a16="http://schemas.microsoft.com/office/drawing/2014/main" id="{6FD0B103-D253-47C0-870A-B5111345A538}"/>
               </a:ext>
             </a:extLst>
           </p:cNvPr>
@@ -7864,7 +7864,7 @@
           <p:cNvPr id="12" name="">
             <a:extLst xmlns:a="http://schemas.openxmlformats.org/drawingml/2006/main">
               <a:ext uri="{FF2B5EF4-FFF2-40B4-BE49-F238E27FC236}">
-                <a16:creationId xmlns:a16="http://schemas.microsoft.com/office/drawing/2014/main" id="{BB0102F0-9892-4EC4-A2F8-535706ED87FB}"/>
+                <a16:creationId xmlns:a16="http://schemas.microsoft.com/office/drawing/2014/main" id="{996FCA17-2CD2-4E73-BF08-68F70CEB02B1}"/>
               </a:ext>
             </a:extLst>
           </p:cNvPr>
@@ -7896,7 +7896,7 @@
           <p:cNvPr id="13" name="">
             <a:extLst xmlns:a="http://schemas.openxmlformats.org/drawingml/2006/main">
               <a:ext uri="{FF2B5EF4-FFF2-40B4-BE49-F238E27FC236}">
-                <a16:creationId xmlns:a16="http://schemas.microsoft.com/office/drawing/2014/main" id="{2C465B93-D6EC-4C1F-B5B4-7F7E5935E053}"/>
+                <a16:creationId xmlns:a16="http://schemas.microsoft.com/office/drawing/2014/main" id="{92922325-6C90-45D1-860B-32C7EAEF17BC}"/>
               </a:ext>
             </a:extLst>
           </p:cNvPr>
@@ -7959,7 +7959,7 @@
           <p:cNvPr id="14" name="">
             <a:extLst xmlns:a="http://schemas.openxmlformats.org/drawingml/2006/main">
               <a:ext uri="{FF2B5EF4-FFF2-40B4-BE49-F238E27FC236}">
-                <a16:creationId xmlns:a16="http://schemas.microsoft.com/office/drawing/2014/main" id="{2D486FEE-210E-45B9-BE89-D0F6FDFACBEF}"/>
+                <a16:creationId xmlns:a16="http://schemas.microsoft.com/office/drawing/2014/main" id="{95C614E2-9551-4FBD-B63C-03FAB8FE1790}"/>
               </a:ext>
             </a:extLst>
           </p:cNvPr>
@@ -8022,7 +8022,7 @@
           <p:cNvPr id="15" name="">
             <a:extLst xmlns:a="http://schemas.openxmlformats.org/drawingml/2006/main">
               <a:ext uri="{FF2B5EF4-FFF2-40B4-BE49-F238E27FC236}">
-                <a16:creationId xmlns:a16="http://schemas.microsoft.com/office/drawing/2014/main" id="{7BFF962B-99AE-4733-8DE5-B265CF2E6567}"/>
+                <a16:creationId xmlns:a16="http://schemas.microsoft.com/office/drawing/2014/main" id="{7FBB04BD-F459-4008-8393-CF4FB6B9EEED}"/>
               </a:ext>
             </a:extLst>
           </p:cNvPr>
@@ -8034,7 +8034,7 @@
         <p:spPr>
           <a:xfrm xmlns:a="http://schemas.openxmlformats.org/drawingml/2006/main">
             <a:off x="3295650" y="4410075"/>
-            <a:ext cx="1619250" cy="114300"/>
+            <a:ext cx="1257300" cy="114300"/>
           </a:xfrm>
           <a:prstGeom xmlns:a="http://schemas.openxmlformats.org/drawingml/2006/main" prst="rect">
             <a:avLst/>
@@ -8056,7 +8056,7 @@
           <p:cNvPr id="16" name="">
             <a:extLst xmlns:a="http://schemas.openxmlformats.org/drawingml/2006/main">
               <a:ext uri="{FF2B5EF4-FFF2-40B4-BE49-F238E27FC236}">
-                <a16:creationId xmlns:a16="http://schemas.microsoft.com/office/drawing/2014/main" id="{404F2BB3-D1AA-4BF5-8AA8-8D03725DC6B0}"/>
+                <a16:creationId xmlns:a16="http://schemas.microsoft.com/office/drawing/2014/main" id="{034D56D1-8041-4737-8B4E-E0474526C1B6}"/>
               </a:ext>
             </a:extLst>
           </p:cNvPr>
@@ -8068,7 +8068,7 @@
         <p:spPr>
           <a:xfrm xmlns:a="http://schemas.openxmlformats.org/drawingml/2006/main">
             <a:off x="3295650" y="4410075"/>
-            <a:ext cx="1619250" cy="114300"/>
+            <a:ext cx="1257300" cy="114300"/>
           </a:xfrm>
           <a:prstGeom xmlns:a="http://schemas.openxmlformats.org/drawingml/2006/main" prst="rect">
             <a:avLst/>
@@ -8088,19 +8088,19 @@
           <p:cNvPr id="17" name="">
             <a:extLst xmlns:a="http://schemas.openxmlformats.org/drawingml/2006/main">
               <a:ext uri="{FF2B5EF4-FFF2-40B4-BE49-F238E27FC236}">
-                <a16:creationId xmlns:a16="http://schemas.microsoft.com/office/drawing/2014/main" id="{AB21488A-69E9-45E2-A6A3-2CB99D5D2C4B}"/>
-              </a:ext>
-            </a:extLst>
-          </p:cNvPr>
-          <p:cNvSpPr>
-            <a:spLocks xmlns:a="http://schemas.openxmlformats.org/drawingml/2006/main" noGrp="1"/>
-          </p:cNvSpPr>
-          <p:nvPr/>
-        </p:nvSpPr>
-        <p:spPr>
-          <a:xfrm xmlns:a="http://schemas.openxmlformats.org/drawingml/2006/main">
-            <a:off x="5010150" y="4381500"/>
-            <a:ext cx="857250" cy="190500"/>
+                <a16:creationId xmlns:a16="http://schemas.microsoft.com/office/drawing/2014/main" id="{DD32C6E1-E63C-4C19-92AC-62B690B56A88}"/>
+              </a:ext>
+            </a:extLst>
+          </p:cNvPr>
+          <p:cNvSpPr>
+            <a:spLocks xmlns:a="http://schemas.openxmlformats.org/drawingml/2006/main" noGrp="1"/>
+          </p:cNvSpPr>
+          <p:nvPr/>
+        </p:nvSpPr>
+        <p:spPr>
+          <a:xfrm xmlns:a="http://schemas.openxmlformats.org/drawingml/2006/main">
+            <a:off x="4648200" y="4381500"/>
+            <a:ext cx="590550" cy="190500"/>
           </a:xfrm>
           <a:prstGeom xmlns:a="http://schemas.openxmlformats.org/drawingml/2006/main" prst="rect">
             <a:avLst/>
@@ -8151,7 +8151,7 @@
           <p:cNvPr id="18" name="">
             <a:extLst xmlns:a="http://schemas.openxmlformats.org/drawingml/2006/main">
               <a:ext uri="{FF2B5EF4-FFF2-40B4-BE49-F238E27FC236}">
-                <a16:creationId xmlns:a16="http://schemas.microsoft.com/office/drawing/2014/main" id="{23B5667A-36BE-4552-B8C9-5C40F4310923}"/>
+                <a16:creationId xmlns:a16="http://schemas.microsoft.com/office/drawing/2014/main" id="{8523C5BB-695A-487B-883F-E29EAD06695F}"/>
               </a:ext>
             </a:extLst>
           </p:cNvPr>
@@ -8214,7 +8214,7 @@
           <p:cNvPr id="19" name="">
             <a:extLst xmlns:a="http://schemas.openxmlformats.org/drawingml/2006/main">
               <a:ext uri="{FF2B5EF4-FFF2-40B4-BE49-F238E27FC236}">
-                <a16:creationId xmlns:a16="http://schemas.microsoft.com/office/drawing/2014/main" id="{250A9F75-FE83-4F81-AE32-FAFD8C3F4363}"/>
+                <a16:creationId xmlns:a16="http://schemas.microsoft.com/office/drawing/2014/main" id="{588E974F-5584-4C88-B355-E67009718367}"/>
               </a:ext>
             </a:extLst>
           </p:cNvPr>
@@ -8226,7 +8226,7 @@
         <p:spPr>
           <a:xfrm xmlns:a="http://schemas.openxmlformats.org/drawingml/2006/main">
             <a:off x="3295650" y="4733925"/>
-            <a:ext cx="1619250" cy="114300"/>
+            <a:ext cx="1257300" cy="114300"/>
           </a:xfrm>
           <a:prstGeom xmlns:a="http://schemas.openxmlformats.org/drawingml/2006/main" prst="rect">
             <a:avLst/>
@@ -8248,7 +8248,7 @@
           <p:cNvPr id="20" name="">
             <a:extLst xmlns:a="http://schemas.openxmlformats.org/drawingml/2006/main">
               <a:ext uri="{FF2B5EF4-FFF2-40B4-BE49-F238E27FC236}">
-                <a16:creationId xmlns:a16="http://schemas.microsoft.com/office/drawing/2014/main" id="{EBB6AA30-B88C-42C5-AD5F-CB8949A6D3A2}"/>
+                <a16:creationId xmlns:a16="http://schemas.microsoft.com/office/drawing/2014/main" id="{5C2DC0CA-790C-42BC-A42F-8EE63B4480E6}"/>
               </a:ext>
             </a:extLst>
           </p:cNvPr>
@@ -8260,7 +8260,7 @@
         <p:spPr>
           <a:xfrm xmlns:a="http://schemas.openxmlformats.org/drawingml/2006/main">
             <a:off x="3295650" y="4733925"/>
-            <a:ext cx="82690" cy="114300"/>
+            <a:ext cx="64207" cy="114300"/>
           </a:xfrm>
           <a:prstGeom xmlns:a="http://schemas.openxmlformats.org/drawingml/2006/main" prst="rect">
             <a:avLst/>
@@ -8280,19 +8280,19 @@
           <p:cNvPr id="21" name="">
             <a:extLst xmlns:a="http://schemas.openxmlformats.org/drawingml/2006/main">
               <a:ext uri="{FF2B5EF4-FFF2-40B4-BE49-F238E27FC236}">
-                <a16:creationId xmlns:a16="http://schemas.microsoft.com/office/drawing/2014/main" id="{BCCDE459-6A54-43CD-99DC-2C7796A85164}"/>
-              </a:ext>
-            </a:extLst>
-          </p:cNvPr>
-          <p:cNvSpPr>
-            <a:spLocks xmlns:a="http://schemas.openxmlformats.org/drawingml/2006/main" noGrp="1"/>
-          </p:cNvSpPr>
-          <p:nvPr/>
-        </p:nvSpPr>
-        <p:spPr>
-          <a:xfrm xmlns:a="http://schemas.openxmlformats.org/drawingml/2006/main">
-            <a:off x="5010150" y="4705350"/>
-            <a:ext cx="857250" cy="190500"/>
+                <a16:creationId xmlns:a16="http://schemas.microsoft.com/office/drawing/2014/main" id="{AC2D7A34-8557-4494-9538-76492E3F5EFD}"/>
+              </a:ext>
+            </a:extLst>
+          </p:cNvPr>
+          <p:cNvSpPr>
+            <a:spLocks xmlns:a="http://schemas.openxmlformats.org/drawingml/2006/main" noGrp="1"/>
+          </p:cNvSpPr>
+          <p:nvPr/>
+        </p:nvSpPr>
+        <p:spPr>
+          <a:xfrm xmlns:a="http://schemas.openxmlformats.org/drawingml/2006/main">
+            <a:off x="4648200" y="4705350"/>
+            <a:ext cx="590550" cy="190500"/>
           </a:xfrm>
           <a:prstGeom xmlns:a="http://schemas.openxmlformats.org/drawingml/2006/main" prst="rect">
             <a:avLst/>
@@ -8343,7 +8343,7 @@
           <p:cNvPr id="22" name="">
             <a:extLst xmlns:a="http://schemas.openxmlformats.org/drawingml/2006/main">
               <a:ext uri="{FF2B5EF4-FFF2-40B4-BE49-F238E27FC236}">
-                <a16:creationId xmlns:a16="http://schemas.microsoft.com/office/drawing/2014/main" id="{DFFB7276-A5FC-4CDB-A3F5-D5FECE86C45F}"/>
+                <a16:creationId xmlns:a16="http://schemas.microsoft.com/office/drawing/2014/main" id="{DB607879-BA2C-4292-B539-241EEFDA7D58}"/>
               </a:ext>
             </a:extLst>
           </p:cNvPr>
@@ -8406,7 +8406,7 @@
           <p:cNvPr id="23" name="">
             <a:extLst xmlns:a="http://schemas.openxmlformats.org/drawingml/2006/main">
               <a:ext uri="{FF2B5EF4-FFF2-40B4-BE49-F238E27FC236}">
-                <a16:creationId xmlns:a16="http://schemas.microsoft.com/office/drawing/2014/main" id="{DC70889B-582A-4005-ADD7-46E83BC31F22}"/>
+                <a16:creationId xmlns:a16="http://schemas.microsoft.com/office/drawing/2014/main" id="{1C211367-19E8-4FBB-A3FC-C3EF60F97D4C}"/>
               </a:ext>
             </a:extLst>
           </p:cNvPr>
@@ -8418,7 +8418,7 @@
         <p:spPr>
           <a:xfrm xmlns:a="http://schemas.openxmlformats.org/drawingml/2006/main">
             <a:off x="3295650" y="5057775"/>
-            <a:ext cx="1619250" cy="114300"/>
+            <a:ext cx="1257300" cy="114300"/>
           </a:xfrm>
           <a:prstGeom xmlns:a="http://schemas.openxmlformats.org/drawingml/2006/main" prst="rect">
             <a:avLst/>
@@ -8440,7 +8440,7 @@
           <p:cNvPr id="24" name="">
             <a:extLst xmlns:a="http://schemas.openxmlformats.org/drawingml/2006/main">
               <a:ext uri="{FF2B5EF4-FFF2-40B4-BE49-F238E27FC236}">
-                <a16:creationId xmlns:a16="http://schemas.microsoft.com/office/drawing/2014/main" id="{8D558114-8177-4E67-BD9B-1DB3114D3934}"/>
+                <a16:creationId xmlns:a16="http://schemas.microsoft.com/office/drawing/2014/main" id="{453B7AFC-5F0D-4677-BBAB-00775D1F4ED2}"/>
               </a:ext>
             </a:extLst>
           </p:cNvPr>
@@ -8452,7 +8452,7 @@
         <p:spPr>
           <a:xfrm xmlns:a="http://schemas.openxmlformats.org/drawingml/2006/main">
             <a:off x="3295650" y="5057775"/>
-            <a:ext cx="80539" cy="114300"/>
+            <a:ext cx="62536" cy="114300"/>
           </a:xfrm>
           <a:prstGeom xmlns:a="http://schemas.openxmlformats.org/drawingml/2006/main" prst="rect">
             <a:avLst/>
@@ -8472,19 +8472,19 @@
           <p:cNvPr id="25" name="">
             <a:extLst xmlns:a="http://schemas.openxmlformats.org/drawingml/2006/main">
               <a:ext uri="{FF2B5EF4-FFF2-40B4-BE49-F238E27FC236}">
-                <a16:creationId xmlns:a16="http://schemas.microsoft.com/office/drawing/2014/main" id="{FB9CC5AA-E2C5-4B0B-86AA-72D179392E66}"/>
-              </a:ext>
-            </a:extLst>
-          </p:cNvPr>
-          <p:cNvSpPr>
-            <a:spLocks xmlns:a="http://schemas.openxmlformats.org/drawingml/2006/main" noGrp="1"/>
-          </p:cNvSpPr>
-          <p:nvPr/>
-        </p:nvSpPr>
-        <p:spPr>
-          <a:xfrm xmlns:a="http://schemas.openxmlformats.org/drawingml/2006/main">
-            <a:off x="5010150" y="5029200"/>
-            <a:ext cx="857250" cy="190500"/>
+                <a16:creationId xmlns:a16="http://schemas.microsoft.com/office/drawing/2014/main" id="{2ADAFEBB-220E-4821-9FDE-7B19CB78BF57}"/>
+              </a:ext>
+            </a:extLst>
+          </p:cNvPr>
+          <p:cNvSpPr>
+            <a:spLocks xmlns:a="http://schemas.openxmlformats.org/drawingml/2006/main" noGrp="1"/>
+          </p:cNvSpPr>
+          <p:nvPr/>
+        </p:nvSpPr>
+        <p:spPr>
+          <a:xfrm xmlns:a="http://schemas.openxmlformats.org/drawingml/2006/main">
+            <a:off x="4648200" y="5029200"/>
+            <a:ext cx="590550" cy="190500"/>
           </a:xfrm>
           <a:prstGeom xmlns:a="http://schemas.openxmlformats.org/drawingml/2006/main" prst="rect">
             <a:avLst/>
@@ -8535,19 +8535,19 @@
           <p:cNvPr id="26" name="">
             <a:extLst xmlns:a="http://schemas.openxmlformats.org/drawingml/2006/main">
               <a:ext uri="{FF2B5EF4-FFF2-40B4-BE49-F238E27FC236}">
-                <a16:creationId xmlns:a16="http://schemas.microsoft.com/office/drawing/2014/main" id="{0D6B4621-E9A9-44C2-B4A1-4FA002A5468F}"/>
-              </a:ext>
-            </a:extLst>
-          </p:cNvPr>
-          <p:cNvSpPr>
-            <a:spLocks xmlns:a="http://schemas.openxmlformats.org/drawingml/2006/main" noGrp="1"/>
-          </p:cNvSpPr>
-          <p:nvPr/>
-        </p:nvSpPr>
-        <p:spPr>
-          <a:xfrm xmlns:a="http://schemas.openxmlformats.org/drawingml/2006/main">
-            <a:off x="3295650" y="4324350"/>
-            <a:ext cx="1752600" cy="857250"/>
+                <a16:creationId xmlns:a16="http://schemas.microsoft.com/office/drawing/2014/main" id="{84FB7AF5-A308-41CC-B363-19D862815C15}"/>
+              </a:ext>
+            </a:extLst>
+          </p:cNvPr>
+          <p:cNvSpPr>
+            <a:spLocks xmlns:a="http://schemas.openxmlformats.org/drawingml/2006/main" noGrp="1"/>
+          </p:cNvSpPr>
+          <p:nvPr/>
+        </p:nvSpPr>
+        <p:spPr>
+          <a:xfrm xmlns:a="http://schemas.openxmlformats.org/drawingml/2006/main">
+            <a:off x="914400" y="5353050"/>
+            <a:ext cx="3857625" cy="209550"/>
           </a:xfrm>
           <a:prstGeom xmlns:a="http://schemas.openxmlformats.org/drawingml/2006/main" prst="rect">
             <a:avLst/>
@@ -8571,10 +8571,10 @@
           <a:p xmlns:a="http://schemas.openxmlformats.org/drawingml/2006/main">
             <a:pPr algn="l">
               <a:lnSpc>
-                <a:spcPct val="112000"/>
+                <a:spcPct val="106000"/>
               </a:lnSpc>
               <a:buNone/>
-              <a:defRPr sz="1200" b="0">
+              <a:defRPr sz="1050" b="0">
                 <a:solidFill>
                   <a:srgbClr val="65737B"/>
                 </a:solidFill>
@@ -8584,7 +8584,7 @@
               </a:defRPr>
             </a:pPr>
             <a:r>
-              <a:rPr sz="1200" b="0">
+              <a:rPr sz="1050" b="0">
                 <a:solidFill>
                   <a:srgbClr val="65737B"/>
                 </a:solidFill>
@@ -8592,7 +8592,7 @@
                 <a:ea typeface="Aptos"/>
                 <a:cs typeface="Aptos"/>
               </a:rPr>
-              <a:t>Base dominates the listed surface today. The next layer has to separate ecosystem activity from catalog spam.</a:t>
+              <a:t>Base dominates the listed surface; the product has to separate ecosystem activity from catalog inflation.</a:t>
             </a:r>
           </a:p>
         </p:txBody>
@@ -8602,7 +8602,7 @@
           <p:cNvPr id="27" name="">
             <a:extLst xmlns:a="http://schemas.openxmlformats.org/drawingml/2006/main">
               <a:ext uri="{FF2B5EF4-FFF2-40B4-BE49-F238E27FC236}">
-                <a16:creationId xmlns:a16="http://schemas.microsoft.com/office/drawing/2014/main" id="{CAEDC7D3-2348-4168-B57F-D5EF9554831F}"/>
+                <a16:creationId xmlns:a16="http://schemas.microsoft.com/office/drawing/2014/main" id="{E6F5513A-2C80-4425-A51A-747EDF7CB242}"/>
               </a:ext>
             </a:extLst>
           </p:cNvPr>
@@ -8634,7 +8634,7 @@
           <p:cNvPr id="28" name="">
             <a:extLst xmlns:a="http://schemas.openxmlformats.org/drawingml/2006/main">
               <a:ext uri="{FF2B5EF4-FFF2-40B4-BE49-F238E27FC236}">
-                <a16:creationId xmlns:a16="http://schemas.microsoft.com/office/drawing/2014/main" id="{4405475A-8B4D-404F-9A82-02F4802E681A}"/>
+                <a16:creationId xmlns:a16="http://schemas.microsoft.com/office/drawing/2014/main" id="{331073B4-E621-4919-9F9A-91512A005722}"/>
               </a:ext>
             </a:extLst>
           </p:cNvPr>
@@ -8697,7 +8697,7 @@
           <p:cNvPr id="29" name="">
             <a:extLst xmlns:a="http://schemas.openxmlformats.org/drawingml/2006/main">
               <a:ext uri="{FF2B5EF4-FFF2-40B4-BE49-F238E27FC236}">
-                <a16:creationId xmlns:a16="http://schemas.microsoft.com/office/drawing/2014/main" id="{0F5AC131-7822-44B6-B8FC-F638F99F9B69}"/>
+                <a16:creationId xmlns:a16="http://schemas.microsoft.com/office/drawing/2014/main" id="{EEFB37B5-E593-4ECF-A0C5-09CA8DF8E5E7}"/>
               </a:ext>
             </a:extLst>
           </p:cNvPr>
@@ -8760,7 +8760,7 @@
           <p:cNvPr id="30" name="">
             <a:extLst xmlns:a="http://schemas.openxmlformats.org/drawingml/2006/main">
               <a:ext uri="{FF2B5EF4-FFF2-40B4-BE49-F238E27FC236}">
-                <a16:creationId xmlns:a16="http://schemas.microsoft.com/office/drawing/2014/main" id="{6FFDB82E-F615-426A-80BC-7A2D5BBC207A}"/>
+                <a16:creationId xmlns:a16="http://schemas.microsoft.com/office/drawing/2014/main" id="{562284EF-307D-4DE1-AA44-C809DB76F824}"/>
               </a:ext>
             </a:extLst>
           </p:cNvPr>
@@ -8772,7 +8772,7 @@
         <p:spPr>
           <a:xfrm xmlns:a="http://schemas.openxmlformats.org/drawingml/2006/main">
             <a:off x="8801100" y="4410075"/>
-            <a:ext cx="1619250" cy="114300"/>
+            <a:ext cx="1257300" cy="114300"/>
           </a:xfrm>
           <a:prstGeom xmlns:a="http://schemas.openxmlformats.org/drawingml/2006/main" prst="rect">
             <a:avLst/>
@@ -8794,7 +8794,7 @@
           <p:cNvPr id="31" name="">
             <a:extLst xmlns:a="http://schemas.openxmlformats.org/drawingml/2006/main">
               <a:ext uri="{FF2B5EF4-FFF2-40B4-BE49-F238E27FC236}">
-                <a16:creationId xmlns:a16="http://schemas.microsoft.com/office/drawing/2014/main" id="{66810B93-94C9-4C6D-A152-2D89CF49841B}"/>
+                <a16:creationId xmlns:a16="http://schemas.microsoft.com/office/drawing/2014/main" id="{E7DEF380-52AD-4BFB-B2A7-B451E3425F83}"/>
               </a:ext>
             </a:extLst>
           </p:cNvPr>
@@ -8806,7 +8806,7 @@
         <p:spPr>
           <a:xfrm xmlns:a="http://schemas.openxmlformats.org/drawingml/2006/main">
             <a:off x="8801100" y="4410075"/>
-            <a:ext cx="1619250" cy="114300"/>
+            <a:ext cx="1257300" cy="114300"/>
           </a:xfrm>
           <a:prstGeom xmlns:a="http://schemas.openxmlformats.org/drawingml/2006/main" prst="rect">
             <a:avLst/>
@@ -8826,19 +8826,19 @@
           <p:cNvPr id="32" name="">
             <a:extLst xmlns:a="http://schemas.openxmlformats.org/drawingml/2006/main">
               <a:ext uri="{FF2B5EF4-FFF2-40B4-BE49-F238E27FC236}">
-                <a16:creationId xmlns:a16="http://schemas.microsoft.com/office/drawing/2014/main" id="{EB1C0867-BB0F-47C1-8E9C-1EBA2D5EE2C1}"/>
-              </a:ext>
-            </a:extLst>
-          </p:cNvPr>
-          <p:cNvSpPr>
-            <a:spLocks xmlns:a="http://schemas.openxmlformats.org/drawingml/2006/main" noGrp="1"/>
-          </p:cNvSpPr>
-          <p:nvPr/>
-        </p:nvSpPr>
-        <p:spPr>
-          <a:xfrm xmlns:a="http://schemas.openxmlformats.org/drawingml/2006/main">
-            <a:off x="10515600" y="4381500"/>
-            <a:ext cx="857250" cy="190500"/>
+                <a16:creationId xmlns:a16="http://schemas.microsoft.com/office/drawing/2014/main" id="{5979FF5A-979C-454E-8409-FB3C6BD5B586}"/>
+              </a:ext>
+            </a:extLst>
+          </p:cNvPr>
+          <p:cNvSpPr>
+            <a:spLocks xmlns:a="http://schemas.openxmlformats.org/drawingml/2006/main" noGrp="1"/>
+          </p:cNvSpPr>
+          <p:nvPr/>
+        </p:nvSpPr>
+        <p:spPr>
+          <a:xfrm xmlns:a="http://schemas.openxmlformats.org/drawingml/2006/main">
+            <a:off x="10153650" y="4381500"/>
+            <a:ext cx="590550" cy="190500"/>
           </a:xfrm>
           <a:prstGeom xmlns:a="http://schemas.openxmlformats.org/drawingml/2006/main" prst="rect">
             <a:avLst/>
@@ -8889,7 +8889,7 @@
           <p:cNvPr id="33" name="">
             <a:extLst xmlns:a="http://schemas.openxmlformats.org/drawingml/2006/main">
               <a:ext uri="{FF2B5EF4-FFF2-40B4-BE49-F238E27FC236}">
-                <a16:creationId xmlns:a16="http://schemas.microsoft.com/office/drawing/2014/main" id="{F59220D2-28D7-4A3D-8845-DB1076C60AD9}"/>
+                <a16:creationId xmlns:a16="http://schemas.microsoft.com/office/drawing/2014/main" id="{B1937A8D-755B-4F55-A6C7-7FBE1D59A3AE}"/>
               </a:ext>
             </a:extLst>
           </p:cNvPr>
@@ -8952,7 +8952,7 @@
           <p:cNvPr id="34" name="">
             <a:extLst xmlns:a="http://schemas.openxmlformats.org/drawingml/2006/main">
               <a:ext uri="{FF2B5EF4-FFF2-40B4-BE49-F238E27FC236}">
-                <a16:creationId xmlns:a16="http://schemas.microsoft.com/office/drawing/2014/main" id="{256772F9-ECC7-4E5A-9C56-446EAC45CDA7}"/>
+                <a16:creationId xmlns:a16="http://schemas.microsoft.com/office/drawing/2014/main" id="{7B682BB0-6BD5-4AD8-ACD0-A7E0C4CD0427}"/>
               </a:ext>
             </a:extLst>
           </p:cNvPr>
@@ -8964,7 +8964,7 @@
         <p:spPr>
           <a:xfrm xmlns:a="http://schemas.openxmlformats.org/drawingml/2006/main">
             <a:off x="8801100" y="4733925"/>
-            <a:ext cx="1619250" cy="114300"/>
+            <a:ext cx="1257300" cy="114300"/>
           </a:xfrm>
           <a:prstGeom xmlns:a="http://schemas.openxmlformats.org/drawingml/2006/main" prst="rect">
             <a:avLst/>
@@ -8986,7 +8986,7 @@
           <p:cNvPr id="35" name="">
             <a:extLst xmlns:a="http://schemas.openxmlformats.org/drawingml/2006/main">
               <a:ext uri="{FF2B5EF4-FFF2-40B4-BE49-F238E27FC236}">
-                <a16:creationId xmlns:a16="http://schemas.microsoft.com/office/drawing/2014/main" id="{B99D0446-F71F-47CA-8E85-BD3F99DB003B}"/>
+                <a16:creationId xmlns:a16="http://schemas.microsoft.com/office/drawing/2014/main" id="{F4CC8A52-B799-4EB8-9877-5297C7868BF9}"/>
               </a:ext>
             </a:extLst>
           </p:cNvPr>
@@ -8998,7 +8998,7 @@
         <p:spPr>
           <a:xfrm xmlns:a="http://schemas.openxmlformats.org/drawingml/2006/main">
             <a:off x="8801100" y="4733925"/>
-            <a:ext cx="466802" cy="114300"/>
+            <a:ext cx="362458" cy="114300"/>
           </a:xfrm>
           <a:prstGeom xmlns:a="http://schemas.openxmlformats.org/drawingml/2006/main" prst="rect">
             <a:avLst/>
@@ -9018,19 +9018,19 @@
           <p:cNvPr id="36" name="">
             <a:extLst xmlns:a="http://schemas.openxmlformats.org/drawingml/2006/main">
               <a:ext uri="{FF2B5EF4-FFF2-40B4-BE49-F238E27FC236}">
-                <a16:creationId xmlns:a16="http://schemas.microsoft.com/office/drawing/2014/main" id="{643168AA-173F-4504-A5BB-DA86B4F1FF54}"/>
-              </a:ext>
-            </a:extLst>
-          </p:cNvPr>
-          <p:cNvSpPr>
-            <a:spLocks xmlns:a="http://schemas.openxmlformats.org/drawingml/2006/main" noGrp="1"/>
-          </p:cNvSpPr>
-          <p:nvPr/>
-        </p:nvSpPr>
-        <p:spPr>
-          <a:xfrm xmlns:a="http://schemas.openxmlformats.org/drawingml/2006/main">
-            <a:off x="10515600" y="4705350"/>
-            <a:ext cx="857250" cy="190500"/>
+                <a16:creationId xmlns:a16="http://schemas.microsoft.com/office/drawing/2014/main" id="{E8EE33B2-44F1-44E8-8B22-E53CF3CE4268}"/>
+              </a:ext>
+            </a:extLst>
+          </p:cNvPr>
+          <p:cNvSpPr>
+            <a:spLocks xmlns:a="http://schemas.openxmlformats.org/drawingml/2006/main" noGrp="1"/>
+          </p:cNvSpPr>
+          <p:nvPr/>
+        </p:nvSpPr>
+        <p:spPr>
+          <a:xfrm xmlns:a="http://schemas.openxmlformats.org/drawingml/2006/main">
+            <a:off x="10153650" y="4705350"/>
+            <a:ext cx="590550" cy="190500"/>
           </a:xfrm>
           <a:prstGeom xmlns:a="http://schemas.openxmlformats.org/drawingml/2006/main" prst="rect">
             <a:avLst/>
@@ -9081,7 +9081,7 @@
           <p:cNvPr id="37" name="">
             <a:extLst xmlns:a="http://schemas.openxmlformats.org/drawingml/2006/main">
               <a:ext uri="{FF2B5EF4-FFF2-40B4-BE49-F238E27FC236}">
-                <a16:creationId xmlns:a16="http://schemas.microsoft.com/office/drawing/2014/main" id="{6264B0F2-AE4D-422C-9673-8184F8D4F214}"/>
+                <a16:creationId xmlns:a16="http://schemas.microsoft.com/office/drawing/2014/main" id="{8010D889-EBEA-498E-9942-CC6D6ED9E76F}"/>
               </a:ext>
             </a:extLst>
           </p:cNvPr>
@@ -9144,7 +9144,7 @@
           <p:cNvPr id="38" name="">
             <a:extLst xmlns:a="http://schemas.openxmlformats.org/drawingml/2006/main">
               <a:ext uri="{FF2B5EF4-FFF2-40B4-BE49-F238E27FC236}">
-                <a16:creationId xmlns:a16="http://schemas.microsoft.com/office/drawing/2014/main" id="{CEE0058C-0163-46DC-A815-EC512CBF4666}"/>
+                <a16:creationId xmlns:a16="http://schemas.microsoft.com/office/drawing/2014/main" id="{6E6D94D1-8E06-4EE8-85B3-1960DAE4D502}"/>
               </a:ext>
             </a:extLst>
           </p:cNvPr>
@@ -9156,7 +9156,7 @@
         <p:spPr>
           <a:xfrm xmlns:a="http://schemas.openxmlformats.org/drawingml/2006/main">
             <a:off x="8801100" y="5057775"/>
-            <a:ext cx="1619250" cy="114300"/>
+            <a:ext cx="1257300" cy="114300"/>
           </a:xfrm>
           <a:prstGeom xmlns:a="http://schemas.openxmlformats.org/drawingml/2006/main" prst="rect">
             <a:avLst/>
@@ -9178,7 +9178,7 @@
           <p:cNvPr id="39" name="">
             <a:extLst xmlns:a="http://schemas.openxmlformats.org/drawingml/2006/main">
               <a:ext uri="{FF2B5EF4-FFF2-40B4-BE49-F238E27FC236}">
-                <a16:creationId xmlns:a16="http://schemas.microsoft.com/office/drawing/2014/main" id="{701A7984-1D1F-4043-B9D0-EDC81A0F8DF6}"/>
+                <a16:creationId xmlns:a16="http://schemas.microsoft.com/office/drawing/2014/main" id="{64752577-A6BA-4E04-854C-8C04BA9283E7}"/>
               </a:ext>
             </a:extLst>
           </p:cNvPr>
@@ -9190,7 +9190,7 @@
         <p:spPr>
           <a:xfrm xmlns:a="http://schemas.openxmlformats.org/drawingml/2006/main">
             <a:off x="8801100" y="5057775"/>
-            <a:ext cx="383680" cy="114300"/>
+            <a:ext cx="297916" cy="114300"/>
           </a:xfrm>
           <a:prstGeom xmlns:a="http://schemas.openxmlformats.org/drawingml/2006/main" prst="rect">
             <a:avLst/>
@@ -9210,19 +9210,19 @@
           <p:cNvPr id="40" name="">
             <a:extLst xmlns:a="http://schemas.openxmlformats.org/drawingml/2006/main">
               <a:ext uri="{FF2B5EF4-FFF2-40B4-BE49-F238E27FC236}">
-                <a16:creationId xmlns:a16="http://schemas.microsoft.com/office/drawing/2014/main" id="{C751EC17-1A7A-4AA7-B771-E5980729D46B}"/>
-              </a:ext>
-            </a:extLst>
-          </p:cNvPr>
-          <p:cNvSpPr>
-            <a:spLocks xmlns:a="http://schemas.openxmlformats.org/drawingml/2006/main" noGrp="1"/>
-          </p:cNvSpPr>
-          <p:nvPr/>
-        </p:nvSpPr>
-        <p:spPr>
-          <a:xfrm xmlns:a="http://schemas.openxmlformats.org/drawingml/2006/main">
-            <a:off x="10515600" y="5029200"/>
-            <a:ext cx="857250" cy="190500"/>
+                <a16:creationId xmlns:a16="http://schemas.microsoft.com/office/drawing/2014/main" id="{1EDBA5A6-9E85-406E-BF92-9F6606A98052}"/>
+              </a:ext>
+            </a:extLst>
+          </p:cNvPr>
+          <p:cNvSpPr>
+            <a:spLocks xmlns:a="http://schemas.openxmlformats.org/drawingml/2006/main" noGrp="1"/>
+          </p:cNvSpPr>
+          <p:nvPr/>
+        </p:nvSpPr>
+        <p:spPr>
+          <a:xfrm xmlns:a="http://schemas.openxmlformats.org/drawingml/2006/main">
+            <a:off x="10153650" y="5029200"/>
+            <a:ext cx="590550" cy="190500"/>
           </a:xfrm>
           <a:prstGeom xmlns:a="http://schemas.openxmlformats.org/drawingml/2006/main" prst="rect">
             <a:avLst/>
@@ -9273,19 +9273,19 @@
           <p:cNvPr id="41" name="">
             <a:extLst xmlns:a="http://schemas.openxmlformats.org/drawingml/2006/main">
               <a:ext uri="{FF2B5EF4-FFF2-40B4-BE49-F238E27FC236}">
-                <a16:creationId xmlns:a16="http://schemas.microsoft.com/office/drawing/2014/main" id="{A30D7B14-0B01-49A0-8BDC-DCB593C2938F}"/>
-              </a:ext>
-            </a:extLst>
-          </p:cNvPr>
-          <p:cNvSpPr>
-            <a:spLocks xmlns:a="http://schemas.openxmlformats.org/drawingml/2006/main" noGrp="1"/>
-          </p:cNvSpPr>
-          <p:nvPr/>
-        </p:nvSpPr>
-        <p:spPr>
-          <a:xfrm xmlns:a="http://schemas.openxmlformats.org/drawingml/2006/main">
-            <a:off x="8801100" y="4324350"/>
-            <a:ext cx="1752600" cy="857250"/>
+                <a16:creationId xmlns:a16="http://schemas.microsoft.com/office/drawing/2014/main" id="{F098F4E7-672F-408A-8B53-42B582BAD412}"/>
+              </a:ext>
+            </a:extLst>
+          </p:cNvPr>
+          <p:cNvSpPr>
+            <a:spLocks xmlns:a="http://schemas.openxmlformats.org/drawingml/2006/main" noGrp="1"/>
+          </p:cNvSpPr>
+          <p:nvPr/>
+        </p:nvSpPr>
+        <p:spPr>
+          <a:xfrm xmlns:a="http://schemas.openxmlformats.org/drawingml/2006/main">
+            <a:off x="6419850" y="5353050"/>
+            <a:ext cx="3857625" cy="209550"/>
           </a:xfrm>
           <a:prstGeom xmlns:a="http://schemas.openxmlformats.org/drawingml/2006/main" prst="rect">
             <a:avLst/>
@@ -9309,10 +9309,10 @@
           <a:p xmlns:a="http://schemas.openxmlformats.org/drawingml/2006/main">
             <a:pPr algn="l">
               <a:lnSpc>
-                <a:spcPct val="112000"/>
+                <a:spcPct val="106000"/>
               </a:lnSpc>
               <a:buNone/>
-              <a:defRPr sz="1200" b="0">
+              <a:defRPr sz="1050" b="0">
                 <a:solidFill>
                   <a:srgbClr val="65737B"/>
                 </a:solidFill>
@@ -9322,7 +9322,7 @@
               </a:defRPr>
             </a:pPr>
             <a:r>
-              <a:rPr sz="1200" b="0">
+              <a:rPr sz="1050" b="0">
                 <a:solidFill>
                   <a:srgbClr val="65737B"/>
                 </a:solidFill>
@@ -9330,7 +9330,7 @@
                 <a:ea typeface="Aptos"/>
                 <a:cs typeface="Aptos"/>
               </a:rPr>
-              <a:t>The useful primitive is the cheap probe: spend pennies, collect a receipt, stop early when evidence is weak.</a:t>
+              <a:t>The useful primitive is the cheap probe: spend pennies, collect a receipt, stop early.</a:t>
             </a:r>
           </a:p>
         </p:txBody>
@@ -9340,7 +9340,7 @@
           <p:cNvPr id="42" name="">
             <a:extLst xmlns:a="http://schemas.openxmlformats.org/drawingml/2006/main">
               <a:ext uri="{FF2B5EF4-FFF2-40B4-BE49-F238E27FC236}">
-                <a16:creationId xmlns:a16="http://schemas.microsoft.com/office/drawing/2014/main" id="{090547FE-0E3A-45E8-8E28-793D6F5542ED}"/>
+                <a16:creationId xmlns:a16="http://schemas.microsoft.com/office/drawing/2014/main" id="{73D0CB0B-F914-4617-A0A8-75443C470F15}"/>
               </a:ext>
             </a:extLst>
           </p:cNvPr>
@@ -9403,7 +9403,7 @@
           <p:cNvPr id="43" name="">
             <a:extLst xmlns:a="http://schemas.openxmlformats.org/drawingml/2006/main">
               <a:ext uri="{FF2B5EF4-FFF2-40B4-BE49-F238E27FC236}">
-                <a16:creationId xmlns:a16="http://schemas.microsoft.com/office/drawing/2014/main" id="{8FFA27BD-0DE3-4471-B605-397AE6E7D6FA}"/>
+                <a16:creationId xmlns:a16="http://schemas.microsoft.com/office/drawing/2014/main" id="{95856B0C-2A84-4796-AE17-DCED6680B1F2}"/>
               </a:ext>
             </a:extLst>
           </p:cNvPr>
@@ -9435,7 +9435,7 @@
           <p:cNvPr id="44" name="">
             <a:extLst xmlns:a="http://schemas.openxmlformats.org/drawingml/2006/main">
               <a:ext uri="{FF2B5EF4-FFF2-40B4-BE49-F238E27FC236}">
-                <a16:creationId xmlns:a16="http://schemas.microsoft.com/office/drawing/2014/main" id="{03840D1C-3ECE-4A34-A5F1-3B0F7F3BDE19}"/>
+                <a16:creationId xmlns:a16="http://schemas.microsoft.com/office/drawing/2014/main" id="{C31104C8-D917-47CA-86CA-D3F415F3465C}"/>
               </a:ext>
             </a:extLst>
           </p:cNvPr>
@@ -9498,7 +9498,7 @@
           <p:cNvPr id="45" name="">
             <a:extLst xmlns:a="http://schemas.openxmlformats.org/drawingml/2006/main">
               <a:ext uri="{FF2B5EF4-FFF2-40B4-BE49-F238E27FC236}">
-                <a16:creationId xmlns:a16="http://schemas.microsoft.com/office/drawing/2014/main" id="{E6632423-6E66-4C3B-9D92-2B9165E8BE4D}"/>
+                <a16:creationId xmlns:a16="http://schemas.microsoft.com/office/drawing/2014/main" id="{96A8A5F9-6CF8-470A-A3C6-11E2B3768E1F}"/>
               </a:ext>
             </a:extLst>
           </p:cNvPr>
@@ -9559,7 +9559,7 @@
     </p:spTree>
     <p:extLst>
       <p:ext uri="{BB962C8B-B14F-4D97-AF65-F5344CB8AC3E}">
-        <p14:creationId xmlns:p14="http://schemas.microsoft.com/office/powerpoint/2010/main" val="880354582"/>
+        <p14:creationId xmlns:p14="http://schemas.microsoft.com/office/powerpoint/2010/main" val="1082522161"/>
       </p:ext>
     </p:extLst>
   </p:cSld>
@@ -9590,7 +9590,7 @@
           <p:cNvPr id="1" name="">
             <a:extLst xmlns:a="http://schemas.openxmlformats.org/drawingml/2006/main">
               <a:ext uri="{FF2B5EF4-FFF2-40B4-BE49-F238E27FC236}">
-                <a16:creationId xmlns:a16="http://schemas.microsoft.com/office/drawing/2014/main" id="{CE1FD07F-3A0F-41A7-BF7D-A50AE48BDE03}"/>
+                <a16:creationId xmlns:a16="http://schemas.microsoft.com/office/drawing/2014/main" id="{7BA53B5F-31C0-4C50-A77C-F83921C940F2}"/>
               </a:ext>
             </a:extLst>
           </p:cNvPr>
@@ -9653,7 +9653,7 @@
           <p:cNvPr id="2" name="">
             <a:extLst xmlns:a="http://schemas.openxmlformats.org/drawingml/2006/main">
               <a:ext uri="{FF2B5EF4-FFF2-40B4-BE49-F238E27FC236}">
-                <a16:creationId xmlns:a16="http://schemas.microsoft.com/office/drawing/2014/main" id="{D72BD120-418B-4D35-84C1-CDEFB807AFC8}"/>
+                <a16:creationId xmlns:a16="http://schemas.microsoft.com/office/drawing/2014/main" id="{C5E5F73A-6900-4D33-BFBE-6035FBB93354}"/>
               </a:ext>
             </a:extLst>
           </p:cNvPr>
@@ -9720,7 +9720,7 @@
           <p:cNvPr id="3" name="">
             <a:extLst xmlns:a="http://schemas.openxmlformats.org/drawingml/2006/main">
               <a:ext uri="{FF2B5EF4-FFF2-40B4-BE49-F238E27FC236}">
-                <a16:creationId xmlns:a16="http://schemas.microsoft.com/office/drawing/2014/main" id="{5F5068FF-0B75-483A-8B7F-11D849198F77}"/>
+                <a16:creationId xmlns:a16="http://schemas.microsoft.com/office/drawing/2014/main" id="{CA746005-0E72-413C-B781-BDAE2266CAC5}"/>
               </a:ext>
             </a:extLst>
           </p:cNvPr>
@@ -9787,7 +9787,7 @@
           <p:cNvPr id="4" name="">
             <a:extLst xmlns:a="http://schemas.openxmlformats.org/drawingml/2006/main">
               <a:ext uri="{FF2B5EF4-FFF2-40B4-BE49-F238E27FC236}">
-                <a16:creationId xmlns:a16="http://schemas.microsoft.com/office/drawing/2014/main" id="{CDBEFFD5-9408-49DC-9DA1-324FDF347F08}"/>
+                <a16:creationId xmlns:a16="http://schemas.microsoft.com/office/drawing/2014/main" id="{9ECA4A0A-9ED5-449F-B391-A308052FB442}"/>
               </a:ext>
             </a:extLst>
           </p:cNvPr>
@@ -9819,7 +9819,7 @@
           <p:cNvPr id="5" name="">
             <a:extLst xmlns:a="http://schemas.openxmlformats.org/drawingml/2006/main">
               <a:ext uri="{FF2B5EF4-FFF2-40B4-BE49-F238E27FC236}">
-                <a16:creationId xmlns:a16="http://schemas.microsoft.com/office/drawing/2014/main" id="{AA9479BD-FF6D-4EC7-AD59-87C338925F7A}"/>
+                <a16:creationId xmlns:a16="http://schemas.microsoft.com/office/drawing/2014/main" id="{A4EAE0BC-0FF6-4605-A830-3FA8FE485E01}"/>
               </a:ext>
             </a:extLst>
           </p:cNvPr>
@@ -9882,7 +9882,7 @@
           <p:cNvPr id="6" name="">
             <a:extLst xmlns:a="http://schemas.openxmlformats.org/drawingml/2006/main">
               <a:ext uri="{FF2B5EF4-FFF2-40B4-BE49-F238E27FC236}">
-                <a16:creationId xmlns:a16="http://schemas.microsoft.com/office/drawing/2014/main" id="{6850F884-DEB7-42CD-A971-1A1405852192}"/>
+                <a16:creationId xmlns:a16="http://schemas.microsoft.com/office/drawing/2014/main" id="{0E44FC86-03C0-474D-8D8B-ABF7AD48070F}"/>
               </a:ext>
             </a:extLst>
           </p:cNvPr>
@@ -9945,7 +9945,7 @@
           <p:cNvPr id="7" name="">
             <a:extLst xmlns:a="http://schemas.openxmlformats.org/drawingml/2006/main">
               <a:ext uri="{FF2B5EF4-FFF2-40B4-BE49-F238E27FC236}">
-                <a16:creationId xmlns:a16="http://schemas.microsoft.com/office/drawing/2014/main" id="{1620A26F-CA8A-4B01-B561-CCFAF6F624D2}"/>
+                <a16:creationId xmlns:a16="http://schemas.microsoft.com/office/drawing/2014/main" id="{8FFB45DC-03F8-4E49-B8C2-C07AEA5EF400}"/>
               </a:ext>
             </a:extLst>
           </p:cNvPr>
@@ -9979,7 +9979,7 @@
           <p:cNvPr id="8" name="">
             <a:extLst xmlns:a="http://schemas.openxmlformats.org/drawingml/2006/main">
               <a:ext uri="{FF2B5EF4-FFF2-40B4-BE49-F238E27FC236}">
-                <a16:creationId xmlns:a16="http://schemas.microsoft.com/office/drawing/2014/main" id="{A8039E86-C1A1-43BE-960F-0B41593D7AA0}"/>
+                <a16:creationId xmlns:a16="http://schemas.microsoft.com/office/drawing/2014/main" id="{5A395832-40C0-40DC-BBC5-A3D66A6A06B6}"/>
               </a:ext>
             </a:extLst>
           </p:cNvPr>
@@ -10011,7 +10011,7 @@
           <p:cNvPr id="9" name="">
             <a:extLst xmlns:a="http://schemas.openxmlformats.org/drawingml/2006/main">
               <a:ext uri="{FF2B5EF4-FFF2-40B4-BE49-F238E27FC236}">
-                <a16:creationId xmlns:a16="http://schemas.microsoft.com/office/drawing/2014/main" id="{6839FA44-7681-4D5C-B58A-618081BF1D45}"/>
+                <a16:creationId xmlns:a16="http://schemas.microsoft.com/office/drawing/2014/main" id="{585F3173-CCF1-4586-A2F4-DF33FF6CB579}"/>
               </a:ext>
             </a:extLst>
           </p:cNvPr>
@@ -10074,7 +10074,7 @@
           <p:cNvPr id="10" name="">
             <a:extLst xmlns:a="http://schemas.openxmlformats.org/drawingml/2006/main">
               <a:ext uri="{FF2B5EF4-FFF2-40B4-BE49-F238E27FC236}">
-                <a16:creationId xmlns:a16="http://schemas.microsoft.com/office/drawing/2014/main" id="{5DF2BE6F-A55B-40FC-9598-0B9752213E7A}"/>
+                <a16:creationId xmlns:a16="http://schemas.microsoft.com/office/drawing/2014/main" id="{6BF5E804-33FE-4D60-8941-A377BFD00A4D}"/>
               </a:ext>
             </a:extLst>
           </p:cNvPr>
@@ -10137,7 +10137,7 @@
           <p:cNvPr id="11" name="">
             <a:extLst xmlns:a="http://schemas.openxmlformats.org/drawingml/2006/main">
               <a:ext uri="{FF2B5EF4-FFF2-40B4-BE49-F238E27FC236}">
-                <a16:creationId xmlns:a16="http://schemas.microsoft.com/office/drawing/2014/main" id="{FFF91997-7B44-4D1F-89FA-9E7FD39F2943}"/>
+                <a16:creationId xmlns:a16="http://schemas.microsoft.com/office/drawing/2014/main" id="{4463F9E4-B78E-4501-91B4-19A9B058F0D8}"/>
               </a:ext>
             </a:extLst>
           </p:cNvPr>
@@ -10171,7 +10171,7 @@
           <p:cNvPr id="12" name="">
             <a:extLst xmlns:a="http://schemas.openxmlformats.org/drawingml/2006/main">
               <a:ext uri="{FF2B5EF4-FFF2-40B4-BE49-F238E27FC236}">
-                <a16:creationId xmlns:a16="http://schemas.microsoft.com/office/drawing/2014/main" id="{57D3D6FF-67BF-41A2-8CC1-BCF8B2E29047}"/>
+                <a16:creationId xmlns:a16="http://schemas.microsoft.com/office/drawing/2014/main" id="{89D1F161-E8AD-444D-886C-D7069057AA9E}"/>
               </a:ext>
             </a:extLst>
           </p:cNvPr>
@@ -10203,7 +10203,7 @@
           <p:cNvPr id="13" name="">
             <a:extLst xmlns:a="http://schemas.openxmlformats.org/drawingml/2006/main">
               <a:ext uri="{FF2B5EF4-FFF2-40B4-BE49-F238E27FC236}">
-                <a16:creationId xmlns:a16="http://schemas.microsoft.com/office/drawing/2014/main" id="{49EEEA9B-D86E-4319-98EC-5AAD0EAF5FD3}"/>
+                <a16:creationId xmlns:a16="http://schemas.microsoft.com/office/drawing/2014/main" id="{5BFC2E19-2ADD-44C9-B5F6-9ED4C11F895F}"/>
               </a:ext>
             </a:extLst>
           </p:cNvPr>
@@ -10266,7 +10266,7 @@
           <p:cNvPr id="14" name="">
             <a:extLst xmlns:a="http://schemas.openxmlformats.org/drawingml/2006/main">
               <a:ext uri="{FF2B5EF4-FFF2-40B4-BE49-F238E27FC236}">
-                <a16:creationId xmlns:a16="http://schemas.microsoft.com/office/drawing/2014/main" id="{BA0D68A6-F91A-4690-8E59-98A8EB57B42C}"/>
+                <a16:creationId xmlns:a16="http://schemas.microsoft.com/office/drawing/2014/main" id="{89BAF945-CD6C-4A2F-A1B5-D087BDC5DFEC}"/>
               </a:ext>
             </a:extLst>
           </p:cNvPr>
@@ -10329,7 +10329,7 @@
           <p:cNvPr id="15" name="">
             <a:extLst xmlns:a="http://schemas.openxmlformats.org/drawingml/2006/main">
               <a:ext uri="{FF2B5EF4-FFF2-40B4-BE49-F238E27FC236}">
-                <a16:creationId xmlns:a16="http://schemas.microsoft.com/office/drawing/2014/main" id="{F3C131DB-FBAC-4AB6-9256-39811D3C69BF}"/>
+                <a16:creationId xmlns:a16="http://schemas.microsoft.com/office/drawing/2014/main" id="{2B3DBE6D-5412-4121-AB43-2A280A68EE90}"/>
               </a:ext>
             </a:extLst>
           </p:cNvPr>
@@ -10363,7 +10363,7 @@
           <p:cNvPr id="16" name="">
             <a:extLst xmlns:a="http://schemas.openxmlformats.org/drawingml/2006/main">
               <a:ext uri="{FF2B5EF4-FFF2-40B4-BE49-F238E27FC236}">
-                <a16:creationId xmlns:a16="http://schemas.microsoft.com/office/drawing/2014/main" id="{EB0BF33C-7251-4954-8BB8-B2AF32EE52C7}"/>
+                <a16:creationId xmlns:a16="http://schemas.microsoft.com/office/drawing/2014/main" id="{4DDCE97D-816A-4839-B35A-0BEE42832FC8}"/>
               </a:ext>
             </a:extLst>
           </p:cNvPr>
@@ -10395,7 +10395,7 @@
           <p:cNvPr id="17" name="">
             <a:extLst xmlns:a="http://schemas.openxmlformats.org/drawingml/2006/main">
               <a:ext uri="{FF2B5EF4-FFF2-40B4-BE49-F238E27FC236}">
-                <a16:creationId xmlns:a16="http://schemas.microsoft.com/office/drawing/2014/main" id="{12B0A7A0-24F5-413C-A9BA-8317778C9C6B}"/>
+                <a16:creationId xmlns:a16="http://schemas.microsoft.com/office/drawing/2014/main" id="{45BF0263-66F6-49BB-AF5C-A887B672B986}"/>
               </a:ext>
             </a:extLst>
           </p:cNvPr>
@@ -10458,7 +10458,7 @@
           <p:cNvPr id="18" name="">
             <a:extLst xmlns:a="http://schemas.openxmlformats.org/drawingml/2006/main">
               <a:ext uri="{FF2B5EF4-FFF2-40B4-BE49-F238E27FC236}">
-                <a16:creationId xmlns:a16="http://schemas.microsoft.com/office/drawing/2014/main" id="{94885721-C2C7-45FB-95F6-49B4336C3F2E}"/>
+                <a16:creationId xmlns:a16="http://schemas.microsoft.com/office/drawing/2014/main" id="{9F2D55E7-D54D-4CED-929C-8635906AFC26}"/>
               </a:ext>
             </a:extLst>
           </p:cNvPr>
@@ -10521,7 +10521,7 @@
           <p:cNvPr id="19" name="">
             <a:extLst xmlns:a="http://schemas.openxmlformats.org/drawingml/2006/main">
               <a:ext uri="{FF2B5EF4-FFF2-40B4-BE49-F238E27FC236}">
-                <a16:creationId xmlns:a16="http://schemas.microsoft.com/office/drawing/2014/main" id="{961DBB3F-9F4D-46CA-BD28-7596AFCCFB4D}"/>
+                <a16:creationId xmlns:a16="http://schemas.microsoft.com/office/drawing/2014/main" id="{D76880EA-CDE8-4714-A56A-935777C7B72E}"/>
               </a:ext>
             </a:extLst>
           </p:cNvPr>
@@ -10555,7 +10555,7 @@
           <p:cNvPr id="20" name="">
             <a:extLst xmlns:a="http://schemas.openxmlformats.org/drawingml/2006/main">
               <a:ext uri="{FF2B5EF4-FFF2-40B4-BE49-F238E27FC236}">
-                <a16:creationId xmlns:a16="http://schemas.microsoft.com/office/drawing/2014/main" id="{7F14522E-2E24-4D81-8945-7877E2E47D24}"/>
+                <a16:creationId xmlns:a16="http://schemas.microsoft.com/office/drawing/2014/main" id="{0E5270F1-533A-4DF5-81B0-ACC2F7461A4E}"/>
               </a:ext>
             </a:extLst>
           </p:cNvPr>
@@ -10587,7 +10587,7 @@
           <p:cNvPr id="21" name="">
             <a:extLst xmlns:a="http://schemas.openxmlformats.org/drawingml/2006/main">
               <a:ext uri="{FF2B5EF4-FFF2-40B4-BE49-F238E27FC236}">
-                <a16:creationId xmlns:a16="http://schemas.microsoft.com/office/drawing/2014/main" id="{1D301700-59D9-496A-935A-3C9E095C1B49}"/>
+                <a16:creationId xmlns:a16="http://schemas.microsoft.com/office/drawing/2014/main" id="{1BE565EB-E443-4812-945F-CBF933C69304}"/>
               </a:ext>
             </a:extLst>
           </p:cNvPr>
@@ -10650,7 +10650,7 @@
           <p:cNvPr id="22" name="">
             <a:extLst xmlns:a="http://schemas.openxmlformats.org/drawingml/2006/main">
               <a:ext uri="{FF2B5EF4-FFF2-40B4-BE49-F238E27FC236}">
-                <a16:creationId xmlns:a16="http://schemas.microsoft.com/office/drawing/2014/main" id="{6E446088-8C54-440E-8AA2-EA2858E0D525}"/>
+                <a16:creationId xmlns:a16="http://schemas.microsoft.com/office/drawing/2014/main" id="{8379827E-B5A5-4F23-8B14-B63C63BBC774}"/>
               </a:ext>
             </a:extLst>
           </p:cNvPr>
@@ -10713,7 +10713,7 @@
           <p:cNvPr id="23" name="">
             <a:extLst xmlns:a="http://schemas.openxmlformats.org/drawingml/2006/main">
               <a:ext uri="{FF2B5EF4-FFF2-40B4-BE49-F238E27FC236}">
-                <a16:creationId xmlns:a16="http://schemas.microsoft.com/office/drawing/2014/main" id="{4163AAB0-7C72-4B87-A9B2-D93B0364B437}"/>
+                <a16:creationId xmlns:a16="http://schemas.microsoft.com/office/drawing/2014/main" id="{8A326871-974F-4483-BE3A-871EC5D521C2}"/>
               </a:ext>
             </a:extLst>
           </p:cNvPr>
@@ -10747,7 +10747,7 @@
           <p:cNvPr id="24" name="">
             <a:extLst xmlns:a="http://schemas.openxmlformats.org/drawingml/2006/main">
               <a:ext uri="{FF2B5EF4-FFF2-40B4-BE49-F238E27FC236}">
-                <a16:creationId xmlns:a16="http://schemas.microsoft.com/office/drawing/2014/main" id="{08C82596-0855-41FA-BDFE-E209ED908D6D}"/>
+                <a16:creationId xmlns:a16="http://schemas.microsoft.com/office/drawing/2014/main" id="{C2EB4001-9BB3-4B93-85FF-C77B3F7D75EF}"/>
               </a:ext>
             </a:extLst>
           </p:cNvPr>
@@ -10779,7 +10779,7 @@
           <p:cNvPr id="25" name="">
             <a:extLst xmlns:a="http://schemas.openxmlformats.org/drawingml/2006/main">
               <a:ext uri="{FF2B5EF4-FFF2-40B4-BE49-F238E27FC236}">
-                <a16:creationId xmlns:a16="http://schemas.microsoft.com/office/drawing/2014/main" id="{D0BE9864-8160-4B39-8EAD-E404EEE1D1D6}"/>
+                <a16:creationId xmlns:a16="http://schemas.microsoft.com/office/drawing/2014/main" id="{4551FA2F-6E0C-4573-B2F8-B9AF350BBCF2}"/>
               </a:ext>
             </a:extLst>
           </p:cNvPr>
@@ -10842,7 +10842,7 @@
           <p:cNvPr id="26" name="">
             <a:extLst xmlns:a="http://schemas.openxmlformats.org/drawingml/2006/main">
               <a:ext uri="{FF2B5EF4-FFF2-40B4-BE49-F238E27FC236}">
-                <a16:creationId xmlns:a16="http://schemas.microsoft.com/office/drawing/2014/main" id="{8DF8CB06-3B0F-4CB1-9026-993372EF9A52}"/>
+                <a16:creationId xmlns:a16="http://schemas.microsoft.com/office/drawing/2014/main" id="{E7D4C33F-0FFE-4CD0-9B29-C18197C425F9}"/>
               </a:ext>
             </a:extLst>
           </p:cNvPr>
@@ -10909,7 +10909,7 @@
           <p:cNvPr id="27" name="">
             <a:extLst xmlns:a="http://schemas.openxmlformats.org/drawingml/2006/main">
               <a:ext uri="{FF2B5EF4-FFF2-40B4-BE49-F238E27FC236}">
-                <a16:creationId xmlns:a16="http://schemas.microsoft.com/office/drawing/2014/main" id="{D3BA2FFF-15B0-4589-B988-2A25F38954F1}"/>
+                <a16:creationId xmlns:a16="http://schemas.microsoft.com/office/drawing/2014/main" id="{586095BC-403E-4447-AFA0-18B5ECEC2AD6}"/>
               </a:ext>
             </a:extLst>
           </p:cNvPr>
@@ -10941,7 +10941,7 @@
           <p:cNvPr id="28" name="">
             <a:extLst xmlns:a="http://schemas.openxmlformats.org/drawingml/2006/main">
               <a:ext uri="{FF2B5EF4-FFF2-40B4-BE49-F238E27FC236}">
-                <a16:creationId xmlns:a16="http://schemas.microsoft.com/office/drawing/2014/main" id="{8DE75F08-2936-424E-A09C-93E03AF5F3EF}"/>
+                <a16:creationId xmlns:a16="http://schemas.microsoft.com/office/drawing/2014/main" id="{88A1F11C-7FF1-4729-8373-BD68304038B6}"/>
               </a:ext>
             </a:extLst>
           </p:cNvPr>
@@ -10973,7 +10973,7 @@
           <p:cNvPr id="29" name="">
             <a:extLst xmlns:a="http://schemas.openxmlformats.org/drawingml/2006/main">
               <a:ext uri="{FF2B5EF4-FFF2-40B4-BE49-F238E27FC236}">
-                <a16:creationId xmlns:a16="http://schemas.microsoft.com/office/drawing/2014/main" id="{6BDF9726-9598-4EFD-B97C-F83C9504D69C}"/>
+                <a16:creationId xmlns:a16="http://schemas.microsoft.com/office/drawing/2014/main" id="{3554561B-8839-469B-A703-F870E7A212C7}"/>
               </a:ext>
             </a:extLst>
           </p:cNvPr>
@@ -11036,7 +11036,7 @@
           <p:cNvPr id="30" name="">
             <a:extLst xmlns:a="http://schemas.openxmlformats.org/drawingml/2006/main">
               <a:ext uri="{FF2B5EF4-FFF2-40B4-BE49-F238E27FC236}">
-                <a16:creationId xmlns:a16="http://schemas.microsoft.com/office/drawing/2014/main" id="{AD0FF5EF-4BDD-44FC-9195-43B0663AB65D}"/>
+                <a16:creationId xmlns:a16="http://schemas.microsoft.com/office/drawing/2014/main" id="{344410D7-DE51-4E4C-A55F-3E7473AD9DBA}"/>
               </a:ext>
             </a:extLst>
           </p:cNvPr>
@@ -11103,7 +11103,7 @@
           <p:cNvPr id="31" name="">
             <a:extLst xmlns:a="http://schemas.openxmlformats.org/drawingml/2006/main">
               <a:ext uri="{FF2B5EF4-FFF2-40B4-BE49-F238E27FC236}">
-                <a16:creationId xmlns:a16="http://schemas.microsoft.com/office/drawing/2014/main" id="{35F7C192-A49C-4E6A-AA30-D0DDFFAC2A25}"/>
+                <a16:creationId xmlns:a16="http://schemas.microsoft.com/office/drawing/2014/main" id="{C1FFAE24-5496-4AAC-8244-833765AAB1B6}"/>
               </a:ext>
             </a:extLst>
           </p:cNvPr>
@@ -11135,7 +11135,7 @@
           <p:cNvPr id="32" name="">
             <a:extLst xmlns:a="http://schemas.openxmlformats.org/drawingml/2006/main">
               <a:ext uri="{FF2B5EF4-FFF2-40B4-BE49-F238E27FC236}">
-                <a16:creationId xmlns:a16="http://schemas.microsoft.com/office/drawing/2014/main" id="{89CD3462-E837-46B4-8EB6-FE72F2B70FD9}"/>
+                <a16:creationId xmlns:a16="http://schemas.microsoft.com/office/drawing/2014/main" id="{896FB773-5C19-4055-9A3E-38730B8D56D3}"/>
               </a:ext>
             </a:extLst>
           </p:cNvPr>
@@ -11167,7 +11167,7 @@
           <p:cNvPr id="33" name="">
             <a:extLst xmlns:a="http://schemas.openxmlformats.org/drawingml/2006/main">
               <a:ext uri="{FF2B5EF4-FFF2-40B4-BE49-F238E27FC236}">
-                <a16:creationId xmlns:a16="http://schemas.microsoft.com/office/drawing/2014/main" id="{E67D7DA3-9FC6-4B2A-9E1D-CEF41A4BE1A7}"/>
+                <a16:creationId xmlns:a16="http://schemas.microsoft.com/office/drawing/2014/main" id="{088119C8-8D8F-4989-8753-688F4C4C2299}"/>
               </a:ext>
             </a:extLst>
           </p:cNvPr>
@@ -11230,7 +11230,7 @@
           <p:cNvPr id="34" name="">
             <a:extLst xmlns:a="http://schemas.openxmlformats.org/drawingml/2006/main">
               <a:ext uri="{FF2B5EF4-FFF2-40B4-BE49-F238E27FC236}">
-                <a16:creationId xmlns:a16="http://schemas.microsoft.com/office/drawing/2014/main" id="{6CDBA2A4-954F-46EA-972A-DA331227BB41}"/>
+                <a16:creationId xmlns:a16="http://schemas.microsoft.com/office/drawing/2014/main" id="{14D53C25-17B5-453E-B7B7-9E8BA3E96490}"/>
               </a:ext>
             </a:extLst>
           </p:cNvPr>
@@ -11297,7 +11297,7 @@
           <p:cNvPr id="35" name="">
             <a:extLst xmlns:a="http://schemas.openxmlformats.org/drawingml/2006/main">
               <a:ext uri="{FF2B5EF4-FFF2-40B4-BE49-F238E27FC236}">
-                <a16:creationId xmlns:a16="http://schemas.microsoft.com/office/drawing/2014/main" id="{2E24C28C-4728-46DD-AFBA-DC8D7E71F921}"/>
+                <a16:creationId xmlns:a16="http://schemas.microsoft.com/office/drawing/2014/main" id="{0ACF5CC0-F61B-474A-BE30-8651E8FCA7D2}"/>
               </a:ext>
             </a:extLst>
           </p:cNvPr>
@@ -11360,7 +11360,7 @@
           <p:cNvPr id="36" name="">
             <a:extLst xmlns:a="http://schemas.openxmlformats.org/drawingml/2006/main">
               <a:ext uri="{FF2B5EF4-FFF2-40B4-BE49-F238E27FC236}">
-                <a16:creationId xmlns:a16="http://schemas.microsoft.com/office/drawing/2014/main" id="{DF3F9436-B1D9-4376-B385-B9C19AB96295}"/>
+                <a16:creationId xmlns:a16="http://schemas.microsoft.com/office/drawing/2014/main" id="{F3325052-F709-4FEC-BA2E-39019A2E64E1}"/>
               </a:ext>
             </a:extLst>
           </p:cNvPr>
@@ -11392,7 +11392,7 @@
           <p:cNvPr id="37" name="">
             <a:extLst xmlns:a="http://schemas.openxmlformats.org/drawingml/2006/main">
               <a:ext uri="{FF2B5EF4-FFF2-40B4-BE49-F238E27FC236}">
-                <a16:creationId xmlns:a16="http://schemas.microsoft.com/office/drawing/2014/main" id="{A08A62EF-CD82-4B3F-967A-6E75A0ECF32D}"/>
+                <a16:creationId xmlns:a16="http://schemas.microsoft.com/office/drawing/2014/main" id="{741C172B-FF07-4B8B-B72A-4E7BEE303646}"/>
               </a:ext>
             </a:extLst>
           </p:cNvPr>
@@ -11455,7 +11455,7 @@
           <p:cNvPr id="38" name="">
             <a:extLst xmlns:a="http://schemas.openxmlformats.org/drawingml/2006/main">
               <a:ext uri="{FF2B5EF4-FFF2-40B4-BE49-F238E27FC236}">
-                <a16:creationId xmlns:a16="http://schemas.microsoft.com/office/drawing/2014/main" id="{DF415AF8-C6D1-46B9-A516-1807536DEFD6}"/>
+                <a16:creationId xmlns:a16="http://schemas.microsoft.com/office/drawing/2014/main" id="{5794EA64-D3E6-4154-A9E0-A179BD2B03D2}"/>
               </a:ext>
             </a:extLst>
           </p:cNvPr>
@@ -11516,7 +11516,7 @@
     </p:spTree>
     <p:extLst>
       <p:ext uri="{BB962C8B-B14F-4D97-AF65-F5344CB8AC3E}">
-        <p14:creationId xmlns:p14="http://schemas.microsoft.com/office/powerpoint/2010/main" val="1514204252"/>
+        <p14:creationId xmlns:p14="http://schemas.microsoft.com/office/powerpoint/2010/main" val="255013019"/>
       </p:ext>
     </p:extLst>
   </p:cSld>
@@ -11547,7 +11547,7 @@
           <p:cNvPr id="1" name="">
             <a:extLst xmlns:a="http://schemas.openxmlformats.org/drawingml/2006/main">
               <a:ext uri="{FF2B5EF4-FFF2-40B4-BE49-F238E27FC236}">
-                <a16:creationId xmlns:a16="http://schemas.microsoft.com/office/drawing/2014/main" id="{D1756163-807F-45A2-A755-7D207CF2BF67}"/>
+                <a16:creationId xmlns:a16="http://schemas.microsoft.com/office/drawing/2014/main" id="{50722344-B976-40F1-9D4D-4C5A40E9BB1D}"/>
               </a:ext>
             </a:extLst>
           </p:cNvPr>
@@ -11610,7 +11610,7 @@
           <p:cNvPr id="2" name="">
             <a:extLst xmlns:a="http://schemas.openxmlformats.org/drawingml/2006/main">
               <a:ext uri="{FF2B5EF4-FFF2-40B4-BE49-F238E27FC236}">
-                <a16:creationId xmlns:a16="http://schemas.microsoft.com/office/drawing/2014/main" id="{3CD7973F-A8E2-4E10-BB25-4401E5D398F4}"/>
+                <a16:creationId xmlns:a16="http://schemas.microsoft.com/office/drawing/2014/main" id="{2014EA45-B985-471E-9DE0-BFF0DCE5F0BA}"/>
               </a:ext>
             </a:extLst>
           </p:cNvPr>
@@ -11677,7 +11677,7 @@
           <p:cNvPr id="3" name="">
             <a:extLst xmlns:a="http://schemas.openxmlformats.org/drawingml/2006/main">
               <a:ext uri="{FF2B5EF4-FFF2-40B4-BE49-F238E27FC236}">
-                <a16:creationId xmlns:a16="http://schemas.microsoft.com/office/drawing/2014/main" id="{C5DF1889-4E02-49D4-9C05-17AC92A14885}"/>
+                <a16:creationId xmlns:a16="http://schemas.microsoft.com/office/drawing/2014/main" id="{A170CFCF-AC38-4FDE-84BD-FF0F8FB49BB2}"/>
               </a:ext>
             </a:extLst>
           </p:cNvPr>
@@ -11744,7 +11744,7 @@
           <p:cNvPr id="4" name="">
             <a:extLst xmlns:a="http://schemas.openxmlformats.org/drawingml/2006/main">
               <a:ext uri="{FF2B5EF4-FFF2-40B4-BE49-F238E27FC236}">
-                <a16:creationId xmlns:a16="http://schemas.microsoft.com/office/drawing/2014/main" id="{E74A6AE0-A0D4-46B1-B99F-889B0D77015E}"/>
+                <a16:creationId xmlns:a16="http://schemas.microsoft.com/office/drawing/2014/main" id="{A0F884B3-5B47-4B3E-9D3F-485F8DD61396}"/>
               </a:ext>
             </a:extLst>
           </p:cNvPr>
@@ -11776,7 +11776,7 @@
           <p:cNvPr id="5" name="">
             <a:extLst xmlns:a="http://schemas.openxmlformats.org/drawingml/2006/main">
               <a:ext uri="{FF2B5EF4-FFF2-40B4-BE49-F238E27FC236}">
-                <a16:creationId xmlns:a16="http://schemas.microsoft.com/office/drawing/2014/main" id="{4BB7A12E-EB08-467C-8468-0D36796E1222}"/>
+                <a16:creationId xmlns:a16="http://schemas.microsoft.com/office/drawing/2014/main" id="{3E1DB092-FC4C-422D-A3BA-7C7ED22F7DC1}"/>
               </a:ext>
             </a:extLst>
           </p:cNvPr>
@@ -11839,7 +11839,7 @@
           <p:cNvPr id="6" name="">
             <a:extLst xmlns:a="http://schemas.openxmlformats.org/drawingml/2006/main">
               <a:ext uri="{FF2B5EF4-FFF2-40B4-BE49-F238E27FC236}">
-                <a16:creationId xmlns:a16="http://schemas.microsoft.com/office/drawing/2014/main" id="{5A99D277-581E-4339-BA98-638AA3F9686B}"/>
+                <a16:creationId xmlns:a16="http://schemas.microsoft.com/office/drawing/2014/main" id="{5122018C-C274-4E4A-9DBB-F01BA54EDB67}"/>
               </a:ext>
             </a:extLst>
           </p:cNvPr>
@@ -11902,7 +11902,7 @@
           <p:cNvPr id="7" name="">
             <a:extLst xmlns:a="http://schemas.openxmlformats.org/drawingml/2006/main">
               <a:ext uri="{FF2B5EF4-FFF2-40B4-BE49-F238E27FC236}">
-                <a16:creationId xmlns:a16="http://schemas.microsoft.com/office/drawing/2014/main" id="{2CE7202A-FAB3-4715-AA2C-C9F7B2B8592C}"/>
+                <a16:creationId xmlns:a16="http://schemas.microsoft.com/office/drawing/2014/main" id="{D949F5B9-0B47-4447-AF7F-73C4FA63E33B}"/>
               </a:ext>
             </a:extLst>
           </p:cNvPr>
@@ -11914,7 +11914,7 @@
         <p:spPr>
           <a:xfrm xmlns:a="http://schemas.openxmlformats.org/drawingml/2006/main">
             <a:off x="3295650" y="3190875"/>
-            <a:ext cx="2000250" cy="114300"/>
+            <a:ext cx="1619250" cy="114300"/>
           </a:xfrm>
           <a:prstGeom xmlns:a="http://schemas.openxmlformats.org/drawingml/2006/main" prst="rect">
             <a:avLst/>
@@ -11936,7 +11936,7 @@
           <p:cNvPr id="8" name="">
             <a:extLst xmlns:a="http://schemas.openxmlformats.org/drawingml/2006/main">
               <a:ext uri="{FF2B5EF4-FFF2-40B4-BE49-F238E27FC236}">
-                <a16:creationId xmlns:a16="http://schemas.microsoft.com/office/drawing/2014/main" id="{FD897E7F-23D9-4EE0-94C6-469C29323BD9}"/>
+                <a16:creationId xmlns:a16="http://schemas.microsoft.com/office/drawing/2014/main" id="{5B95BD44-B7B9-4AA7-9AEE-12BB98B1BF84}"/>
               </a:ext>
             </a:extLst>
           </p:cNvPr>
@@ -11948,7 +11948,7 @@
         <p:spPr>
           <a:xfrm xmlns:a="http://schemas.openxmlformats.org/drawingml/2006/main">
             <a:off x="3295650" y="3190875"/>
-            <a:ext cx="2000250" cy="114300"/>
+            <a:ext cx="1619250" cy="114300"/>
           </a:xfrm>
           <a:prstGeom xmlns:a="http://schemas.openxmlformats.org/drawingml/2006/main" prst="rect">
             <a:avLst/>
@@ -11968,19 +11968,19 @@
           <p:cNvPr id="9" name="">
             <a:extLst xmlns:a="http://schemas.openxmlformats.org/drawingml/2006/main">
               <a:ext uri="{FF2B5EF4-FFF2-40B4-BE49-F238E27FC236}">
-                <a16:creationId xmlns:a16="http://schemas.microsoft.com/office/drawing/2014/main" id="{B12D7241-9FA3-4323-A11F-F82AD4790C0E}"/>
-              </a:ext>
-            </a:extLst>
-          </p:cNvPr>
-          <p:cNvSpPr>
-            <a:spLocks xmlns:a="http://schemas.openxmlformats.org/drawingml/2006/main" noGrp="1"/>
-          </p:cNvSpPr>
-          <p:nvPr/>
-        </p:nvSpPr>
-        <p:spPr>
-          <a:xfrm xmlns:a="http://schemas.openxmlformats.org/drawingml/2006/main">
-            <a:off x="5391150" y="3162300"/>
-            <a:ext cx="857250" cy="190500"/>
+                <a16:creationId xmlns:a16="http://schemas.microsoft.com/office/drawing/2014/main" id="{B5D17EE7-CEC1-4524-8F80-99988963BDFA}"/>
+              </a:ext>
+            </a:extLst>
+          </p:cNvPr>
+          <p:cNvSpPr>
+            <a:spLocks xmlns:a="http://schemas.openxmlformats.org/drawingml/2006/main" noGrp="1"/>
+          </p:cNvSpPr>
+          <p:nvPr/>
+        </p:nvSpPr>
+        <p:spPr>
+          <a:xfrm xmlns:a="http://schemas.openxmlformats.org/drawingml/2006/main">
+            <a:off x="5010150" y="3162300"/>
+            <a:ext cx="552450" cy="190500"/>
           </a:xfrm>
           <a:prstGeom xmlns:a="http://schemas.openxmlformats.org/drawingml/2006/main" prst="rect">
             <a:avLst/>
@@ -12031,7 +12031,7 @@
           <p:cNvPr id="10" name="">
             <a:extLst xmlns:a="http://schemas.openxmlformats.org/drawingml/2006/main">
               <a:ext uri="{FF2B5EF4-FFF2-40B4-BE49-F238E27FC236}">
-                <a16:creationId xmlns:a16="http://schemas.microsoft.com/office/drawing/2014/main" id="{ADC6F43D-AC3F-4D2D-B0FF-749DF1BE7B95}"/>
+                <a16:creationId xmlns:a16="http://schemas.microsoft.com/office/drawing/2014/main" id="{99430139-18AB-4E78-AC38-32D49EDA8F33}"/>
               </a:ext>
             </a:extLst>
           </p:cNvPr>
@@ -12094,7 +12094,7 @@
           <p:cNvPr id="11" name="">
             <a:extLst xmlns:a="http://schemas.openxmlformats.org/drawingml/2006/main">
               <a:ext uri="{FF2B5EF4-FFF2-40B4-BE49-F238E27FC236}">
-                <a16:creationId xmlns:a16="http://schemas.microsoft.com/office/drawing/2014/main" id="{A68B432E-FA75-4A86-9018-FAC4C06DA259}"/>
+                <a16:creationId xmlns:a16="http://schemas.microsoft.com/office/drawing/2014/main" id="{66631484-7AB8-4BB4-9BE1-A2C3D215AD6E}"/>
               </a:ext>
             </a:extLst>
           </p:cNvPr>
@@ -12106,7 +12106,7 @@
         <p:spPr>
           <a:xfrm xmlns:a="http://schemas.openxmlformats.org/drawingml/2006/main">
             <a:off x="3295650" y="3667125"/>
-            <a:ext cx="2000250" cy="114300"/>
+            <a:ext cx="1619250" cy="114300"/>
           </a:xfrm>
           <a:prstGeom xmlns:a="http://schemas.openxmlformats.org/drawingml/2006/main" prst="rect">
             <a:avLst/>
@@ -12128,7 +12128,7 @@
           <p:cNvPr id="12" name="">
             <a:extLst xmlns:a="http://schemas.openxmlformats.org/drawingml/2006/main">
               <a:ext uri="{FF2B5EF4-FFF2-40B4-BE49-F238E27FC236}">
-                <a16:creationId xmlns:a16="http://schemas.microsoft.com/office/drawing/2014/main" id="{1011634E-AA70-431C-A33C-E1AF43BC5DF8}"/>
+                <a16:creationId xmlns:a16="http://schemas.microsoft.com/office/drawing/2014/main" id="{192AF1F0-6FB2-41BF-94BD-C2E387AB319A}"/>
               </a:ext>
             </a:extLst>
           </p:cNvPr>
@@ -12140,7 +12140,7 @@
         <p:spPr>
           <a:xfrm xmlns:a="http://schemas.openxmlformats.org/drawingml/2006/main">
             <a:off x="3295650" y="3667125"/>
-            <a:ext cx="1837264" cy="114300"/>
+            <a:ext cx="1487309" cy="114300"/>
           </a:xfrm>
           <a:prstGeom xmlns:a="http://schemas.openxmlformats.org/drawingml/2006/main" prst="rect">
             <a:avLst/>
@@ -12160,19 +12160,19 @@
           <p:cNvPr id="13" name="">
             <a:extLst xmlns:a="http://schemas.openxmlformats.org/drawingml/2006/main">
               <a:ext uri="{FF2B5EF4-FFF2-40B4-BE49-F238E27FC236}">
-                <a16:creationId xmlns:a16="http://schemas.microsoft.com/office/drawing/2014/main" id="{272BDBE5-237B-48F8-9F02-53494EEE8546}"/>
-              </a:ext>
-            </a:extLst>
-          </p:cNvPr>
-          <p:cNvSpPr>
-            <a:spLocks xmlns:a="http://schemas.openxmlformats.org/drawingml/2006/main" noGrp="1"/>
-          </p:cNvSpPr>
-          <p:nvPr/>
-        </p:nvSpPr>
-        <p:spPr>
-          <a:xfrm xmlns:a="http://schemas.openxmlformats.org/drawingml/2006/main">
-            <a:off x="5391150" y="3638550"/>
-            <a:ext cx="857250" cy="190500"/>
+                <a16:creationId xmlns:a16="http://schemas.microsoft.com/office/drawing/2014/main" id="{7FF6DFE2-E233-49BC-A642-5EF3356209F8}"/>
+              </a:ext>
+            </a:extLst>
+          </p:cNvPr>
+          <p:cNvSpPr>
+            <a:spLocks xmlns:a="http://schemas.openxmlformats.org/drawingml/2006/main" noGrp="1"/>
+          </p:cNvSpPr>
+          <p:nvPr/>
+        </p:nvSpPr>
+        <p:spPr>
+          <a:xfrm xmlns:a="http://schemas.openxmlformats.org/drawingml/2006/main">
+            <a:off x="5010150" y="3638550"/>
+            <a:ext cx="552450" cy="190500"/>
           </a:xfrm>
           <a:prstGeom xmlns:a="http://schemas.openxmlformats.org/drawingml/2006/main" prst="rect">
             <a:avLst/>
@@ -12223,7 +12223,7 @@
           <p:cNvPr id="14" name="">
             <a:extLst xmlns:a="http://schemas.openxmlformats.org/drawingml/2006/main">
               <a:ext uri="{FF2B5EF4-FFF2-40B4-BE49-F238E27FC236}">
-                <a16:creationId xmlns:a16="http://schemas.microsoft.com/office/drawing/2014/main" id="{CDE1988A-1214-423B-B47A-FDF9EF99DA42}"/>
+                <a16:creationId xmlns:a16="http://schemas.microsoft.com/office/drawing/2014/main" id="{FAEE2CB3-FB64-4AEC-854C-30D316D5FEF8}"/>
               </a:ext>
             </a:extLst>
           </p:cNvPr>
@@ -12286,7 +12286,7 @@
           <p:cNvPr id="15" name="">
             <a:extLst xmlns:a="http://schemas.openxmlformats.org/drawingml/2006/main">
               <a:ext uri="{FF2B5EF4-FFF2-40B4-BE49-F238E27FC236}">
-                <a16:creationId xmlns:a16="http://schemas.microsoft.com/office/drawing/2014/main" id="{7752FD48-9AB0-445D-88CA-C815850B0CEF}"/>
+                <a16:creationId xmlns:a16="http://schemas.microsoft.com/office/drawing/2014/main" id="{7E78A9B5-DFDA-435D-B477-6A2CC90DDA8E}"/>
               </a:ext>
             </a:extLst>
           </p:cNvPr>
@@ -12298,7 +12298,7 @@
         <p:spPr>
           <a:xfrm xmlns:a="http://schemas.openxmlformats.org/drawingml/2006/main">
             <a:off x="3295650" y="4143375"/>
-            <a:ext cx="2000250" cy="114300"/>
+            <a:ext cx="1619250" cy="114300"/>
           </a:xfrm>
           <a:prstGeom xmlns:a="http://schemas.openxmlformats.org/drawingml/2006/main" prst="rect">
             <a:avLst/>
@@ -12320,7 +12320,7 @@
           <p:cNvPr id="16" name="">
             <a:extLst xmlns:a="http://schemas.openxmlformats.org/drawingml/2006/main">
               <a:ext uri="{FF2B5EF4-FFF2-40B4-BE49-F238E27FC236}">
-                <a16:creationId xmlns:a16="http://schemas.microsoft.com/office/drawing/2014/main" id="{E57DF4DC-FBDF-4EC9-9977-701BEF4DB7E0}"/>
+                <a16:creationId xmlns:a16="http://schemas.microsoft.com/office/drawing/2014/main" id="{D1743DBC-70A0-4890-B353-F3174AF4D37A}"/>
               </a:ext>
             </a:extLst>
           </p:cNvPr>
@@ -12332,7 +12332,7 @@
         <p:spPr>
           <a:xfrm xmlns:a="http://schemas.openxmlformats.org/drawingml/2006/main">
             <a:off x="3295650" y="4143375"/>
-            <a:ext cx="260458" cy="114300"/>
+            <a:ext cx="210847" cy="114300"/>
           </a:xfrm>
           <a:prstGeom xmlns:a="http://schemas.openxmlformats.org/drawingml/2006/main" prst="rect">
             <a:avLst/>
@@ -12352,19 +12352,19 @@
           <p:cNvPr id="17" name="">
             <a:extLst xmlns:a="http://schemas.openxmlformats.org/drawingml/2006/main">
               <a:ext uri="{FF2B5EF4-FFF2-40B4-BE49-F238E27FC236}">
-                <a16:creationId xmlns:a16="http://schemas.microsoft.com/office/drawing/2014/main" id="{9C833779-83F1-4B03-BFA9-0817B851F570}"/>
-              </a:ext>
-            </a:extLst>
-          </p:cNvPr>
-          <p:cNvSpPr>
-            <a:spLocks xmlns:a="http://schemas.openxmlformats.org/drawingml/2006/main" noGrp="1"/>
-          </p:cNvSpPr>
-          <p:nvPr/>
-        </p:nvSpPr>
-        <p:spPr>
-          <a:xfrm xmlns:a="http://schemas.openxmlformats.org/drawingml/2006/main">
-            <a:off x="5391150" y="4114800"/>
-            <a:ext cx="857250" cy="190500"/>
+                <a16:creationId xmlns:a16="http://schemas.microsoft.com/office/drawing/2014/main" id="{9F90DBC5-EBE1-4FC2-8580-3A2A93748D8F}"/>
+              </a:ext>
+            </a:extLst>
+          </p:cNvPr>
+          <p:cNvSpPr>
+            <a:spLocks xmlns:a="http://schemas.openxmlformats.org/drawingml/2006/main" noGrp="1"/>
+          </p:cNvSpPr>
+          <p:nvPr/>
+        </p:nvSpPr>
+        <p:spPr>
+          <a:xfrm xmlns:a="http://schemas.openxmlformats.org/drawingml/2006/main">
+            <a:off x="5010150" y="4114800"/>
+            <a:ext cx="552450" cy="190500"/>
           </a:xfrm>
           <a:prstGeom xmlns:a="http://schemas.openxmlformats.org/drawingml/2006/main" prst="rect">
             <a:avLst/>
@@ -12415,7 +12415,7 @@
           <p:cNvPr id="18" name="">
             <a:extLst xmlns:a="http://schemas.openxmlformats.org/drawingml/2006/main">
               <a:ext uri="{FF2B5EF4-FFF2-40B4-BE49-F238E27FC236}">
-                <a16:creationId xmlns:a16="http://schemas.microsoft.com/office/drawing/2014/main" id="{3C03294A-15FF-4368-8EBB-9652F528E3AA}"/>
+                <a16:creationId xmlns:a16="http://schemas.microsoft.com/office/drawing/2014/main" id="{BF568D5F-7C7B-4D28-9E63-96D035A24218}"/>
               </a:ext>
             </a:extLst>
           </p:cNvPr>
@@ -12478,7 +12478,7 @@
           <p:cNvPr id="19" name="">
             <a:extLst xmlns:a="http://schemas.openxmlformats.org/drawingml/2006/main">
               <a:ext uri="{FF2B5EF4-FFF2-40B4-BE49-F238E27FC236}">
-                <a16:creationId xmlns:a16="http://schemas.microsoft.com/office/drawing/2014/main" id="{1032C314-A370-4353-A10E-A41E491D9A91}"/>
+                <a16:creationId xmlns:a16="http://schemas.microsoft.com/office/drawing/2014/main" id="{84C1DB14-66A0-4042-B56C-03990FF35B07}"/>
               </a:ext>
             </a:extLst>
           </p:cNvPr>
@@ -12490,7 +12490,7 @@
         <p:spPr>
           <a:xfrm xmlns:a="http://schemas.openxmlformats.org/drawingml/2006/main">
             <a:off x="3295650" y="4619625"/>
-            <a:ext cx="2000250" cy="114300"/>
+            <a:ext cx="1619250" cy="114300"/>
           </a:xfrm>
           <a:prstGeom xmlns:a="http://schemas.openxmlformats.org/drawingml/2006/main" prst="rect">
             <a:avLst/>
@@ -12512,7 +12512,7 @@
           <p:cNvPr id="20" name="">
             <a:extLst xmlns:a="http://schemas.openxmlformats.org/drawingml/2006/main">
               <a:ext uri="{FF2B5EF4-FFF2-40B4-BE49-F238E27FC236}">
-                <a16:creationId xmlns:a16="http://schemas.microsoft.com/office/drawing/2014/main" id="{9B4BC232-AFAC-4422-9365-EF199BCF11BF}"/>
+                <a16:creationId xmlns:a16="http://schemas.microsoft.com/office/drawing/2014/main" id="{B052C903-63EF-4A57-BCCF-16CDD5B59BF4}"/>
               </a:ext>
             </a:extLst>
           </p:cNvPr>
@@ -12524,7 +12524,7 @@
         <p:spPr>
           <a:xfrm xmlns:a="http://schemas.openxmlformats.org/drawingml/2006/main">
             <a:off x="3295650" y="4619625"/>
-            <a:ext cx="221788" cy="114300"/>
+            <a:ext cx="179543" cy="114300"/>
           </a:xfrm>
           <a:prstGeom xmlns:a="http://schemas.openxmlformats.org/drawingml/2006/main" prst="rect">
             <a:avLst/>
@@ -12544,19 +12544,19 @@
           <p:cNvPr id="21" name="">
             <a:extLst xmlns:a="http://schemas.openxmlformats.org/drawingml/2006/main">
               <a:ext uri="{FF2B5EF4-FFF2-40B4-BE49-F238E27FC236}">
-                <a16:creationId xmlns:a16="http://schemas.microsoft.com/office/drawing/2014/main" id="{90C2DABF-1F52-40CE-A6DC-23D95D2D5668}"/>
-              </a:ext>
-            </a:extLst>
-          </p:cNvPr>
-          <p:cNvSpPr>
-            <a:spLocks xmlns:a="http://schemas.openxmlformats.org/drawingml/2006/main" noGrp="1"/>
-          </p:cNvSpPr>
-          <p:nvPr/>
-        </p:nvSpPr>
-        <p:spPr>
-          <a:xfrm xmlns:a="http://schemas.openxmlformats.org/drawingml/2006/main">
-            <a:off x="5391150" y="4591050"/>
-            <a:ext cx="857250" cy="190500"/>
+                <a16:creationId xmlns:a16="http://schemas.microsoft.com/office/drawing/2014/main" id="{F9E16F44-3001-46EF-8810-15F23C7CA62E}"/>
+              </a:ext>
+            </a:extLst>
+          </p:cNvPr>
+          <p:cNvSpPr>
+            <a:spLocks xmlns:a="http://schemas.openxmlformats.org/drawingml/2006/main" noGrp="1"/>
+          </p:cNvSpPr>
+          <p:nvPr/>
+        </p:nvSpPr>
+        <p:spPr>
+          <a:xfrm xmlns:a="http://schemas.openxmlformats.org/drawingml/2006/main">
+            <a:off x="5010150" y="4591050"/>
+            <a:ext cx="552450" cy="190500"/>
           </a:xfrm>
           <a:prstGeom xmlns:a="http://schemas.openxmlformats.org/drawingml/2006/main" prst="rect">
             <a:avLst/>
@@ -12607,7 +12607,7 @@
           <p:cNvPr id="22" name="">
             <a:extLst xmlns:a="http://schemas.openxmlformats.org/drawingml/2006/main">
               <a:ext uri="{FF2B5EF4-FFF2-40B4-BE49-F238E27FC236}">
-                <a16:creationId xmlns:a16="http://schemas.microsoft.com/office/drawing/2014/main" id="{D2BAF31E-73A3-48B8-82F6-A68F775FD5C5}"/>
+                <a16:creationId xmlns:a16="http://schemas.microsoft.com/office/drawing/2014/main" id="{189DDA1F-DFD4-480B-9F53-CA8CCF31B7C8}"/>
               </a:ext>
             </a:extLst>
           </p:cNvPr>
@@ -12639,7 +12639,7 @@
           <p:cNvPr id="23" name="">
             <a:extLst xmlns:a="http://schemas.openxmlformats.org/drawingml/2006/main">
               <a:ext uri="{FF2B5EF4-FFF2-40B4-BE49-F238E27FC236}">
-                <a16:creationId xmlns:a16="http://schemas.microsoft.com/office/drawing/2014/main" id="{6DCEF1F6-44D1-4148-997A-980CF0A06277}"/>
+                <a16:creationId xmlns:a16="http://schemas.microsoft.com/office/drawing/2014/main" id="{DF89474C-1EFC-4962-8A6F-236C3B62FBB6}"/>
               </a:ext>
             </a:extLst>
           </p:cNvPr>
@@ -12702,7 +12702,7 @@
           <p:cNvPr id="24" name="">
             <a:extLst xmlns:a="http://schemas.openxmlformats.org/drawingml/2006/main">
               <a:ext uri="{FF2B5EF4-FFF2-40B4-BE49-F238E27FC236}">
-                <a16:creationId xmlns:a16="http://schemas.microsoft.com/office/drawing/2014/main" id="{E27955C4-50C1-4E9F-904A-93BDA65D8431}"/>
+                <a16:creationId xmlns:a16="http://schemas.microsoft.com/office/drawing/2014/main" id="{4790CCD6-2720-4F9A-98DD-D105ED58D3B2}"/>
               </a:ext>
             </a:extLst>
           </p:cNvPr>
@@ -12765,7 +12765,7 @@
           <p:cNvPr id="25" name="">
             <a:extLst xmlns:a="http://schemas.openxmlformats.org/drawingml/2006/main">
               <a:ext uri="{FF2B5EF4-FFF2-40B4-BE49-F238E27FC236}">
-                <a16:creationId xmlns:a16="http://schemas.microsoft.com/office/drawing/2014/main" id="{4F564B2E-AA13-4B9B-8A3D-A71B1A7155A9}"/>
+                <a16:creationId xmlns:a16="http://schemas.microsoft.com/office/drawing/2014/main" id="{886C6898-2D6E-4D46-8456-2F04679B87EA}"/>
               </a:ext>
             </a:extLst>
           </p:cNvPr>
@@ -12832,7 +12832,7 @@
           <p:cNvPr id="26" name="">
             <a:extLst xmlns:a="http://schemas.openxmlformats.org/drawingml/2006/main">
               <a:ext uri="{FF2B5EF4-FFF2-40B4-BE49-F238E27FC236}">
-                <a16:creationId xmlns:a16="http://schemas.microsoft.com/office/drawing/2014/main" id="{19EC0930-59DF-4BD8-83DC-E64247058A9B}"/>
+                <a16:creationId xmlns:a16="http://schemas.microsoft.com/office/drawing/2014/main" id="{F6FA5B67-BE06-4013-9901-F94A59461CE6}"/>
               </a:ext>
             </a:extLst>
           </p:cNvPr>
@@ -12895,7 +12895,7 @@
           <p:cNvPr id="27" name="">
             <a:extLst xmlns:a="http://schemas.openxmlformats.org/drawingml/2006/main">
               <a:ext uri="{FF2B5EF4-FFF2-40B4-BE49-F238E27FC236}">
-                <a16:creationId xmlns:a16="http://schemas.microsoft.com/office/drawing/2014/main" id="{D323B0D8-5DB8-4609-B353-DE7D64ED128E}"/>
+                <a16:creationId xmlns:a16="http://schemas.microsoft.com/office/drawing/2014/main" id="{54659694-DD2F-48F9-9301-7D4D3D221B43}"/>
               </a:ext>
             </a:extLst>
           </p:cNvPr>
@@ -12962,7 +12962,7 @@
           <p:cNvPr id="28" name="">
             <a:extLst xmlns:a="http://schemas.openxmlformats.org/drawingml/2006/main">
               <a:ext uri="{FF2B5EF4-FFF2-40B4-BE49-F238E27FC236}">
-                <a16:creationId xmlns:a16="http://schemas.microsoft.com/office/drawing/2014/main" id="{AA2718C2-AD04-4BE2-90C4-7A6870F8482C}"/>
+                <a16:creationId xmlns:a16="http://schemas.microsoft.com/office/drawing/2014/main" id="{02157B68-36DA-4127-BD29-231977095534}"/>
               </a:ext>
             </a:extLst>
           </p:cNvPr>
@@ -13025,7 +13025,7 @@
           <p:cNvPr id="29" name="">
             <a:extLst xmlns:a="http://schemas.openxmlformats.org/drawingml/2006/main">
               <a:ext uri="{FF2B5EF4-FFF2-40B4-BE49-F238E27FC236}">
-                <a16:creationId xmlns:a16="http://schemas.microsoft.com/office/drawing/2014/main" id="{475FFFE9-8052-4873-815C-E81ADB444EC6}"/>
+                <a16:creationId xmlns:a16="http://schemas.microsoft.com/office/drawing/2014/main" id="{6E577D2D-1F18-4ACC-B0DC-9697A264D48F}"/>
               </a:ext>
             </a:extLst>
           </p:cNvPr>
@@ -13092,7 +13092,7 @@
           <p:cNvPr id="30" name="">
             <a:extLst xmlns:a="http://schemas.openxmlformats.org/drawingml/2006/main">
               <a:ext uri="{FF2B5EF4-FFF2-40B4-BE49-F238E27FC236}">
-                <a16:creationId xmlns:a16="http://schemas.microsoft.com/office/drawing/2014/main" id="{83C43492-6975-4E01-8939-3D7A2417F6FE}"/>
+                <a16:creationId xmlns:a16="http://schemas.microsoft.com/office/drawing/2014/main" id="{1F04A6A1-196A-4485-945E-3D72F43A3673}"/>
               </a:ext>
             </a:extLst>
           </p:cNvPr>
@@ -13124,7 +13124,7 @@
           <p:cNvPr id="31" name="">
             <a:extLst xmlns:a="http://schemas.openxmlformats.org/drawingml/2006/main">
               <a:ext uri="{FF2B5EF4-FFF2-40B4-BE49-F238E27FC236}">
-                <a16:creationId xmlns:a16="http://schemas.microsoft.com/office/drawing/2014/main" id="{32119DEB-A73B-4E03-A918-FDCB000B755A}"/>
+                <a16:creationId xmlns:a16="http://schemas.microsoft.com/office/drawing/2014/main" id="{85208437-1157-4F6D-85B8-2B149A14F535}"/>
               </a:ext>
             </a:extLst>
           </p:cNvPr>
@@ -13156,7 +13156,7 @@
           <p:cNvPr id="32" name="">
             <a:extLst xmlns:a="http://schemas.openxmlformats.org/drawingml/2006/main">
               <a:ext uri="{FF2B5EF4-FFF2-40B4-BE49-F238E27FC236}">
-                <a16:creationId xmlns:a16="http://schemas.microsoft.com/office/drawing/2014/main" id="{D802D266-1069-44FE-9B3E-2F1369EF2DA5}"/>
+                <a16:creationId xmlns:a16="http://schemas.microsoft.com/office/drawing/2014/main" id="{37903784-8161-4EBD-A5AF-CA1B0C55C4B0}"/>
               </a:ext>
             </a:extLst>
           </p:cNvPr>
@@ -13223,7 +13223,7 @@
           <p:cNvPr id="33" name="">
             <a:extLst xmlns:a="http://schemas.openxmlformats.org/drawingml/2006/main">
               <a:ext uri="{FF2B5EF4-FFF2-40B4-BE49-F238E27FC236}">
-                <a16:creationId xmlns:a16="http://schemas.microsoft.com/office/drawing/2014/main" id="{0111C5F3-1A3C-429B-93CE-89BB060B8EFE}"/>
+                <a16:creationId xmlns:a16="http://schemas.microsoft.com/office/drawing/2014/main" id="{CAA6E47F-70DD-4D68-9EEF-2ED747454636}"/>
               </a:ext>
             </a:extLst>
           </p:cNvPr>
@@ -13286,7 +13286,7 @@
           <p:cNvPr id="34" name="">
             <a:extLst xmlns:a="http://schemas.openxmlformats.org/drawingml/2006/main">
               <a:ext uri="{FF2B5EF4-FFF2-40B4-BE49-F238E27FC236}">
-                <a16:creationId xmlns:a16="http://schemas.microsoft.com/office/drawing/2014/main" id="{4DD76B39-E6DA-4B5A-9B3F-6AA1CD5B788F}"/>
+                <a16:creationId xmlns:a16="http://schemas.microsoft.com/office/drawing/2014/main" id="{361AB778-4619-4B4E-8EE9-1BDF482901DA}"/>
               </a:ext>
             </a:extLst>
           </p:cNvPr>
@@ -13318,7 +13318,7 @@
           <p:cNvPr id="35" name="">
             <a:extLst xmlns:a="http://schemas.openxmlformats.org/drawingml/2006/main">
               <a:ext uri="{FF2B5EF4-FFF2-40B4-BE49-F238E27FC236}">
-                <a16:creationId xmlns:a16="http://schemas.microsoft.com/office/drawing/2014/main" id="{86003DD2-08EF-44F8-81E5-9D79AE636960}"/>
+                <a16:creationId xmlns:a16="http://schemas.microsoft.com/office/drawing/2014/main" id="{984FE5CE-673F-465D-9C2E-4810EAD44205}"/>
               </a:ext>
             </a:extLst>
           </p:cNvPr>
@@ -13381,7 +13381,7 @@
           <p:cNvPr id="36" name="">
             <a:extLst xmlns:a="http://schemas.openxmlformats.org/drawingml/2006/main">
               <a:ext uri="{FF2B5EF4-FFF2-40B4-BE49-F238E27FC236}">
-                <a16:creationId xmlns:a16="http://schemas.microsoft.com/office/drawing/2014/main" id="{C8213F12-9285-4587-96F2-8AF79D5CF546}"/>
+                <a16:creationId xmlns:a16="http://schemas.microsoft.com/office/drawing/2014/main" id="{006E0808-9E2C-4AA2-BCB3-FB1262FBF07C}"/>
               </a:ext>
             </a:extLst>
           </p:cNvPr>
@@ -13442,7 +13442,7 @@
     </p:spTree>
     <p:extLst>
       <p:ext uri="{BB962C8B-B14F-4D97-AF65-F5344CB8AC3E}">
-        <p14:creationId xmlns:p14="http://schemas.microsoft.com/office/powerpoint/2010/main" val="1800584457"/>
+        <p14:creationId xmlns:p14="http://schemas.microsoft.com/office/powerpoint/2010/main" val="1226466060"/>
       </p:ext>
     </p:extLst>
   </p:cSld>
@@ -13473,7 +13473,7 @@
           <p:cNvPr id="1" name="">
             <a:extLst xmlns:a="http://schemas.openxmlformats.org/drawingml/2006/main">
               <a:ext uri="{FF2B5EF4-FFF2-40B4-BE49-F238E27FC236}">
-                <a16:creationId xmlns:a16="http://schemas.microsoft.com/office/drawing/2014/main" id="{ABA1320A-9AC1-415A-899A-2F280133A99D}"/>
+                <a16:creationId xmlns:a16="http://schemas.microsoft.com/office/drawing/2014/main" id="{30B83682-41B7-4264-8413-372CBE984B4D}"/>
               </a:ext>
             </a:extLst>
           </p:cNvPr>
@@ -13536,7 +13536,7 @@
           <p:cNvPr id="2" name="">
             <a:extLst xmlns:a="http://schemas.openxmlformats.org/drawingml/2006/main">
               <a:ext uri="{FF2B5EF4-FFF2-40B4-BE49-F238E27FC236}">
-                <a16:creationId xmlns:a16="http://schemas.microsoft.com/office/drawing/2014/main" id="{876EFFE9-AB18-4B30-9607-A8CCF7DCE7C2}"/>
+                <a16:creationId xmlns:a16="http://schemas.microsoft.com/office/drawing/2014/main" id="{B606A888-26D5-4E33-91C0-BCCAA8638EAD}"/>
               </a:ext>
             </a:extLst>
           </p:cNvPr>
@@ -13603,7 +13603,7 @@
           <p:cNvPr id="3" name="">
             <a:extLst xmlns:a="http://schemas.openxmlformats.org/drawingml/2006/main">
               <a:ext uri="{FF2B5EF4-FFF2-40B4-BE49-F238E27FC236}">
-                <a16:creationId xmlns:a16="http://schemas.microsoft.com/office/drawing/2014/main" id="{9DA7AF11-E1C2-43BE-B4D3-AEAD80FACD56}"/>
+                <a16:creationId xmlns:a16="http://schemas.microsoft.com/office/drawing/2014/main" id="{299AB854-F798-47D1-8258-29EA0428F464}"/>
               </a:ext>
             </a:extLst>
           </p:cNvPr>
@@ -13670,7 +13670,7 @@
           <p:cNvPr id="4" name="">
             <a:extLst xmlns:a="http://schemas.openxmlformats.org/drawingml/2006/main">
               <a:ext uri="{FF2B5EF4-FFF2-40B4-BE49-F238E27FC236}">
-                <a16:creationId xmlns:a16="http://schemas.microsoft.com/office/drawing/2014/main" id="{F87A41AC-2810-4301-A445-C1AC9CE325EA}"/>
+                <a16:creationId xmlns:a16="http://schemas.microsoft.com/office/drawing/2014/main" id="{4138E417-F73C-43AE-937C-D2BFA532A376}"/>
               </a:ext>
             </a:extLst>
           </p:cNvPr>
@@ -13702,7 +13702,7 @@
           <p:cNvPr id="5" name="">
             <a:extLst xmlns:a="http://schemas.openxmlformats.org/drawingml/2006/main">
               <a:ext uri="{FF2B5EF4-FFF2-40B4-BE49-F238E27FC236}">
-                <a16:creationId xmlns:a16="http://schemas.microsoft.com/office/drawing/2014/main" id="{B9539136-2586-489A-9EC7-119FA7E537B7}"/>
+                <a16:creationId xmlns:a16="http://schemas.microsoft.com/office/drawing/2014/main" id="{EE8B5F0F-F8F4-42B5-9627-CD4941C186D9}"/>
               </a:ext>
             </a:extLst>
           </p:cNvPr>
@@ -13765,7 +13765,7 @@
           <p:cNvPr id="6" name="">
             <a:extLst xmlns:a="http://schemas.openxmlformats.org/drawingml/2006/main">
               <a:ext uri="{FF2B5EF4-FFF2-40B4-BE49-F238E27FC236}">
-                <a16:creationId xmlns:a16="http://schemas.microsoft.com/office/drawing/2014/main" id="{89342451-CD4A-475F-A89F-CFEBE1502D95}"/>
+                <a16:creationId xmlns:a16="http://schemas.microsoft.com/office/drawing/2014/main" id="{0F772E77-16D5-40F2-9E29-C94B325DB1A2}"/>
               </a:ext>
             </a:extLst>
           </p:cNvPr>
@@ -13797,7 +13797,7 @@
           <p:cNvPr id="7" name="">
             <a:extLst xmlns:a="http://schemas.openxmlformats.org/drawingml/2006/main">
               <a:ext uri="{FF2B5EF4-FFF2-40B4-BE49-F238E27FC236}">
-                <a16:creationId xmlns:a16="http://schemas.microsoft.com/office/drawing/2014/main" id="{9BD46393-1B7A-4F62-B34C-14BA5874F879}"/>
+                <a16:creationId xmlns:a16="http://schemas.microsoft.com/office/drawing/2014/main" id="{C4CEEA44-A798-410A-8EC7-F6560E24AF28}"/>
               </a:ext>
             </a:extLst>
           </p:cNvPr>
@@ -13860,7 +13860,7 @@
           <p:cNvPr id="8" name="">
             <a:extLst xmlns:a="http://schemas.openxmlformats.org/drawingml/2006/main">
               <a:ext uri="{FF2B5EF4-FFF2-40B4-BE49-F238E27FC236}">
-                <a16:creationId xmlns:a16="http://schemas.microsoft.com/office/drawing/2014/main" id="{47BBD216-B032-43A3-AAB7-C9EEAFD9E3AB}"/>
+                <a16:creationId xmlns:a16="http://schemas.microsoft.com/office/drawing/2014/main" id="{20862B60-4175-4AA4-B8E0-DF537B7D2E87}"/>
               </a:ext>
             </a:extLst>
           </p:cNvPr>
@@ -13923,7 +13923,7 @@
           <p:cNvPr id="9" name="">
             <a:extLst xmlns:a="http://schemas.openxmlformats.org/drawingml/2006/main">
               <a:ext uri="{FF2B5EF4-FFF2-40B4-BE49-F238E27FC236}">
-                <a16:creationId xmlns:a16="http://schemas.microsoft.com/office/drawing/2014/main" id="{D6CEC54F-376F-4E3A-8B60-DCC1C9A95092}"/>
+                <a16:creationId xmlns:a16="http://schemas.microsoft.com/office/drawing/2014/main" id="{9666DDC9-676E-40D3-A2BA-5C2A9D767FA4}"/>
               </a:ext>
             </a:extLst>
           </p:cNvPr>
@@ -13955,7 +13955,7 @@
           <p:cNvPr id="10" name="">
             <a:extLst xmlns:a="http://schemas.openxmlformats.org/drawingml/2006/main">
               <a:ext uri="{FF2B5EF4-FFF2-40B4-BE49-F238E27FC236}">
-                <a16:creationId xmlns:a16="http://schemas.microsoft.com/office/drawing/2014/main" id="{A2819DF1-2CB4-46BF-88ED-FBDB27422303}"/>
+                <a16:creationId xmlns:a16="http://schemas.microsoft.com/office/drawing/2014/main" id="{A8F471FF-00AA-43D8-996E-5CF3B244726A}"/>
               </a:ext>
             </a:extLst>
           </p:cNvPr>
@@ -14018,7 +14018,7 @@
           <p:cNvPr id="11" name="">
             <a:extLst xmlns:a="http://schemas.openxmlformats.org/drawingml/2006/main">
               <a:ext uri="{FF2B5EF4-FFF2-40B4-BE49-F238E27FC236}">
-                <a16:creationId xmlns:a16="http://schemas.microsoft.com/office/drawing/2014/main" id="{D46E9133-21FE-4547-9A9C-96CD8DA53022}"/>
+                <a16:creationId xmlns:a16="http://schemas.microsoft.com/office/drawing/2014/main" id="{7569FAEF-BE80-4352-B7FE-319BCFE97160}"/>
               </a:ext>
             </a:extLst>
           </p:cNvPr>
@@ -14081,7 +14081,7 @@
           <p:cNvPr id="12" name="">
             <a:extLst xmlns:a="http://schemas.openxmlformats.org/drawingml/2006/main">
               <a:ext uri="{FF2B5EF4-FFF2-40B4-BE49-F238E27FC236}">
-                <a16:creationId xmlns:a16="http://schemas.microsoft.com/office/drawing/2014/main" id="{3FA73319-F82A-402C-B0A3-9CDF97387D5E}"/>
+                <a16:creationId xmlns:a16="http://schemas.microsoft.com/office/drawing/2014/main" id="{B0B749A9-D4DE-4148-98B8-A42A647C6AB3}"/>
               </a:ext>
             </a:extLst>
           </p:cNvPr>
@@ -14113,7 +14113,7 @@
           <p:cNvPr id="13" name="">
             <a:extLst xmlns:a="http://schemas.openxmlformats.org/drawingml/2006/main">
               <a:ext uri="{FF2B5EF4-FFF2-40B4-BE49-F238E27FC236}">
-                <a16:creationId xmlns:a16="http://schemas.microsoft.com/office/drawing/2014/main" id="{691DC46A-7A07-4C07-AF28-4B14F0C9F86F}"/>
+                <a16:creationId xmlns:a16="http://schemas.microsoft.com/office/drawing/2014/main" id="{91E8C93B-3758-4A04-BADE-A1EECBF01EF0}"/>
               </a:ext>
             </a:extLst>
           </p:cNvPr>
@@ -14176,7 +14176,7 @@
           <p:cNvPr id="14" name="">
             <a:extLst xmlns:a="http://schemas.openxmlformats.org/drawingml/2006/main">
               <a:ext uri="{FF2B5EF4-FFF2-40B4-BE49-F238E27FC236}">
-                <a16:creationId xmlns:a16="http://schemas.microsoft.com/office/drawing/2014/main" id="{D4FEF28C-3991-46FA-8895-10D0C305DEA4}"/>
+                <a16:creationId xmlns:a16="http://schemas.microsoft.com/office/drawing/2014/main" id="{E1F8C13F-D037-49E8-A31E-63112C68563B}"/>
               </a:ext>
             </a:extLst>
           </p:cNvPr>
@@ -14239,7 +14239,7 @@
           <p:cNvPr id="15" name="">
             <a:extLst xmlns:a="http://schemas.openxmlformats.org/drawingml/2006/main">
               <a:ext uri="{FF2B5EF4-FFF2-40B4-BE49-F238E27FC236}">
-                <a16:creationId xmlns:a16="http://schemas.microsoft.com/office/drawing/2014/main" id="{D3FA0431-6265-46A0-914D-79172491B92A}"/>
+                <a16:creationId xmlns:a16="http://schemas.microsoft.com/office/drawing/2014/main" id="{AF492165-C9E8-4E53-B046-DCCE0CE408BF}"/>
               </a:ext>
             </a:extLst>
           </p:cNvPr>
@@ -14271,7 +14271,7 @@
           <p:cNvPr id="16" name="">
             <a:extLst xmlns:a="http://schemas.openxmlformats.org/drawingml/2006/main">
               <a:ext uri="{FF2B5EF4-FFF2-40B4-BE49-F238E27FC236}">
-                <a16:creationId xmlns:a16="http://schemas.microsoft.com/office/drawing/2014/main" id="{B7199522-597F-4C60-A41D-5E15E0EF713B}"/>
+                <a16:creationId xmlns:a16="http://schemas.microsoft.com/office/drawing/2014/main" id="{AABEFB46-F433-416F-8F3A-5C70CECA5171}"/>
               </a:ext>
             </a:extLst>
           </p:cNvPr>
@@ -14334,7 +14334,7 @@
           <p:cNvPr id="17" name="">
             <a:extLst xmlns:a="http://schemas.openxmlformats.org/drawingml/2006/main">
               <a:ext uri="{FF2B5EF4-FFF2-40B4-BE49-F238E27FC236}">
-                <a16:creationId xmlns:a16="http://schemas.microsoft.com/office/drawing/2014/main" id="{540B0D52-772B-44AC-85F2-17BACE137FA6}"/>
+                <a16:creationId xmlns:a16="http://schemas.microsoft.com/office/drawing/2014/main" id="{830E8488-A5D9-4C93-9B33-251707398963}"/>
               </a:ext>
             </a:extLst>
           </p:cNvPr>
@@ -14397,7 +14397,7 @@
           <p:cNvPr id="18" name="">
             <a:extLst xmlns:a="http://schemas.openxmlformats.org/drawingml/2006/main">
               <a:ext uri="{FF2B5EF4-FFF2-40B4-BE49-F238E27FC236}">
-                <a16:creationId xmlns:a16="http://schemas.microsoft.com/office/drawing/2014/main" id="{F70E59FE-DA8F-4333-ADE7-9EC0F4EB1F9F}"/>
+                <a16:creationId xmlns:a16="http://schemas.microsoft.com/office/drawing/2014/main" id="{737AD6A1-A25B-44C6-8E31-1C490CB593E8}"/>
               </a:ext>
             </a:extLst>
           </p:cNvPr>
@@ -14429,7 +14429,7 @@
           <p:cNvPr id="19" name="">
             <a:extLst xmlns:a="http://schemas.openxmlformats.org/drawingml/2006/main">
               <a:ext uri="{FF2B5EF4-FFF2-40B4-BE49-F238E27FC236}">
-                <a16:creationId xmlns:a16="http://schemas.microsoft.com/office/drawing/2014/main" id="{487D3E18-677B-4E5B-8EE4-E9D2C9CB2282}"/>
+                <a16:creationId xmlns:a16="http://schemas.microsoft.com/office/drawing/2014/main" id="{253F16E2-E389-460C-8863-968470B09545}"/>
               </a:ext>
             </a:extLst>
           </p:cNvPr>
@@ -14492,7 +14492,7 @@
           <p:cNvPr id="20" name="">
             <a:extLst xmlns:a="http://schemas.openxmlformats.org/drawingml/2006/main">
               <a:ext uri="{FF2B5EF4-FFF2-40B4-BE49-F238E27FC236}">
-                <a16:creationId xmlns:a16="http://schemas.microsoft.com/office/drawing/2014/main" id="{4549514B-837C-48B7-94D7-3004C4BBAB54}"/>
+                <a16:creationId xmlns:a16="http://schemas.microsoft.com/office/drawing/2014/main" id="{913A8E35-5AD2-4A0C-8D2B-7AE15B8902CE}"/>
               </a:ext>
             </a:extLst>
           </p:cNvPr>
@@ -14555,7 +14555,7 @@
           <p:cNvPr id="21" name="">
             <a:extLst xmlns:a="http://schemas.openxmlformats.org/drawingml/2006/main">
               <a:ext uri="{FF2B5EF4-FFF2-40B4-BE49-F238E27FC236}">
-                <a16:creationId xmlns:a16="http://schemas.microsoft.com/office/drawing/2014/main" id="{10126138-CDE4-4A4F-BCB6-38415EB3B4D6}"/>
+                <a16:creationId xmlns:a16="http://schemas.microsoft.com/office/drawing/2014/main" id="{879BD98A-7B96-43B8-92DE-DBCC52DFAA6F}"/>
               </a:ext>
             </a:extLst>
           </p:cNvPr>
@@ -14587,7 +14587,7 @@
           <p:cNvPr id="22" name="">
             <a:extLst xmlns:a="http://schemas.openxmlformats.org/drawingml/2006/main">
               <a:ext uri="{FF2B5EF4-FFF2-40B4-BE49-F238E27FC236}">
-                <a16:creationId xmlns:a16="http://schemas.microsoft.com/office/drawing/2014/main" id="{1E59832D-9A95-49DE-B1DA-2B0D622E5458}"/>
+                <a16:creationId xmlns:a16="http://schemas.microsoft.com/office/drawing/2014/main" id="{119826F4-4907-47C1-8902-A5686EA19D87}"/>
               </a:ext>
             </a:extLst>
           </p:cNvPr>
@@ -14650,7 +14650,7 @@
           <p:cNvPr id="23" name="">
             <a:extLst xmlns:a="http://schemas.openxmlformats.org/drawingml/2006/main">
               <a:ext uri="{FF2B5EF4-FFF2-40B4-BE49-F238E27FC236}">
-                <a16:creationId xmlns:a16="http://schemas.microsoft.com/office/drawing/2014/main" id="{907EEB81-B6B7-4CBC-84C3-69F4D3E4D5F7}"/>
+                <a16:creationId xmlns:a16="http://schemas.microsoft.com/office/drawing/2014/main" id="{039172AE-EE20-4062-8723-3594206A7E08}"/>
               </a:ext>
             </a:extLst>
           </p:cNvPr>
@@ -14713,7 +14713,7 @@
           <p:cNvPr id="24" name="">
             <a:extLst xmlns:a="http://schemas.openxmlformats.org/drawingml/2006/main">
               <a:ext uri="{FF2B5EF4-FFF2-40B4-BE49-F238E27FC236}">
-                <a16:creationId xmlns:a16="http://schemas.microsoft.com/office/drawing/2014/main" id="{768E3F42-84BA-4ABD-9A69-B6F19F126643}"/>
+                <a16:creationId xmlns:a16="http://schemas.microsoft.com/office/drawing/2014/main" id="{ADFF53F3-A797-41B8-96E4-61413892DF36}"/>
               </a:ext>
             </a:extLst>
           </p:cNvPr>
@@ -14745,7 +14745,7 @@
           <p:cNvPr id="25" name="">
             <a:extLst xmlns:a="http://schemas.openxmlformats.org/drawingml/2006/main">
               <a:ext uri="{FF2B5EF4-FFF2-40B4-BE49-F238E27FC236}">
-                <a16:creationId xmlns:a16="http://schemas.microsoft.com/office/drawing/2014/main" id="{C1F241DC-4D7E-49D5-9325-F305C95F3A4D}"/>
+                <a16:creationId xmlns:a16="http://schemas.microsoft.com/office/drawing/2014/main" id="{127D625D-1266-41F9-8B07-39946E133657}"/>
               </a:ext>
             </a:extLst>
           </p:cNvPr>
@@ -14808,7 +14808,7 @@
           <p:cNvPr id="26" name="">
             <a:extLst xmlns:a="http://schemas.openxmlformats.org/drawingml/2006/main">
               <a:ext uri="{FF2B5EF4-FFF2-40B4-BE49-F238E27FC236}">
-                <a16:creationId xmlns:a16="http://schemas.microsoft.com/office/drawing/2014/main" id="{4EE4FA4F-FD6B-4EFC-861B-EC2735F18328}"/>
+                <a16:creationId xmlns:a16="http://schemas.microsoft.com/office/drawing/2014/main" id="{A95CD9BB-737F-4737-9D8B-3CAA969898A4}"/>
               </a:ext>
             </a:extLst>
           </p:cNvPr>
@@ -14871,7 +14871,7 @@
           <p:cNvPr id="27" name="">
             <a:extLst xmlns:a="http://schemas.openxmlformats.org/drawingml/2006/main">
               <a:ext uri="{FF2B5EF4-FFF2-40B4-BE49-F238E27FC236}">
-                <a16:creationId xmlns:a16="http://schemas.microsoft.com/office/drawing/2014/main" id="{50C83181-4396-469A-986E-357AAEB86AD5}"/>
+                <a16:creationId xmlns:a16="http://schemas.microsoft.com/office/drawing/2014/main" id="{9331D46A-5E8A-4DC0-9939-CB2A95598BEB}"/>
               </a:ext>
             </a:extLst>
           </p:cNvPr>
@@ -14903,7 +14903,7 @@
           <p:cNvPr id="28" name="">
             <a:extLst xmlns:a="http://schemas.openxmlformats.org/drawingml/2006/main">
               <a:ext uri="{FF2B5EF4-FFF2-40B4-BE49-F238E27FC236}">
-                <a16:creationId xmlns:a16="http://schemas.microsoft.com/office/drawing/2014/main" id="{36AC28F3-8FA6-4306-BFED-402AACDF4525}"/>
+                <a16:creationId xmlns:a16="http://schemas.microsoft.com/office/drawing/2014/main" id="{A26F2186-73E2-4C7B-9293-AC22E2FFA7D5}"/>
               </a:ext>
             </a:extLst>
           </p:cNvPr>
@@ -14966,7 +14966,7 @@
           <p:cNvPr id="29" name="">
             <a:extLst xmlns:a="http://schemas.openxmlformats.org/drawingml/2006/main">
               <a:ext uri="{FF2B5EF4-FFF2-40B4-BE49-F238E27FC236}">
-                <a16:creationId xmlns:a16="http://schemas.microsoft.com/office/drawing/2014/main" id="{EB48F71A-819C-4AF0-B0B9-C64E3F9DB4E7}"/>
+                <a16:creationId xmlns:a16="http://schemas.microsoft.com/office/drawing/2014/main" id="{3F252646-6106-4568-A8B8-BB062F4C9B8D}"/>
               </a:ext>
             </a:extLst>
           </p:cNvPr>
@@ -15029,7 +15029,7 @@
           <p:cNvPr id="30" name="">
             <a:extLst xmlns:a="http://schemas.openxmlformats.org/drawingml/2006/main">
               <a:ext uri="{FF2B5EF4-FFF2-40B4-BE49-F238E27FC236}">
-                <a16:creationId xmlns:a16="http://schemas.microsoft.com/office/drawing/2014/main" id="{481CADBC-570B-45CD-AD65-FBA7EC025023}"/>
+                <a16:creationId xmlns:a16="http://schemas.microsoft.com/office/drawing/2014/main" id="{45FFEE00-7D2B-4482-B970-3B9E104286E9}"/>
               </a:ext>
             </a:extLst>
           </p:cNvPr>
@@ -15061,7 +15061,7 @@
           <p:cNvPr id="31" name="">
             <a:extLst xmlns:a="http://schemas.openxmlformats.org/drawingml/2006/main">
               <a:ext uri="{FF2B5EF4-FFF2-40B4-BE49-F238E27FC236}">
-                <a16:creationId xmlns:a16="http://schemas.microsoft.com/office/drawing/2014/main" id="{95F91BEB-996E-4F2E-90F2-33C1F9BB8051}"/>
+                <a16:creationId xmlns:a16="http://schemas.microsoft.com/office/drawing/2014/main" id="{F83B3AFF-F6C9-4F39-853F-AE034C6FBDD1}"/>
               </a:ext>
             </a:extLst>
           </p:cNvPr>
@@ -15124,7 +15124,7 @@
           <p:cNvPr id="32" name="">
             <a:extLst xmlns:a="http://schemas.openxmlformats.org/drawingml/2006/main">
               <a:ext uri="{FF2B5EF4-FFF2-40B4-BE49-F238E27FC236}">
-                <a16:creationId xmlns:a16="http://schemas.microsoft.com/office/drawing/2014/main" id="{FE48A186-B929-40ED-90C7-C2FE66A0C2A0}"/>
+                <a16:creationId xmlns:a16="http://schemas.microsoft.com/office/drawing/2014/main" id="{78BF5452-471B-4E71-985F-BA6C2CEE8299}"/>
               </a:ext>
             </a:extLst>
           </p:cNvPr>
@@ -15187,7 +15187,7 @@
           <p:cNvPr id="33" name="">
             <a:extLst xmlns:a="http://schemas.openxmlformats.org/drawingml/2006/main">
               <a:ext uri="{FF2B5EF4-FFF2-40B4-BE49-F238E27FC236}">
-                <a16:creationId xmlns:a16="http://schemas.microsoft.com/office/drawing/2014/main" id="{771C22BC-1241-4FA5-8BA9-36936663E200}"/>
+                <a16:creationId xmlns:a16="http://schemas.microsoft.com/office/drawing/2014/main" id="{39973831-B340-40DC-AB3D-89E9D0049B24}"/>
               </a:ext>
             </a:extLst>
           </p:cNvPr>
@@ -15219,7 +15219,7 @@
           <p:cNvPr id="34" name="">
             <a:extLst xmlns:a="http://schemas.openxmlformats.org/drawingml/2006/main">
               <a:ext uri="{FF2B5EF4-FFF2-40B4-BE49-F238E27FC236}">
-                <a16:creationId xmlns:a16="http://schemas.microsoft.com/office/drawing/2014/main" id="{8C45D86E-17CB-4C11-9438-EFCBB1BB2164}"/>
+                <a16:creationId xmlns:a16="http://schemas.microsoft.com/office/drawing/2014/main" id="{A70152F0-956C-4D94-BED9-F7E7B834A12A}"/>
               </a:ext>
             </a:extLst>
           </p:cNvPr>
@@ -15282,7 +15282,7 @@
           <p:cNvPr id="35" name="">
             <a:extLst xmlns:a="http://schemas.openxmlformats.org/drawingml/2006/main">
               <a:ext uri="{FF2B5EF4-FFF2-40B4-BE49-F238E27FC236}">
-                <a16:creationId xmlns:a16="http://schemas.microsoft.com/office/drawing/2014/main" id="{AB6E102D-48C8-4DE4-8FAD-F57C04895815}"/>
+                <a16:creationId xmlns:a16="http://schemas.microsoft.com/office/drawing/2014/main" id="{B888558F-0923-4C28-B583-0C709B10DB53}"/>
               </a:ext>
             </a:extLst>
           </p:cNvPr>
@@ -15345,7 +15345,7 @@
           <p:cNvPr id="36" name="">
             <a:extLst xmlns:a="http://schemas.openxmlformats.org/drawingml/2006/main">
               <a:ext uri="{FF2B5EF4-FFF2-40B4-BE49-F238E27FC236}">
-                <a16:creationId xmlns:a16="http://schemas.microsoft.com/office/drawing/2014/main" id="{D7799461-1054-45CA-9978-3D802566AE9C}"/>
+                <a16:creationId xmlns:a16="http://schemas.microsoft.com/office/drawing/2014/main" id="{500F7BDA-954C-48C0-B42E-B35A0E29D9E6}"/>
               </a:ext>
             </a:extLst>
           </p:cNvPr>
@@ -15377,7 +15377,7 @@
           <p:cNvPr id="37" name="">
             <a:extLst xmlns:a="http://schemas.openxmlformats.org/drawingml/2006/main">
               <a:ext uri="{FF2B5EF4-FFF2-40B4-BE49-F238E27FC236}">
-                <a16:creationId xmlns:a16="http://schemas.microsoft.com/office/drawing/2014/main" id="{FFF2654F-97D2-4891-B88C-59B8DD6AE60E}"/>
+                <a16:creationId xmlns:a16="http://schemas.microsoft.com/office/drawing/2014/main" id="{9245D438-94F6-45E2-BD0D-F72869556E67}"/>
               </a:ext>
             </a:extLst>
           </p:cNvPr>
@@ -15440,7 +15440,7 @@
           <p:cNvPr id="38" name="">
             <a:extLst xmlns:a="http://schemas.openxmlformats.org/drawingml/2006/main">
               <a:ext uri="{FF2B5EF4-FFF2-40B4-BE49-F238E27FC236}">
-                <a16:creationId xmlns:a16="http://schemas.microsoft.com/office/drawing/2014/main" id="{175FAA24-4CDB-463B-9C54-FC7EC25B8CF1}"/>
+                <a16:creationId xmlns:a16="http://schemas.microsoft.com/office/drawing/2014/main" id="{65F10F63-CB76-4006-A37F-DEBF7221DB6A}"/>
               </a:ext>
             </a:extLst>
           </p:cNvPr>
@@ -15503,7 +15503,7 @@
           <p:cNvPr id="39" name="">
             <a:extLst xmlns:a="http://schemas.openxmlformats.org/drawingml/2006/main">
               <a:ext uri="{FF2B5EF4-FFF2-40B4-BE49-F238E27FC236}">
-                <a16:creationId xmlns:a16="http://schemas.microsoft.com/office/drawing/2014/main" id="{C47780EB-2B52-498B-AA54-A28F3A06609C}"/>
+                <a16:creationId xmlns:a16="http://schemas.microsoft.com/office/drawing/2014/main" id="{DF678264-52AA-4666-929A-3156A244A316}"/>
               </a:ext>
             </a:extLst>
           </p:cNvPr>
@@ -15535,7 +15535,7 @@
           <p:cNvPr id="40" name="">
             <a:extLst xmlns:a="http://schemas.openxmlformats.org/drawingml/2006/main">
               <a:ext uri="{FF2B5EF4-FFF2-40B4-BE49-F238E27FC236}">
-                <a16:creationId xmlns:a16="http://schemas.microsoft.com/office/drawing/2014/main" id="{DDD335BD-8BD5-4909-BF8B-1F2704DAF80F}"/>
+                <a16:creationId xmlns:a16="http://schemas.microsoft.com/office/drawing/2014/main" id="{0CFE92B0-5E44-4837-B923-A5FEBB741823}"/>
               </a:ext>
             </a:extLst>
           </p:cNvPr>
@@ -15598,7 +15598,7 @@
           <p:cNvPr id="41" name="">
             <a:extLst xmlns:a="http://schemas.openxmlformats.org/drawingml/2006/main">
               <a:ext uri="{FF2B5EF4-FFF2-40B4-BE49-F238E27FC236}">
-                <a16:creationId xmlns:a16="http://schemas.microsoft.com/office/drawing/2014/main" id="{2ABE7E19-6E1F-4169-8452-820A72F3E9E1}"/>
+                <a16:creationId xmlns:a16="http://schemas.microsoft.com/office/drawing/2014/main" id="{5E7783B2-8358-4BB1-AC64-2BF86C638049}"/>
               </a:ext>
             </a:extLst>
           </p:cNvPr>
@@ -15661,7 +15661,7 @@
           <p:cNvPr id="42" name="">
             <a:extLst xmlns:a="http://schemas.openxmlformats.org/drawingml/2006/main">
               <a:ext uri="{FF2B5EF4-FFF2-40B4-BE49-F238E27FC236}">
-                <a16:creationId xmlns:a16="http://schemas.microsoft.com/office/drawing/2014/main" id="{C2001BCA-1E37-4499-A9E1-AE0E11B82886}"/>
+                <a16:creationId xmlns:a16="http://schemas.microsoft.com/office/drawing/2014/main" id="{EDE6B86C-943E-4202-97D8-0708324E9B71}"/>
               </a:ext>
             </a:extLst>
           </p:cNvPr>
@@ -15693,7 +15693,7 @@
           <p:cNvPr id="43" name="">
             <a:extLst xmlns:a="http://schemas.openxmlformats.org/drawingml/2006/main">
               <a:ext uri="{FF2B5EF4-FFF2-40B4-BE49-F238E27FC236}">
-                <a16:creationId xmlns:a16="http://schemas.microsoft.com/office/drawing/2014/main" id="{07BF79FE-7767-42FD-9522-091BE766D17C}"/>
+                <a16:creationId xmlns:a16="http://schemas.microsoft.com/office/drawing/2014/main" id="{1D9B6D1A-3C3A-4342-8A61-E52C18B59417}"/>
               </a:ext>
             </a:extLst>
           </p:cNvPr>
@@ -15756,7 +15756,7 @@
           <p:cNvPr id="44" name="">
             <a:extLst xmlns:a="http://schemas.openxmlformats.org/drawingml/2006/main">
               <a:ext uri="{FF2B5EF4-FFF2-40B4-BE49-F238E27FC236}">
-                <a16:creationId xmlns:a16="http://schemas.microsoft.com/office/drawing/2014/main" id="{4E92B6D5-A925-4E57-A99A-B8385AC3D9DA}"/>
+                <a16:creationId xmlns:a16="http://schemas.microsoft.com/office/drawing/2014/main" id="{ADAFD550-A437-4359-B28C-FDDACC1F5A6F}"/>
               </a:ext>
             </a:extLst>
           </p:cNvPr>
@@ -15819,7 +15819,7 @@
           <p:cNvPr id="45" name="">
             <a:extLst xmlns:a="http://schemas.openxmlformats.org/drawingml/2006/main">
               <a:ext uri="{FF2B5EF4-FFF2-40B4-BE49-F238E27FC236}">
-                <a16:creationId xmlns:a16="http://schemas.microsoft.com/office/drawing/2014/main" id="{83CD0C83-8D65-45E4-9D23-B7D276993EEE}"/>
+                <a16:creationId xmlns:a16="http://schemas.microsoft.com/office/drawing/2014/main" id="{2457844C-0313-47ED-B0DD-28EDF6C1854A}"/>
               </a:ext>
             </a:extLst>
           </p:cNvPr>
@@ -15851,7 +15851,7 @@
           <p:cNvPr id="46" name="">
             <a:extLst xmlns:a="http://schemas.openxmlformats.org/drawingml/2006/main">
               <a:ext uri="{FF2B5EF4-FFF2-40B4-BE49-F238E27FC236}">
-                <a16:creationId xmlns:a16="http://schemas.microsoft.com/office/drawing/2014/main" id="{8CA26869-1B19-4446-B180-F495C20A39B9}"/>
+                <a16:creationId xmlns:a16="http://schemas.microsoft.com/office/drawing/2014/main" id="{606C9B9A-772D-4666-8645-2F43F4A4112D}"/>
               </a:ext>
             </a:extLst>
           </p:cNvPr>
@@ -15914,7 +15914,7 @@
           <p:cNvPr id="47" name="">
             <a:extLst xmlns:a="http://schemas.openxmlformats.org/drawingml/2006/main">
               <a:ext uri="{FF2B5EF4-FFF2-40B4-BE49-F238E27FC236}">
-                <a16:creationId xmlns:a16="http://schemas.microsoft.com/office/drawing/2014/main" id="{ADEAB4DF-E0DF-4C4D-A550-BBF9FD43E5E5}"/>
+                <a16:creationId xmlns:a16="http://schemas.microsoft.com/office/drawing/2014/main" id="{5A960454-B20B-4BFF-A202-A32D457C2AAC}"/>
               </a:ext>
             </a:extLst>
           </p:cNvPr>
@@ -15977,7 +15977,7 @@
           <p:cNvPr id="48" name="">
             <a:extLst xmlns:a="http://schemas.openxmlformats.org/drawingml/2006/main">
               <a:ext uri="{FF2B5EF4-FFF2-40B4-BE49-F238E27FC236}">
-                <a16:creationId xmlns:a16="http://schemas.microsoft.com/office/drawing/2014/main" id="{B672305A-82FD-4B66-89A0-D654C58DB02A}"/>
+                <a16:creationId xmlns:a16="http://schemas.microsoft.com/office/drawing/2014/main" id="{5F2B6C46-EF6E-43A4-BAAE-435FAE74BF0A}"/>
               </a:ext>
             </a:extLst>
           </p:cNvPr>
@@ -16009,7 +16009,7 @@
           <p:cNvPr id="49" name="">
             <a:extLst xmlns:a="http://schemas.openxmlformats.org/drawingml/2006/main">
               <a:ext uri="{FF2B5EF4-FFF2-40B4-BE49-F238E27FC236}">
-                <a16:creationId xmlns:a16="http://schemas.microsoft.com/office/drawing/2014/main" id="{0D3FB0FF-D33F-496B-9268-6BEAC68ADC2B}"/>
+                <a16:creationId xmlns:a16="http://schemas.microsoft.com/office/drawing/2014/main" id="{E927F704-B750-455F-AB51-50CEDF8251CF}"/>
               </a:ext>
             </a:extLst>
           </p:cNvPr>
@@ -16072,7 +16072,7 @@
           <p:cNvPr id="50" name="">
             <a:extLst xmlns:a="http://schemas.openxmlformats.org/drawingml/2006/main">
               <a:ext uri="{FF2B5EF4-FFF2-40B4-BE49-F238E27FC236}">
-                <a16:creationId xmlns:a16="http://schemas.microsoft.com/office/drawing/2014/main" id="{5CF13D22-A252-471E-ABDB-C3887900210F}"/>
+                <a16:creationId xmlns:a16="http://schemas.microsoft.com/office/drawing/2014/main" id="{64CC5159-93BB-44E5-8BCF-3A1CA83DDC94}"/>
               </a:ext>
             </a:extLst>
           </p:cNvPr>
@@ -16135,7 +16135,7 @@
           <p:cNvPr id="51" name="">
             <a:extLst xmlns:a="http://schemas.openxmlformats.org/drawingml/2006/main">
               <a:ext uri="{FF2B5EF4-FFF2-40B4-BE49-F238E27FC236}">
-                <a16:creationId xmlns:a16="http://schemas.microsoft.com/office/drawing/2014/main" id="{10848BB5-0CBE-4ED7-8FB3-433C629EFCBA}"/>
+                <a16:creationId xmlns:a16="http://schemas.microsoft.com/office/drawing/2014/main" id="{4E106983-BD97-4EA3-85DC-0F1633024601}"/>
               </a:ext>
             </a:extLst>
           </p:cNvPr>
@@ -16167,7 +16167,7 @@
           <p:cNvPr id="52" name="">
             <a:extLst xmlns:a="http://schemas.openxmlformats.org/drawingml/2006/main">
               <a:ext uri="{FF2B5EF4-FFF2-40B4-BE49-F238E27FC236}">
-                <a16:creationId xmlns:a16="http://schemas.microsoft.com/office/drawing/2014/main" id="{DECBA539-7D17-414D-965C-694A5790DB2E}"/>
+                <a16:creationId xmlns:a16="http://schemas.microsoft.com/office/drawing/2014/main" id="{A0ECF009-55D4-4A0A-A1E3-E442CE51A735}"/>
               </a:ext>
             </a:extLst>
           </p:cNvPr>
@@ -16230,7 +16230,7 @@
           <p:cNvPr id="53" name="">
             <a:extLst xmlns:a="http://schemas.openxmlformats.org/drawingml/2006/main">
               <a:ext uri="{FF2B5EF4-FFF2-40B4-BE49-F238E27FC236}">
-                <a16:creationId xmlns:a16="http://schemas.microsoft.com/office/drawing/2014/main" id="{B52952FF-82FC-4105-920D-69A3E3FD3C08}"/>
+                <a16:creationId xmlns:a16="http://schemas.microsoft.com/office/drawing/2014/main" id="{1BE12676-9D1F-45EF-A514-AE74F66A5A01}"/>
               </a:ext>
             </a:extLst>
           </p:cNvPr>
@@ -16293,7 +16293,7 @@
           <p:cNvPr id="54" name="">
             <a:extLst xmlns:a="http://schemas.openxmlformats.org/drawingml/2006/main">
               <a:ext uri="{FF2B5EF4-FFF2-40B4-BE49-F238E27FC236}">
-                <a16:creationId xmlns:a16="http://schemas.microsoft.com/office/drawing/2014/main" id="{B93AFFC1-A613-4259-85C3-9A582FAE39CC}"/>
+                <a16:creationId xmlns:a16="http://schemas.microsoft.com/office/drawing/2014/main" id="{728303C2-8110-4D4B-8F47-5F7D3FAB8F77}"/>
               </a:ext>
             </a:extLst>
           </p:cNvPr>
@@ -16325,7 +16325,7 @@
           <p:cNvPr id="55" name="">
             <a:extLst xmlns:a="http://schemas.openxmlformats.org/drawingml/2006/main">
               <a:ext uri="{FF2B5EF4-FFF2-40B4-BE49-F238E27FC236}">
-                <a16:creationId xmlns:a16="http://schemas.microsoft.com/office/drawing/2014/main" id="{8CE93E9E-5C3E-4F4C-89B4-E4E8409E6C7D}"/>
+                <a16:creationId xmlns:a16="http://schemas.microsoft.com/office/drawing/2014/main" id="{519EE5E5-7614-4AF7-A079-B1CE3FE4BEAD}"/>
               </a:ext>
             </a:extLst>
           </p:cNvPr>
@@ -16388,7 +16388,7 @@
           <p:cNvPr id="56" name="">
             <a:extLst xmlns:a="http://schemas.openxmlformats.org/drawingml/2006/main">
               <a:ext uri="{FF2B5EF4-FFF2-40B4-BE49-F238E27FC236}">
-                <a16:creationId xmlns:a16="http://schemas.microsoft.com/office/drawing/2014/main" id="{197223D1-EA92-4543-8ABC-ECA2D2400A5F}"/>
+                <a16:creationId xmlns:a16="http://schemas.microsoft.com/office/drawing/2014/main" id="{4002D0A3-F56C-44DF-A6E6-1D6C0FCE1A6C}"/>
               </a:ext>
             </a:extLst>
           </p:cNvPr>
@@ -16451,7 +16451,7 @@
           <p:cNvPr id="57" name="">
             <a:extLst xmlns:a="http://schemas.openxmlformats.org/drawingml/2006/main">
               <a:ext uri="{FF2B5EF4-FFF2-40B4-BE49-F238E27FC236}">
-                <a16:creationId xmlns:a16="http://schemas.microsoft.com/office/drawing/2014/main" id="{ECD2B810-FDFE-44D4-A53E-2C6A57F64FA1}"/>
+                <a16:creationId xmlns:a16="http://schemas.microsoft.com/office/drawing/2014/main" id="{7625CE7E-C751-4F41-A4CB-295DB1BF678C}"/>
               </a:ext>
             </a:extLst>
           </p:cNvPr>
@@ -16483,7 +16483,7 @@
           <p:cNvPr id="58" name="">
             <a:extLst xmlns:a="http://schemas.openxmlformats.org/drawingml/2006/main">
               <a:ext uri="{FF2B5EF4-FFF2-40B4-BE49-F238E27FC236}">
-                <a16:creationId xmlns:a16="http://schemas.microsoft.com/office/drawing/2014/main" id="{C23D4CF3-4A75-41E7-BB46-9CFCE638B50E}"/>
+                <a16:creationId xmlns:a16="http://schemas.microsoft.com/office/drawing/2014/main" id="{E99EE062-60E9-4BB3-BEA0-8A36A7E66E53}"/>
               </a:ext>
             </a:extLst>
           </p:cNvPr>
@@ -16546,7 +16546,7 @@
           <p:cNvPr id="59" name="">
             <a:extLst xmlns:a="http://schemas.openxmlformats.org/drawingml/2006/main">
               <a:ext uri="{FF2B5EF4-FFF2-40B4-BE49-F238E27FC236}">
-                <a16:creationId xmlns:a16="http://schemas.microsoft.com/office/drawing/2014/main" id="{0C2D8D4F-3689-4EE3-A966-76EF9D63CC3A}"/>
+                <a16:creationId xmlns:a16="http://schemas.microsoft.com/office/drawing/2014/main" id="{09D22FD6-6B54-4370-A9C9-A6F90FE9A2B3}"/>
               </a:ext>
             </a:extLst>
           </p:cNvPr>
@@ -16609,7 +16609,7 @@
           <p:cNvPr id="60" name="">
             <a:extLst xmlns:a="http://schemas.openxmlformats.org/drawingml/2006/main">
               <a:ext uri="{FF2B5EF4-FFF2-40B4-BE49-F238E27FC236}">
-                <a16:creationId xmlns:a16="http://schemas.microsoft.com/office/drawing/2014/main" id="{BCB4F85F-D95F-457D-90CC-3BB6E7436163}"/>
+                <a16:creationId xmlns:a16="http://schemas.microsoft.com/office/drawing/2014/main" id="{8799939D-6B26-4920-9CCD-F4088C9C683A}"/>
               </a:ext>
             </a:extLst>
           </p:cNvPr>
@@ -16641,7 +16641,7 @@
           <p:cNvPr id="61" name="">
             <a:extLst xmlns:a="http://schemas.openxmlformats.org/drawingml/2006/main">
               <a:ext uri="{FF2B5EF4-FFF2-40B4-BE49-F238E27FC236}">
-                <a16:creationId xmlns:a16="http://schemas.microsoft.com/office/drawing/2014/main" id="{0E7E538A-2ACA-49F1-A4EB-94026C120110}"/>
+                <a16:creationId xmlns:a16="http://schemas.microsoft.com/office/drawing/2014/main" id="{D594A95A-0BA6-4598-AB67-273DA540E5B7}"/>
               </a:ext>
             </a:extLst>
           </p:cNvPr>
@@ -16704,7 +16704,7 @@
           <p:cNvPr id="62" name="">
             <a:extLst xmlns:a="http://schemas.openxmlformats.org/drawingml/2006/main">
               <a:ext uri="{FF2B5EF4-FFF2-40B4-BE49-F238E27FC236}">
-                <a16:creationId xmlns:a16="http://schemas.microsoft.com/office/drawing/2014/main" id="{0E42568B-502F-4A58-A77E-8C250151E733}"/>
+                <a16:creationId xmlns:a16="http://schemas.microsoft.com/office/drawing/2014/main" id="{B37BC3B8-8F45-49CF-AFCA-8F485BB7A866}"/>
               </a:ext>
             </a:extLst>
           </p:cNvPr>
@@ -16767,7 +16767,7 @@
           <p:cNvPr id="63" name="">
             <a:extLst xmlns:a="http://schemas.openxmlformats.org/drawingml/2006/main">
               <a:ext uri="{FF2B5EF4-FFF2-40B4-BE49-F238E27FC236}">
-                <a16:creationId xmlns:a16="http://schemas.microsoft.com/office/drawing/2014/main" id="{633BEB2A-042C-42DD-BDE2-0761737D1A35}"/>
+                <a16:creationId xmlns:a16="http://schemas.microsoft.com/office/drawing/2014/main" id="{C4784276-2815-4C3E-BB66-74271B05E7E6}"/>
               </a:ext>
             </a:extLst>
           </p:cNvPr>
@@ -16799,7 +16799,7 @@
           <p:cNvPr id="64" name="">
             <a:extLst xmlns:a="http://schemas.openxmlformats.org/drawingml/2006/main">
               <a:ext uri="{FF2B5EF4-FFF2-40B4-BE49-F238E27FC236}">
-                <a16:creationId xmlns:a16="http://schemas.microsoft.com/office/drawing/2014/main" id="{68973703-F186-4BCE-BB52-D077CE93B8BA}"/>
+                <a16:creationId xmlns:a16="http://schemas.microsoft.com/office/drawing/2014/main" id="{8052EE5C-FA71-49D8-9393-FA157E925B2A}"/>
               </a:ext>
             </a:extLst>
           </p:cNvPr>
@@ -16862,7 +16862,7 @@
           <p:cNvPr id="65" name="">
             <a:extLst xmlns:a="http://schemas.openxmlformats.org/drawingml/2006/main">
               <a:ext uri="{FF2B5EF4-FFF2-40B4-BE49-F238E27FC236}">
-                <a16:creationId xmlns:a16="http://schemas.microsoft.com/office/drawing/2014/main" id="{CCA0B313-F0EA-4DB7-87ED-17837FA63DDD}"/>
+                <a16:creationId xmlns:a16="http://schemas.microsoft.com/office/drawing/2014/main" id="{73330BA9-8F30-4A96-BC79-70E40DF418AB}"/>
               </a:ext>
             </a:extLst>
           </p:cNvPr>
@@ -16894,7 +16894,7 @@
           <p:cNvPr id="66" name="">
             <a:extLst xmlns:a="http://schemas.openxmlformats.org/drawingml/2006/main">
               <a:ext uri="{FF2B5EF4-FFF2-40B4-BE49-F238E27FC236}">
-                <a16:creationId xmlns:a16="http://schemas.microsoft.com/office/drawing/2014/main" id="{B287605D-B936-481A-B578-2134630AD34C}"/>
+                <a16:creationId xmlns:a16="http://schemas.microsoft.com/office/drawing/2014/main" id="{A55CB807-601E-433F-955A-4BB859CF90B2}"/>
               </a:ext>
             </a:extLst>
           </p:cNvPr>
@@ -16926,7 +16926,7 @@
           <p:cNvPr id="67" name="">
             <a:extLst xmlns:a="http://schemas.openxmlformats.org/drawingml/2006/main">
               <a:ext uri="{FF2B5EF4-FFF2-40B4-BE49-F238E27FC236}">
-                <a16:creationId xmlns:a16="http://schemas.microsoft.com/office/drawing/2014/main" id="{8CB91AD7-6770-445D-AD46-7B4AA42EF728}"/>
+                <a16:creationId xmlns:a16="http://schemas.microsoft.com/office/drawing/2014/main" id="{4EAB83EC-FB0B-4B81-A4A8-B7801BFA3007}"/>
               </a:ext>
             </a:extLst>
           </p:cNvPr>
@@ -16989,7 +16989,7 @@
           <p:cNvPr id="68" name="">
             <a:extLst xmlns:a="http://schemas.openxmlformats.org/drawingml/2006/main">
               <a:ext uri="{FF2B5EF4-FFF2-40B4-BE49-F238E27FC236}">
-                <a16:creationId xmlns:a16="http://schemas.microsoft.com/office/drawing/2014/main" id="{69059A25-122F-49CB-BD7F-FCFD9EEB0005}"/>
+                <a16:creationId xmlns:a16="http://schemas.microsoft.com/office/drawing/2014/main" id="{62F0B85B-2560-442E-9DE9-E355C0A4AEDF}"/>
               </a:ext>
             </a:extLst>
           </p:cNvPr>
@@ -17056,7 +17056,7 @@
           <p:cNvPr id="69" name="">
             <a:extLst xmlns:a="http://schemas.openxmlformats.org/drawingml/2006/main">
               <a:ext uri="{FF2B5EF4-FFF2-40B4-BE49-F238E27FC236}">
-                <a16:creationId xmlns:a16="http://schemas.microsoft.com/office/drawing/2014/main" id="{016004D5-B0B6-4DEC-B0A0-BCED38C40FBE}"/>
+                <a16:creationId xmlns:a16="http://schemas.microsoft.com/office/drawing/2014/main" id="{43FC03E6-7299-4231-B62A-2099F9BE1A41}"/>
               </a:ext>
             </a:extLst>
           </p:cNvPr>
@@ -17088,7 +17088,7 @@
           <p:cNvPr id="70" name="">
             <a:extLst xmlns:a="http://schemas.openxmlformats.org/drawingml/2006/main">
               <a:ext uri="{FF2B5EF4-FFF2-40B4-BE49-F238E27FC236}">
-                <a16:creationId xmlns:a16="http://schemas.microsoft.com/office/drawing/2014/main" id="{C2C2F685-E89C-4EF4-AD94-5ADACA1B9305}"/>
+                <a16:creationId xmlns:a16="http://schemas.microsoft.com/office/drawing/2014/main" id="{53CAA86D-0987-40F2-91DF-09ECC8506625}"/>
               </a:ext>
             </a:extLst>
           </p:cNvPr>
@@ -17120,7 +17120,7 @@
           <p:cNvPr id="71" name="">
             <a:extLst xmlns:a="http://schemas.openxmlformats.org/drawingml/2006/main">
               <a:ext uri="{FF2B5EF4-FFF2-40B4-BE49-F238E27FC236}">
-                <a16:creationId xmlns:a16="http://schemas.microsoft.com/office/drawing/2014/main" id="{C9684735-8F0C-4C53-90E0-88BAE0C2002B}"/>
+                <a16:creationId xmlns:a16="http://schemas.microsoft.com/office/drawing/2014/main" id="{81A57CC2-4491-4019-BD1D-DBB529F8447F}"/>
               </a:ext>
             </a:extLst>
           </p:cNvPr>
@@ -17183,7 +17183,7 @@
           <p:cNvPr id="72" name="">
             <a:extLst xmlns:a="http://schemas.openxmlformats.org/drawingml/2006/main">
               <a:ext uri="{FF2B5EF4-FFF2-40B4-BE49-F238E27FC236}">
-                <a16:creationId xmlns:a16="http://schemas.microsoft.com/office/drawing/2014/main" id="{53B625C1-B307-4BEF-8A76-BDCAAC4C7DC3}"/>
+                <a16:creationId xmlns:a16="http://schemas.microsoft.com/office/drawing/2014/main" id="{4BA71FEA-FF0A-4D78-A958-C8A28E333F16}"/>
               </a:ext>
             </a:extLst>
           </p:cNvPr>
@@ -17250,7 +17250,7 @@
           <p:cNvPr id="73" name="">
             <a:extLst xmlns:a="http://schemas.openxmlformats.org/drawingml/2006/main">
               <a:ext uri="{FF2B5EF4-FFF2-40B4-BE49-F238E27FC236}">
-                <a16:creationId xmlns:a16="http://schemas.microsoft.com/office/drawing/2014/main" id="{3E7B2207-1C8B-4C05-BEDB-DD69775EDE9E}"/>
+                <a16:creationId xmlns:a16="http://schemas.microsoft.com/office/drawing/2014/main" id="{94F7EF32-CD38-4DC8-96F4-F51734B61854}"/>
               </a:ext>
             </a:extLst>
           </p:cNvPr>
@@ -17313,7 +17313,7 @@
           <p:cNvPr id="74" name="">
             <a:extLst xmlns:a="http://schemas.openxmlformats.org/drawingml/2006/main">
               <a:ext uri="{FF2B5EF4-FFF2-40B4-BE49-F238E27FC236}">
-                <a16:creationId xmlns:a16="http://schemas.microsoft.com/office/drawing/2014/main" id="{CCC6E45D-6E58-4A59-82F8-04D7A173260A}"/>
+                <a16:creationId xmlns:a16="http://schemas.microsoft.com/office/drawing/2014/main" id="{97108FC0-E548-4BF1-97BB-7CF524E31654}"/>
               </a:ext>
             </a:extLst>
           </p:cNvPr>
@@ -17345,7 +17345,7 @@
           <p:cNvPr id="75" name="">
             <a:extLst xmlns:a="http://schemas.openxmlformats.org/drawingml/2006/main">
               <a:ext uri="{FF2B5EF4-FFF2-40B4-BE49-F238E27FC236}">
-                <a16:creationId xmlns:a16="http://schemas.microsoft.com/office/drawing/2014/main" id="{68959542-3E99-4EA1-8152-D02D0441E060}"/>
+                <a16:creationId xmlns:a16="http://schemas.microsoft.com/office/drawing/2014/main" id="{74031AF1-2087-4FAD-9EAA-BA7F7C662090}"/>
               </a:ext>
             </a:extLst>
           </p:cNvPr>
@@ -17408,7 +17408,7 @@
           <p:cNvPr id="76" name="">
             <a:extLst xmlns:a="http://schemas.openxmlformats.org/drawingml/2006/main">
               <a:ext uri="{FF2B5EF4-FFF2-40B4-BE49-F238E27FC236}">
-                <a16:creationId xmlns:a16="http://schemas.microsoft.com/office/drawing/2014/main" id="{664C379A-3F24-4647-A2BF-406F607E1CEF}"/>
+                <a16:creationId xmlns:a16="http://schemas.microsoft.com/office/drawing/2014/main" id="{A53C5819-989C-410B-A52B-0342D513E41B}"/>
               </a:ext>
             </a:extLst>
           </p:cNvPr>
@@ -17469,7 +17469,7 @@
     </p:spTree>
     <p:extLst>
       <p:ext uri="{BB962C8B-B14F-4D97-AF65-F5344CB8AC3E}">
-        <p14:creationId xmlns:p14="http://schemas.microsoft.com/office/powerpoint/2010/main" val="1001168661"/>
+        <p14:creationId xmlns:p14="http://schemas.microsoft.com/office/powerpoint/2010/main" val="995318522"/>
       </p:ext>
     </p:extLst>
   </p:cSld>
@@ -17500,7 +17500,7 @@
           <p:cNvPr id="1" name="">
             <a:extLst xmlns:a="http://schemas.openxmlformats.org/drawingml/2006/main">
               <a:ext uri="{FF2B5EF4-FFF2-40B4-BE49-F238E27FC236}">
-                <a16:creationId xmlns:a16="http://schemas.microsoft.com/office/drawing/2014/main" id="{A2EBA334-D127-4E73-8FCB-21B36FBF6E6F}"/>
+                <a16:creationId xmlns:a16="http://schemas.microsoft.com/office/drawing/2014/main" id="{D3D738D4-1C1B-4082-AC5A-62095560D8EC}"/>
               </a:ext>
             </a:extLst>
           </p:cNvPr>
@@ -17563,7 +17563,7 @@
           <p:cNvPr id="2" name="">
             <a:extLst xmlns:a="http://schemas.openxmlformats.org/drawingml/2006/main">
               <a:ext uri="{FF2B5EF4-FFF2-40B4-BE49-F238E27FC236}">
-                <a16:creationId xmlns:a16="http://schemas.microsoft.com/office/drawing/2014/main" id="{5B383306-0471-4F1F-A238-B2015C0ECEC7}"/>
+                <a16:creationId xmlns:a16="http://schemas.microsoft.com/office/drawing/2014/main" id="{2F352C8E-CBD3-4FE2-8453-FCC42FF7DE8D}"/>
               </a:ext>
             </a:extLst>
           </p:cNvPr>
@@ -17630,7 +17630,7 @@
           <p:cNvPr id="3" name="">
             <a:extLst xmlns:a="http://schemas.openxmlformats.org/drawingml/2006/main">
               <a:ext uri="{FF2B5EF4-FFF2-40B4-BE49-F238E27FC236}">
-                <a16:creationId xmlns:a16="http://schemas.microsoft.com/office/drawing/2014/main" id="{5065EF85-6A07-46FE-B5AA-D15BD2A6F496}"/>
+                <a16:creationId xmlns:a16="http://schemas.microsoft.com/office/drawing/2014/main" id="{6D73D1EE-AA47-4CA3-AEBD-068693E6CF90}"/>
               </a:ext>
             </a:extLst>
           </p:cNvPr>
@@ -17697,7 +17697,7 @@
           <p:cNvPr id="4" name="">
             <a:extLst xmlns:a="http://schemas.openxmlformats.org/drawingml/2006/main">
               <a:ext uri="{FF2B5EF4-FFF2-40B4-BE49-F238E27FC236}">
-                <a16:creationId xmlns:a16="http://schemas.microsoft.com/office/drawing/2014/main" id="{C53671E2-02F1-47C8-A05E-F59CC8494C5D}"/>
+                <a16:creationId xmlns:a16="http://schemas.microsoft.com/office/drawing/2014/main" id="{8BA441C5-623C-4666-A64C-922834F48843}"/>
               </a:ext>
             </a:extLst>
           </p:cNvPr>
@@ -17729,7 +17729,7 @@
           <p:cNvPr id="5" name="">
             <a:extLst xmlns:a="http://schemas.openxmlformats.org/drawingml/2006/main">
               <a:ext uri="{FF2B5EF4-FFF2-40B4-BE49-F238E27FC236}">
-                <a16:creationId xmlns:a16="http://schemas.microsoft.com/office/drawing/2014/main" id="{7815C358-7ECA-423C-9957-4FB9AA736243}"/>
+                <a16:creationId xmlns:a16="http://schemas.microsoft.com/office/drawing/2014/main" id="{16D72792-960A-495B-B821-AB58FAEE3D9B}"/>
               </a:ext>
             </a:extLst>
           </p:cNvPr>
@@ -17761,7 +17761,7 @@
           <p:cNvPr id="6" name="">
             <a:extLst xmlns:a="http://schemas.openxmlformats.org/drawingml/2006/main">
               <a:ext uri="{FF2B5EF4-FFF2-40B4-BE49-F238E27FC236}">
-                <a16:creationId xmlns:a16="http://schemas.microsoft.com/office/drawing/2014/main" id="{9E7791A2-4ECE-4846-A8C5-21401FABF5F9}"/>
+                <a16:creationId xmlns:a16="http://schemas.microsoft.com/office/drawing/2014/main" id="{B021291A-F8C3-4152-BE7E-F77172BBCC8B}"/>
               </a:ext>
             </a:extLst>
           </p:cNvPr>
@@ -17824,7 +17824,7 @@
           <p:cNvPr id="7" name="">
             <a:extLst xmlns:a="http://schemas.openxmlformats.org/drawingml/2006/main">
               <a:ext uri="{FF2B5EF4-FFF2-40B4-BE49-F238E27FC236}">
-                <a16:creationId xmlns:a16="http://schemas.microsoft.com/office/drawing/2014/main" id="{0006216A-3420-4734-9398-D63895A1CC62}"/>
+                <a16:creationId xmlns:a16="http://schemas.microsoft.com/office/drawing/2014/main" id="{F346C671-7BD5-4157-A630-801FD9876403}"/>
               </a:ext>
             </a:extLst>
           </p:cNvPr>
@@ -17891,7 +17891,7 @@
           <p:cNvPr id="8" name="">
             <a:extLst xmlns:a="http://schemas.openxmlformats.org/drawingml/2006/main">
               <a:ext uri="{FF2B5EF4-FFF2-40B4-BE49-F238E27FC236}">
-                <a16:creationId xmlns:a16="http://schemas.microsoft.com/office/drawing/2014/main" id="{7BAFFCF3-37A9-4A26-AA9F-4FC0C03EA60D}"/>
+                <a16:creationId xmlns:a16="http://schemas.microsoft.com/office/drawing/2014/main" id="{898DAC09-F184-4427-9D06-59276671AA71}"/>
               </a:ext>
             </a:extLst>
           </p:cNvPr>
@@ -17925,7 +17925,7 @@
           <p:cNvPr id="9" name="">
             <a:extLst xmlns:a="http://schemas.openxmlformats.org/drawingml/2006/main">
               <a:ext uri="{FF2B5EF4-FFF2-40B4-BE49-F238E27FC236}">
-                <a16:creationId xmlns:a16="http://schemas.microsoft.com/office/drawing/2014/main" id="{DF730E79-3516-437C-8BBF-6D004198C878}"/>
+                <a16:creationId xmlns:a16="http://schemas.microsoft.com/office/drawing/2014/main" id="{F3759540-8EBF-416E-93FF-9A3EB5333D12}"/>
               </a:ext>
             </a:extLst>
           </p:cNvPr>
@@ -17957,7 +17957,7 @@
           <p:cNvPr id="10" name="">
             <a:extLst xmlns:a="http://schemas.openxmlformats.org/drawingml/2006/main">
               <a:ext uri="{FF2B5EF4-FFF2-40B4-BE49-F238E27FC236}">
-                <a16:creationId xmlns:a16="http://schemas.microsoft.com/office/drawing/2014/main" id="{60900D06-25A4-4EC8-B860-0FBCCF492D95}"/>
+                <a16:creationId xmlns:a16="http://schemas.microsoft.com/office/drawing/2014/main" id="{75B556A7-A7DC-4EA1-828C-25148D1EEC2E}"/>
               </a:ext>
             </a:extLst>
           </p:cNvPr>
@@ -17989,7 +17989,7 @@
           <p:cNvPr id="11" name="">
             <a:extLst xmlns:a="http://schemas.openxmlformats.org/drawingml/2006/main">
               <a:ext uri="{FF2B5EF4-FFF2-40B4-BE49-F238E27FC236}">
-                <a16:creationId xmlns:a16="http://schemas.microsoft.com/office/drawing/2014/main" id="{CF0AEF72-23F9-4289-BECD-6105DCE782DB}"/>
+                <a16:creationId xmlns:a16="http://schemas.microsoft.com/office/drawing/2014/main" id="{2150C7DE-0BC8-42EB-B8EA-86826D346905}"/>
               </a:ext>
             </a:extLst>
           </p:cNvPr>
@@ -18021,7 +18021,7 @@
           <p:cNvPr id="12" name="">
             <a:extLst xmlns:a="http://schemas.openxmlformats.org/drawingml/2006/main">
               <a:ext uri="{FF2B5EF4-FFF2-40B4-BE49-F238E27FC236}">
-                <a16:creationId xmlns:a16="http://schemas.microsoft.com/office/drawing/2014/main" id="{D8FA384C-CE3C-4252-975F-92DCF0F6F591}"/>
+                <a16:creationId xmlns:a16="http://schemas.microsoft.com/office/drawing/2014/main" id="{D7EF082A-FD06-49BC-B95C-6B60DF0360DC}"/>
               </a:ext>
             </a:extLst>
           </p:cNvPr>
@@ -18084,7 +18084,7 @@
           <p:cNvPr id="13" name="">
             <a:extLst xmlns:a="http://schemas.openxmlformats.org/drawingml/2006/main">
               <a:ext uri="{FF2B5EF4-FFF2-40B4-BE49-F238E27FC236}">
-                <a16:creationId xmlns:a16="http://schemas.microsoft.com/office/drawing/2014/main" id="{7610D6DF-004F-4D00-BAA4-9D9C2CB3E91F}"/>
+                <a16:creationId xmlns:a16="http://schemas.microsoft.com/office/drawing/2014/main" id="{2E4F4BE0-4803-44CC-87AD-BFC8FE080BFF}"/>
               </a:ext>
             </a:extLst>
           </p:cNvPr>
@@ -18151,7 +18151,7 @@
           <p:cNvPr id="14" name="">
             <a:extLst xmlns:a="http://schemas.openxmlformats.org/drawingml/2006/main">
               <a:ext uri="{FF2B5EF4-FFF2-40B4-BE49-F238E27FC236}">
-                <a16:creationId xmlns:a16="http://schemas.microsoft.com/office/drawing/2014/main" id="{6416FCFD-7452-46EE-8CF8-B652A8761C95}"/>
+                <a16:creationId xmlns:a16="http://schemas.microsoft.com/office/drawing/2014/main" id="{DF6559A3-C4E9-4040-AEF8-BA3E6E49510E}"/>
               </a:ext>
             </a:extLst>
           </p:cNvPr>
@@ -18185,7 +18185,7 @@
           <p:cNvPr id="15" name="">
             <a:extLst xmlns:a="http://schemas.openxmlformats.org/drawingml/2006/main">
               <a:ext uri="{FF2B5EF4-FFF2-40B4-BE49-F238E27FC236}">
-                <a16:creationId xmlns:a16="http://schemas.microsoft.com/office/drawing/2014/main" id="{A75B9D0F-8548-49EA-BF88-0D55812D1EA7}"/>
+                <a16:creationId xmlns:a16="http://schemas.microsoft.com/office/drawing/2014/main" id="{059D16C8-EBC1-4408-A484-0259EC1ACCA2}"/>
               </a:ext>
             </a:extLst>
           </p:cNvPr>
@@ -18217,7 +18217,7 @@
           <p:cNvPr id="16" name="">
             <a:extLst xmlns:a="http://schemas.openxmlformats.org/drawingml/2006/main">
               <a:ext uri="{FF2B5EF4-FFF2-40B4-BE49-F238E27FC236}">
-                <a16:creationId xmlns:a16="http://schemas.microsoft.com/office/drawing/2014/main" id="{ED34BD79-F7C8-4222-9911-49EE26316E91}"/>
+                <a16:creationId xmlns:a16="http://schemas.microsoft.com/office/drawing/2014/main" id="{80DE65D0-2661-41F0-A24E-BDDDE706E685}"/>
               </a:ext>
             </a:extLst>
           </p:cNvPr>
@@ -18249,7 +18249,7 @@
           <p:cNvPr id="17" name="">
             <a:extLst xmlns:a="http://schemas.openxmlformats.org/drawingml/2006/main">
               <a:ext uri="{FF2B5EF4-FFF2-40B4-BE49-F238E27FC236}">
-                <a16:creationId xmlns:a16="http://schemas.microsoft.com/office/drawing/2014/main" id="{8CA5D409-DC22-4F30-AA54-84A4797BFC68}"/>
+                <a16:creationId xmlns:a16="http://schemas.microsoft.com/office/drawing/2014/main" id="{6ADB968B-A8B3-44FB-9A7C-6ACBCC6CF7EE}"/>
               </a:ext>
             </a:extLst>
           </p:cNvPr>
@@ -18281,7 +18281,7 @@
           <p:cNvPr id="18" name="">
             <a:extLst xmlns:a="http://schemas.openxmlformats.org/drawingml/2006/main">
               <a:ext uri="{FF2B5EF4-FFF2-40B4-BE49-F238E27FC236}">
-                <a16:creationId xmlns:a16="http://schemas.microsoft.com/office/drawing/2014/main" id="{F648DA98-193F-4E13-9980-801C57CEB24E}"/>
+                <a16:creationId xmlns:a16="http://schemas.microsoft.com/office/drawing/2014/main" id="{57624637-A074-4A19-BB46-857B58322386}"/>
               </a:ext>
             </a:extLst>
           </p:cNvPr>
@@ -18344,7 +18344,7 @@
           <p:cNvPr id="19" name="">
             <a:extLst xmlns:a="http://schemas.openxmlformats.org/drawingml/2006/main">
               <a:ext uri="{FF2B5EF4-FFF2-40B4-BE49-F238E27FC236}">
-                <a16:creationId xmlns:a16="http://schemas.microsoft.com/office/drawing/2014/main" id="{02D410A3-F31C-4B45-949B-54AB90D53838}"/>
+                <a16:creationId xmlns:a16="http://schemas.microsoft.com/office/drawing/2014/main" id="{3FABCE0B-63BD-4D82-9812-D7687799A626}"/>
               </a:ext>
             </a:extLst>
           </p:cNvPr>
@@ -18411,7 +18411,7 @@
           <p:cNvPr id="20" name="">
             <a:extLst xmlns:a="http://schemas.openxmlformats.org/drawingml/2006/main">
               <a:ext uri="{FF2B5EF4-FFF2-40B4-BE49-F238E27FC236}">
-                <a16:creationId xmlns:a16="http://schemas.microsoft.com/office/drawing/2014/main" id="{2AEF1796-275C-477E-A450-E3CC253DEF09}"/>
+                <a16:creationId xmlns:a16="http://schemas.microsoft.com/office/drawing/2014/main" id="{1F83C52C-0820-470E-976F-3DA1713B785E}"/>
               </a:ext>
             </a:extLst>
           </p:cNvPr>
@@ -18445,7 +18445,7 @@
           <p:cNvPr id="21" name="">
             <a:extLst xmlns:a="http://schemas.openxmlformats.org/drawingml/2006/main">
               <a:ext uri="{FF2B5EF4-FFF2-40B4-BE49-F238E27FC236}">
-                <a16:creationId xmlns:a16="http://schemas.microsoft.com/office/drawing/2014/main" id="{FFDF4475-2A9E-4397-9621-5623A9B2D4F0}"/>
+                <a16:creationId xmlns:a16="http://schemas.microsoft.com/office/drawing/2014/main" id="{71811D9F-7FBA-4E56-ADCD-03CAAFB4132B}"/>
               </a:ext>
             </a:extLst>
           </p:cNvPr>
@@ -18477,7 +18477,7 @@
           <p:cNvPr id="22" name="">
             <a:extLst xmlns:a="http://schemas.openxmlformats.org/drawingml/2006/main">
               <a:ext uri="{FF2B5EF4-FFF2-40B4-BE49-F238E27FC236}">
-                <a16:creationId xmlns:a16="http://schemas.microsoft.com/office/drawing/2014/main" id="{92BB58A1-3159-415D-8AE6-9F12E8C4AAFE}"/>
+                <a16:creationId xmlns:a16="http://schemas.microsoft.com/office/drawing/2014/main" id="{F23D22ED-0D2B-4A70-A048-3CB454AEB1E5}"/>
               </a:ext>
             </a:extLst>
           </p:cNvPr>
@@ -18540,7 +18540,7 @@
           <p:cNvPr id="23" name="">
             <a:extLst xmlns:a="http://schemas.openxmlformats.org/drawingml/2006/main">
               <a:ext uri="{FF2B5EF4-FFF2-40B4-BE49-F238E27FC236}">
-                <a16:creationId xmlns:a16="http://schemas.microsoft.com/office/drawing/2014/main" id="{1902331A-361E-403D-8799-677819C5FE79}"/>
+                <a16:creationId xmlns:a16="http://schemas.microsoft.com/office/drawing/2014/main" id="{5703300D-FB9C-48AA-806E-C3F243825827}"/>
               </a:ext>
             </a:extLst>
           </p:cNvPr>
@@ -18572,7 +18572,7 @@
           <p:cNvPr id="24" name="">
             <a:extLst xmlns:a="http://schemas.openxmlformats.org/drawingml/2006/main">
               <a:ext uri="{FF2B5EF4-FFF2-40B4-BE49-F238E27FC236}">
-                <a16:creationId xmlns:a16="http://schemas.microsoft.com/office/drawing/2014/main" id="{D7468ED4-F6D8-4263-8DC4-7DBA6D7CAF06}"/>
+                <a16:creationId xmlns:a16="http://schemas.microsoft.com/office/drawing/2014/main" id="{9EB913B9-A6F4-44BE-AFCE-A2D846E8DD60}"/>
               </a:ext>
             </a:extLst>
           </p:cNvPr>
@@ -18635,7 +18635,7 @@
           <p:cNvPr id="25" name="">
             <a:extLst xmlns:a="http://schemas.openxmlformats.org/drawingml/2006/main">
               <a:ext uri="{FF2B5EF4-FFF2-40B4-BE49-F238E27FC236}">
-                <a16:creationId xmlns:a16="http://schemas.microsoft.com/office/drawing/2014/main" id="{EF56D7FE-438B-440B-8762-59F6DA8D4C4E}"/>
+                <a16:creationId xmlns:a16="http://schemas.microsoft.com/office/drawing/2014/main" id="{F725F2E2-E3A8-4331-B632-5F3792ABAB5E}"/>
               </a:ext>
             </a:extLst>
           </p:cNvPr>
@@ -18696,7 +18696,7 @@
     </p:spTree>
     <p:extLst>
       <p:ext uri="{BB962C8B-B14F-4D97-AF65-F5344CB8AC3E}">
-        <p14:creationId xmlns:p14="http://schemas.microsoft.com/office/powerpoint/2010/main" val="332937094"/>
+        <p14:creationId xmlns:p14="http://schemas.microsoft.com/office/powerpoint/2010/main" val="124041450"/>
       </p:ext>
     </p:extLst>
   </p:cSld>
@@ -18727,7 +18727,7 @@
           <p:cNvPr id="1" name="">
             <a:extLst xmlns:a="http://schemas.openxmlformats.org/drawingml/2006/main">
               <a:ext uri="{FF2B5EF4-FFF2-40B4-BE49-F238E27FC236}">
-                <a16:creationId xmlns:a16="http://schemas.microsoft.com/office/drawing/2014/main" id="{6EB447CA-FB5D-4A7A-A8B9-3483B48B4B45}"/>
+                <a16:creationId xmlns:a16="http://schemas.microsoft.com/office/drawing/2014/main" id="{93F0FF78-24DA-4C37-B6C2-EC6EC51CC94E}"/>
               </a:ext>
             </a:extLst>
           </p:cNvPr>
@@ -18790,7 +18790,7 @@
           <p:cNvPr id="2" name="">
             <a:extLst xmlns:a="http://schemas.openxmlformats.org/drawingml/2006/main">
               <a:ext uri="{FF2B5EF4-FFF2-40B4-BE49-F238E27FC236}">
-                <a16:creationId xmlns:a16="http://schemas.microsoft.com/office/drawing/2014/main" id="{AC094105-F128-434A-B0D3-21887B90F5D5}"/>
+                <a16:creationId xmlns:a16="http://schemas.microsoft.com/office/drawing/2014/main" id="{08B76F4B-1534-40A0-A858-3FD910B84AD3}"/>
               </a:ext>
             </a:extLst>
           </p:cNvPr>
@@ -18857,7 +18857,7 @@
           <p:cNvPr id="3" name="">
             <a:extLst xmlns:a="http://schemas.openxmlformats.org/drawingml/2006/main">
               <a:ext uri="{FF2B5EF4-FFF2-40B4-BE49-F238E27FC236}">
-                <a16:creationId xmlns:a16="http://schemas.microsoft.com/office/drawing/2014/main" id="{32561CE2-0128-4309-AF7D-7DB792AC070E}"/>
+                <a16:creationId xmlns:a16="http://schemas.microsoft.com/office/drawing/2014/main" id="{2D03D82B-D14F-4CEA-9518-DA3BF0AC6E00}"/>
               </a:ext>
             </a:extLst>
           </p:cNvPr>
@@ -18924,7 +18924,7 @@
           <p:cNvPr id="4" name="">
             <a:extLst xmlns:a="http://schemas.openxmlformats.org/drawingml/2006/main">
               <a:ext uri="{FF2B5EF4-FFF2-40B4-BE49-F238E27FC236}">
-                <a16:creationId xmlns:a16="http://schemas.microsoft.com/office/drawing/2014/main" id="{1C62E253-9859-454E-B3DF-53C15624E180}"/>
+                <a16:creationId xmlns:a16="http://schemas.microsoft.com/office/drawing/2014/main" id="{EC820CF7-875E-4D85-80A8-FEF648776C99}"/>
               </a:ext>
             </a:extLst>
           </p:cNvPr>
@@ -18956,7 +18956,7 @@
           <p:cNvPr id="5" name="">
             <a:extLst xmlns:a="http://schemas.openxmlformats.org/drawingml/2006/main">
               <a:ext uri="{FF2B5EF4-FFF2-40B4-BE49-F238E27FC236}">
-                <a16:creationId xmlns:a16="http://schemas.microsoft.com/office/drawing/2014/main" id="{FF60B980-5674-4662-B9BC-992020744F1B}"/>
+                <a16:creationId xmlns:a16="http://schemas.microsoft.com/office/drawing/2014/main" id="{41075DEF-0383-440D-A10B-A7476D349BC9}"/>
               </a:ext>
             </a:extLst>
           </p:cNvPr>
@@ -18988,7 +18988,7 @@
           <p:cNvPr id="6" name="">
             <a:extLst xmlns:a="http://schemas.openxmlformats.org/drawingml/2006/main">
               <a:ext uri="{FF2B5EF4-FFF2-40B4-BE49-F238E27FC236}">
-                <a16:creationId xmlns:a16="http://schemas.microsoft.com/office/drawing/2014/main" id="{F79EDDFF-FD39-45EC-9576-B040821F0E33}"/>
+                <a16:creationId xmlns:a16="http://schemas.microsoft.com/office/drawing/2014/main" id="{7947BCC5-6C65-4B97-8DEF-EB92349BF045}"/>
               </a:ext>
             </a:extLst>
           </p:cNvPr>
@@ -19051,7 +19051,7 @@
           <p:cNvPr id="7" name="">
             <a:extLst xmlns:a="http://schemas.openxmlformats.org/drawingml/2006/main">
               <a:ext uri="{FF2B5EF4-FFF2-40B4-BE49-F238E27FC236}">
-                <a16:creationId xmlns:a16="http://schemas.microsoft.com/office/drawing/2014/main" id="{C372E896-9DD2-4C56-B260-1EBDBB47FFBA}"/>
+                <a16:creationId xmlns:a16="http://schemas.microsoft.com/office/drawing/2014/main" id="{5399B584-7678-461C-9138-4197FD564BBC}"/>
               </a:ext>
             </a:extLst>
           </p:cNvPr>
@@ -19118,7 +19118,7 @@
           <p:cNvPr id="8" name="">
             <a:extLst xmlns:a="http://schemas.openxmlformats.org/drawingml/2006/main">
               <a:ext uri="{FF2B5EF4-FFF2-40B4-BE49-F238E27FC236}">
-                <a16:creationId xmlns:a16="http://schemas.microsoft.com/office/drawing/2014/main" id="{ABE8E2F1-9B21-465C-9325-BF7DC2A77C18}"/>
+                <a16:creationId xmlns:a16="http://schemas.microsoft.com/office/drawing/2014/main" id="{590B00B2-41C8-463E-886D-35590FE5B291}"/>
               </a:ext>
             </a:extLst>
           </p:cNvPr>
@@ -19150,7 +19150,7 @@
           <p:cNvPr id="9" name="">
             <a:extLst xmlns:a="http://schemas.openxmlformats.org/drawingml/2006/main">
               <a:ext uri="{FF2B5EF4-FFF2-40B4-BE49-F238E27FC236}">
-                <a16:creationId xmlns:a16="http://schemas.microsoft.com/office/drawing/2014/main" id="{454E250F-D464-438D-AF0E-4FAE88D75B7C}"/>
+                <a16:creationId xmlns:a16="http://schemas.microsoft.com/office/drawing/2014/main" id="{3321C56E-11ED-4EC1-95F5-127BFEE52066}"/>
               </a:ext>
             </a:extLst>
           </p:cNvPr>
@@ -19182,7 +19182,7 @@
           <p:cNvPr id="10" name="">
             <a:extLst xmlns:a="http://schemas.openxmlformats.org/drawingml/2006/main">
               <a:ext uri="{FF2B5EF4-FFF2-40B4-BE49-F238E27FC236}">
-                <a16:creationId xmlns:a16="http://schemas.microsoft.com/office/drawing/2014/main" id="{5A076F2E-CC68-45BC-8AB8-46EAA31D1E6D}"/>
+                <a16:creationId xmlns:a16="http://schemas.microsoft.com/office/drawing/2014/main" id="{09FCE60F-2A48-4000-B347-D7DBF2918C56}"/>
               </a:ext>
             </a:extLst>
           </p:cNvPr>
@@ -19245,7 +19245,7 @@
           <p:cNvPr id="11" name="">
             <a:extLst xmlns:a="http://schemas.openxmlformats.org/drawingml/2006/main">
               <a:ext uri="{FF2B5EF4-FFF2-40B4-BE49-F238E27FC236}">
-                <a16:creationId xmlns:a16="http://schemas.microsoft.com/office/drawing/2014/main" id="{661DAD70-AD0A-4CD9-A975-5F4FE673FB81}"/>
+                <a16:creationId xmlns:a16="http://schemas.microsoft.com/office/drawing/2014/main" id="{8651C157-9CA2-41EE-B359-F8CAE511AF3D}"/>
               </a:ext>
             </a:extLst>
           </p:cNvPr>
@@ -19312,7 +19312,7 @@
           <p:cNvPr id="12" name="">
             <a:extLst xmlns:a="http://schemas.openxmlformats.org/drawingml/2006/main">
               <a:ext uri="{FF2B5EF4-FFF2-40B4-BE49-F238E27FC236}">
-                <a16:creationId xmlns:a16="http://schemas.microsoft.com/office/drawing/2014/main" id="{48F44199-B5D2-420C-907D-A7E0034B48AB}"/>
+                <a16:creationId xmlns:a16="http://schemas.microsoft.com/office/drawing/2014/main" id="{AB0A29D2-2524-4F44-A937-23C0064E0DED}"/>
               </a:ext>
             </a:extLst>
           </p:cNvPr>
@@ -19344,7 +19344,7 @@
           <p:cNvPr id="13" name="">
             <a:extLst xmlns:a="http://schemas.openxmlformats.org/drawingml/2006/main">
               <a:ext uri="{FF2B5EF4-FFF2-40B4-BE49-F238E27FC236}">
-                <a16:creationId xmlns:a16="http://schemas.microsoft.com/office/drawing/2014/main" id="{345553E9-90E5-4452-970A-453512920BEC}"/>
+                <a16:creationId xmlns:a16="http://schemas.microsoft.com/office/drawing/2014/main" id="{B6618D0A-6F55-469E-B96B-988506752356}"/>
               </a:ext>
             </a:extLst>
           </p:cNvPr>
@@ -19376,7 +19376,7 @@
           <p:cNvPr id="14" name="">
             <a:extLst xmlns:a="http://schemas.openxmlformats.org/drawingml/2006/main">
               <a:ext uri="{FF2B5EF4-FFF2-40B4-BE49-F238E27FC236}">
-                <a16:creationId xmlns:a16="http://schemas.microsoft.com/office/drawing/2014/main" id="{BC325F4B-2B4B-4905-8233-85A7D1BC1B16}"/>
+                <a16:creationId xmlns:a16="http://schemas.microsoft.com/office/drawing/2014/main" id="{13838AF5-63B0-4841-8576-320E216D8DA7}"/>
               </a:ext>
             </a:extLst>
           </p:cNvPr>
@@ -19439,7 +19439,7 @@
           <p:cNvPr id="15" name="">
             <a:extLst xmlns:a="http://schemas.openxmlformats.org/drawingml/2006/main">
               <a:ext uri="{FF2B5EF4-FFF2-40B4-BE49-F238E27FC236}">
-                <a16:creationId xmlns:a16="http://schemas.microsoft.com/office/drawing/2014/main" id="{60F3B69C-2A80-4DA9-AECB-DDCF9255EF6D}"/>
+                <a16:creationId xmlns:a16="http://schemas.microsoft.com/office/drawing/2014/main" id="{68B8C6E8-FFA7-4170-8411-F3854ED0F654}"/>
               </a:ext>
             </a:extLst>
           </p:cNvPr>
@@ -19506,7 +19506,7 @@
           <p:cNvPr id="16" name="">
             <a:extLst xmlns:a="http://schemas.openxmlformats.org/drawingml/2006/main">
               <a:ext uri="{FF2B5EF4-FFF2-40B4-BE49-F238E27FC236}">
-                <a16:creationId xmlns:a16="http://schemas.microsoft.com/office/drawing/2014/main" id="{86F77243-2D47-4DC7-A5A3-98F49273DC7B}"/>
+                <a16:creationId xmlns:a16="http://schemas.microsoft.com/office/drawing/2014/main" id="{D89FAECF-596B-4F37-AF20-1D39B9BBDA49}"/>
               </a:ext>
             </a:extLst>
           </p:cNvPr>
@@ -19538,7 +19538,7 @@
           <p:cNvPr id="17" name="">
             <a:extLst xmlns:a="http://schemas.openxmlformats.org/drawingml/2006/main">
               <a:ext uri="{FF2B5EF4-FFF2-40B4-BE49-F238E27FC236}">
-                <a16:creationId xmlns:a16="http://schemas.microsoft.com/office/drawing/2014/main" id="{31C7F7C8-E6AB-4565-9CD0-023A4AA7152B}"/>
+                <a16:creationId xmlns:a16="http://schemas.microsoft.com/office/drawing/2014/main" id="{48F961AF-A327-4BB2-B1DC-55A0C4B16BF2}"/>
               </a:ext>
             </a:extLst>
           </p:cNvPr>
@@ -19570,7 +19570,7 @@
           <p:cNvPr id="18" name="">
             <a:extLst xmlns:a="http://schemas.openxmlformats.org/drawingml/2006/main">
               <a:ext uri="{FF2B5EF4-FFF2-40B4-BE49-F238E27FC236}">
-                <a16:creationId xmlns:a16="http://schemas.microsoft.com/office/drawing/2014/main" id="{A6CA36E6-F3D3-43DF-A42E-0AA8D20635E6}"/>
+                <a16:creationId xmlns:a16="http://schemas.microsoft.com/office/drawing/2014/main" id="{B2379B50-FBFC-41A9-9B36-14F9E0CA06F2}"/>
               </a:ext>
             </a:extLst>
           </p:cNvPr>
@@ -19633,7 +19633,7 @@
           <p:cNvPr id="19" name="">
             <a:extLst xmlns:a="http://schemas.openxmlformats.org/drawingml/2006/main">
               <a:ext uri="{FF2B5EF4-FFF2-40B4-BE49-F238E27FC236}">
-                <a16:creationId xmlns:a16="http://schemas.microsoft.com/office/drawing/2014/main" id="{46A21570-B9A7-413F-A508-61806BA13142}"/>
+                <a16:creationId xmlns:a16="http://schemas.microsoft.com/office/drawing/2014/main" id="{DD802F91-4AC7-40D7-B3AC-1E11CB6EFFE0}"/>
               </a:ext>
             </a:extLst>
           </p:cNvPr>
@@ -19700,7 +19700,7 @@
           <p:cNvPr id="20" name="">
             <a:extLst xmlns:a="http://schemas.openxmlformats.org/drawingml/2006/main">
               <a:ext uri="{FF2B5EF4-FFF2-40B4-BE49-F238E27FC236}">
-                <a16:creationId xmlns:a16="http://schemas.microsoft.com/office/drawing/2014/main" id="{547FD849-FC1D-48AC-9167-29CCF8DAAD90}"/>
+                <a16:creationId xmlns:a16="http://schemas.microsoft.com/office/drawing/2014/main" id="{7F9C61EF-CC0F-4C08-BB82-0A72B4ADE960}"/>
               </a:ext>
             </a:extLst>
           </p:cNvPr>
@@ -19732,7 +19732,7 @@
           <p:cNvPr id="21" name="">
             <a:extLst xmlns:a="http://schemas.openxmlformats.org/drawingml/2006/main">
               <a:ext uri="{FF2B5EF4-FFF2-40B4-BE49-F238E27FC236}">
-                <a16:creationId xmlns:a16="http://schemas.microsoft.com/office/drawing/2014/main" id="{EC1B6B10-69D1-4389-8138-07A777A4869D}"/>
+                <a16:creationId xmlns:a16="http://schemas.microsoft.com/office/drawing/2014/main" id="{61AA0AFC-6E77-4911-9B2C-BA74E741EC8C}"/>
               </a:ext>
             </a:extLst>
           </p:cNvPr>
@@ -19799,7 +19799,7 @@
           <p:cNvPr id="22" name="">
             <a:extLst xmlns:a="http://schemas.openxmlformats.org/drawingml/2006/main">
               <a:ext uri="{FF2B5EF4-FFF2-40B4-BE49-F238E27FC236}">
-                <a16:creationId xmlns:a16="http://schemas.microsoft.com/office/drawing/2014/main" id="{FE8AD96B-D0CC-4FB5-B6BF-75C15AFD3133}"/>
+                <a16:creationId xmlns:a16="http://schemas.microsoft.com/office/drawing/2014/main" id="{43F9012A-6C5D-49BE-BFB2-522231792C22}"/>
               </a:ext>
             </a:extLst>
           </p:cNvPr>
@@ -19831,7 +19831,7 @@
           <p:cNvPr id="23" name="">
             <a:extLst xmlns:a="http://schemas.openxmlformats.org/drawingml/2006/main">
               <a:ext uri="{FF2B5EF4-FFF2-40B4-BE49-F238E27FC236}">
-                <a16:creationId xmlns:a16="http://schemas.microsoft.com/office/drawing/2014/main" id="{35D16CAA-8186-4C67-B99F-D9C7F09D0D4D}"/>
+                <a16:creationId xmlns:a16="http://schemas.microsoft.com/office/drawing/2014/main" id="{3B6D71DB-D400-40C0-87F0-C84DAB5307C9}"/>
               </a:ext>
             </a:extLst>
           </p:cNvPr>
@@ -19894,7 +19894,7 @@
           <p:cNvPr id="24" name="">
             <a:extLst xmlns:a="http://schemas.openxmlformats.org/drawingml/2006/main">
               <a:ext uri="{FF2B5EF4-FFF2-40B4-BE49-F238E27FC236}">
-                <a16:creationId xmlns:a16="http://schemas.microsoft.com/office/drawing/2014/main" id="{9A5E8711-3212-4AC6-AD64-C73F7D692C4A}"/>
+                <a16:creationId xmlns:a16="http://schemas.microsoft.com/office/drawing/2014/main" id="{58DAF718-1841-4142-8AD7-B07A4AC19C62}"/>
               </a:ext>
             </a:extLst>
           </p:cNvPr>
@@ -19955,7 +19955,7 @@
     </p:spTree>
     <p:extLst>
       <p:ext uri="{BB962C8B-B14F-4D97-AF65-F5344CB8AC3E}">
-        <p14:creationId xmlns:p14="http://schemas.microsoft.com/office/powerpoint/2010/main" val="693066242"/>
+        <p14:creationId xmlns:p14="http://schemas.microsoft.com/office/powerpoint/2010/main" val="1216330727"/>
       </p:ext>
     </p:extLst>
   </p:cSld>

</xml_diff>

<commit_message>
Tighten RouteSignal pitch render
Refine pitch metric sizing, slide spacing, and regenerated PowerPoint/render artifacts after visual layout adjustments.

Timestamp: 2026-05-21T04:11:05Z
</commit_message>
<xml_diff>
--- a/pitch/routesignal-hackathon-pitch.pptx
+++ b/pitch/routesignal-hackathon-pitch.pptx
@@ -2,20 +2,20 @@
 <file path=ppt/presentation.xml><?xml version="1.0" encoding="utf-8"?>
 <p:presentation xmlns:p="http://schemas.openxmlformats.org/presentationml/2006/main">
   <p:sldMasterIdLst>
-    <p:sldMasterId xmlns:r="http://schemas.openxmlformats.org/officeDocument/2006/relationships" id="2147483648" r:id="R11c0ef667ef04f59"/>
+    <p:sldMasterId xmlns:r="http://schemas.openxmlformats.org/officeDocument/2006/relationships" id="2147483648" r:id="R01222ea71fce42e7"/>
   </p:sldMasterIdLst>
   <p:notesMasterIdLst>
-    <p:notesMasterId xmlns:r="http://schemas.openxmlformats.org/officeDocument/2006/relationships" r:id="R8dd81e4fd9844cd1"/>
+    <p:notesMasterId xmlns:r="http://schemas.openxmlformats.org/officeDocument/2006/relationships" r:id="R8fa2b2cbf8554eb3"/>
   </p:notesMasterIdLst>
   <p:sldIdLst>
-    <p:sldId xmlns:r="http://schemas.openxmlformats.org/officeDocument/2006/relationships" id="256" r:id="Rcb894ee1e90d4e6c"/>
-    <p:sldId xmlns:r="http://schemas.openxmlformats.org/officeDocument/2006/relationships" id="257" r:id="R0b454a5993b245df"/>
-    <p:sldId xmlns:r="http://schemas.openxmlformats.org/officeDocument/2006/relationships" id="258" r:id="Re0778b2fcf314996"/>
-    <p:sldId xmlns:r="http://schemas.openxmlformats.org/officeDocument/2006/relationships" id="259" r:id="Re8c2160a96514d23"/>
-    <p:sldId xmlns:r="http://schemas.openxmlformats.org/officeDocument/2006/relationships" id="260" r:id="R6a94fdcb2fa24efb"/>
-    <p:sldId xmlns:r="http://schemas.openxmlformats.org/officeDocument/2006/relationships" id="261" r:id="R500dfd2d29754535"/>
-    <p:sldId xmlns:r="http://schemas.openxmlformats.org/officeDocument/2006/relationships" id="262" r:id="Rccb556179dda4e0c"/>
-    <p:sldId xmlns:r="http://schemas.openxmlformats.org/officeDocument/2006/relationships" id="263" r:id="R35f5a9d9717a494b"/>
+    <p:sldId xmlns:r="http://schemas.openxmlformats.org/officeDocument/2006/relationships" id="256" r:id="R4e5bf58bec5b4b85"/>
+    <p:sldId xmlns:r="http://schemas.openxmlformats.org/officeDocument/2006/relationships" id="257" r:id="R645a1469e6b241eb"/>
+    <p:sldId xmlns:r="http://schemas.openxmlformats.org/officeDocument/2006/relationships" id="258" r:id="R5eaa6e674d954ff8"/>
+    <p:sldId xmlns:r="http://schemas.openxmlformats.org/officeDocument/2006/relationships" id="259" r:id="R308ee16387d14fcc"/>
+    <p:sldId xmlns:r="http://schemas.openxmlformats.org/officeDocument/2006/relationships" id="260" r:id="R3029dc1c29014d5c"/>
+    <p:sldId xmlns:r="http://schemas.openxmlformats.org/officeDocument/2006/relationships" id="261" r:id="R6505d221c3e64a1f"/>
+    <p:sldId xmlns:r="http://schemas.openxmlformats.org/officeDocument/2006/relationships" id="262" r:id="R0c43a11243ce4eb8"/>
+    <p:sldId xmlns:r="http://schemas.openxmlformats.org/officeDocument/2006/relationships" id="263" r:id="R6d60651b6d92477f"/>
   </p:sldIdLst>
   <p:sldSz cx="12192000" cy="6858000"/>
   <p:notesSz cx="6858000" cy="9144000"/>
@@ -1024,7 +1024,7 @@
   </p:cSld>
   <p:clrMap bg1="lt1" tx1="dk1" bg2="lt2" tx2="dk2" accent1="accent1" accent2="accent2" accent3="accent3" accent4="accent4" accent5="accent5" accent6="accent6" hlink="hlink" folHlink="folHlink"/>
   <p:sldLayoutIdLst>
-    <p:sldLayoutId xmlns:r="http://schemas.openxmlformats.org/officeDocument/2006/relationships" id="2147483649" r:id="Rd3a687b170af4c32"/>
+    <p:sldLayoutId xmlns:r="http://schemas.openxmlformats.org/officeDocument/2006/relationships" id="2147483649" r:id="R86c7e4352b0c48e0"/>
   </p:sldLayoutIdLst>
   <p:txStyles>
     <p:titleStyle>
@@ -1334,7 +1334,7 @@
           <p:nvPr/>
         </p:nvPicPr>
         <p:blipFill>
-          <a:blip xmlns:r="http://schemas.openxmlformats.org/officeDocument/2006/relationships" xmlns:a="http://schemas.openxmlformats.org/drawingml/2006/main" r:embed="Rf593bb4497d142ca"/>
+          <a:blip xmlns:r="http://schemas.openxmlformats.org/officeDocument/2006/relationships" xmlns:a="http://schemas.openxmlformats.org/drawingml/2006/main" r:embed="Rcc6c790de01c4ebb"/>
           <a:srcRect xmlns:a="http://schemas.openxmlformats.org/drawingml/2006/main" l="23814" t="0" r="23814" b="0"/>
           <a:stretch xmlns:a="http://schemas.openxmlformats.org/drawingml/2006/main">
             <a:fillRect l="0" t="0" r="0" b="0"/>
@@ -1355,7 +1355,7 @@
           <p:cNvPr id="2" name="">
             <a:extLst xmlns:a="http://schemas.openxmlformats.org/drawingml/2006/main">
               <a:ext uri="{FF2B5EF4-FFF2-40B4-BE49-F238E27FC236}">
-                <a16:creationId xmlns:a16="http://schemas.microsoft.com/office/drawing/2014/main" id="{955C4E98-0E2E-43B1-B7A1-4871B6829D7F}"/>
+                <a16:creationId xmlns:a16="http://schemas.microsoft.com/office/drawing/2014/main" id="{6799F585-2ADF-4C17-9D32-C6551B83E726}"/>
               </a:ext>
             </a:extLst>
           </p:cNvPr>
@@ -1391,7 +1391,7 @@
           <p:cNvPr id="3" name="">
             <a:extLst xmlns:a="http://schemas.openxmlformats.org/drawingml/2006/main">
               <a:ext uri="{FF2B5EF4-FFF2-40B4-BE49-F238E27FC236}">
-                <a16:creationId xmlns:a16="http://schemas.microsoft.com/office/drawing/2014/main" id="{87715C3F-794C-4AE3-B9E0-CAC3135018EB}"/>
+                <a16:creationId xmlns:a16="http://schemas.microsoft.com/office/drawing/2014/main" id="{3F94AD42-2FAB-43B0-AE53-FB0934FB7CB4}"/>
               </a:ext>
             </a:extLst>
           </p:cNvPr>
@@ -1423,7 +1423,7 @@
           <p:cNvPr id="4" name="">
             <a:extLst xmlns:a="http://schemas.openxmlformats.org/drawingml/2006/main">
               <a:ext uri="{FF2B5EF4-FFF2-40B4-BE49-F238E27FC236}">
-                <a16:creationId xmlns:a16="http://schemas.microsoft.com/office/drawing/2014/main" id="{97BF86B7-AA53-4D59-A405-54BF52A2CA45}"/>
+                <a16:creationId xmlns:a16="http://schemas.microsoft.com/office/drawing/2014/main" id="{BDA03A7A-FFF8-4B2E-8165-87E7DE17DD71}"/>
               </a:ext>
             </a:extLst>
           </p:cNvPr>
@@ -1486,7 +1486,7 @@
           <p:cNvPr id="5" name="">
             <a:extLst xmlns:a="http://schemas.openxmlformats.org/drawingml/2006/main">
               <a:ext uri="{FF2B5EF4-FFF2-40B4-BE49-F238E27FC236}">
-                <a16:creationId xmlns:a16="http://schemas.microsoft.com/office/drawing/2014/main" id="{68D7D5B7-AF99-4183-B135-B7DDB6FCEA3C}"/>
+                <a16:creationId xmlns:a16="http://schemas.microsoft.com/office/drawing/2014/main" id="{FD287D24-2629-4EB7-871E-603A56B201EF}"/>
               </a:ext>
             </a:extLst>
           </p:cNvPr>
@@ -1553,7 +1553,7 @@
           <p:cNvPr id="6" name="">
             <a:extLst xmlns:a="http://schemas.openxmlformats.org/drawingml/2006/main">
               <a:ext uri="{FF2B5EF4-FFF2-40B4-BE49-F238E27FC236}">
-                <a16:creationId xmlns:a16="http://schemas.microsoft.com/office/drawing/2014/main" id="{34C9ED30-4536-4306-8F6D-85631D2385B6}"/>
+                <a16:creationId xmlns:a16="http://schemas.microsoft.com/office/drawing/2014/main" id="{AA081FC1-05D1-4299-AD83-3FA4722E5756}"/>
               </a:ext>
             </a:extLst>
           </p:cNvPr>
@@ -1620,7 +1620,7 @@
           <p:cNvPr id="7" name="">
             <a:extLst xmlns:a="http://schemas.openxmlformats.org/drawingml/2006/main">
               <a:ext uri="{FF2B5EF4-FFF2-40B4-BE49-F238E27FC236}">
-                <a16:creationId xmlns:a16="http://schemas.microsoft.com/office/drawing/2014/main" id="{064A4A85-7075-482E-AC70-49C6CB6D6A05}"/>
+                <a16:creationId xmlns:a16="http://schemas.microsoft.com/office/drawing/2014/main" id="{61D50A71-7C03-4437-8D91-459148AC8B0D}"/>
               </a:ext>
             </a:extLst>
           </p:cNvPr>
@@ -1687,7 +1687,7 @@
           <p:cNvPr id="8" name="">
             <a:extLst xmlns:a="http://schemas.openxmlformats.org/drawingml/2006/main">
               <a:ext uri="{FF2B5EF4-FFF2-40B4-BE49-F238E27FC236}">
-                <a16:creationId xmlns:a16="http://schemas.microsoft.com/office/drawing/2014/main" id="{926154C2-E80E-4E56-8497-1D5DC2A15608}"/>
+                <a16:creationId xmlns:a16="http://schemas.microsoft.com/office/drawing/2014/main" id="{132AFB88-F926-48E1-B363-84EF2CC080A7}"/>
               </a:ext>
             </a:extLst>
           </p:cNvPr>
@@ -1699,7 +1699,7 @@
         <p:spPr>
           <a:xfrm xmlns:a="http://schemas.openxmlformats.org/drawingml/2006/main">
             <a:off x="571500" y="4686300"/>
-            <a:ext cx="2000250" cy="495300"/>
+            <a:ext cx="1714500" cy="457200"/>
           </a:xfrm>
           <a:prstGeom xmlns:a="http://schemas.openxmlformats.org/drawingml/2006/main" prst="rect">
             <a:avLst/>
@@ -1750,19 +1750,19 @@
           <p:cNvPr id="9" name="">
             <a:extLst xmlns:a="http://schemas.openxmlformats.org/drawingml/2006/main">
               <a:ext uri="{FF2B5EF4-FFF2-40B4-BE49-F238E27FC236}">
-                <a16:creationId xmlns:a16="http://schemas.microsoft.com/office/drawing/2014/main" id="{55F1720D-C129-4609-B99F-358572946F5F}"/>
-              </a:ext>
-            </a:extLst>
-          </p:cNvPr>
-          <p:cNvSpPr>
-            <a:spLocks xmlns:a="http://schemas.openxmlformats.org/drawingml/2006/main" noGrp="1"/>
-          </p:cNvSpPr>
-          <p:nvPr/>
-        </p:nvSpPr>
-        <p:spPr>
-          <a:xfrm xmlns:a="http://schemas.openxmlformats.org/drawingml/2006/main">
-            <a:off x="571500" y="5162550"/>
-            <a:ext cx="2000250" cy="419100"/>
+                <a16:creationId xmlns:a16="http://schemas.microsoft.com/office/drawing/2014/main" id="{CFB35C5A-28D0-4B5B-A736-462D32FC5630}"/>
+              </a:ext>
+            </a:extLst>
+          </p:cNvPr>
+          <p:cNvSpPr>
+            <a:spLocks xmlns:a="http://schemas.openxmlformats.org/drawingml/2006/main" noGrp="1"/>
+          </p:cNvSpPr>
+          <p:nvPr/>
+        </p:nvSpPr>
+        <p:spPr>
+          <a:xfrm xmlns:a="http://schemas.openxmlformats.org/drawingml/2006/main">
+            <a:off x="571500" y="5219700"/>
+            <a:ext cx="1714500" cy="342900"/>
           </a:xfrm>
           <a:prstGeom xmlns:a="http://schemas.openxmlformats.org/drawingml/2006/main" prst="rect">
             <a:avLst/>
@@ -1817,7 +1817,7 @@
           <p:cNvPr id="10" name="">
             <a:extLst xmlns:a="http://schemas.openxmlformats.org/drawingml/2006/main">
               <a:ext uri="{FF2B5EF4-FFF2-40B4-BE49-F238E27FC236}">
-                <a16:creationId xmlns:a16="http://schemas.microsoft.com/office/drawing/2014/main" id="{A89650A4-0019-4861-AE17-1D78D74055D8}"/>
+                <a16:creationId xmlns:a16="http://schemas.microsoft.com/office/drawing/2014/main" id="{414EF852-D542-4001-8A44-5248D251F611}"/>
               </a:ext>
             </a:extLst>
           </p:cNvPr>
@@ -1829,7 +1829,7 @@
         <p:spPr>
           <a:xfrm xmlns:a="http://schemas.openxmlformats.org/drawingml/2006/main">
             <a:off x="2705100" y="4686300"/>
-            <a:ext cx="2000250" cy="495300"/>
+            <a:ext cx="1714500" cy="457200"/>
           </a:xfrm>
           <a:prstGeom xmlns:a="http://schemas.openxmlformats.org/drawingml/2006/main" prst="rect">
             <a:avLst/>
@@ -1880,19 +1880,19 @@
           <p:cNvPr id="11" name="">
             <a:extLst xmlns:a="http://schemas.openxmlformats.org/drawingml/2006/main">
               <a:ext uri="{FF2B5EF4-FFF2-40B4-BE49-F238E27FC236}">
-                <a16:creationId xmlns:a16="http://schemas.microsoft.com/office/drawing/2014/main" id="{42F8EC8F-12D6-4ECF-8696-9BF3B89F2455}"/>
-              </a:ext>
-            </a:extLst>
-          </p:cNvPr>
-          <p:cNvSpPr>
-            <a:spLocks xmlns:a="http://schemas.openxmlformats.org/drawingml/2006/main" noGrp="1"/>
-          </p:cNvSpPr>
-          <p:nvPr/>
-        </p:nvSpPr>
-        <p:spPr>
-          <a:xfrm xmlns:a="http://schemas.openxmlformats.org/drawingml/2006/main">
-            <a:off x="2705100" y="5162550"/>
-            <a:ext cx="2000250" cy="419100"/>
+                <a16:creationId xmlns:a16="http://schemas.microsoft.com/office/drawing/2014/main" id="{0AF3BAF3-F2BD-460D-8CF1-C6F3A49D9AB3}"/>
+              </a:ext>
+            </a:extLst>
+          </p:cNvPr>
+          <p:cNvSpPr>
+            <a:spLocks xmlns:a="http://schemas.openxmlformats.org/drawingml/2006/main" noGrp="1"/>
+          </p:cNvSpPr>
+          <p:nvPr/>
+        </p:nvSpPr>
+        <p:spPr>
+          <a:xfrm xmlns:a="http://schemas.openxmlformats.org/drawingml/2006/main">
+            <a:off x="2705100" y="5219700"/>
+            <a:ext cx="1714500" cy="342900"/>
           </a:xfrm>
           <a:prstGeom xmlns:a="http://schemas.openxmlformats.org/drawingml/2006/main" prst="rect">
             <a:avLst/>
@@ -1947,7 +1947,7 @@
           <p:cNvPr id="12" name="">
             <a:extLst xmlns:a="http://schemas.openxmlformats.org/drawingml/2006/main">
               <a:ext uri="{FF2B5EF4-FFF2-40B4-BE49-F238E27FC236}">
-                <a16:creationId xmlns:a16="http://schemas.microsoft.com/office/drawing/2014/main" id="{8CD6F7FC-2505-4E22-A6C9-96B21A1BC98E}"/>
+                <a16:creationId xmlns:a16="http://schemas.microsoft.com/office/drawing/2014/main" id="{4741CE34-0E1B-4077-A7CE-8739272BEC68}"/>
               </a:ext>
             </a:extLst>
           </p:cNvPr>
@@ -1959,7 +1959,7 @@
         <p:spPr>
           <a:xfrm xmlns:a="http://schemas.openxmlformats.org/drawingml/2006/main">
             <a:off x="4629150" y="4686300"/>
-            <a:ext cx="2000250" cy="495300"/>
+            <a:ext cx="1714500" cy="457200"/>
           </a:xfrm>
           <a:prstGeom xmlns:a="http://schemas.openxmlformats.org/drawingml/2006/main" prst="rect">
             <a:avLst/>
@@ -2010,19 +2010,19 @@
           <p:cNvPr id="13" name="">
             <a:extLst xmlns:a="http://schemas.openxmlformats.org/drawingml/2006/main">
               <a:ext uri="{FF2B5EF4-FFF2-40B4-BE49-F238E27FC236}">
-                <a16:creationId xmlns:a16="http://schemas.microsoft.com/office/drawing/2014/main" id="{0877BF8E-C379-431A-BD19-E1F3D8B40DB5}"/>
-              </a:ext>
-            </a:extLst>
-          </p:cNvPr>
-          <p:cNvSpPr>
-            <a:spLocks xmlns:a="http://schemas.openxmlformats.org/drawingml/2006/main" noGrp="1"/>
-          </p:cNvSpPr>
-          <p:nvPr/>
-        </p:nvSpPr>
-        <p:spPr>
-          <a:xfrm xmlns:a="http://schemas.openxmlformats.org/drawingml/2006/main">
-            <a:off x="4629150" y="5162550"/>
-            <a:ext cx="2000250" cy="419100"/>
+                <a16:creationId xmlns:a16="http://schemas.microsoft.com/office/drawing/2014/main" id="{06813B7F-7A79-4B73-833E-2D02263CDBF3}"/>
+              </a:ext>
+            </a:extLst>
+          </p:cNvPr>
+          <p:cNvSpPr>
+            <a:spLocks xmlns:a="http://schemas.openxmlformats.org/drawingml/2006/main" noGrp="1"/>
+          </p:cNvSpPr>
+          <p:nvPr/>
+        </p:nvSpPr>
+        <p:spPr>
+          <a:xfrm xmlns:a="http://schemas.openxmlformats.org/drawingml/2006/main">
+            <a:off x="4629150" y="5219700"/>
+            <a:ext cx="1714500" cy="342900"/>
           </a:xfrm>
           <a:prstGeom xmlns:a="http://schemas.openxmlformats.org/drawingml/2006/main" prst="rect">
             <a:avLst/>
@@ -2077,7 +2077,7 @@
           <p:cNvPr id="14" name="">
             <a:extLst xmlns:a="http://schemas.openxmlformats.org/drawingml/2006/main">
               <a:ext uri="{FF2B5EF4-FFF2-40B4-BE49-F238E27FC236}">
-                <a16:creationId xmlns:a16="http://schemas.microsoft.com/office/drawing/2014/main" id="{28B45F79-5FFC-46D7-B38B-5303DB271B40}"/>
+                <a16:creationId xmlns:a16="http://schemas.microsoft.com/office/drawing/2014/main" id="{FC5E7C53-7021-4FEE-BC07-EF888CDA62F2}"/>
               </a:ext>
             </a:extLst>
           </p:cNvPr>
@@ -2109,7 +2109,7 @@
           <p:cNvPr id="15" name="">
             <a:extLst xmlns:a="http://schemas.openxmlformats.org/drawingml/2006/main">
               <a:ext uri="{FF2B5EF4-FFF2-40B4-BE49-F238E27FC236}">
-                <a16:creationId xmlns:a16="http://schemas.microsoft.com/office/drawing/2014/main" id="{DD530DCE-77AD-4D0C-8411-A2E4659B2136}"/>
+                <a16:creationId xmlns:a16="http://schemas.microsoft.com/office/drawing/2014/main" id="{FFA727FF-1A6F-41CA-A81B-34041B05AA8A}"/>
               </a:ext>
             </a:extLst>
           </p:cNvPr>
@@ -2172,7 +2172,7 @@
           <p:cNvPr id="16" name="">
             <a:extLst xmlns:a="http://schemas.openxmlformats.org/drawingml/2006/main">
               <a:ext uri="{FF2B5EF4-FFF2-40B4-BE49-F238E27FC236}">
-                <a16:creationId xmlns:a16="http://schemas.microsoft.com/office/drawing/2014/main" id="{17341A16-C8F7-4BB5-98F9-0D57204A984F}"/>
+                <a16:creationId xmlns:a16="http://schemas.microsoft.com/office/drawing/2014/main" id="{97029115-A92A-47CA-A6C7-D7B70AE7AADC}"/>
               </a:ext>
             </a:extLst>
           </p:cNvPr>
@@ -2233,7 +2233,7 @@
     </p:spTree>
     <p:extLst>
       <p:ext uri="{BB962C8B-B14F-4D97-AF65-F5344CB8AC3E}">
-        <p14:creationId xmlns:p14="http://schemas.microsoft.com/office/powerpoint/2010/main" val="1543227665"/>
+        <p14:creationId xmlns:p14="http://schemas.microsoft.com/office/powerpoint/2010/main" val="1486989717"/>
       </p:ext>
     </p:extLst>
   </p:cSld>
@@ -2264,7 +2264,7 @@
           <p:cNvPr id="1" name="">
             <a:extLst xmlns:a="http://schemas.openxmlformats.org/drawingml/2006/main">
               <a:ext uri="{FF2B5EF4-FFF2-40B4-BE49-F238E27FC236}">
-                <a16:creationId xmlns:a16="http://schemas.microsoft.com/office/drawing/2014/main" id="{7E06280A-2C87-4922-BBA1-17395B82162C}"/>
+                <a16:creationId xmlns:a16="http://schemas.microsoft.com/office/drawing/2014/main" id="{7001A8C0-45C8-48A4-A176-16BFB1268F4D}"/>
               </a:ext>
             </a:extLst>
           </p:cNvPr>
@@ -2327,7 +2327,7 @@
           <p:cNvPr id="2" name="">
             <a:extLst xmlns:a="http://schemas.openxmlformats.org/drawingml/2006/main">
               <a:ext uri="{FF2B5EF4-FFF2-40B4-BE49-F238E27FC236}">
-                <a16:creationId xmlns:a16="http://schemas.microsoft.com/office/drawing/2014/main" id="{D3EF07DE-CEF2-4C0B-A1C5-D11F67DB833A}"/>
+                <a16:creationId xmlns:a16="http://schemas.microsoft.com/office/drawing/2014/main" id="{2439EDE0-6E2D-4C3C-ADC4-C83261811C00}"/>
               </a:ext>
             </a:extLst>
           </p:cNvPr>
@@ -2394,7 +2394,7 @@
           <p:cNvPr id="3" name="">
             <a:extLst xmlns:a="http://schemas.openxmlformats.org/drawingml/2006/main">
               <a:ext uri="{FF2B5EF4-FFF2-40B4-BE49-F238E27FC236}">
-                <a16:creationId xmlns:a16="http://schemas.microsoft.com/office/drawing/2014/main" id="{B3C96CCF-B821-4BAC-91F6-B7FFF7769EF1}"/>
+                <a16:creationId xmlns:a16="http://schemas.microsoft.com/office/drawing/2014/main" id="{D00694AA-6AD6-49BD-B6BD-CC69B7CE0353}"/>
               </a:ext>
             </a:extLst>
           </p:cNvPr>
@@ -2461,7 +2461,7 @@
           <p:cNvPr id="4" name="">
             <a:extLst xmlns:a="http://schemas.openxmlformats.org/drawingml/2006/main">
               <a:ext uri="{FF2B5EF4-FFF2-40B4-BE49-F238E27FC236}">
-                <a16:creationId xmlns:a16="http://schemas.microsoft.com/office/drawing/2014/main" id="{B9A4366A-7909-4DAD-BB47-4657A65DAA6C}"/>
+                <a16:creationId xmlns:a16="http://schemas.microsoft.com/office/drawing/2014/main" id="{A1ECCCC7-98EE-40A1-BDA9-F7E38E0DB0C7}"/>
               </a:ext>
             </a:extLst>
           </p:cNvPr>
@@ -2495,7 +2495,7 @@
           <p:cNvPr id="5" name="">
             <a:extLst xmlns:a="http://schemas.openxmlformats.org/drawingml/2006/main">
               <a:ext uri="{FF2B5EF4-FFF2-40B4-BE49-F238E27FC236}">
-                <a16:creationId xmlns:a16="http://schemas.microsoft.com/office/drawing/2014/main" id="{D21240EF-1F82-46F2-AA5D-DF1E662709F1}"/>
+                <a16:creationId xmlns:a16="http://schemas.microsoft.com/office/drawing/2014/main" id="{FE9BE149-6B22-4EF4-8B1A-82F6811E1807}"/>
               </a:ext>
             </a:extLst>
           </p:cNvPr>
@@ -2529,7 +2529,7 @@
           <p:cNvPr id="6" name="">
             <a:extLst xmlns:a="http://schemas.openxmlformats.org/drawingml/2006/main">
               <a:ext uri="{FF2B5EF4-FFF2-40B4-BE49-F238E27FC236}">
-                <a16:creationId xmlns:a16="http://schemas.microsoft.com/office/drawing/2014/main" id="{64B3B270-CE01-429E-A5C4-A792DE5B2E7F}"/>
+                <a16:creationId xmlns:a16="http://schemas.microsoft.com/office/drawing/2014/main" id="{75AA364C-C948-4413-97A0-25AEF1F3D399}"/>
               </a:ext>
             </a:extLst>
           </p:cNvPr>
@@ -2563,7 +2563,7 @@
           <p:cNvPr id="7" name="">
             <a:extLst xmlns:a="http://schemas.openxmlformats.org/drawingml/2006/main">
               <a:ext uri="{FF2B5EF4-FFF2-40B4-BE49-F238E27FC236}">
-                <a16:creationId xmlns:a16="http://schemas.microsoft.com/office/drawing/2014/main" id="{E0977D2B-1997-468F-AAF8-F65A1DFDB3AB}"/>
+                <a16:creationId xmlns:a16="http://schemas.microsoft.com/office/drawing/2014/main" id="{F9CEAD16-3C6C-4DF8-AD4D-6513F488105D}"/>
               </a:ext>
             </a:extLst>
           </p:cNvPr>
@@ -2597,7 +2597,7 @@
           <p:cNvPr id="8" name="">
             <a:extLst xmlns:a="http://schemas.openxmlformats.org/drawingml/2006/main">
               <a:ext uri="{FF2B5EF4-FFF2-40B4-BE49-F238E27FC236}">
-                <a16:creationId xmlns:a16="http://schemas.microsoft.com/office/drawing/2014/main" id="{E278BC12-1E23-465C-89FB-F0B4F5A4A046}"/>
+                <a16:creationId xmlns:a16="http://schemas.microsoft.com/office/drawing/2014/main" id="{30A210D6-872D-41A4-BE0C-CA821E431766}"/>
               </a:ext>
             </a:extLst>
           </p:cNvPr>
@@ -2631,7 +2631,7 @@
           <p:cNvPr id="9" name="">
             <a:extLst xmlns:a="http://schemas.openxmlformats.org/drawingml/2006/main">
               <a:ext uri="{FF2B5EF4-FFF2-40B4-BE49-F238E27FC236}">
-                <a16:creationId xmlns:a16="http://schemas.microsoft.com/office/drawing/2014/main" id="{02325945-6097-4985-9526-5F349B3F5CA2}"/>
+                <a16:creationId xmlns:a16="http://schemas.microsoft.com/office/drawing/2014/main" id="{58A58868-5302-4CC5-92D4-7459FA695912}"/>
               </a:ext>
             </a:extLst>
           </p:cNvPr>
@@ -2665,7 +2665,7 @@
           <p:cNvPr id="10" name="">
             <a:extLst xmlns:a="http://schemas.openxmlformats.org/drawingml/2006/main">
               <a:ext uri="{FF2B5EF4-FFF2-40B4-BE49-F238E27FC236}">
-                <a16:creationId xmlns:a16="http://schemas.microsoft.com/office/drawing/2014/main" id="{B3A4EBAE-C020-4213-946C-F506EC119EB9}"/>
+                <a16:creationId xmlns:a16="http://schemas.microsoft.com/office/drawing/2014/main" id="{9B3D3EC2-E378-4DE7-91BA-8A681099648E}"/>
               </a:ext>
             </a:extLst>
           </p:cNvPr>
@@ -2699,7 +2699,7 @@
           <p:cNvPr id="11" name="">
             <a:extLst xmlns:a="http://schemas.openxmlformats.org/drawingml/2006/main">
               <a:ext uri="{FF2B5EF4-FFF2-40B4-BE49-F238E27FC236}">
-                <a16:creationId xmlns:a16="http://schemas.microsoft.com/office/drawing/2014/main" id="{DD901E1C-DF42-44BB-8472-435C3E2187BA}"/>
+                <a16:creationId xmlns:a16="http://schemas.microsoft.com/office/drawing/2014/main" id="{BFCB9F56-5612-4B09-9A4C-BEE3AE5C2F99}"/>
               </a:ext>
             </a:extLst>
           </p:cNvPr>
@@ -2733,7 +2733,7 @@
           <p:cNvPr id="12" name="">
             <a:extLst xmlns:a="http://schemas.openxmlformats.org/drawingml/2006/main">
               <a:ext uri="{FF2B5EF4-FFF2-40B4-BE49-F238E27FC236}">
-                <a16:creationId xmlns:a16="http://schemas.microsoft.com/office/drawing/2014/main" id="{D9572B43-EDA8-4E5C-9AD5-6B8BA5AB1953}"/>
+                <a16:creationId xmlns:a16="http://schemas.microsoft.com/office/drawing/2014/main" id="{7957DEC2-2B33-4252-B772-2126CD218447}"/>
               </a:ext>
             </a:extLst>
           </p:cNvPr>
@@ -2767,7 +2767,7 @@
           <p:cNvPr id="13" name="">
             <a:extLst xmlns:a="http://schemas.openxmlformats.org/drawingml/2006/main">
               <a:ext uri="{FF2B5EF4-FFF2-40B4-BE49-F238E27FC236}">
-                <a16:creationId xmlns:a16="http://schemas.microsoft.com/office/drawing/2014/main" id="{9BA190C8-4A3D-4F8A-8A7B-535605B4AA97}"/>
+                <a16:creationId xmlns:a16="http://schemas.microsoft.com/office/drawing/2014/main" id="{CA5667C4-0B42-4DDC-8E4B-44616FEDA434}"/>
               </a:ext>
             </a:extLst>
           </p:cNvPr>
@@ -2801,7 +2801,7 @@
           <p:cNvPr id="14" name="">
             <a:extLst xmlns:a="http://schemas.openxmlformats.org/drawingml/2006/main">
               <a:ext uri="{FF2B5EF4-FFF2-40B4-BE49-F238E27FC236}">
-                <a16:creationId xmlns:a16="http://schemas.microsoft.com/office/drawing/2014/main" id="{3091E2DC-D8B0-4C5F-82A9-923732403204}"/>
+                <a16:creationId xmlns:a16="http://schemas.microsoft.com/office/drawing/2014/main" id="{FBC35FCC-3674-4E30-997F-D89C6098E40B}"/>
               </a:ext>
             </a:extLst>
           </p:cNvPr>
@@ -2835,7 +2835,7 @@
           <p:cNvPr id="15" name="">
             <a:extLst xmlns:a="http://schemas.openxmlformats.org/drawingml/2006/main">
               <a:ext uri="{FF2B5EF4-FFF2-40B4-BE49-F238E27FC236}">
-                <a16:creationId xmlns:a16="http://schemas.microsoft.com/office/drawing/2014/main" id="{7C67AED0-B7BA-4CF9-B5C1-1B111053FF86}"/>
+                <a16:creationId xmlns:a16="http://schemas.microsoft.com/office/drawing/2014/main" id="{7533C949-91DE-4B58-9171-2A76A3F4E59A}"/>
               </a:ext>
             </a:extLst>
           </p:cNvPr>
@@ -2869,7 +2869,7 @@
           <p:cNvPr id="16" name="">
             <a:extLst xmlns:a="http://schemas.openxmlformats.org/drawingml/2006/main">
               <a:ext uri="{FF2B5EF4-FFF2-40B4-BE49-F238E27FC236}">
-                <a16:creationId xmlns:a16="http://schemas.microsoft.com/office/drawing/2014/main" id="{3E990B68-B8A9-418F-A424-88AD9A5AA310}"/>
+                <a16:creationId xmlns:a16="http://schemas.microsoft.com/office/drawing/2014/main" id="{7064E149-00F5-4AD6-AE36-194842E4176E}"/>
               </a:ext>
             </a:extLst>
           </p:cNvPr>
@@ -2903,7 +2903,7 @@
           <p:cNvPr id="17" name="">
             <a:extLst xmlns:a="http://schemas.openxmlformats.org/drawingml/2006/main">
               <a:ext uri="{FF2B5EF4-FFF2-40B4-BE49-F238E27FC236}">
-                <a16:creationId xmlns:a16="http://schemas.microsoft.com/office/drawing/2014/main" id="{5CD0BDBC-3F16-40D1-B060-AC504DC7EE78}"/>
+                <a16:creationId xmlns:a16="http://schemas.microsoft.com/office/drawing/2014/main" id="{E2D0AB8E-1384-4D6A-8B5E-AC96E102A70E}"/>
               </a:ext>
             </a:extLst>
           </p:cNvPr>
@@ -2937,7 +2937,7 @@
           <p:cNvPr id="18" name="">
             <a:extLst xmlns:a="http://schemas.openxmlformats.org/drawingml/2006/main">
               <a:ext uri="{FF2B5EF4-FFF2-40B4-BE49-F238E27FC236}">
-                <a16:creationId xmlns:a16="http://schemas.microsoft.com/office/drawing/2014/main" id="{5D6502B3-DBF1-41A6-B30F-7B566E0EACDF}"/>
+                <a16:creationId xmlns:a16="http://schemas.microsoft.com/office/drawing/2014/main" id="{9C0FF8F8-33CD-454B-8236-1FF06D56C951}"/>
               </a:ext>
             </a:extLst>
           </p:cNvPr>
@@ -2971,7 +2971,7 @@
           <p:cNvPr id="19" name="">
             <a:extLst xmlns:a="http://schemas.openxmlformats.org/drawingml/2006/main">
               <a:ext uri="{FF2B5EF4-FFF2-40B4-BE49-F238E27FC236}">
-                <a16:creationId xmlns:a16="http://schemas.microsoft.com/office/drawing/2014/main" id="{1190D16F-B28E-48EE-B7F2-4204A0645E13}"/>
+                <a16:creationId xmlns:a16="http://schemas.microsoft.com/office/drawing/2014/main" id="{BA0FBDF9-D71C-4A55-9C1A-3DD26128F3EA}"/>
               </a:ext>
             </a:extLst>
           </p:cNvPr>
@@ -3005,7 +3005,7 @@
           <p:cNvPr id="20" name="">
             <a:extLst xmlns:a="http://schemas.openxmlformats.org/drawingml/2006/main">
               <a:ext uri="{FF2B5EF4-FFF2-40B4-BE49-F238E27FC236}">
-                <a16:creationId xmlns:a16="http://schemas.microsoft.com/office/drawing/2014/main" id="{E1C87DB9-1D12-46ED-B2F0-13F0120D90C3}"/>
+                <a16:creationId xmlns:a16="http://schemas.microsoft.com/office/drawing/2014/main" id="{1B9A203A-FBAA-40DC-A51E-CBF02D07B3EA}"/>
               </a:ext>
             </a:extLst>
           </p:cNvPr>
@@ -3039,7 +3039,7 @@
           <p:cNvPr id="21" name="">
             <a:extLst xmlns:a="http://schemas.openxmlformats.org/drawingml/2006/main">
               <a:ext uri="{FF2B5EF4-FFF2-40B4-BE49-F238E27FC236}">
-                <a16:creationId xmlns:a16="http://schemas.microsoft.com/office/drawing/2014/main" id="{8370DD99-0214-4599-9F63-BEDBD848343F}"/>
+                <a16:creationId xmlns:a16="http://schemas.microsoft.com/office/drawing/2014/main" id="{67108C2B-88C3-4BF3-88FA-8278B249D20E}"/>
               </a:ext>
             </a:extLst>
           </p:cNvPr>
@@ -3073,7 +3073,7 @@
           <p:cNvPr id="22" name="">
             <a:extLst xmlns:a="http://schemas.openxmlformats.org/drawingml/2006/main">
               <a:ext uri="{FF2B5EF4-FFF2-40B4-BE49-F238E27FC236}">
-                <a16:creationId xmlns:a16="http://schemas.microsoft.com/office/drawing/2014/main" id="{42BC0F0D-2545-4EAC-8429-56F969356AEF}"/>
+                <a16:creationId xmlns:a16="http://schemas.microsoft.com/office/drawing/2014/main" id="{0DE40863-2343-487C-BF82-ED4D55A376A3}"/>
               </a:ext>
             </a:extLst>
           </p:cNvPr>
@@ -3107,7 +3107,7 @@
           <p:cNvPr id="23" name="">
             <a:extLst xmlns:a="http://schemas.openxmlformats.org/drawingml/2006/main">
               <a:ext uri="{FF2B5EF4-FFF2-40B4-BE49-F238E27FC236}">
-                <a16:creationId xmlns:a16="http://schemas.microsoft.com/office/drawing/2014/main" id="{DBCAD59F-2EA1-4F07-B8EC-4E5C692FFB8D}"/>
+                <a16:creationId xmlns:a16="http://schemas.microsoft.com/office/drawing/2014/main" id="{C5FCFC23-8D0B-4E6B-A834-64E399C84238}"/>
               </a:ext>
             </a:extLst>
           </p:cNvPr>
@@ -3141,7 +3141,7 @@
           <p:cNvPr id="24" name="">
             <a:extLst xmlns:a="http://schemas.openxmlformats.org/drawingml/2006/main">
               <a:ext uri="{FF2B5EF4-FFF2-40B4-BE49-F238E27FC236}">
-                <a16:creationId xmlns:a16="http://schemas.microsoft.com/office/drawing/2014/main" id="{982FA721-515A-4E4F-ACE2-C8EF185AAB61}"/>
+                <a16:creationId xmlns:a16="http://schemas.microsoft.com/office/drawing/2014/main" id="{E51A7EA4-BC12-45EB-9448-0DBD5FBE2459}"/>
               </a:ext>
             </a:extLst>
           </p:cNvPr>
@@ -3175,7 +3175,7 @@
           <p:cNvPr id="25" name="">
             <a:extLst xmlns:a="http://schemas.openxmlformats.org/drawingml/2006/main">
               <a:ext uri="{FF2B5EF4-FFF2-40B4-BE49-F238E27FC236}">
-                <a16:creationId xmlns:a16="http://schemas.microsoft.com/office/drawing/2014/main" id="{7AAC41C3-BE1D-4B90-B448-4461E7B1D1D1}"/>
+                <a16:creationId xmlns:a16="http://schemas.microsoft.com/office/drawing/2014/main" id="{FAC8849D-1882-4503-9419-E7E4626B93E8}"/>
               </a:ext>
             </a:extLst>
           </p:cNvPr>
@@ -3209,7 +3209,7 @@
           <p:cNvPr id="26" name="">
             <a:extLst xmlns:a="http://schemas.openxmlformats.org/drawingml/2006/main">
               <a:ext uri="{FF2B5EF4-FFF2-40B4-BE49-F238E27FC236}">
-                <a16:creationId xmlns:a16="http://schemas.microsoft.com/office/drawing/2014/main" id="{080C4B3D-6F43-409F-8946-785CD6AE5FCA}"/>
+                <a16:creationId xmlns:a16="http://schemas.microsoft.com/office/drawing/2014/main" id="{46B85398-C0DE-41F9-85A6-AEE91AB03EB9}"/>
               </a:ext>
             </a:extLst>
           </p:cNvPr>
@@ -3243,7 +3243,7 @@
           <p:cNvPr id="27" name="">
             <a:extLst xmlns:a="http://schemas.openxmlformats.org/drawingml/2006/main">
               <a:ext uri="{FF2B5EF4-FFF2-40B4-BE49-F238E27FC236}">
-                <a16:creationId xmlns:a16="http://schemas.microsoft.com/office/drawing/2014/main" id="{4AD55E3A-90F4-4EB2-8F66-70B159CCFDFF}"/>
+                <a16:creationId xmlns:a16="http://schemas.microsoft.com/office/drawing/2014/main" id="{70C1DAF3-E546-416A-BD4B-C62C719697A0}"/>
               </a:ext>
             </a:extLst>
           </p:cNvPr>
@@ -3277,7 +3277,7 @@
           <p:cNvPr id="28" name="">
             <a:extLst xmlns:a="http://schemas.openxmlformats.org/drawingml/2006/main">
               <a:ext uri="{FF2B5EF4-FFF2-40B4-BE49-F238E27FC236}">
-                <a16:creationId xmlns:a16="http://schemas.microsoft.com/office/drawing/2014/main" id="{1D37AC29-6E7E-4935-9C34-C4389F1076E1}"/>
+                <a16:creationId xmlns:a16="http://schemas.microsoft.com/office/drawing/2014/main" id="{1B5BFB04-2CEB-4D99-B79A-1AAE1DE3A697}"/>
               </a:ext>
             </a:extLst>
           </p:cNvPr>
@@ -3311,7 +3311,7 @@
           <p:cNvPr id="29" name="">
             <a:extLst xmlns:a="http://schemas.openxmlformats.org/drawingml/2006/main">
               <a:ext uri="{FF2B5EF4-FFF2-40B4-BE49-F238E27FC236}">
-                <a16:creationId xmlns:a16="http://schemas.microsoft.com/office/drawing/2014/main" id="{F66C3B70-338B-4354-8517-7AE451DFE5AE}"/>
+                <a16:creationId xmlns:a16="http://schemas.microsoft.com/office/drawing/2014/main" id="{2FFC9620-6022-4A3B-85E8-78572497CACE}"/>
               </a:ext>
             </a:extLst>
           </p:cNvPr>
@@ -3345,7 +3345,7 @@
           <p:cNvPr id="30" name="">
             <a:extLst xmlns:a="http://schemas.openxmlformats.org/drawingml/2006/main">
               <a:ext uri="{FF2B5EF4-FFF2-40B4-BE49-F238E27FC236}">
-                <a16:creationId xmlns:a16="http://schemas.microsoft.com/office/drawing/2014/main" id="{F4AD8120-8CF4-471A-8F91-DD18C41478E6}"/>
+                <a16:creationId xmlns:a16="http://schemas.microsoft.com/office/drawing/2014/main" id="{BC662781-B00F-47E3-BF3F-FBEF281AF167}"/>
               </a:ext>
             </a:extLst>
           </p:cNvPr>
@@ -3379,7 +3379,7 @@
           <p:cNvPr id="31" name="">
             <a:extLst xmlns:a="http://schemas.openxmlformats.org/drawingml/2006/main">
               <a:ext uri="{FF2B5EF4-FFF2-40B4-BE49-F238E27FC236}">
-                <a16:creationId xmlns:a16="http://schemas.microsoft.com/office/drawing/2014/main" id="{633BFAB1-196E-4C2E-9253-84C43D6B982E}"/>
+                <a16:creationId xmlns:a16="http://schemas.microsoft.com/office/drawing/2014/main" id="{300FD765-0CEA-469F-8EFC-C4DC05F39212}"/>
               </a:ext>
             </a:extLst>
           </p:cNvPr>
@@ -3413,7 +3413,7 @@
           <p:cNvPr id="32" name="">
             <a:extLst xmlns:a="http://schemas.openxmlformats.org/drawingml/2006/main">
               <a:ext uri="{FF2B5EF4-FFF2-40B4-BE49-F238E27FC236}">
-                <a16:creationId xmlns:a16="http://schemas.microsoft.com/office/drawing/2014/main" id="{E834D057-9D85-42DD-A286-28B7817D26B9}"/>
+                <a16:creationId xmlns:a16="http://schemas.microsoft.com/office/drawing/2014/main" id="{C214E17C-6E27-49D1-86F5-4F49ACA350B2}"/>
               </a:ext>
             </a:extLst>
           </p:cNvPr>
@@ -3447,7 +3447,7 @@
           <p:cNvPr id="33" name="">
             <a:extLst xmlns:a="http://schemas.openxmlformats.org/drawingml/2006/main">
               <a:ext uri="{FF2B5EF4-FFF2-40B4-BE49-F238E27FC236}">
-                <a16:creationId xmlns:a16="http://schemas.microsoft.com/office/drawing/2014/main" id="{0DEA1797-6743-4841-A8B3-4ABCBA210FCE}"/>
+                <a16:creationId xmlns:a16="http://schemas.microsoft.com/office/drawing/2014/main" id="{0DAC04DA-74E5-4F34-AC46-16F851CEDF5F}"/>
               </a:ext>
             </a:extLst>
           </p:cNvPr>
@@ -3481,7 +3481,7 @@
           <p:cNvPr id="34" name="">
             <a:extLst xmlns:a="http://schemas.openxmlformats.org/drawingml/2006/main">
               <a:ext uri="{FF2B5EF4-FFF2-40B4-BE49-F238E27FC236}">
-                <a16:creationId xmlns:a16="http://schemas.microsoft.com/office/drawing/2014/main" id="{5732F7EA-AE59-4B35-94A2-B1A32658B701}"/>
+                <a16:creationId xmlns:a16="http://schemas.microsoft.com/office/drawing/2014/main" id="{BE5DD8AC-D501-410C-93B6-1A4B803C4189}"/>
               </a:ext>
             </a:extLst>
           </p:cNvPr>
@@ -3515,7 +3515,7 @@
           <p:cNvPr id="35" name="">
             <a:extLst xmlns:a="http://schemas.openxmlformats.org/drawingml/2006/main">
               <a:ext uri="{FF2B5EF4-FFF2-40B4-BE49-F238E27FC236}">
-                <a16:creationId xmlns:a16="http://schemas.microsoft.com/office/drawing/2014/main" id="{0E7A29EB-E695-4EDC-AFD6-9C30B63CDC39}"/>
+                <a16:creationId xmlns:a16="http://schemas.microsoft.com/office/drawing/2014/main" id="{9CC337EE-3812-4EE2-AB37-6161735AA850}"/>
               </a:ext>
             </a:extLst>
           </p:cNvPr>
@@ -3549,7 +3549,7 @@
           <p:cNvPr id="36" name="">
             <a:extLst xmlns:a="http://schemas.openxmlformats.org/drawingml/2006/main">
               <a:ext uri="{FF2B5EF4-FFF2-40B4-BE49-F238E27FC236}">
-                <a16:creationId xmlns:a16="http://schemas.microsoft.com/office/drawing/2014/main" id="{290710D2-2717-46E1-9130-3FF1D9F25CD6}"/>
+                <a16:creationId xmlns:a16="http://schemas.microsoft.com/office/drawing/2014/main" id="{03E4733D-0D02-44E2-AA91-657EF26D1C8F}"/>
               </a:ext>
             </a:extLst>
           </p:cNvPr>
@@ -3583,7 +3583,7 @@
           <p:cNvPr id="37" name="">
             <a:extLst xmlns:a="http://schemas.openxmlformats.org/drawingml/2006/main">
               <a:ext uri="{FF2B5EF4-FFF2-40B4-BE49-F238E27FC236}">
-                <a16:creationId xmlns:a16="http://schemas.microsoft.com/office/drawing/2014/main" id="{A7CE8725-D0AE-4A13-8B55-158ACDE80ABC}"/>
+                <a16:creationId xmlns:a16="http://schemas.microsoft.com/office/drawing/2014/main" id="{8F3D29C9-B7B6-4E46-8AB2-6694FEE16EFC}"/>
               </a:ext>
             </a:extLst>
           </p:cNvPr>
@@ -3617,7 +3617,7 @@
           <p:cNvPr id="38" name="">
             <a:extLst xmlns:a="http://schemas.openxmlformats.org/drawingml/2006/main">
               <a:ext uri="{FF2B5EF4-FFF2-40B4-BE49-F238E27FC236}">
-                <a16:creationId xmlns:a16="http://schemas.microsoft.com/office/drawing/2014/main" id="{444A1C59-6D3C-42AB-AC05-551157F8E08E}"/>
+                <a16:creationId xmlns:a16="http://schemas.microsoft.com/office/drawing/2014/main" id="{1B58D860-63BF-4D25-84DF-F68B9CA334F2}"/>
               </a:ext>
             </a:extLst>
           </p:cNvPr>
@@ -3651,7 +3651,7 @@
           <p:cNvPr id="39" name="">
             <a:extLst xmlns:a="http://schemas.openxmlformats.org/drawingml/2006/main">
               <a:ext uri="{FF2B5EF4-FFF2-40B4-BE49-F238E27FC236}">
-                <a16:creationId xmlns:a16="http://schemas.microsoft.com/office/drawing/2014/main" id="{FB66F15F-0884-4DBD-83D8-93BC35342C09}"/>
+                <a16:creationId xmlns:a16="http://schemas.microsoft.com/office/drawing/2014/main" id="{8A473D82-E4C7-4DF4-AAD4-288222DD4B61}"/>
               </a:ext>
             </a:extLst>
           </p:cNvPr>
@@ -3685,7 +3685,7 @@
           <p:cNvPr id="40" name="">
             <a:extLst xmlns:a="http://schemas.openxmlformats.org/drawingml/2006/main">
               <a:ext uri="{FF2B5EF4-FFF2-40B4-BE49-F238E27FC236}">
-                <a16:creationId xmlns:a16="http://schemas.microsoft.com/office/drawing/2014/main" id="{1CF3EBE9-38A1-45F8-BC85-4A33F3A8B991}"/>
+                <a16:creationId xmlns:a16="http://schemas.microsoft.com/office/drawing/2014/main" id="{169C39D5-49C3-4809-8102-6799E16E8F16}"/>
               </a:ext>
             </a:extLst>
           </p:cNvPr>
@@ -3719,7 +3719,7 @@
           <p:cNvPr id="41" name="">
             <a:extLst xmlns:a="http://schemas.openxmlformats.org/drawingml/2006/main">
               <a:ext uri="{FF2B5EF4-FFF2-40B4-BE49-F238E27FC236}">
-                <a16:creationId xmlns:a16="http://schemas.microsoft.com/office/drawing/2014/main" id="{E372AD63-90E1-43D8-82D8-CB08A65A6CA2}"/>
+                <a16:creationId xmlns:a16="http://schemas.microsoft.com/office/drawing/2014/main" id="{C0446442-C545-4AA2-B594-E29FA045FBDF}"/>
               </a:ext>
             </a:extLst>
           </p:cNvPr>
@@ -3753,7 +3753,7 @@
           <p:cNvPr id="42" name="">
             <a:extLst xmlns:a="http://schemas.openxmlformats.org/drawingml/2006/main">
               <a:ext uri="{FF2B5EF4-FFF2-40B4-BE49-F238E27FC236}">
-                <a16:creationId xmlns:a16="http://schemas.microsoft.com/office/drawing/2014/main" id="{6D2E87F6-A3CC-466C-999D-56EAE848BE00}"/>
+                <a16:creationId xmlns:a16="http://schemas.microsoft.com/office/drawing/2014/main" id="{CF4E46F5-C1E7-4C02-9F11-57C20E7BBCE4}"/>
               </a:ext>
             </a:extLst>
           </p:cNvPr>
@@ -3787,7 +3787,7 @@
           <p:cNvPr id="43" name="">
             <a:extLst xmlns:a="http://schemas.openxmlformats.org/drawingml/2006/main">
               <a:ext uri="{FF2B5EF4-FFF2-40B4-BE49-F238E27FC236}">
-                <a16:creationId xmlns:a16="http://schemas.microsoft.com/office/drawing/2014/main" id="{22D01BD6-3681-47BC-AB0B-362AAEE67587}"/>
+                <a16:creationId xmlns:a16="http://schemas.microsoft.com/office/drawing/2014/main" id="{142B247C-BC14-4180-A374-D46CAE516BCA}"/>
               </a:ext>
             </a:extLst>
           </p:cNvPr>
@@ -3821,7 +3821,7 @@
           <p:cNvPr id="44" name="">
             <a:extLst xmlns:a="http://schemas.openxmlformats.org/drawingml/2006/main">
               <a:ext uri="{FF2B5EF4-FFF2-40B4-BE49-F238E27FC236}">
-                <a16:creationId xmlns:a16="http://schemas.microsoft.com/office/drawing/2014/main" id="{3E2BD45F-7385-4A5D-989F-64A982B19B2F}"/>
+                <a16:creationId xmlns:a16="http://schemas.microsoft.com/office/drawing/2014/main" id="{EC90F9EF-73D2-4DAE-9291-68EB81E33ACD}"/>
               </a:ext>
             </a:extLst>
           </p:cNvPr>
@@ -3855,7 +3855,7 @@
           <p:cNvPr id="45" name="">
             <a:extLst xmlns:a="http://schemas.openxmlformats.org/drawingml/2006/main">
               <a:ext uri="{FF2B5EF4-FFF2-40B4-BE49-F238E27FC236}">
-                <a16:creationId xmlns:a16="http://schemas.microsoft.com/office/drawing/2014/main" id="{4F27EAA4-A1B5-4252-8875-278296E7D4D1}"/>
+                <a16:creationId xmlns:a16="http://schemas.microsoft.com/office/drawing/2014/main" id="{495C3CF0-8AB4-4D38-9A87-64602BF863CA}"/>
               </a:ext>
             </a:extLst>
           </p:cNvPr>
@@ -3889,7 +3889,7 @@
           <p:cNvPr id="46" name="">
             <a:extLst xmlns:a="http://schemas.openxmlformats.org/drawingml/2006/main">
               <a:ext uri="{FF2B5EF4-FFF2-40B4-BE49-F238E27FC236}">
-                <a16:creationId xmlns:a16="http://schemas.microsoft.com/office/drawing/2014/main" id="{AAFCBE49-3F1F-46D2-9110-252DBDF1B189}"/>
+                <a16:creationId xmlns:a16="http://schemas.microsoft.com/office/drawing/2014/main" id="{3220F6A6-4304-46F8-B147-96D1B1910D42}"/>
               </a:ext>
             </a:extLst>
           </p:cNvPr>
@@ -3923,7 +3923,7 @@
           <p:cNvPr id="47" name="">
             <a:extLst xmlns:a="http://schemas.openxmlformats.org/drawingml/2006/main">
               <a:ext uri="{FF2B5EF4-FFF2-40B4-BE49-F238E27FC236}">
-                <a16:creationId xmlns:a16="http://schemas.microsoft.com/office/drawing/2014/main" id="{0CB510D3-115E-4433-BFA0-36D8F0C3E0CF}"/>
+                <a16:creationId xmlns:a16="http://schemas.microsoft.com/office/drawing/2014/main" id="{C147BC84-7F2E-4341-A113-47AD609334D3}"/>
               </a:ext>
             </a:extLst>
           </p:cNvPr>
@@ -3957,7 +3957,7 @@
           <p:cNvPr id="48" name="">
             <a:extLst xmlns:a="http://schemas.openxmlformats.org/drawingml/2006/main">
               <a:ext uri="{FF2B5EF4-FFF2-40B4-BE49-F238E27FC236}">
-                <a16:creationId xmlns:a16="http://schemas.microsoft.com/office/drawing/2014/main" id="{A9D23018-6D48-4725-93EA-773F1101D459}"/>
+                <a16:creationId xmlns:a16="http://schemas.microsoft.com/office/drawing/2014/main" id="{854DF6CB-0847-4C4D-9118-8FC75651B3EC}"/>
               </a:ext>
             </a:extLst>
           </p:cNvPr>
@@ -3991,7 +3991,7 @@
           <p:cNvPr id="49" name="">
             <a:extLst xmlns:a="http://schemas.openxmlformats.org/drawingml/2006/main">
               <a:ext uri="{FF2B5EF4-FFF2-40B4-BE49-F238E27FC236}">
-                <a16:creationId xmlns:a16="http://schemas.microsoft.com/office/drawing/2014/main" id="{5A470371-E85F-4199-8F1D-0F347EAD1B00}"/>
+                <a16:creationId xmlns:a16="http://schemas.microsoft.com/office/drawing/2014/main" id="{E3C81CE5-150C-47CF-840E-AEB2C2FF0108}"/>
               </a:ext>
             </a:extLst>
           </p:cNvPr>
@@ -4025,7 +4025,7 @@
           <p:cNvPr id="50" name="">
             <a:extLst xmlns:a="http://schemas.openxmlformats.org/drawingml/2006/main">
               <a:ext uri="{FF2B5EF4-FFF2-40B4-BE49-F238E27FC236}">
-                <a16:creationId xmlns:a16="http://schemas.microsoft.com/office/drawing/2014/main" id="{F6468DB0-0C44-4D8B-9DF2-0933D197B5E7}"/>
+                <a16:creationId xmlns:a16="http://schemas.microsoft.com/office/drawing/2014/main" id="{76755B59-647A-4D77-B57B-302F4E3539CD}"/>
               </a:ext>
             </a:extLst>
           </p:cNvPr>
@@ -4059,7 +4059,7 @@
           <p:cNvPr id="51" name="">
             <a:extLst xmlns:a="http://schemas.openxmlformats.org/drawingml/2006/main">
               <a:ext uri="{FF2B5EF4-FFF2-40B4-BE49-F238E27FC236}">
-                <a16:creationId xmlns:a16="http://schemas.microsoft.com/office/drawing/2014/main" id="{565FB5C9-1306-4C1C-AFB5-E3D26925C4B6}"/>
+                <a16:creationId xmlns:a16="http://schemas.microsoft.com/office/drawing/2014/main" id="{92CC7C79-0B74-491B-8828-6C91C801191F}"/>
               </a:ext>
             </a:extLst>
           </p:cNvPr>
@@ -4093,7 +4093,7 @@
           <p:cNvPr id="52" name="">
             <a:extLst xmlns:a="http://schemas.openxmlformats.org/drawingml/2006/main">
               <a:ext uri="{FF2B5EF4-FFF2-40B4-BE49-F238E27FC236}">
-                <a16:creationId xmlns:a16="http://schemas.microsoft.com/office/drawing/2014/main" id="{6F45A012-673E-4CAD-B22A-7CFDBA0144FE}"/>
+                <a16:creationId xmlns:a16="http://schemas.microsoft.com/office/drawing/2014/main" id="{7E9C3ABB-5FD4-4BA9-9F10-4283F7F51924}"/>
               </a:ext>
             </a:extLst>
           </p:cNvPr>
@@ -4127,7 +4127,7 @@
           <p:cNvPr id="53" name="">
             <a:extLst xmlns:a="http://schemas.openxmlformats.org/drawingml/2006/main">
               <a:ext uri="{FF2B5EF4-FFF2-40B4-BE49-F238E27FC236}">
-                <a16:creationId xmlns:a16="http://schemas.microsoft.com/office/drawing/2014/main" id="{0688FBCB-2C92-41FA-9C53-49C15FA99889}"/>
+                <a16:creationId xmlns:a16="http://schemas.microsoft.com/office/drawing/2014/main" id="{4BD9A536-2710-4EDC-891E-FADA405B26A8}"/>
               </a:ext>
             </a:extLst>
           </p:cNvPr>
@@ -4161,7 +4161,7 @@
           <p:cNvPr id="54" name="">
             <a:extLst xmlns:a="http://schemas.openxmlformats.org/drawingml/2006/main">
               <a:ext uri="{FF2B5EF4-FFF2-40B4-BE49-F238E27FC236}">
-                <a16:creationId xmlns:a16="http://schemas.microsoft.com/office/drawing/2014/main" id="{6E7E27B7-7C0E-42CD-A787-6D136E15DB0E}"/>
+                <a16:creationId xmlns:a16="http://schemas.microsoft.com/office/drawing/2014/main" id="{A6C6B287-DE61-457B-ADE2-422BB7B109D1}"/>
               </a:ext>
             </a:extLst>
           </p:cNvPr>
@@ -4195,7 +4195,7 @@
           <p:cNvPr id="55" name="">
             <a:extLst xmlns:a="http://schemas.openxmlformats.org/drawingml/2006/main">
               <a:ext uri="{FF2B5EF4-FFF2-40B4-BE49-F238E27FC236}">
-                <a16:creationId xmlns:a16="http://schemas.microsoft.com/office/drawing/2014/main" id="{C6175563-C851-484A-B005-DA615E84F366}"/>
+                <a16:creationId xmlns:a16="http://schemas.microsoft.com/office/drawing/2014/main" id="{37A85F8E-4A18-4009-8F29-D76CA21AB1D8}"/>
               </a:ext>
             </a:extLst>
           </p:cNvPr>
@@ -4229,7 +4229,7 @@
           <p:cNvPr id="56" name="">
             <a:extLst xmlns:a="http://schemas.openxmlformats.org/drawingml/2006/main">
               <a:ext uri="{FF2B5EF4-FFF2-40B4-BE49-F238E27FC236}">
-                <a16:creationId xmlns:a16="http://schemas.microsoft.com/office/drawing/2014/main" id="{570F51BF-7908-4AC3-8203-15395F335CE0}"/>
+                <a16:creationId xmlns:a16="http://schemas.microsoft.com/office/drawing/2014/main" id="{F9CC33DD-FEDA-45D3-906A-D6FB06921864}"/>
               </a:ext>
             </a:extLst>
           </p:cNvPr>
@@ -4263,7 +4263,7 @@
           <p:cNvPr id="57" name="">
             <a:extLst xmlns:a="http://schemas.openxmlformats.org/drawingml/2006/main">
               <a:ext uri="{FF2B5EF4-FFF2-40B4-BE49-F238E27FC236}">
-                <a16:creationId xmlns:a16="http://schemas.microsoft.com/office/drawing/2014/main" id="{A0FDDBAF-89D6-4CFF-921E-295B3AD7F52C}"/>
+                <a16:creationId xmlns:a16="http://schemas.microsoft.com/office/drawing/2014/main" id="{FF5F78EC-C987-436D-A10A-09511EFE68CC}"/>
               </a:ext>
             </a:extLst>
           </p:cNvPr>
@@ -4297,7 +4297,7 @@
           <p:cNvPr id="58" name="">
             <a:extLst xmlns:a="http://schemas.openxmlformats.org/drawingml/2006/main">
               <a:ext uri="{FF2B5EF4-FFF2-40B4-BE49-F238E27FC236}">
-                <a16:creationId xmlns:a16="http://schemas.microsoft.com/office/drawing/2014/main" id="{31174D9C-5B31-4366-A90A-63DE8F7F4EB1}"/>
+                <a16:creationId xmlns:a16="http://schemas.microsoft.com/office/drawing/2014/main" id="{C56F1086-BB37-409C-AEB1-FBA5F6632B87}"/>
               </a:ext>
             </a:extLst>
           </p:cNvPr>
@@ -4331,7 +4331,7 @@
           <p:cNvPr id="59" name="">
             <a:extLst xmlns:a="http://schemas.openxmlformats.org/drawingml/2006/main">
               <a:ext uri="{FF2B5EF4-FFF2-40B4-BE49-F238E27FC236}">
-                <a16:creationId xmlns:a16="http://schemas.microsoft.com/office/drawing/2014/main" id="{465671A5-0828-4A9D-8ACA-8DC455D4CA5E}"/>
+                <a16:creationId xmlns:a16="http://schemas.microsoft.com/office/drawing/2014/main" id="{FCBE87D6-47C1-444F-B60D-72EB2917B1FA}"/>
               </a:ext>
             </a:extLst>
           </p:cNvPr>
@@ -4365,7 +4365,7 @@
           <p:cNvPr id="60" name="">
             <a:extLst xmlns:a="http://schemas.openxmlformats.org/drawingml/2006/main">
               <a:ext uri="{FF2B5EF4-FFF2-40B4-BE49-F238E27FC236}">
-                <a16:creationId xmlns:a16="http://schemas.microsoft.com/office/drawing/2014/main" id="{CB213283-18E5-4F92-9C87-D60B556F2086}"/>
+                <a16:creationId xmlns:a16="http://schemas.microsoft.com/office/drawing/2014/main" id="{EDEF5A72-CF98-46F6-BDAA-28F8B530110B}"/>
               </a:ext>
             </a:extLst>
           </p:cNvPr>
@@ -4399,7 +4399,7 @@
           <p:cNvPr id="61" name="">
             <a:extLst xmlns:a="http://schemas.openxmlformats.org/drawingml/2006/main">
               <a:ext uri="{FF2B5EF4-FFF2-40B4-BE49-F238E27FC236}">
-                <a16:creationId xmlns:a16="http://schemas.microsoft.com/office/drawing/2014/main" id="{01B90540-CCE5-4B5C-A3E1-99845C444B70}"/>
+                <a16:creationId xmlns:a16="http://schemas.microsoft.com/office/drawing/2014/main" id="{10404262-AB46-4B3C-AC35-AF05F81EE6F3}"/>
               </a:ext>
             </a:extLst>
           </p:cNvPr>
@@ -4433,7 +4433,7 @@
           <p:cNvPr id="62" name="">
             <a:extLst xmlns:a="http://schemas.openxmlformats.org/drawingml/2006/main">
               <a:ext uri="{FF2B5EF4-FFF2-40B4-BE49-F238E27FC236}">
-                <a16:creationId xmlns:a16="http://schemas.microsoft.com/office/drawing/2014/main" id="{D6973122-5E96-4D06-9F6B-011C591AD16C}"/>
+                <a16:creationId xmlns:a16="http://schemas.microsoft.com/office/drawing/2014/main" id="{B0E6364C-B64E-4208-8360-E839DAB1EA65}"/>
               </a:ext>
             </a:extLst>
           </p:cNvPr>
@@ -4467,7 +4467,7 @@
           <p:cNvPr id="63" name="">
             <a:extLst xmlns:a="http://schemas.openxmlformats.org/drawingml/2006/main">
               <a:ext uri="{FF2B5EF4-FFF2-40B4-BE49-F238E27FC236}">
-                <a16:creationId xmlns:a16="http://schemas.microsoft.com/office/drawing/2014/main" id="{F50405AF-9AA0-44CB-9E8C-2B29A6C2C302}"/>
+                <a16:creationId xmlns:a16="http://schemas.microsoft.com/office/drawing/2014/main" id="{AE9C9B4C-7A31-4921-BF34-069FE72A94E3}"/>
               </a:ext>
             </a:extLst>
           </p:cNvPr>
@@ -4501,7 +4501,7 @@
           <p:cNvPr id="64" name="">
             <a:extLst xmlns:a="http://schemas.openxmlformats.org/drawingml/2006/main">
               <a:ext uri="{FF2B5EF4-FFF2-40B4-BE49-F238E27FC236}">
-                <a16:creationId xmlns:a16="http://schemas.microsoft.com/office/drawing/2014/main" id="{810A1D8B-B3FE-46B3-A096-71B7D49BB4BC}"/>
+                <a16:creationId xmlns:a16="http://schemas.microsoft.com/office/drawing/2014/main" id="{8EDC9890-6EF8-4C71-A95C-97632031A5FC}"/>
               </a:ext>
             </a:extLst>
           </p:cNvPr>
@@ -4535,7 +4535,7 @@
           <p:cNvPr id="65" name="">
             <a:extLst xmlns:a="http://schemas.openxmlformats.org/drawingml/2006/main">
               <a:ext uri="{FF2B5EF4-FFF2-40B4-BE49-F238E27FC236}">
-                <a16:creationId xmlns:a16="http://schemas.microsoft.com/office/drawing/2014/main" id="{9BD0506C-C26B-4E4F-89C8-744EFB87D03B}"/>
+                <a16:creationId xmlns:a16="http://schemas.microsoft.com/office/drawing/2014/main" id="{3AEA44A1-1814-4DDD-9CEE-A0EAADB1EB5C}"/>
               </a:ext>
             </a:extLst>
           </p:cNvPr>
@@ -4569,7 +4569,7 @@
           <p:cNvPr id="66" name="">
             <a:extLst xmlns:a="http://schemas.openxmlformats.org/drawingml/2006/main">
               <a:ext uri="{FF2B5EF4-FFF2-40B4-BE49-F238E27FC236}">
-                <a16:creationId xmlns:a16="http://schemas.microsoft.com/office/drawing/2014/main" id="{FEDAB8AD-73ED-417C-A109-ADF55314D92F}"/>
+                <a16:creationId xmlns:a16="http://schemas.microsoft.com/office/drawing/2014/main" id="{C91B525D-AE0B-4265-A181-79D969CB8C6D}"/>
               </a:ext>
             </a:extLst>
           </p:cNvPr>
@@ -4603,7 +4603,7 @@
           <p:cNvPr id="67" name="">
             <a:extLst xmlns:a="http://schemas.openxmlformats.org/drawingml/2006/main">
               <a:ext uri="{FF2B5EF4-FFF2-40B4-BE49-F238E27FC236}">
-                <a16:creationId xmlns:a16="http://schemas.microsoft.com/office/drawing/2014/main" id="{775DBF11-2F58-4E10-B867-05A4D30BEF12}"/>
+                <a16:creationId xmlns:a16="http://schemas.microsoft.com/office/drawing/2014/main" id="{25964636-8C49-4F6E-BACC-EC7C72001B19}"/>
               </a:ext>
             </a:extLst>
           </p:cNvPr>
@@ -4637,7 +4637,7 @@
           <p:cNvPr id="68" name="">
             <a:extLst xmlns:a="http://schemas.openxmlformats.org/drawingml/2006/main">
               <a:ext uri="{FF2B5EF4-FFF2-40B4-BE49-F238E27FC236}">
-                <a16:creationId xmlns:a16="http://schemas.microsoft.com/office/drawing/2014/main" id="{DCB47729-5652-4176-B3C9-EE41241A999F}"/>
+                <a16:creationId xmlns:a16="http://schemas.microsoft.com/office/drawing/2014/main" id="{71944D15-D155-4B07-97C0-F77948975664}"/>
               </a:ext>
             </a:extLst>
           </p:cNvPr>
@@ -4671,7 +4671,7 @@
           <p:cNvPr id="69" name="">
             <a:extLst xmlns:a="http://schemas.openxmlformats.org/drawingml/2006/main">
               <a:ext uri="{FF2B5EF4-FFF2-40B4-BE49-F238E27FC236}">
-                <a16:creationId xmlns:a16="http://schemas.microsoft.com/office/drawing/2014/main" id="{67F53D6C-8F02-456C-A7D7-3EEAB7BB2908}"/>
+                <a16:creationId xmlns:a16="http://schemas.microsoft.com/office/drawing/2014/main" id="{527E6984-B3E5-42CC-886F-0AC43631F62C}"/>
               </a:ext>
             </a:extLst>
           </p:cNvPr>
@@ -4705,7 +4705,7 @@
           <p:cNvPr id="70" name="">
             <a:extLst xmlns:a="http://schemas.openxmlformats.org/drawingml/2006/main">
               <a:ext uri="{FF2B5EF4-FFF2-40B4-BE49-F238E27FC236}">
-                <a16:creationId xmlns:a16="http://schemas.microsoft.com/office/drawing/2014/main" id="{9CD45085-A338-41A6-A3A4-52211EA20AA7}"/>
+                <a16:creationId xmlns:a16="http://schemas.microsoft.com/office/drawing/2014/main" id="{4BCD28D7-2479-4D28-82DD-DF63EF224E52}"/>
               </a:ext>
             </a:extLst>
           </p:cNvPr>
@@ -4739,7 +4739,7 @@
           <p:cNvPr id="71" name="">
             <a:extLst xmlns:a="http://schemas.openxmlformats.org/drawingml/2006/main">
               <a:ext uri="{FF2B5EF4-FFF2-40B4-BE49-F238E27FC236}">
-                <a16:creationId xmlns:a16="http://schemas.microsoft.com/office/drawing/2014/main" id="{BE62C9C0-3310-4237-888D-D99DA7E86808}"/>
+                <a16:creationId xmlns:a16="http://schemas.microsoft.com/office/drawing/2014/main" id="{AA19CDFC-400C-4264-A117-0890E19188C3}"/>
               </a:ext>
             </a:extLst>
           </p:cNvPr>
@@ -4773,7 +4773,7 @@
           <p:cNvPr id="72" name="">
             <a:extLst xmlns:a="http://schemas.openxmlformats.org/drawingml/2006/main">
               <a:ext uri="{FF2B5EF4-FFF2-40B4-BE49-F238E27FC236}">
-                <a16:creationId xmlns:a16="http://schemas.microsoft.com/office/drawing/2014/main" id="{EA88F51E-C671-4FC3-9B39-CFE0DDBD8E13}"/>
+                <a16:creationId xmlns:a16="http://schemas.microsoft.com/office/drawing/2014/main" id="{5BB58FD4-519E-4C34-9707-1CD88D98DAF5}"/>
               </a:ext>
             </a:extLst>
           </p:cNvPr>
@@ -4807,7 +4807,7 @@
           <p:cNvPr id="73" name="">
             <a:extLst xmlns:a="http://schemas.openxmlformats.org/drawingml/2006/main">
               <a:ext uri="{FF2B5EF4-FFF2-40B4-BE49-F238E27FC236}">
-                <a16:creationId xmlns:a16="http://schemas.microsoft.com/office/drawing/2014/main" id="{2002BF9A-A5E7-46E2-B482-F60A20DF07C2}"/>
+                <a16:creationId xmlns:a16="http://schemas.microsoft.com/office/drawing/2014/main" id="{82042D84-92C3-43B4-9155-AF9287AEDB25}"/>
               </a:ext>
             </a:extLst>
           </p:cNvPr>
@@ -4841,7 +4841,7 @@
           <p:cNvPr id="74" name="">
             <a:extLst xmlns:a="http://schemas.openxmlformats.org/drawingml/2006/main">
               <a:ext uri="{FF2B5EF4-FFF2-40B4-BE49-F238E27FC236}">
-                <a16:creationId xmlns:a16="http://schemas.microsoft.com/office/drawing/2014/main" id="{76B599B1-7740-4F8D-9EA9-09604DDF0C45}"/>
+                <a16:creationId xmlns:a16="http://schemas.microsoft.com/office/drawing/2014/main" id="{3AE6C8C0-7FB0-4635-A1DF-05E4D4440B4A}"/>
               </a:ext>
             </a:extLst>
           </p:cNvPr>
@@ -4875,7 +4875,7 @@
           <p:cNvPr id="75" name="">
             <a:extLst xmlns:a="http://schemas.openxmlformats.org/drawingml/2006/main">
               <a:ext uri="{FF2B5EF4-FFF2-40B4-BE49-F238E27FC236}">
-                <a16:creationId xmlns:a16="http://schemas.microsoft.com/office/drawing/2014/main" id="{6B993998-3922-453A-8FC1-517D6003AFDE}"/>
+                <a16:creationId xmlns:a16="http://schemas.microsoft.com/office/drawing/2014/main" id="{20B378FA-EBC9-4ACD-8961-29D51D5DD0B3}"/>
               </a:ext>
             </a:extLst>
           </p:cNvPr>
@@ -4909,7 +4909,7 @@
           <p:cNvPr id="76" name="">
             <a:extLst xmlns:a="http://schemas.openxmlformats.org/drawingml/2006/main">
               <a:ext uri="{FF2B5EF4-FFF2-40B4-BE49-F238E27FC236}">
-                <a16:creationId xmlns:a16="http://schemas.microsoft.com/office/drawing/2014/main" id="{E1AACCE1-5230-4C45-86F9-029E76377175}"/>
+                <a16:creationId xmlns:a16="http://schemas.microsoft.com/office/drawing/2014/main" id="{6D9CC666-682F-4DCE-B2F1-F903B337B50B}"/>
               </a:ext>
             </a:extLst>
           </p:cNvPr>
@@ -4943,7 +4943,7 @@
           <p:cNvPr id="77" name="">
             <a:extLst xmlns:a="http://schemas.openxmlformats.org/drawingml/2006/main">
               <a:ext uri="{FF2B5EF4-FFF2-40B4-BE49-F238E27FC236}">
-                <a16:creationId xmlns:a16="http://schemas.microsoft.com/office/drawing/2014/main" id="{17C6BA69-B5AB-4BC8-9232-0A40387DB229}"/>
+                <a16:creationId xmlns:a16="http://schemas.microsoft.com/office/drawing/2014/main" id="{B5F9CC1A-669B-498B-B9D9-E9F206954CC7}"/>
               </a:ext>
             </a:extLst>
           </p:cNvPr>
@@ -4977,7 +4977,7 @@
           <p:cNvPr id="78" name="">
             <a:extLst xmlns:a="http://schemas.openxmlformats.org/drawingml/2006/main">
               <a:ext uri="{FF2B5EF4-FFF2-40B4-BE49-F238E27FC236}">
-                <a16:creationId xmlns:a16="http://schemas.microsoft.com/office/drawing/2014/main" id="{6823F967-0FBF-480F-96C9-E4AA909EE860}"/>
+                <a16:creationId xmlns:a16="http://schemas.microsoft.com/office/drawing/2014/main" id="{7A0720FE-123A-4128-B5EA-B5789FEACC38}"/>
               </a:ext>
             </a:extLst>
           </p:cNvPr>
@@ -5011,7 +5011,7 @@
           <p:cNvPr id="79" name="">
             <a:extLst xmlns:a="http://schemas.openxmlformats.org/drawingml/2006/main">
               <a:ext uri="{FF2B5EF4-FFF2-40B4-BE49-F238E27FC236}">
-                <a16:creationId xmlns:a16="http://schemas.microsoft.com/office/drawing/2014/main" id="{FAF7F706-AC37-455D-AA56-A6109EFFE190}"/>
+                <a16:creationId xmlns:a16="http://schemas.microsoft.com/office/drawing/2014/main" id="{384E2B06-071D-4A43-9F12-89B5C9C92921}"/>
               </a:ext>
             </a:extLst>
           </p:cNvPr>
@@ -5045,7 +5045,7 @@
           <p:cNvPr id="80" name="">
             <a:extLst xmlns:a="http://schemas.openxmlformats.org/drawingml/2006/main">
               <a:ext uri="{FF2B5EF4-FFF2-40B4-BE49-F238E27FC236}">
-                <a16:creationId xmlns:a16="http://schemas.microsoft.com/office/drawing/2014/main" id="{C6416DF6-D545-45E8-A20A-24788BFCA547}"/>
+                <a16:creationId xmlns:a16="http://schemas.microsoft.com/office/drawing/2014/main" id="{26E07B93-01B9-4A95-B60A-B6276FBBC6C7}"/>
               </a:ext>
             </a:extLst>
           </p:cNvPr>
@@ -5079,7 +5079,7 @@
           <p:cNvPr id="81" name="">
             <a:extLst xmlns:a="http://schemas.openxmlformats.org/drawingml/2006/main">
               <a:ext uri="{FF2B5EF4-FFF2-40B4-BE49-F238E27FC236}">
-                <a16:creationId xmlns:a16="http://schemas.microsoft.com/office/drawing/2014/main" id="{B36ACEC1-C819-4445-9CAD-CCBCF61CFA53}"/>
+                <a16:creationId xmlns:a16="http://schemas.microsoft.com/office/drawing/2014/main" id="{A9C94E6D-5617-4414-8CEA-9F9A0D9FF850}"/>
               </a:ext>
             </a:extLst>
           </p:cNvPr>
@@ -5113,7 +5113,7 @@
           <p:cNvPr id="82" name="">
             <a:extLst xmlns:a="http://schemas.openxmlformats.org/drawingml/2006/main">
               <a:ext uri="{FF2B5EF4-FFF2-40B4-BE49-F238E27FC236}">
-                <a16:creationId xmlns:a16="http://schemas.microsoft.com/office/drawing/2014/main" id="{686F336C-C54A-47F9-8481-42DF5B891393}"/>
+                <a16:creationId xmlns:a16="http://schemas.microsoft.com/office/drawing/2014/main" id="{D12222B9-BA84-4E58-AD84-756E4E2DF790}"/>
               </a:ext>
             </a:extLst>
           </p:cNvPr>
@@ -5147,7 +5147,7 @@
           <p:cNvPr id="83" name="">
             <a:extLst xmlns:a="http://schemas.openxmlformats.org/drawingml/2006/main">
               <a:ext uri="{FF2B5EF4-FFF2-40B4-BE49-F238E27FC236}">
-                <a16:creationId xmlns:a16="http://schemas.microsoft.com/office/drawing/2014/main" id="{E630886B-3C88-48D9-834B-7EA2091695A0}"/>
+                <a16:creationId xmlns:a16="http://schemas.microsoft.com/office/drawing/2014/main" id="{4EAE3CDA-816C-4D86-89D6-151FB6040CDF}"/>
               </a:ext>
             </a:extLst>
           </p:cNvPr>
@@ -5181,7 +5181,7 @@
           <p:cNvPr id="84" name="">
             <a:extLst xmlns:a="http://schemas.openxmlformats.org/drawingml/2006/main">
               <a:ext uri="{FF2B5EF4-FFF2-40B4-BE49-F238E27FC236}">
-                <a16:creationId xmlns:a16="http://schemas.microsoft.com/office/drawing/2014/main" id="{6B3E07DC-124A-4ACF-A67D-0ABBC0529125}"/>
+                <a16:creationId xmlns:a16="http://schemas.microsoft.com/office/drawing/2014/main" id="{D0FEFE6D-58FB-433D-99C4-8A9694EF7E96}"/>
               </a:ext>
             </a:extLst>
           </p:cNvPr>
@@ -5215,7 +5215,7 @@
           <p:cNvPr id="85" name="">
             <a:extLst xmlns:a="http://schemas.openxmlformats.org/drawingml/2006/main">
               <a:ext uri="{FF2B5EF4-FFF2-40B4-BE49-F238E27FC236}">
-                <a16:creationId xmlns:a16="http://schemas.microsoft.com/office/drawing/2014/main" id="{5947CF18-0A74-4158-AAE7-399149ADBF24}"/>
+                <a16:creationId xmlns:a16="http://schemas.microsoft.com/office/drawing/2014/main" id="{C8044F71-B78D-48EA-86A1-92DE62F010E1}"/>
               </a:ext>
             </a:extLst>
           </p:cNvPr>
@@ -5249,7 +5249,7 @@
           <p:cNvPr id="86" name="">
             <a:extLst xmlns:a="http://schemas.openxmlformats.org/drawingml/2006/main">
               <a:ext uri="{FF2B5EF4-FFF2-40B4-BE49-F238E27FC236}">
-                <a16:creationId xmlns:a16="http://schemas.microsoft.com/office/drawing/2014/main" id="{B7B21D53-346D-447F-AD44-56CA0AFA3A48}"/>
+                <a16:creationId xmlns:a16="http://schemas.microsoft.com/office/drawing/2014/main" id="{8E510E26-272B-42C7-9B62-C11EDDF998BF}"/>
               </a:ext>
             </a:extLst>
           </p:cNvPr>
@@ -5283,7 +5283,7 @@
           <p:cNvPr id="87" name="">
             <a:extLst xmlns:a="http://schemas.openxmlformats.org/drawingml/2006/main">
               <a:ext uri="{FF2B5EF4-FFF2-40B4-BE49-F238E27FC236}">
-                <a16:creationId xmlns:a16="http://schemas.microsoft.com/office/drawing/2014/main" id="{4D6F9D32-7A8A-4680-AC17-DC27746B2B7D}"/>
+                <a16:creationId xmlns:a16="http://schemas.microsoft.com/office/drawing/2014/main" id="{FFB21433-BFDF-4F55-8DAA-E0CB7D92521E}"/>
               </a:ext>
             </a:extLst>
           </p:cNvPr>
@@ -5317,7 +5317,7 @@
           <p:cNvPr id="88" name="">
             <a:extLst xmlns:a="http://schemas.openxmlformats.org/drawingml/2006/main">
               <a:ext uri="{FF2B5EF4-FFF2-40B4-BE49-F238E27FC236}">
-                <a16:creationId xmlns:a16="http://schemas.microsoft.com/office/drawing/2014/main" id="{D395AAA1-5E10-4CF2-835D-69A3F0C876CB}"/>
+                <a16:creationId xmlns:a16="http://schemas.microsoft.com/office/drawing/2014/main" id="{4CDE37C6-B7EB-4FB2-AAFA-D5BA132A61C4}"/>
               </a:ext>
             </a:extLst>
           </p:cNvPr>
@@ -5351,7 +5351,7 @@
           <p:cNvPr id="89" name="">
             <a:extLst xmlns:a="http://schemas.openxmlformats.org/drawingml/2006/main">
               <a:ext uri="{FF2B5EF4-FFF2-40B4-BE49-F238E27FC236}">
-                <a16:creationId xmlns:a16="http://schemas.microsoft.com/office/drawing/2014/main" id="{23D5AB63-E68F-4D62-BEF1-D6628701F44C}"/>
+                <a16:creationId xmlns:a16="http://schemas.microsoft.com/office/drawing/2014/main" id="{2EA1D609-9E30-4D02-8675-01A4CA762A8A}"/>
               </a:ext>
             </a:extLst>
           </p:cNvPr>
@@ -5385,7 +5385,7 @@
           <p:cNvPr id="90" name="">
             <a:extLst xmlns:a="http://schemas.openxmlformats.org/drawingml/2006/main">
               <a:ext uri="{FF2B5EF4-FFF2-40B4-BE49-F238E27FC236}">
-                <a16:creationId xmlns:a16="http://schemas.microsoft.com/office/drawing/2014/main" id="{646E9301-886B-439A-938B-297D49636AC1}"/>
+                <a16:creationId xmlns:a16="http://schemas.microsoft.com/office/drawing/2014/main" id="{3301E1C1-1486-4B72-8F1A-5A62B6D46B24}"/>
               </a:ext>
             </a:extLst>
           </p:cNvPr>
@@ -5419,7 +5419,7 @@
           <p:cNvPr id="91" name="">
             <a:extLst xmlns:a="http://schemas.openxmlformats.org/drawingml/2006/main">
               <a:ext uri="{FF2B5EF4-FFF2-40B4-BE49-F238E27FC236}">
-                <a16:creationId xmlns:a16="http://schemas.microsoft.com/office/drawing/2014/main" id="{6C441074-50E7-430F-ABEA-8DC458E7DE46}"/>
+                <a16:creationId xmlns:a16="http://schemas.microsoft.com/office/drawing/2014/main" id="{369C1C3E-A6C0-4E28-9563-61C4B693DED0}"/>
               </a:ext>
             </a:extLst>
           </p:cNvPr>
@@ -5453,7 +5453,7 @@
           <p:cNvPr id="92" name="">
             <a:extLst xmlns:a="http://schemas.openxmlformats.org/drawingml/2006/main">
               <a:ext uri="{FF2B5EF4-FFF2-40B4-BE49-F238E27FC236}">
-                <a16:creationId xmlns:a16="http://schemas.microsoft.com/office/drawing/2014/main" id="{1E24916B-1B38-4C91-AF2D-5E35C0D1F1DB}"/>
+                <a16:creationId xmlns:a16="http://schemas.microsoft.com/office/drawing/2014/main" id="{3BA3928F-D0B4-4983-8CAC-3EB87EE7FEC1}"/>
               </a:ext>
             </a:extLst>
           </p:cNvPr>
@@ -5487,7 +5487,7 @@
           <p:cNvPr id="93" name="">
             <a:extLst xmlns:a="http://schemas.openxmlformats.org/drawingml/2006/main">
               <a:ext uri="{FF2B5EF4-FFF2-40B4-BE49-F238E27FC236}">
-                <a16:creationId xmlns:a16="http://schemas.microsoft.com/office/drawing/2014/main" id="{ADB3069E-7FC6-43FE-B97F-5E5A37CDFAA5}"/>
+                <a16:creationId xmlns:a16="http://schemas.microsoft.com/office/drawing/2014/main" id="{31F30BF5-DECF-4A2A-83A9-05685DC1E975}"/>
               </a:ext>
             </a:extLst>
           </p:cNvPr>
@@ -5521,7 +5521,7 @@
           <p:cNvPr id="94" name="">
             <a:extLst xmlns:a="http://schemas.openxmlformats.org/drawingml/2006/main">
               <a:ext uri="{FF2B5EF4-FFF2-40B4-BE49-F238E27FC236}">
-                <a16:creationId xmlns:a16="http://schemas.microsoft.com/office/drawing/2014/main" id="{DA4BE8A6-C458-4C4B-A86A-935F15C6CC55}"/>
+                <a16:creationId xmlns:a16="http://schemas.microsoft.com/office/drawing/2014/main" id="{F1599CE3-5F3F-4ACA-A2E5-E9D28EC991E6}"/>
               </a:ext>
             </a:extLst>
           </p:cNvPr>
@@ -5555,7 +5555,7 @@
           <p:cNvPr id="95" name="">
             <a:extLst xmlns:a="http://schemas.openxmlformats.org/drawingml/2006/main">
               <a:ext uri="{FF2B5EF4-FFF2-40B4-BE49-F238E27FC236}">
-                <a16:creationId xmlns:a16="http://schemas.microsoft.com/office/drawing/2014/main" id="{75E8520D-072F-45C4-B1C2-77FF6F2BF632}"/>
+                <a16:creationId xmlns:a16="http://schemas.microsoft.com/office/drawing/2014/main" id="{A948DFE4-54D1-47C0-A928-47326EAF0B3B}"/>
               </a:ext>
             </a:extLst>
           </p:cNvPr>
@@ -5589,7 +5589,7 @@
           <p:cNvPr id="96" name="">
             <a:extLst xmlns:a="http://schemas.openxmlformats.org/drawingml/2006/main">
               <a:ext uri="{FF2B5EF4-FFF2-40B4-BE49-F238E27FC236}">
-                <a16:creationId xmlns:a16="http://schemas.microsoft.com/office/drawing/2014/main" id="{F16EB392-5727-4882-B004-18CC6474781D}"/>
+                <a16:creationId xmlns:a16="http://schemas.microsoft.com/office/drawing/2014/main" id="{77BB0E95-F080-4E78-950D-8732EBFA059E}"/>
               </a:ext>
             </a:extLst>
           </p:cNvPr>
@@ -5623,7 +5623,7 @@
           <p:cNvPr id="97" name="">
             <a:extLst xmlns:a="http://schemas.openxmlformats.org/drawingml/2006/main">
               <a:ext uri="{FF2B5EF4-FFF2-40B4-BE49-F238E27FC236}">
-                <a16:creationId xmlns:a16="http://schemas.microsoft.com/office/drawing/2014/main" id="{8E375C43-BF55-43B3-A0E5-D9D7AD3F32BB}"/>
+                <a16:creationId xmlns:a16="http://schemas.microsoft.com/office/drawing/2014/main" id="{2A5C2125-D24A-490A-AB3A-FB5ABE805CA5}"/>
               </a:ext>
             </a:extLst>
           </p:cNvPr>
@@ -5657,7 +5657,7 @@
           <p:cNvPr id="98" name="">
             <a:extLst xmlns:a="http://schemas.openxmlformats.org/drawingml/2006/main">
               <a:ext uri="{FF2B5EF4-FFF2-40B4-BE49-F238E27FC236}">
-                <a16:creationId xmlns:a16="http://schemas.microsoft.com/office/drawing/2014/main" id="{F8E72EF1-4086-4E8B-ABAA-3D27019498A9}"/>
+                <a16:creationId xmlns:a16="http://schemas.microsoft.com/office/drawing/2014/main" id="{5406CC5A-2C92-4F37-9CFD-BEB9A65F319B}"/>
               </a:ext>
             </a:extLst>
           </p:cNvPr>
@@ -5691,7 +5691,7 @@
           <p:cNvPr id="99" name="">
             <a:extLst xmlns:a="http://schemas.openxmlformats.org/drawingml/2006/main">
               <a:ext uri="{FF2B5EF4-FFF2-40B4-BE49-F238E27FC236}">
-                <a16:creationId xmlns:a16="http://schemas.microsoft.com/office/drawing/2014/main" id="{DDE52B24-0D02-4299-A531-6A912DF3A898}"/>
+                <a16:creationId xmlns:a16="http://schemas.microsoft.com/office/drawing/2014/main" id="{ECEA6C5A-7CE6-4DE8-96B3-6470DB328BFC}"/>
               </a:ext>
             </a:extLst>
           </p:cNvPr>
@@ -5725,7 +5725,7 @@
           <p:cNvPr id="100" name="">
             <a:extLst xmlns:a="http://schemas.openxmlformats.org/drawingml/2006/main">
               <a:ext uri="{FF2B5EF4-FFF2-40B4-BE49-F238E27FC236}">
-                <a16:creationId xmlns:a16="http://schemas.microsoft.com/office/drawing/2014/main" id="{1024582D-91F9-448F-B642-B6A17D1A9AC6}"/>
+                <a16:creationId xmlns:a16="http://schemas.microsoft.com/office/drawing/2014/main" id="{02EC6AF8-3627-430E-8B5C-6809744AB645}"/>
               </a:ext>
             </a:extLst>
           </p:cNvPr>
@@ -5757,7 +5757,7 @@
           <p:cNvPr id="101" name="">
             <a:extLst xmlns:a="http://schemas.openxmlformats.org/drawingml/2006/main">
               <a:ext uri="{FF2B5EF4-FFF2-40B4-BE49-F238E27FC236}">
-                <a16:creationId xmlns:a16="http://schemas.microsoft.com/office/drawing/2014/main" id="{74B33431-ADD5-4876-83CF-5BD97718D73E}"/>
+                <a16:creationId xmlns:a16="http://schemas.microsoft.com/office/drawing/2014/main" id="{505A6A0B-6478-47C0-A60B-45EDFA397403}"/>
               </a:ext>
             </a:extLst>
           </p:cNvPr>
@@ -5791,7 +5791,7 @@
           <p:cNvPr id="102" name="">
             <a:extLst xmlns:a="http://schemas.openxmlformats.org/drawingml/2006/main">
               <a:ext uri="{FF2B5EF4-FFF2-40B4-BE49-F238E27FC236}">
-                <a16:creationId xmlns:a16="http://schemas.microsoft.com/office/drawing/2014/main" id="{8375F5BC-1D9D-4843-ABFC-AB4264A7A859}"/>
+                <a16:creationId xmlns:a16="http://schemas.microsoft.com/office/drawing/2014/main" id="{9A6731AB-40EC-4355-91B3-63668C002D25}"/>
               </a:ext>
             </a:extLst>
           </p:cNvPr>
@@ -5825,7 +5825,7 @@
           <p:cNvPr id="103" name="">
             <a:extLst xmlns:a="http://schemas.openxmlformats.org/drawingml/2006/main">
               <a:ext uri="{FF2B5EF4-FFF2-40B4-BE49-F238E27FC236}">
-                <a16:creationId xmlns:a16="http://schemas.microsoft.com/office/drawing/2014/main" id="{2DCCE72C-8336-484D-B8D1-B53BCEA6188E}"/>
+                <a16:creationId xmlns:a16="http://schemas.microsoft.com/office/drawing/2014/main" id="{F25FBF02-CA5F-44CE-AC5F-9B0DAE957A07}"/>
               </a:ext>
             </a:extLst>
           </p:cNvPr>
@@ -5859,7 +5859,7 @@
           <p:cNvPr id="104" name="">
             <a:extLst xmlns:a="http://schemas.openxmlformats.org/drawingml/2006/main">
               <a:ext uri="{FF2B5EF4-FFF2-40B4-BE49-F238E27FC236}">
-                <a16:creationId xmlns:a16="http://schemas.microsoft.com/office/drawing/2014/main" id="{C8E86DCF-E9D4-4DB9-B289-1C7DF914B93E}"/>
+                <a16:creationId xmlns:a16="http://schemas.microsoft.com/office/drawing/2014/main" id="{D3C79B0F-96D6-46D0-9557-C32D89811356}"/>
               </a:ext>
             </a:extLst>
           </p:cNvPr>
@@ -5893,7 +5893,7 @@
           <p:cNvPr id="105" name="">
             <a:extLst xmlns:a="http://schemas.openxmlformats.org/drawingml/2006/main">
               <a:ext uri="{FF2B5EF4-FFF2-40B4-BE49-F238E27FC236}">
-                <a16:creationId xmlns:a16="http://schemas.microsoft.com/office/drawing/2014/main" id="{BFFC6BE3-9911-4C6C-952C-FC7FB5B1F4CB}"/>
+                <a16:creationId xmlns:a16="http://schemas.microsoft.com/office/drawing/2014/main" id="{C19DFEF7-92F8-4ACA-9664-27378C720AFE}"/>
               </a:ext>
             </a:extLst>
           </p:cNvPr>
@@ -5927,7 +5927,7 @@
           <p:cNvPr id="106" name="">
             <a:extLst xmlns:a="http://schemas.openxmlformats.org/drawingml/2006/main">
               <a:ext uri="{FF2B5EF4-FFF2-40B4-BE49-F238E27FC236}">
-                <a16:creationId xmlns:a16="http://schemas.microsoft.com/office/drawing/2014/main" id="{1B3A242A-D4A0-4055-BE63-54267CF826F0}"/>
+                <a16:creationId xmlns:a16="http://schemas.microsoft.com/office/drawing/2014/main" id="{1916A460-49FB-4B79-A220-A6C55AD739C3}"/>
               </a:ext>
             </a:extLst>
           </p:cNvPr>
@@ -5961,7 +5961,7 @@
           <p:cNvPr id="107" name="">
             <a:extLst xmlns:a="http://schemas.openxmlformats.org/drawingml/2006/main">
               <a:ext uri="{FF2B5EF4-FFF2-40B4-BE49-F238E27FC236}">
-                <a16:creationId xmlns:a16="http://schemas.microsoft.com/office/drawing/2014/main" id="{A06E75F0-7506-41CC-B1CF-F849DC5106C0}"/>
+                <a16:creationId xmlns:a16="http://schemas.microsoft.com/office/drawing/2014/main" id="{C88AF906-F69E-41C5-A6CC-21F2F79CC363}"/>
               </a:ext>
             </a:extLst>
           </p:cNvPr>
@@ -5995,7 +5995,7 @@
           <p:cNvPr id="108" name="">
             <a:extLst xmlns:a="http://schemas.openxmlformats.org/drawingml/2006/main">
               <a:ext uri="{FF2B5EF4-FFF2-40B4-BE49-F238E27FC236}">
-                <a16:creationId xmlns:a16="http://schemas.microsoft.com/office/drawing/2014/main" id="{5B92CDC7-9052-480A-ACDE-AF7912B6C3F5}"/>
+                <a16:creationId xmlns:a16="http://schemas.microsoft.com/office/drawing/2014/main" id="{0B5DD9B3-AB71-4EB7-AB2B-096287C03E14}"/>
               </a:ext>
             </a:extLst>
           </p:cNvPr>
@@ -6029,7 +6029,7 @@
           <p:cNvPr id="109" name="">
             <a:extLst xmlns:a="http://schemas.openxmlformats.org/drawingml/2006/main">
               <a:ext uri="{FF2B5EF4-FFF2-40B4-BE49-F238E27FC236}">
-                <a16:creationId xmlns:a16="http://schemas.microsoft.com/office/drawing/2014/main" id="{A28B2001-39B2-41C0-9A27-348609D1AD6E}"/>
+                <a16:creationId xmlns:a16="http://schemas.microsoft.com/office/drawing/2014/main" id="{ACC21638-B272-4C38-9BB2-70B28CC351C5}"/>
               </a:ext>
             </a:extLst>
           </p:cNvPr>
@@ -6063,7 +6063,7 @@
           <p:cNvPr id="110" name="">
             <a:extLst xmlns:a="http://schemas.openxmlformats.org/drawingml/2006/main">
               <a:ext uri="{FF2B5EF4-FFF2-40B4-BE49-F238E27FC236}">
-                <a16:creationId xmlns:a16="http://schemas.microsoft.com/office/drawing/2014/main" id="{95C250A1-8397-4BAF-8C2F-65E6DA8B4906}"/>
+                <a16:creationId xmlns:a16="http://schemas.microsoft.com/office/drawing/2014/main" id="{19BB0BCC-D4E9-4FB4-9D36-A33575C87DE5}"/>
               </a:ext>
             </a:extLst>
           </p:cNvPr>
@@ -6097,7 +6097,7 @@
           <p:cNvPr id="111" name="">
             <a:extLst xmlns:a="http://schemas.openxmlformats.org/drawingml/2006/main">
               <a:ext uri="{FF2B5EF4-FFF2-40B4-BE49-F238E27FC236}">
-                <a16:creationId xmlns:a16="http://schemas.microsoft.com/office/drawing/2014/main" id="{FF5A2BD9-4D92-448D-BD8D-0AF8806BF1EC}"/>
+                <a16:creationId xmlns:a16="http://schemas.microsoft.com/office/drawing/2014/main" id="{7481A0AE-2624-4CB8-89FA-E6EEE43501FF}"/>
               </a:ext>
             </a:extLst>
           </p:cNvPr>
@@ -6131,7 +6131,7 @@
           <p:cNvPr id="112" name="">
             <a:extLst xmlns:a="http://schemas.openxmlformats.org/drawingml/2006/main">
               <a:ext uri="{FF2B5EF4-FFF2-40B4-BE49-F238E27FC236}">
-                <a16:creationId xmlns:a16="http://schemas.microsoft.com/office/drawing/2014/main" id="{2FD0ECD2-540B-4575-ACC9-3EA0AAB29BED}"/>
+                <a16:creationId xmlns:a16="http://schemas.microsoft.com/office/drawing/2014/main" id="{8CCEA27A-89D3-4368-8088-1CA8D9960CF6}"/>
               </a:ext>
             </a:extLst>
           </p:cNvPr>
@@ -6165,7 +6165,7 @@
           <p:cNvPr id="113" name="">
             <a:extLst xmlns:a="http://schemas.openxmlformats.org/drawingml/2006/main">
               <a:ext uri="{FF2B5EF4-FFF2-40B4-BE49-F238E27FC236}">
-                <a16:creationId xmlns:a16="http://schemas.microsoft.com/office/drawing/2014/main" id="{5E957B8A-80E8-4EE5-8178-4D632D935B79}"/>
+                <a16:creationId xmlns:a16="http://schemas.microsoft.com/office/drawing/2014/main" id="{ACFCD77C-FA62-48CC-A53C-FABB7133F44B}"/>
               </a:ext>
             </a:extLst>
           </p:cNvPr>
@@ -6199,7 +6199,7 @@
           <p:cNvPr id="114" name="">
             <a:extLst xmlns:a="http://schemas.openxmlformats.org/drawingml/2006/main">
               <a:ext uri="{FF2B5EF4-FFF2-40B4-BE49-F238E27FC236}">
-                <a16:creationId xmlns:a16="http://schemas.microsoft.com/office/drawing/2014/main" id="{37181BF4-6224-43B9-B1C0-FB80DCE79277}"/>
+                <a16:creationId xmlns:a16="http://schemas.microsoft.com/office/drawing/2014/main" id="{D56672AB-E13F-4A93-87EC-8BD9B087F3B6}"/>
               </a:ext>
             </a:extLst>
           </p:cNvPr>
@@ -6262,7 +6262,7 @@
           <p:cNvPr id="115" name="">
             <a:extLst xmlns:a="http://schemas.openxmlformats.org/drawingml/2006/main">
               <a:ext uri="{FF2B5EF4-FFF2-40B4-BE49-F238E27FC236}">
-                <a16:creationId xmlns:a16="http://schemas.microsoft.com/office/drawing/2014/main" id="{57854300-DEED-447E-9DAD-312505C3B17F}"/>
+                <a16:creationId xmlns:a16="http://schemas.microsoft.com/office/drawing/2014/main" id="{062CC726-6D97-47B8-8C5B-FC464FDF021E}"/>
               </a:ext>
             </a:extLst>
           </p:cNvPr>
@@ -6294,7 +6294,7 @@
           <p:cNvPr id="116" name="">
             <a:extLst xmlns:a="http://schemas.openxmlformats.org/drawingml/2006/main">
               <a:ext uri="{FF2B5EF4-FFF2-40B4-BE49-F238E27FC236}">
-                <a16:creationId xmlns:a16="http://schemas.microsoft.com/office/drawing/2014/main" id="{30A659E7-40EA-4CD3-BFFB-473E0DC0A30B}"/>
+                <a16:creationId xmlns:a16="http://schemas.microsoft.com/office/drawing/2014/main" id="{1CA2207D-472F-413A-98F4-5721AB88ADA1}"/>
               </a:ext>
             </a:extLst>
           </p:cNvPr>
@@ -6326,7 +6326,7 @@
           <p:cNvPr id="117" name="">
             <a:extLst xmlns:a="http://schemas.openxmlformats.org/drawingml/2006/main">
               <a:ext uri="{FF2B5EF4-FFF2-40B4-BE49-F238E27FC236}">
-                <a16:creationId xmlns:a16="http://schemas.microsoft.com/office/drawing/2014/main" id="{22BA769A-5D70-44B3-A509-CB847E8AF766}"/>
+                <a16:creationId xmlns:a16="http://schemas.microsoft.com/office/drawing/2014/main" id="{9CE356FF-7908-4C53-AC34-4A6236AF064E}"/>
               </a:ext>
             </a:extLst>
           </p:cNvPr>
@@ -6389,7 +6389,7 @@
           <p:cNvPr id="118" name="">
             <a:extLst xmlns:a="http://schemas.openxmlformats.org/drawingml/2006/main">
               <a:ext uri="{FF2B5EF4-FFF2-40B4-BE49-F238E27FC236}">
-                <a16:creationId xmlns:a16="http://schemas.microsoft.com/office/drawing/2014/main" id="{401AA6F7-4AC5-40F6-9E3F-4A839544E4E0}"/>
+                <a16:creationId xmlns:a16="http://schemas.microsoft.com/office/drawing/2014/main" id="{1DF833CE-DADD-4E7A-AC27-C30630535288}"/>
               </a:ext>
             </a:extLst>
           </p:cNvPr>
@@ -6421,7 +6421,7 @@
           <p:cNvPr id="119" name="">
             <a:extLst xmlns:a="http://schemas.openxmlformats.org/drawingml/2006/main">
               <a:ext uri="{FF2B5EF4-FFF2-40B4-BE49-F238E27FC236}">
-                <a16:creationId xmlns:a16="http://schemas.microsoft.com/office/drawing/2014/main" id="{17C9A6C5-0833-43F6-8D6F-0447AC9B3DE0}"/>
+                <a16:creationId xmlns:a16="http://schemas.microsoft.com/office/drawing/2014/main" id="{2C9509E1-D782-4DE0-9AB1-ABA7D855AEE8}"/>
               </a:ext>
             </a:extLst>
           </p:cNvPr>
@@ -6453,7 +6453,7 @@
           <p:cNvPr id="120" name="">
             <a:extLst xmlns:a="http://schemas.openxmlformats.org/drawingml/2006/main">
               <a:ext uri="{FF2B5EF4-FFF2-40B4-BE49-F238E27FC236}">
-                <a16:creationId xmlns:a16="http://schemas.microsoft.com/office/drawing/2014/main" id="{A4F22F63-3B68-497E-BF4F-6AB36BEB521C}"/>
+                <a16:creationId xmlns:a16="http://schemas.microsoft.com/office/drawing/2014/main" id="{CE774A4C-84B4-4475-B413-A5D8694A291B}"/>
               </a:ext>
             </a:extLst>
           </p:cNvPr>
@@ -6516,7 +6516,7 @@
           <p:cNvPr id="121" name="">
             <a:extLst xmlns:a="http://schemas.openxmlformats.org/drawingml/2006/main">
               <a:ext uri="{FF2B5EF4-FFF2-40B4-BE49-F238E27FC236}">
-                <a16:creationId xmlns:a16="http://schemas.microsoft.com/office/drawing/2014/main" id="{7E21BE7F-58FF-41F5-8B6E-B7B89EEE4685}"/>
+                <a16:creationId xmlns:a16="http://schemas.microsoft.com/office/drawing/2014/main" id="{BC16A8ED-1991-404E-8F63-DEB87D437C44}"/>
               </a:ext>
             </a:extLst>
           </p:cNvPr>
@@ -6548,7 +6548,7 @@
           <p:cNvPr id="122" name="">
             <a:extLst xmlns:a="http://schemas.openxmlformats.org/drawingml/2006/main">
               <a:ext uri="{FF2B5EF4-FFF2-40B4-BE49-F238E27FC236}">
-                <a16:creationId xmlns:a16="http://schemas.microsoft.com/office/drawing/2014/main" id="{E0CD0E48-C8F0-4B4F-BE8D-E3AEF0D8892A}"/>
+                <a16:creationId xmlns:a16="http://schemas.microsoft.com/office/drawing/2014/main" id="{38680AF2-CB7F-461E-9122-444095D93EC9}"/>
               </a:ext>
             </a:extLst>
           </p:cNvPr>
@@ -6580,7 +6580,7 @@
           <p:cNvPr id="123" name="">
             <a:extLst xmlns:a="http://schemas.openxmlformats.org/drawingml/2006/main">
               <a:ext uri="{FF2B5EF4-FFF2-40B4-BE49-F238E27FC236}">
-                <a16:creationId xmlns:a16="http://schemas.microsoft.com/office/drawing/2014/main" id="{E0BC1AFC-A827-4136-BB5A-9E02923E0A0A}"/>
+                <a16:creationId xmlns:a16="http://schemas.microsoft.com/office/drawing/2014/main" id="{C940FC6D-21BC-4BE3-9865-E27A2C978D63}"/>
               </a:ext>
             </a:extLst>
           </p:cNvPr>
@@ -6643,7 +6643,7 @@
           <p:cNvPr id="124" name="">
             <a:extLst xmlns:a="http://schemas.openxmlformats.org/drawingml/2006/main">
               <a:ext uri="{FF2B5EF4-FFF2-40B4-BE49-F238E27FC236}">
-                <a16:creationId xmlns:a16="http://schemas.microsoft.com/office/drawing/2014/main" id="{EB724EB0-E899-4DB6-9D91-658CF9E6421F}"/>
+                <a16:creationId xmlns:a16="http://schemas.microsoft.com/office/drawing/2014/main" id="{9271C0F0-A766-481D-88CF-0B118B859C50}"/>
               </a:ext>
             </a:extLst>
           </p:cNvPr>
@@ -6675,7 +6675,7 @@
           <p:cNvPr id="125" name="">
             <a:extLst xmlns:a="http://schemas.openxmlformats.org/drawingml/2006/main">
               <a:ext uri="{FF2B5EF4-FFF2-40B4-BE49-F238E27FC236}">
-                <a16:creationId xmlns:a16="http://schemas.microsoft.com/office/drawing/2014/main" id="{F15C74D9-ACD1-49A3-9892-3A1F1773A7A9}"/>
+                <a16:creationId xmlns:a16="http://schemas.microsoft.com/office/drawing/2014/main" id="{DF270FD8-8119-4225-8F1B-2D5B34964611}"/>
               </a:ext>
             </a:extLst>
           </p:cNvPr>
@@ -6707,7 +6707,7 @@
           <p:cNvPr id="126" name="">
             <a:extLst xmlns:a="http://schemas.openxmlformats.org/drawingml/2006/main">
               <a:ext uri="{FF2B5EF4-FFF2-40B4-BE49-F238E27FC236}">
-                <a16:creationId xmlns:a16="http://schemas.microsoft.com/office/drawing/2014/main" id="{01538746-28F5-4CCB-845E-BC840216C582}"/>
+                <a16:creationId xmlns:a16="http://schemas.microsoft.com/office/drawing/2014/main" id="{C74942AA-14C2-4B44-8AF3-C214B156C75F}"/>
               </a:ext>
             </a:extLst>
           </p:cNvPr>
@@ -6770,7 +6770,7 @@
           <p:cNvPr id="127" name="">
             <a:extLst xmlns:a="http://schemas.openxmlformats.org/drawingml/2006/main">
               <a:ext uri="{FF2B5EF4-FFF2-40B4-BE49-F238E27FC236}">
-                <a16:creationId xmlns:a16="http://schemas.microsoft.com/office/drawing/2014/main" id="{EC808D9F-BD07-47E9-AC46-A8A11CEE2A32}"/>
+                <a16:creationId xmlns:a16="http://schemas.microsoft.com/office/drawing/2014/main" id="{5ADF5ADE-A429-4FB6-9311-6EB0A96C2852}"/>
               </a:ext>
             </a:extLst>
           </p:cNvPr>
@@ -6802,7 +6802,7 @@
           <p:cNvPr id="128" name="">
             <a:extLst xmlns:a="http://schemas.openxmlformats.org/drawingml/2006/main">
               <a:ext uri="{FF2B5EF4-FFF2-40B4-BE49-F238E27FC236}">
-                <a16:creationId xmlns:a16="http://schemas.microsoft.com/office/drawing/2014/main" id="{E828E894-7E9A-4B1D-BCD5-633B8C47406F}"/>
+                <a16:creationId xmlns:a16="http://schemas.microsoft.com/office/drawing/2014/main" id="{EB41F193-7B2D-48EA-AC0B-4E60FA9EA425}"/>
               </a:ext>
             </a:extLst>
           </p:cNvPr>
@@ -6865,7 +6865,7 @@
           <p:cNvPr id="129" name="">
             <a:extLst xmlns:a="http://schemas.openxmlformats.org/drawingml/2006/main">
               <a:ext uri="{FF2B5EF4-FFF2-40B4-BE49-F238E27FC236}">
-                <a16:creationId xmlns:a16="http://schemas.microsoft.com/office/drawing/2014/main" id="{0D765698-8B21-47F4-901E-E5D797BE23FC}"/>
+                <a16:creationId xmlns:a16="http://schemas.microsoft.com/office/drawing/2014/main" id="{20344787-43B0-4A8F-9389-8C46747A5A14}"/>
               </a:ext>
             </a:extLst>
           </p:cNvPr>
@@ -6897,7 +6897,7 @@
           <p:cNvPr id="130" name="">
             <a:extLst xmlns:a="http://schemas.openxmlformats.org/drawingml/2006/main">
               <a:ext uri="{FF2B5EF4-FFF2-40B4-BE49-F238E27FC236}">
-                <a16:creationId xmlns:a16="http://schemas.microsoft.com/office/drawing/2014/main" id="{6BEE59BD-0397-4384-9CAA-D3B0DCB091B9}"/>
+                <a16:creationId xmlns:a16="http://schemas.microsoft.com/office/drawing/2014/main" id="{20C6F088-20DD-43FF-BC90-DF745B2041DF}"/>
               </a:ext>
             </a:extLst>
           </p:cNvPr>
@@ -6960,7 +6960,7 @@
           <p:cNvPr id="131" name="">
             <a:extLst xmlns:a="http://schemas.openxmlformats.org/drawingml/2006/main">
               <a:ext uri="{FF2B5EF4-FFF2-40B4-BE49-F238E27FC236}">
-                <a16:creationId xmlns:a16="http://schemas.microsoft.com/office/drawing/2014/main" id="{01F29113-84C6-4571-BDB6-2E0C3541B442}"/>
+                <a16:creationId xmlns:a16="http://schemas.microsoft.com/office/drawing/2014/main" id="{52DA8180-EBD8-4D3B-B774-FBFA7DC6C428}"/>
               </a:ext>
             </a:extLst>
           </p:cNvPr>
@@ -6992,7 +6992,7 @@
           <p:cNvPr id="132" name="">
             <a:extLst xmlns:a="http://schemas.openxmlformats.org/drawingml/2006/main">
               <a:ext uri="{FF2B5EF4-FFF2-40B4-BE49-F238E27FC236}">
-                <a16:creationId xmlns:a16="http://schemas.microsoft.com/office/drawing/2014/main" id="{1056A67C-05B2-40FE-94B5-DF0A5C752A1F}"/>
+                <a16:creationId xmlns:a16="http://schemas.microsoft.com/office/drawing/2014/main" id="{790D75B4-3043-4E89-B419-1911C67E4BD0}"/>
               </a:ext>
             </a:extLst>
           </p:cNvPr>
@@ -7055,7 +7055,7 @@
           <p:cNvPr id="133" name="">
             <a:extLst xmlns:a="http://schemas.openxmlformats.org/drawingml/2006/main">
               <a:ext uri="{FF2B5EF4-FFF2-40B4-BE49-F238E27FC236}">
-                <a16:creationId xmlns:a16="http://schemas.microsoft.com/office/drawing/2014/main" id="{381657C3-E278-422F-A2E9-ED42134ABD1B}"/>
+                <a16:creationId xmlns:a16="http://schemas.microsoft.com/office/drawing/2014/main" id="{5FC06E05-D6CE-46BE-9768-030C74117BE1}"/>
               </a:ext>
             </a:extLst>
           </p:cNvPr>
@@ -7116,7 +7116,7 @@
     </p:spTree>
     <p:extLst>
       <p:ext uri="{BB962C8B-B14F-4D97-AF65-F5344CB8AC3E}">
-        <p14:creationId xmlns:p14="http://schemas.microsoft.com/office/powerpoint/2010/main" val="40265662"/>
+        <p14:creationId xmlns:p14="http://schemas.microsoft.com/office/powerpoint/2010/main" val="970556176"/>
       </p:ext>
     </p:extLst>
   </p:cSld>
@@ -7147,7 +7147,7 @@
           <p:cNvPr id="1" name="">
             <a:extLst xmlns:a="http://schemas.openxmlformats.org/drawingml/2006/main">
               <a:ext uri="{FF2B5EF4-FFF2-40B4-BE49-F238E27FC236}">
-                <a16:creationId xmlns:a16="http://schemas.microsoft.com/office/drawing/2014/main" id="{C82D00C0-825C-432D-B7C8-42338A6AD800}"/>
+                <a16:creationId xmlns:a16="http://schemas.microsoft.com/office/drawing/2014/main" id="{4E1A2612-8F21-4883-8A8B-70E66556A57E}"/>
               </a:ext>
             </a:extLst>
           </p:cNvPr>
@@ -7210,7 +7210,7 @@
           <p:cNvPr id="2" name="">
             <a:extLst xmlns:a="http://schemas.openxmlformats.org/drawingml/2006/main">
               <a:ext uri="{FF2B5EF4-FFF2-40B4-BE49-F238E27FC236}">
-                <a16:creationId xmlns:a16="http://schemas.microsoft.com/office/drawing/2014/main" id="{2406EF05-D790-4AA1-94A2-A7A5C8D17CAC}"/>
+                <a16:creationId xmlns:a16="http://schemas.microsoft.com/office/drawing/2014/main" id="{8D0A79C7-F133-44A8-9451-B9E2A2C1D481}"/>
               </a:ext>
             </a:extLst>
           </p:cNvPr>
@@ -7277,7 +7277,7 @@
           <p:cNvPr id="3" name="">
             <a:extLst xmlns:a="http://schemas.openxmlformats.org/drawingml/2006/main">
               <a:ext uri="{FF2B5EF4-FFF2-40B4-BE49-F238E27FC236}">
-                <a16:creationId xmlns:a16="http://schemas.microsoft.com/office/drawing/2014/main" id="{B38B1ACB-C4A8-44C9-9BCD-9086BB214459}"/>
+                <a16:creationId xmlns:a16="http://schemas.microsoft.com/office/drawing/2014/main" id="{CBC94086-CB33-4804-BB20-173A3FFD38CA}"/>
               </a:ext>
             </a:extLst>
           </p:cNvPr>
@@ -7344,7 +7344,7 @@
           <p:cNvPr id="4" name="">
             <a:extLst xmlns:a="http://schemas.openxmlformats.org/drawingml/2006/main">
               <a:ext uri="{FF2B5EF4-FFF2-40B4-BE49-F238E27FC236}">
-                <a16:creationId xmlns:a16="http://schemas.microsoft.com/office/drawing/2014/main" id="{B204AEC4-250E-46EB-A20E-1FA9694A4A8D}"/>
+                <a16:creationId xmlns:a16="http://schemas.microsoft.com/office/drawing/2014/main" id="{96E6CC76-0A73-4079-B3C0-F01B191444D1}"/>
               </a:ext>
             </a:extLst>
           </p:cNvPr>
@@ -7356,7 +7356,7 @@
         <p:spPr>
           <a:xfrm xmlns:a="http://schemas.openxmlformats.org/drawingml/2006/main">
             <a:off x="685800" y="2457450"/>
-            <a:ext cx="2000250" cy="495300"/>
+            <a:ext cx="1714500" cy="457200"/>
           </a:xfrm>
           <a:prstGeom xmlns:a="http://schemas.openxmlformats.org/drawingml/2006/main" prst="rect">
             <a:avLst/>
@@ -7407,19 +7407,19 @@
           <p:cNvPr id="5" name="">
             <a:extLst xmlns:a="http://schemas.openxmlformats.org/drawingml/2006/main">
               <a:ext uri="{FF2B5EF4-FFF2-40B4-BE49-F238E27FC236}">
-                <a16:creationId xmlns:a16="http://schemas.microsoft.com/office/drawing/2014/main" id="{184DE7AB-EA3B-41F3-A08B-27A564CA97DF}"/>
-              </a:ext>
-            </a:extLst>
-          </p:cNvPr>
-          <p:cNvSpPr>
-            <a:spLocks xmlns:a="http://schemas.openxmlformats.org/drawingml/2006/main" noGrp="1"/>
-          </p:cNvSpPr>
-          <p:nvPr/>
-        </p:nvSpPr>
-        <p:spPr>
-          <a:xfrm xmlns:a="http://schemas.openxmlformats.org/drawingml/2006/main">
-            <a:off x="685800" y="2933700"/>
-            <a:ext cx="2000250" cy="419100"/>
+                <a16:creationId xmlns:a16="http://schemas.microsoft.com/office/drawing/2014/main" id="{BC45047D-06A6-4F97-A046-68C55EBA3634}"/>
+              </a:ext>
+            </a:extLst>
+          </p:cNvPr>
+          <p:cNvSpPr>
+            <a:spLocks xmlns:a="http://schemas.openxmlformats.org/drawingml/2006/main" noGrp="1"/>
+          </p:cNvSpPr>
+          <p:nvPr/>
+        </p:nvSpPr>
+        <p:spPr>
+          <a:xfrm xmlns:a="http://schemas.openxmlformats.org/drawingml/2006/main">
+            <a:off x="685800" y="2990850"/>
+            <a:ext cx="1714500" cy="342900"/>
           </a:xfrm>
           <a:prstGeom xmlns:a="http://schemas.openxmlformats.org/drawingml/2006/main" prst="rect">
             <a:avLst/>
@@ -7474,7 +7474,7 @@
           <p:cNvPr id="6" name="">
             <a:extLst xmlns:a="http://schemas.openxmlformats.org/drawingml/2006/main">
               <a:ext uri="{FF2B5EF4-FFF2-40B4-BE49-F238E27FC236}">
-                <a16:creationId xmlns:a16="http://schemas.microsoft.com/office/drawing/2014/main" id="{18FD7856-4D79-459D-A312-F947C15B0019}"/>
+                <a16:creationId xmlns:a16="http://schemas.microsoft.com/office/drawing/2014/main" id="{63992B78-AF86-4BEF-B060-6CFA4A29666D}"/>
               </a:ext>
             </a:extLst>
           </p:cNvPr>
@@ -7486,7 +7486,7 @@
         <p:spPr>
           <a:xfrm xmlns:a="http://schemas.openxmlformats.org/drawingml/2006/main">
             <a:off x="2781300" y="2457450"/>
-            <a:ext cx="2000250" cy="495300"/>
+            <a:ext cx="1714500" cy="457200"/>
           </a:xfrm>
           <a:prstGeom xmlns:a="http://schemas.openxmlformats.org/drawingml/2006/main" prst="rect">
             <a:avLst/>
@@ -7537,19 +7537,19 @@
           <p:cNvPr id="7" name="">
             <a:extLst xmlns:a="http://schemas.openxmlformats.org/drawingml/2006/main">
               <a:ext uri="{FF2B5EF4-FFF2-40B4-BE49-F238E27FC236}">
-                <a16:creationId xmlns:a16="http://schemas.microsoft.com/office/drawing/2014/main" id="{5739EB67-5C9D-4E35-B467-326ED1911E7B}"/>
-              </a:ext>
-            </a:extLst>
-          </p:cNvPr>
-          <p:cNvSpPr>
-            <a:spLocks xmlns:a="http://schemas.openxmlformats.org/drawingml/2006/main" noGrp="1"/>
-          </p:cNvSpPr>
-          <p:nvPr/>
-        </p:nvSpPr>
-        <p:spPr>
-          <a:xfrm xmlns:a="http://schemas.openxmlformats.org/drawingml/2006/main">
-            <a:off x="2781300" y="2933700"/>
-            <a:ext cx="2000250" cy="419100"/>
+                <a16:creationId xmlns:a16="http://schemas.microsoft.com/office/drawing/2014/main" id="{BB1674F9-0D58-4BA6-9B29-3CBDD324864B}"/>
+              </a:ext>
+            </a:extLst>
+          </p:cNvPr>
+          <p:cNvSpPr>
+            <a:spLocks xmlns:a="http://schemas.openxmlformats.org/drawingml/2006/main" noGrp="1"/>
+          </p:cNvSpPr>
+          <p:nvPr/>
+        </p:nvSpPr>
+        <p:spPr>
+          <a:xfrm xmlns:a="http://schemas.openxmlformats.org/drawingml/2006/main">
+            <a:off x="2781300" y="2990850"/>
+            <a:ext cx="1714500" cy="342900"/>
           </a:xfrm>
           <a:prstGeom xmlns:a="http://schemas.openxmlformats.org/drawingml/2006/main" prst="rect">
             <a:avLst/>
@@ -7604,7 +7604,7 @@
           <p:cNvPr id="8" name="">
             <a:extLst xmlns:a="http://schemas.openxmlformats.org/drawingml/2006/main">
               <a:ext uri="{FF2B5EF4-FFF2-40B4-BE49-F238E27FC236}">
-                <a16:creationId xmlns:a16="http://schemas.microsoft.com/office/drawing/2014/main" id="{B45E81CC-B169-42E4-8C1B-11B23710F433}"/>
+                <a16:creationId xmlns:a16="http://schemas.microsoft.com/office/drawing/2014/main" id="{BF309F47-449E-493D-86F5-646828F4AD91}"/>
               </a:ext>
             </a:extLst>
           </p:cNvPr>
@@ -7616,7 +7616,7 @@
         <p:spPr>
           <a:xfrm xmlns:a="http://schemas.openxmlformats.org/drawingml/2006/main">
             <a:off x="4876800" y="2457450"/>
-            <a:ext cx="2000250" cy="495300"/>
+            <a:ext cx="1714500" cy="457200"/>
           </a:xfrm>
           <a:prstGeom xmlns:a="http://schemas.openxmlformats.org/drawingml/2006/main" prst="rect">
             <a:avLst/>
@@ -7667,19 +7667,19 @@
           <p:cNvPr id="9" name="">
             <a:extLst xmlns:a="http://schemas.openxmlformats.org/drawingml/2006/main">
               <a:ext uri="{FF2B5EF4-FFF2-40B4-BE49-F238E27FC236}">
-                <a16:creationId xmlns:a16="http://schemas.microsoft.com/office/drawing/2014/main" id="{0B2F75F6-F82A-47EA-A803-73D5252456EE}"/>
-              </a:ext>
-            </a:extLst>
-          </p:cNvPr>
-          <p:cNvSpPr>
-            <a:spLocks xmlns:a="http://schemas.openxmlformats.org/drawingml/2006/main" noGrp="1"/>
-          </p:cNvSpPr>
-          <p:nvPr/>
-        </p:nvSpPr>
-        <p:spPr>
-          <a:xfrm xmlns:a="http://schemas.openxmlformats.org/drawingml/2006/main">
-            <a:off x="4876800" y="2933700"/>
-            <a:ext cx="2000250" cy="419100"/>
+                <a16:creationId xmlns:a16="http://schemas.microsoft.com/office/drawing/2014/main" id="{3A29D9EF-7224-4D01-9981-CC79EA386EAD}"/>
+              </a:ext>
+            </a:extLst>
+          </p:cNvPr>
+          <p:cNvSpPr>
+            <a:spLocks xmlns:a="http://schemas.openxmlformats.org/drawingml/2006/main" noGrp="1"/>
+          </p:cNvSpPr>
+          <p:nvPr/>
+        </p:nvSpPr>
+        <p:spPr>
+          <a:xfrm xmlns:a="http://schemas.openxmlformats.org/drawingml/2006/main">
+            <a:off x="4876800" y="2990850"/>
+            <a:ext cx="1714500" cy="342900"/>
           </a:xfrm>
           <a:prstGeom xmlns:a="http://schemas.openxmlformats.org/drawingml/2006/main" prst="rect">
             <a:avLst/>
@@ -7734,7 +7734,7 @@
           <p:cNvPr id="10" name="">
             <a:extLst xmlns:a="http://schemas.openxmlformats.org/drawingml/2006/main">
               <a:ext uri="{FF2B5EF4-FFF2-40B4-BE49-F238E27FC236}">
-                <a16:creationId xmlns:a16="http://schemas.microsoft.com/office/drawing/2014/main" id="{225FBCC1-37A7-4171-9683-12CAA2CFACDD}"/>
+                <a16:creationId xmlns:a16="http://schemas.microsoft.com/office/drawing/2014/main" id="{F2A8491C-FC2C-4BC4-9D4E-BCFF8C5703DB}"/>
               </a:ext>
             </a:extLst>
           </p:cNvPr>
@@ -7746,7 +7746,7 @@
         <p:spPr>
           <a:xfrm xmlns:a="http://schemas.openxmlformats.org/drawingml/2006/main">
             <a:off x="6972300" y="2457450"/>
-            <a:ext cx="2000250" cy="495300"/>
+            <a:ext cx="1714500" cy="457200"/>
           </a:xfrm>
           <a:prstGeom xmlns:a="http://schemas.openxmlformats.org/drawingml/2006/main" prst="rect">
             <a:avLst/>
@@ -7797,19 +7797,19 @@
           <p:cNvPr id="11" name="">
             <a:extLst xmlns:a="http://schemas.openxmlformats.org/drawingml/2006/main">
               <a:ext uri="{FF2B5EF4-FFF2-40B4-BE49-F238E27FC236}">
-                <a16:creationId xmlns:a16="http://schemas.microsoft.com/office/drawing/2014/main" id="{6FD0B103-D253-47C0-870A-B5111345A538}"/>
-              </a:ext>
-            </a:extLst>
-          </p:cNvPr>
-          <p:cNvSpPr>
-            <a:spLocks xmlns:a="http://schemas.openxmlformats.org/drawingml/2006/main" noGrp="1"/>
-          </p:cNvSpPr>
-          <p:nvPr/>
-        </p:nvSpPr>
-        <p:spPr>
-          <a:xfrm xmlns:a="http://schemas.openxmlformats.org/drawingml/2006/main">
-            <a:off x="6972300" y="2933700"/>
-            <a:ext cx="2000250" cy="419100"/>
+                <a16:creationId xmlns:a16="http://schemas.microsoft.com/office/drawing/2014/main" id="{5C2FC74F-BE66-44DC-97D3-27195DE2E97D}"/>
+              </a:ext>
+            </a:extLst>
+          </p:cNvPr>
+          <p:cNvSpPr>
+            <a:spLocks xmlns:a="http://schemas.openxmlformats.org/drawingml/2006/main" noGrp="1"/>
+          </p:cNvSpPr>
+          <p:nvPr/>
+        </p:nvSpPr>
+        <p:spPr>
+          <a:xfrm xmlns:a="http://schemas.openxmlformats.org/drawingml/2006/main">
+            <a:off x="6972300" y="2990850"/>
+            <a:ext cx="1714500" cy="342900"/>
           </a:xfrm>
           <a:prstGeom xmlns:a="http://schemas.openxmlformats.org/drawingml/2006/main" prst="rect">
             <a:avLst/>
@@ -7864,7 +7864,7 @@
           <p:cNvPr id="12" name="">
             <a:extLst xmlns:a="http://schemas.openxmlformats.org/drawingml/2006/main">
               <a:ext uri="{FF2B5EF4-FFF2-40B4-BE49-F238E27FC236}">
-                <a16:creationId xmlns:a16="http://schemas.microsoft.com/office/drawing/2014/main" id="{996FCA17-2CD2-4E73-BF08-68F70CEB02B1}"/>
+                <a16:creationId xmlns:a16="http://schemas.microsoft.com/office/drawing/2014/main" id="{619F95E4-089D-404C-BB85-863918F8CCF6}"/>
               </a:ext>
             </a:extLst>
           </p:cNvPr>
@@ -7896,7 +7896,7 @@
           <p:cNvPr id="13" name="">
             <a:extLst xmlns:a="http://schemas.openxmlformats.org/drawingml/2006/main">
               <a:ext uri="{FF2B5EF4-FFF2-40B4-BE49-F238E27FC236}">
-                <a16:creationId xmlns:a16="http://schemas.microsoft.com/office/drawing/2014/main" id="{92922325-6C90-45D1-860B-32C7EAEF17BC}"/>
+                <a16:creationId xmlns:a16="http://schemas.microsoft.com/office/drawing/2014/main" id="{91B26793-3611-4D99-9714-5B5CC7CAA972}"/>
               </a:ext>
             </a:extLst>
           </p:cNvPr>
@@ -7959,7 +7959,7 @@
           <p:cNvPr id="14" name="">
             <a:extLst xmlns:a="http://schemas.openxmlformats.org/drawingml/2006/main">
               <a:ext uri="{FF2B5EF4-FFF2-40B4-BE49-F238E27FC236}">
-                <a16:creationId xmlns:a16="http://schemas.microsoft.com/office/drawing/2014/main" id="{95C614E2-9551-4FBD-B63C-03FAB8FE1790}"/>
+                <a16:creationId xmlns:a16="http://schemas.microsoft.com/office/drawing/2014/main" id="{7D09D023-9795-4894-9174-3C6DA89B41D6}"/>
               </a:ext>
             </a:extLst>
           </p:cNvPr>
@@ -8022,7 +8022,7 @@
           <p:cNvPr id="15" name="">
             <a:extLst xmlns:a="http://schemas.openxmlformats.org/drawingml/2006/main">
               <a:ext uri="{FF2B5EF4-FFF2-40B4-BE49-F238E27FC236}">
-                <a16:creationId xmlns:a16="http://schemas.microsoft.com/office/drawing/2014/main" id="{7FBB04BD-F459-4008-8393-CF4FB6B9EEED}"/>
+                <a16:creationId xmlns:a16="http://schemas.microsoft.com/office/drawing/2014/main" id="{D2C59B45-EDBA-4A27-A4C9-9763A3DCD0AD}"/>
               </a:ext>
             </a:extLst>
           </p:cNvPr>
@@ -8056,7 +8056,7 @@
           <p:cNvPr id="16" name="">
             <a:extLst xmlns:a="http://schemas.openxmlformats.org/drawingml/2006/main">
               <a:ext uri="{FF2B5EF4-FFF2-40B4-BE49-F238E27FC236}">
-                <a16:creationId xmlns:a16="http://schemas.microsoft.com/office/drawing/2014/main" id="{034D56D1-8041-4737-8B4E-E0474526C1B6}"/>
+                <a16:creationId xmlns:a16="http://schemas.microsoft.com/office/drawing/2014/main" id="{41FD10DA-6294-4A1C-A91F-38EC7253C11C}"/>
               </a:ext>
             </a:extLst>
           </p:cNvPr>
@@ -8088,7 +8088,7 @@
           <p:cNvPr id="17" name="">
             <a:extLst xmlns:a="http://schemas.openxmlformats.org/drawingml/2006/main">
               <a:ext uri="{FF2B5EF4-FFF2-40B4-BE49-F238E27FC236}">
-                <a16:creationId xmlns:a16="http://schemas.microsoft.com/office/drawing/2014/main" id="{DD32C6E1-E63C-4C19-92AC-62B690B56A88}"/>
+                <a16:creationId xmlns:a16="http://schemas.microsoft.com/office/drawing/2014/main" id="{CB907B38-5031-4247-B2FB-57E22B9EA7AB}"/>
               </a:ext>
             </a:extLst>
           </p:cNvPr>
@@ -8151,7 +8151,7 @@
           <p:cNvPr id="18" name="">
             <a:extLst xmlns:a="http://schemas.openxmlformats.org/drawingml/2006/main">
               <a:ext uri="{FF2B5EF4-FFF2-40B4-BE49-F238E27FC236}">
-                <a16:creationId xmlns:a16="http://schemas.microsoft.com/office/drawing/2014/main" id="{8523C5BB-695A-487B-883F-E29EAD06695F}"/>
+                <a16:creationId xmlns:a16="http://schemas.microsoft.com/office/drawing/2014/main" id="{52AE6051-582B-4FC0-9013-45937DB50F9A}"/>
               </a:ext>
             </a:extLst>
           </p:cNvPr>
@@ -8214,7 +8214,7 @@
           <p:cNvPr id="19" name="">
             <a:extLst xmlns:a="http://schemas.openxmlformats.org/drawingml/2006/main">
               <a:ext uri="{FF2B5EF4-FFF2-40B4-BE49-F238E27FC236}">
-                <a16:creationId xmlns:a16="http://schemas.microsoft.com/office/drawing/2014/main" id="{588E974F-5584-4C88-B355-E67009718367}"/>
+                <a16:creationId xmlns:a16="http://schemas.microsoft.com/office/drawing/2014/main" id="{31EBCC9B-5F0F-4D9D-905C-89F0DA328E41}"/>
               </a:ext>
             </a:extLst>
           </p:cNvPr>
@@ -8248,7 +8248,7 @@
           <p:cNvPr id="20" name="">
             <a:extLst xmlns:a="http://schemas.openxmlformats.org/drawingml/2006/main">
               <a:ext uri="{FF2B5EF4-FFF2-40B4-BE49-F238E27FC236}">
-                <a16:creationId xmlns:a16="http://schemas.microsoft.com/office/drawing/2014/main" id="{5C2DC0CA-790C-42BC-A42F-8EE63B4480E6}"/>
+                <a16:creationId xmlns:a16="http://schemas.microsoft.com/office/drawing/2014/main" id="{F7923DA8-38C2-4B87-86E7-BF7848F0C687}"/>
               </a:ext>
             </a:extLst>
           </p:cNvPr>
@@ -8280,7 +8280,7 @@
           <p:cNvPr id="21" name="">
             <a:extLst xmlns:a="http://schemas.openxmlformats.org/drawingml/2006/main">
               <a:ext uri="{FF2B5EF4-FFF2-40B4-BE49-F238E27FC236}">
-                <a16:creationId xmlns:a16="http://schemas.microsoft.com/office/drawing/2014/main" id="{AC2D7A34-8557-4494-9538-76492E3F5EFD}"/>
+                <a16:creationId xmlns:a16="http://schemas.microsoft.com/office/drawing/2014/main" id="{2F289E50-3023-45E8-9456-26BAE314B56F}"/>
               </a:ext>
             </a:extLst>
           </p:cNvPr>
@@ -8343,7 +8343,7 @@
           <p:cNvPr id="22" name="">
             <a:extLst xmlns:a="http://schemas.openxmlformats.org/drawingml/2006/main">
               <a:ext uri="{FF2B5EF4-FFF2-40B4-BE49-F238E27FC236}">
-                <a16:creationId xmlns:a16="http://schemas.microsoft.com/office/drawing/2014/main" id="{DB607879-BA2C-4292-B539-241EEFDA7D58}"/>
+                <a16:creationId xmlns:a16="http://schemas.microsoft.com/office/drawing/2014/main" id="{936597DE-FD43-42BB-BD45-09A266EACC61}"/>
               </a:ext>
             </a:extLst>
           </p:cNvPr>
@@ -8406,7 +8406,7 @@
           <p:cNvPr id="23" name="">
             <a:extLst xmlns:a="http://schemas.openxmlformats.org/drawingml/2006/main">
               <a:ext uri="{FF2B5EF4-FFF2-40B4-BE49-F238E27FC236}">
-                <a16:creationId xmlns:a16="http://schemas.microsoft.com/office/drawing/2014/main" id="{1C211367-19E8-4FBB-A3FC-C3EF60F97D4C}"/>
+                <a16:creationId xmlns:a16="http://schemas.microsoft.com/office/drawing/2014/main" id="{97C5CC2A-7B30-4116-BFE1-0667FF50A6A5}"/>
               </a:ext>
             </a:extLst>
           </p:cNvPr>
@@ -8440,7 +8440,7 @@
           <p:cNvPr id="24" name="">
             <a:extLst xmlns:a="http://schemas.openxmlformats.org/drawingml/2006/main">
               <a:ext uri="{FF2B5EF4-FFF2-40B4-BE49-F238E27FC236}">
-                <a16:creationId xmlns:a16="http://schemas.microsoft.com/office/drawing/2014/main" id="{453B7AFC-5F0D-4677-BBAB-00775D1F4ED2}"/>
+                <a16:creationId xmlns:a16="http://schemas.microsoft.com/office/drawing/2014/main" id="{BCC12B81-A712-4BDF-8B55-99872CA58F29}"/>
               </a:ext>
             </a:extLst>
           </p:cNvPr>
@@ -8472,7 +8472,7 @@
           <p:cNvPr id="25" name="">
             <a:extLst xmlns:a="http://schemas.openxmlformats.org/drawingml/2006/main">
               <a:ext uri="{FF2B5EF4-FFF2-40B4-BE49-F238E27FC236}">
-                <a16:creationId xmlns:a16="http://schemas.microsoft.com/office/drawing/2014/main" id="{2ADAFEBB-220E-4821-9FDE-7B19CB78BF57}"/>
+                <a16:creationId xmlns:a16="http://schemas.microsoft.com/office/drawing/2014/main" id="{101D3979-892F-4BF3-958E-83CA0725A6EF}"/>
               </a:ext>
             </a:extLst>
           </p:cNvPr>
@@ -8535,19 +8535,19 @@
           <p:cNvPr id="26" name="">
             <a:extLst xmlns:a="http://schemas.openxmlformats.org/drawingml/2006/main">
               <a:ext uri="{FF2B5EF4-FFF2-40B4-BE49-F238E27FC236}">
-                <a16:creationId xmlns:a16="http://schemas.microsoft.com/office/drawing/2014/main" id="{84FB7AF5-A308-41CC-B363-19D862815C15}"/>
-              </a:ext>
-            </a:extLst>
-          </p:cNvPr>
-          <p:cNvSpPr>
-            <a:spLocks xmlns:a="http://schemas.openxmlformats.org/drawingml/2006/main" noGrp="1"/>
-          </p:cNvSpPr>
-          <p:nvPr/>
-        </p:nvSpPr>
-        <p:spPr>
-          <a:xfrm xmlns:a="http://schemas.openxmlformats.org/drawingml/2006/main">
-            <a:off x="914400" y="5353050"/>
-            <a:ext cx="3857625" cy="209550"/>
+                <a16:creationId xmlns:a16="http://schemas.microsoft.com/office/drawing/2014/main" id="{FD307C7B-477C-4F56-8ECC-85BC36C24605}"/>
+              </a:ext>
+            </a:extLst>
+          </p:cNvPr>
+          <p:cNvSpPr>
+            <a:spLocks xmlns:a="http://schemas.openxmlformats.org/drawingml/2006/main" noGrp="1"/>
+          </p:cNvSpPr>
+          <p:nvPr/>
+        </p:nvSpPr>
+        <p:spPr>
+          <a:xfrm xmlns:a="http://schemas.openxmlformats.org/drawingml/2006/main">
+            <a:off x="914400" y="5219700"/>
+            <a:ext cx="3857625" cy="228600"/>
           </a:xfrm>
           <a:prstGeom xmlns:a="http://schemas.openxmlformats.org/drawingml/2006/main" prst="rect">
             <a:avLst/>
@@ -8602,7 +8602,7 @@
           <p:cNvPr id="27" name="">
             <a:extLst xmlns:a="http://schemas.openxmlformats.org/drawingml/2006/main">
               <a:ext uri="{FF2B5EF4-FFF2-40B4-BE49-F238E27FC236}">
-                <a16:creationId xmlns:a16="http://schemas.microsoft.com/office/drawing/2014/main" id="{E6F5513A-2C80-4425-A51A-747EDF7CB242}"/>
+                <a16:creationId xmlns:a16="http://schemas.microsoft.com/office/drawing/2014/main" id="{DBB484E7-81BC-433F-8FC6-36E94D68533F}"/>
               </a:ext>
             </a:extLst>
           </p:cNvPr>
@@ -8634,7 +8634,7 @@
           <p:cNvPr id="28" name="">
             <a:extLst xmlns:a="http://schemas.openxmlformats.org/drawingml/2006/main">
               <a:ext uri="{FF2B5EF4-FFF2-40B4-BE49-F238E27FC236}">
-                <a16:creationId xmlns:a16="http://schemas.microsoft.com/office/drawing/2014/main" id="{331073B4-E621-4919-9F9A-91512A005722}"/>
+                <a16:creationId xmlns:a16="http://schemas.microsoft.com/office/drawing/2014/main" id="{F3847438-CEB3-4E70-BE30-91DDEE09D0E9}"/>
               </a:ext>
             </a:extLst>
           </p:cNvPr>
@@ -8697,7 +8697,7 @@
           <p:cNvPr id="29" name="">
             <a:extLst xmlns:a="http://schemas.openxmlformats.org/drawingml/2006/main">
               <a:ext uri="{FF2B5EF4-FFF2-40B4-BE49-F238E27FC236}">
-                <a16:creationId xmlns:a16="http://schemas.microsoft.com/office/drawing/2014/main" id="{EEFB37B5-E593-4ECF-A0C5-09CA8DF8E5E7}"/>
+                <a16:creationId xmlns:a16="http://schemas.microsoft.com/office/drawing/2014/main" id="{11B0C01D-62AC-4A42-9DC7-6D2BE1A4F84F}"/>
               </a:ext>
             </a:extLst>
           </p:cNvPr>
@@ -8760,7 +8760,7 @@
           <p:cNvPr id="30" name="">
             <a:extLst xmlns:a="http://schemas.openxmlformats.org/drawingml/2006/main">
               <a:ext uri="{FF2B5EF4-FFF2-40B4-BE49-F238E27FC236}">
-                <a16:creationId xmlns:a16="http://schemas.microsoft.com/office/drawing/2014/main" id="{562284EF-307D-4DE1-AA44-C809DB76F824}"/>
+                <a16:creationId xmlns:a16="http://schemas.microsoft.com/office/drawing/2014/main" id="{B038BCC7-D01D-4CD1-B920-92B4E3235430}"/>
               </a:ext>
             </a:extLst>
           </p:cNvPr>
@@ -8794,7 +8794,7 @@
           <p:cNvPr id="31" name="">
             <a:extLst xmlns:a="http://schemas.openxmlformats.org/drawingml/2006/main">
               <a:ext uri="{FF2B5EF4-FFF2-40B4-BE49-F238E27FC236}">
-                <a16:creationId xmlns:a16="http://schemas.microsoft.com/office/drawing/2014/main" id="{E7DEF380-52AD-4BFB-B2A7-B451E3425F83}"/>
+                <a16:creationId xmlns:a16="http://schemas.microsoft.com/office/drawing/2014/main" id="{3B13504A-4535-46BB-92D8-3B20F0601CC5}"/>
               </a:ext>
             </a:extLst>
           </p:cNvPr>
@@ -8826,7 +8826,7 @@
           <p:cNvPr id="32" name="">
             <a:extLst xmlns:a="http://schemas.openxmlformats.org/drawingml/2006/main">
               <a:ext uri="{FF2B5EF4-FFF2-40B4-BE49-F238E27FC236}">
-                <a16:creationId xmlns:a16="http://schemas.microsoft.com/office/drawing/2014/main" id="{5979FF5A-979C-454E-8409-FB3C6BD5B586}"/>
+                <a16:creationId xmlns:a16="http://schemas.microsoft.com/office/drawing/2014/main" id="{1DE7F031-94E1-4293-8BC0-1269231399B5}"/>
               </a:ext>
             </a:extLst>
           </p:cNvPr>
@@ -8889,7 +8889,7 @@
           <p:cNvPr id="33" name="">
             <a:extLst xmlns:a="http://schemas.openxmlformats.org/drawingml/2006/main">
               <a:ext uri="{FF2B5EF4-FFF2-40B4-BE49-F238E27FC236}">
-                <a16:creationId xmlns:a16="http://schemas.microsoft.com/office/drawing/2014/main" id="{B1937A8D-755B-4F55-A6C7-7FBE1D59A3AE}"/>
+                <a16:creationId xmlns:a16="http://schemas.microsoft.com/office/drawing/2014/main" id="{2824B660-E551-4B0A-B731-5B000531E647}"/>
               </a:ext>
             </a:extLst>
           </p:cNvPr>
@@ -8952,7 +8952,7 @@
           <p:cNvPr id="34" name="">
             <a:extLst xmlns:a="http://schemas.openxmlformats.org/drawingml/2006/main">
               <a:ext uri="{FF2B5EF4-FFF2-40B4-BE49-F238E27FC236}">
-                <a16:creationId xmlns:a16="http://schemas.microsoft.com/office/drawing/2014/main" id="{7B682BB0-6BD5-4AD8-ACD0-A7E0C4CD0427}"/>
+                <a16:creationId xmlns:a16="http://schemas.microsoft.com/office/drawing/2014/main" id="{963A6BF1-0ADA-43A8-AA8B-BE5C024BE386}"/>
               </a:ext>
             </a:extLst>
           </p:cNvPr>
@@ -8986,7 +8986,7 @@
           <p:cNvPr id="35" name="">
             <a:extLst xmlns:a="http://schemas.openxmlformats.org/drawingml/2006/main">
               <a:ext uri="{FF2B5EF4-FFF2-40B4-BE49-F238E27FC236}">
-                <a16:creationId xmlns:a16="http://schemas.microsoft.com/office/drawing/2014/main" id="{F4CC8A52-B799-4EB8-9877-5297C7868BF9}"/>
+                <a16:creationId xmlns:a16="http://schemas.microsoft.com/office/drawing/2014/main" id="{85B1C8DF-15FE-4279-8731-EC87C4A88ACA}"/>
               </a:ext>
             </a:extLst>
           </p:cNvPr>
@@ -9018,7 +9018,7 @@
           <p:cNvPr id="36" name="">
             <a:extLst xmlns:a="http://schemas.openxmlformats.org/drawingml/2006/main">
               <a:ext uri="{FF2B5EF4-FFF2-40B4-BE49-F238E27FC236}">
-                <a16:creationId xmlns:a16="http://schemas.microsoft.com/office/drawing/2014/main" id="{E8EE33B2-44F1-44E8-8B22-E53CF3CE4268}"/>
+                <a16:creationId xmlns:a16="http://schemas.microsoft.com/office/drawing/2014/main" id="{EB65F3F8-3EBA-4FF9-87F6-D2D39BB309BD}"/>
               </a:ext>
             </a:extLst>
           </p:cNvPr>
@@ -9081,7 +9081,7 @@
           <p:cNvPr id="37" name="">
             <a:extLst xmlns:a="http://schemas.openxmlformats.org/drawingml/2006/main">
               <a:ext uri="{FF2B5EF4-FFF2-40B4-BE49-F238E27FC236}">
-                <a16:creationId xmlns:a16="http://schemas.microsoft.com/office/drawing/2014/main" id="{8010D889-EBEA-498E-9942-CC6D6ED9E76F}"/>
+                <a16:creationId xmlns:a16="http://schemas.microsoft.com/office/drawing/2014/main" id="{D2F74D7B-A2BE-4F54-AD38-1E447AF2C926}"/>
               </a:ext>
             </a:extLst>
           </p:cNvPr>
@@ -9144,7 +9144,7 @@
           <p:cNvPr id="38" name="">
             <a:extLst xmlns:a="http://schemas.openxmlformats.org/drawingml/2006/main">
               <a:ext uri="{FF2B5EF4-FFF2-40B4-BE49-F238E27FC236}">
-                <a16:creationId xmlns:a16="http://schemas.microsoft.com/office/drawing/2014/main" id="{6E6D94D1-8E06-4EE8-85B3-1960DAE4D502}"/>
+                <a16:creationId xmlns:a16="http://schemas.microsoft.com/office/drawing/2014/main" id="{12EE79E9-8E19-4596-A568-37F6333E7522}"/>
               </a:ext>
             </a:extLst>
           </p:cNvPr>
@@ -9178,7 +9178,7 @@
           <p:cNvPr id="39" name="">
             <a:extLst xmlns:a="http://schemas.openxmlformats.org/drawingml/2006/main">
               <a:ext uri="{FF2B5EF4-FFF2-40B4-BE49-F238E27FC236}">
-                <a16:creationId xmlns:a16="http://schemas.microsoft.com/office/drawing/2014/main" id="{64752577-A6BA-4E04-854C-8C04BA9283E7}"/>
+                <a16:creationId xmlns:a16="http://schemas.microsoft.com/office/drawing/2014/main" id="{D7393702-E1A0-460D-97D9-7185A60C35DB}"/>
               </a:ext>
             </a:extLst>
           </p:cNvPr>
@@ -9210,7 +9210,7 @@
           <p:cNvPr id="40" name="">
             <a:extLst xmlns:a="http://schemas.openxmlformats.org/drawingml/2006/main">
               <a:ext uri="{FF2B5EF4-FFF2-40B4-BE49-F238E27FC236}">
-                <a16:creationId xmlns:a16="http://schemas.microsoft.com/office/drawing/2014/main" id="{1EDBA5A6-9E85-406E-BF92-9F6606A98052}"/>
+                <a16:creationId xmlns:a16="http://schemas.microsoft.com/office/drawing/2014/main" id="{AC4D3756-0BBF-445E-B6F0-E99443CEE728}"/>
               </a:ext>
             </a:extLst>
           </p:cNvPr>
@@ -9273,19 +9273,19 @@
           <p:cNvPr id="41" name="">
             <a:extLst xmlns:a="http://schemas.openxmlformats.org/drawingml/2006/main">
               <a:ext uri="{FF2B5EF4-FFF2-40B4-BE49-F238E27FC236}">
-                <a16:creationId xmlns:a16="http://schemas.microsoft.com/office/drawing/2014/main" id="{F098F4E7-672F-408A-8B53-42B582BAD412}"/>
-              </a:ext>
-            </a:extLst>
-          </p:cNvPr>
-          <p:cNvSpPr>
-            <a:spLocks xmlns:a="http://schemas.openxmlformats.org/drawingml/2006/main" noGrp="1"/>
-          </p:cNvSpPr>
-          <p:nvPr/>
-        </p:nvSpPr>
-        <p:spPr>
-          <a:xfrm xmlns:a="http://schemas.openxmlformats.org/drawingml/2006/main">
-            <a:off x="6419850" y="5353050"/>
-            <a:ext cx="3857625" cy="209550"/>
+                <a16:creationId xmlns:a16="http://schemas.microsoft.com/office/drawing/2014/main" id="{B863B60E-101F-4E0F-B1C5-2A4CCA2E7F0B}"/>
+              </a:ext>
+            </a:extLst>
+          </p:cNvPr>
+          <p:cNvSpPr>
+            <a:spLocks xmlns:a="http://schemas.openxmlformats.org/drawingml/2006/main" noGrp="1"/>
+          </p:cNvSpPr>
+          <p:nvPr/>
+        </p:nvSpPr>
+        <p:spPr>
+          <a:xfrm xmlns:a="http://schemas.openxmlformats.org/drawingml/2006/main">
+            <a:off x="6419850" y="5219700"/>
+            <a:ext cx="3857625" cy="228600"/>
           </a:xfrm>
           <a:prstGeom xmlns:a="http://schemas.openxmlformats.org/drawingml/2006/main" prst="rect">
             <a:avLst/>
@@ -9340,7 +9340,7 @@
           <p:cNvPr id="42" name="">
             <a:extLst xmlns:a="http://schemas.openxmlformats.org/drawingml/2006/main">
               <a:ext uri="{FF2B5EF4-FFF2-40B4-BE49-F238E27FC236}">
-                <a16:creationId xmlns:a16="http://schemas.microsoft.com/office/drawing/2014/main" id="{73D0CB0B-F914-4617-A0A8-75443C470F15}"/>
+                <a16:creationId xmlns:a16="http://schemas.microsoft.com/office/drawing/2014/main" id="{1DA4712E-0B07-48BF-BC0A-E4548E5F4F81}"/>
               </a:ext>
             </a:extLst>
           </p:cNvPr>
@@ -9403,7 +9403,7 @@
           <p:cNvPr id="43" name="">
             <a:extLst xmlns:a="http://schemas.openxmlformats.org/drawingml/2006/main">
               <a:ext uri="{FF2B5EF4-FFF2-40B4-BE49-F238E27FC236}">
-                <a16:creationId xmlns:a16="http://schemas.microsoft.com/office/drawing/2014/main" id="{95856B0C-2A84-4796-AE17-DCED6680B1F2}"/>
+                <a16:creationId xmlns:a16="http://schemas.microsoft.com/office/drawing/2014/main" id="{D63F3A6B-FBFF-47E5-871C-00D70E629784}"/>
               </a:ext>
             </a:extLst>
           </p:cNvPr>
@@ -9435,7 +9435,7 @@
           <p:cNvPr id="44" name="">
             <a:extLst xmlns:a="http://schemas.openxmlformats.org/drawingml/2006/main">
               <a:ext uri="{FF2B5EF4-FFF2-40B4-BE49-F238E27FC236}">
-                <a16:creationId xmlns:a16="http://schemas.microsoft.com/office/drawing/2014/main" id="{C31104C8-D917-47CA-86CA-D3F415F3465C}"/>
+                <a16:creationId xmlns:a16="http://schemas.microsoft.com/office/drawing/2014/main" id="{D0EF95D8-D98B-4E49-9B1B-75658F488ED7}"/>
               </a:ext>
             </a:extLst>
           </p:cNvPr>
@@ -9498,7 +9498,7 @@
           <p:cNvPr id="45" name="">
             <a:extLst xmlns:a="http://schemas.openxmlformats.org/drawingml/2006/main">
               <a:ext uri="{FF2B5EF4-FFF2-40B4-BE49-F238E27FC236}">
-                <a16:creationId xmlns:a16="http://schemas.microsoft.com/office/drawing/2014/main" id="{96A8A5F9-6CF8-470A-A3C6-11E2B3768E1F}"/>
+                <a16:creationId xmlns:a16="http://schemas.microsoft.com/office/drawing/2014/main" id="{64E321AC-F676-4D91-8476-FA0F200FFA5C}"/>
               </a:ext>
             </a:extLst>
           </p:cNvPr>
@@ -9559,7 +9559,7 @@
     </p:spTree>
     <p:extLst>
       <p:ext uri="{BB962C8B-B14F-4D97-AF65-F5344CB8AC3E}">
-        <p14:creationId xmlns:p14="http://schemas.microsoft.com/office/powerpoint/2010/main" val="1082522161"/>
+        <p14:creationId xmlns:p14="http://schemas.microsoft.com/office/powerpoint/2010/main" val="1229948495"/>
       </p:ext>
     </p:extLst>
   </p:cSld>
@@ -9590,7 +9590,7 @@
           <p:cNvPr id="1" name="">
             <a:extLst xmlns:a="http://schemas.openxmlformats.org/drawingml/2006/main">
               <a:ext uri="{FF2B5EF4-FFF2-40B4-BE49-F238E27FC236}">
-                <a16:creationId xmlns:a16="http://schemas.microsoft.com/office/drawing/2014/main" id="{7BA53B5F-31C0-4C50-A77C-F83921C940F2}"/>
+                <a16:creationId xmlns:a16="http://schemas.microsoft.com/office/drawing/2014/main" id="{1457CAA7-21D2-4036-8FC3-5A648A08288E}"/>
               </a:ext>
             </a:extLst>
           </p:cNvPr>
@@ -9653,7 +9653,7 @@
           <p:cNvPr id="2" name="">
             <a:extLst xmlns:a="http://schemas.openxmlformats.org/drawingml/2006/main">
               <a:ext uri="{FF2B5EF4-FFF2-40B4-BE49-F238E27FC236}">
-                <a16:creationId xmlns:a16="http://schemas.microsoft.com/office/drawing/2014/main" id="{C5E5F73A-6900-4D33-BFBE-6035FBB93354}"/>
+                <a16:creationId xmlns:a16="http://schemas.microsoft.com/office/drawing/2014/main" id="{725495BF-2696-4B1F-A5CC-989810568E08}"/>
               </a:ext>
             </a:extLst>
           </p:cNvPr>
@@ -9720,7 +9720,7 @@
           <p:cNvPr id="3" name="">
             <a:extLst xmlns:a="http://schemas.openxmlformats.org/drawingml/2006/main">
               <a:ext uri="{FF2B5EF4-FFF2-40B4-BE49-F238E27FC236}">
-                <a16:creationId xmlns:a16="http://schemas.microsoft.com/office/drawing/2014/main" id="{CA746005-0E72-413C-B781-BDAE2266CAC5}"/>
+                <a16:creationId xmlns:a16="http://schemas.microsoft.com/office/drawing/2014/main" id="{9635BE5B-7C5F-4F5D-8420-D4DFECE7FC8D}"/>
               </a:ext>
             </a:extLst>
           </p:cNvPr>
@@ -9787,7 +9787,7 @@
           <p:cNvPr id="4" name="">
             <a:extLst xmlns:a="http://schemas.openxmlformats.org/drawingml/2006/main">
               <a:ext uri="{FF2B5EF4-FFF2-40B4-BE49-F238E27FC236}">
-                <a16:creationId xmlns:a16="http://schemas.microsoft.com/office/drawing/2014/main" id="{9ECA4A0A-9ED5-449F-B391-A308052FB442}"/>
+                <a16:creationId xmlns:a16="http://schemas.microsoft.com/office/drawing/2014/main" id="{859B0130-9DE5-4885-A03D-DC9E86D3930C}"/>
               </a:ext>
             </a:extLst>
           </p:cNvPr>
@@ -9819,7 +9819,7 @@
           <p:cNvPr id="5" name="">
             <a:extLst xmlns:a="http://schemas.openxmlformats.org/drawingml/2006/main">
               <a:ext uri="{FF2B5EF4-FFF2-40B4-BE49-F238E27FC236}">
-                <a16:creationId xmlns:a16="http://schemas.microsoft.com/office/drawing/2014/main" id="{A4EAE0BC-0FF6-4605-A830-3FA8FE485E01}"/>
+                <a16:creationId xmlns:a16="http://schemas.microsoft.com/office/drawing/2014/main" id="{401E7449-D789-4297-896F-E29D33F439EA}"/>
               </a:ext>
             </a:extLst>
           </p:cNvPr>
@@ -9882,7 +9882,7 @@
           <p:cNvPr id="6" name="">
             <a:extLst xmlns:a="http://schemas.openxmlformats.org/drawingml/2006/main">
               <a:ext uri="{FF2B5EF4-FFF2-40B4-BE49-F238E27FC236}">
-                <a16:creationId xmlns:a16="http://schemas.microsoft.com/office/drawing/2014/main" id="{0E44FC86-03C0-474D-8D8B-ABF7AD48070F}"/>
+                <a16:creationId xmlns:a16="http://schemas.microsoft.com/office/drawing/2014/main" id="{FAC01BC0-E55E-4FEA-A51F-F7DBF022C036}"/>
               </a:ext>
             </a:extLst>
           </p:cNvPr>
@@ -9945,7 +9945,7 @@
           <p:cNvPr id="7" name="">
             <a:extLst xmlns:a="http://schemas.openxmlformats.org/drawingml/2006/main">
               <a:ext uri="{FF2B5EF4-FFF2-40B4-BE49-F238E27FC236}">
-                <a16:creationId xmlns:a16="http://schemas.microsoft.com/office/drawing/2014/main" id="{8FFB45DC-03F8-4E49-B8C2-C07AEA5EF400}"/>
+                <a16:creationId xmlns:a16="http://schemas.microsoft.com/office/drawing/2014/main" id="{1775B342-FB4D-4346-ACC2-457796C77BF4}"/>
               </a:ext>
             </a:extLst>
           </p:cNvPr>
@@ -9979,7 +9979,7 @@
           <p:cNvPr id="8" name="">
             <a:extLst xmlns:a="http://schemas.openxmlformats.org/drawingml/2006/main">
               <a:ext uri="{FF2B5EF4-FFF2-40B4-BE49-F238E27FC236}">
-                <a16:creationId xmlns:a16="http://schemas.microsoft.com/office/drawing/2014/main" id="{5A395832-40C0-40DC-BBC5-A3D66A6A06B6}"/>
+                <a16:creationId xmlns:a16="http://schemas.microsoft.com/office/drawing/2014/main" id="{A0446C0C-06D7-4D46-89B5-4BE01C235705}"/>
               </a:ext>
             </a:extLst>
           </p:cNvPr>
@@ -10011,7 +10011,7 @@
           <p:cNvPr id="9" name="">
             <a:extLst xmlns:a="http://schemas.openxmlformats.org/drawingml/2006/main">
               <a:ext uri="{FF2B5EF4-FFF2-40B4-BE49-F238E27FC236}">
-                <a16:creationId xmlns:a16="http://schemas.microsoft.com/office/drawing/2014/main" id="{585F3173-CCF1-4586-A2F4-DF33FF6CB579}"/>
+                <a16:creationId xmlns:a16="http://schemas.microsoft.com/office/drawing/2014/main" id="{C8AEB312-20FB-47BD-A1E8-FAE08E5F41D2}"/>
               </a:ext>
             </a:extLst>
           </p:cNvPr>
@@ -10074,7 +10074,7 @@
           <p:cNvPr id="10" name="">
             <a:extLst xmlns:a="http://schemas.openxmlformats.org/drawingml/2006/main">
               <a:ext uri="{FF2B5EF4-FFF2-40B4-BE49-F238E27FC236}">
-                <a16:creationId xmlns:a16="http://schemas.microsoft.com/office/drawing/2014/main" id="{6BF5E804-33FE-4D60-8941-A377BFD00A4D}"/>
+                <a16:creationId xmlns:a16="http://schemas.microsoft.com/office/drawing/2014/main" id="{2208808E-1C4A-4C0F-BFE6-D53E0532DCA5}"/>
               </a:ext>
             </a:extLst>
           </p:cNvPr>
@@ -10137,7 +10137,7 @@
           <p:cNvPr id="11" name="">
             <a:extLst xmlns:a="http://schemas.openxmlformats.org/drawingml/2006/main">
               <a:ext uri="{FF2B5EF4-FFF2-40B4-BE49-F238E27FC236}">
-                <a16:creationId xmlns:a16="http://schemas.microsoft.com/office/drawing/2014/main" id="{4463F9E4-B78E-4501-91B4-19A9B058F0D8}"/>
+                <a16:creationId xmlns:a16="http://schemas.microsoft.com/office/drawing/2014/main" id="{CE889AAB-A682-47C5-97FA-9C04E12BA023}"/>
               </a:ext>
             </a:extLst>
           </p:cNvPr>
@@ -10171,7 +10171,7 @@
           <p:cNvPr id="12" name="">
             <a:extLst xmlns:a="http://schemas.openxmlformats.org/drawingml/2006/main">
               <a:ext uri="{FF2B5EF4-FFF2-40B4-BE49-F238E27FC236}">
-                <a16:creationId xmlns:a16="http://schemas.microsoft.com/office/drawing/2014/main" id="{89D1F161-E8AD-444D-886C-D7069057AA9E}"/>
+                <a16:creationId xmlns:a16="http://schemas.microsoft.com/office/drawing/2014/main" id="{C9E902A1-CF38-426B-88CA-301A70ED33A6}"/>
               </a:ext>
             </a:extLst>
           </p:cNvPr>
@@ -10203,7 +10203,7 @@
           <p:cNvPr id="13" name="">
             <a:extLst xmlns:a="http://schemas.openxmlformats.org/drawingml/2006/main">
               <a:ext uri="{FF2B5EF4-FFF2-40B4-BE49-F238E27FC236}">
-                <a16:creationId xmlns:a16="http://schemas.microsoft.com/office/drawing/2014/main" id="{5BFC2E19-2ADD-44C9-B5F6-9ED4C11F895F}"/>
+                <a16:creationId xmlns:a16="http://schemas.microsoft.com/office/drawing/2014/main" id="{9EEF5C23-1A0D-485F-B771-270064885C23}"/>
               </a:ext>
             </a:extLst>
           </p:cNvPr>
@@ -10266,7 +10266,7 @@
           <p:cNvPr id="14" name="">
             <a:extLst xmlns:a="http://schemas.openxmlformats.org/drawingml/2006/main">
               <a:ext uri="{FF2B5EF4-FFF2-40B4-BE49-F238E27FC236}">
-                <a16:creationId xmlns:a16="http://schemas.microsoft.com/office/drawing/2014/main" id="{89BAF945-CD6C-4A2F-A1B5-D087BDC5DFEC}"/>
+                <a16:creationId xmlns:a16="http://schemas.microsoft.com/office/drawing/2014/main" id="{BE53A71F-40B9-4875-A757-A5E57758EF0B}"/>
               </a:ext>
             </a:extLst>
           </p:cNvPr>
@@ -10329,7 +10329,7 @@
           <p:cNvPr id="15" name="">
             <a:extLst xmlns:a="http://schemas.openxmlformats.org/drawingml/2006/main">
               <a:ext uri="{FF2B5EF4-FFF2-40B4-BE49-F238E27FC236}">
-                <a16:creationId xmlns:a16="http://schemas.microsoft.com/office/drawing/2014/main" id="{2B3DBE6D-5412-4121-AB43-2A280A68EE90}"/>
+                <a16:creationId xmlns:a16="http://schemas.microsoft.com/office/drawing/2014/main" id="{2C4721D0-6C0C-4B5C-9574-CEE9432519CC}"/>
               </a:ext>
             </a:extLst>
           </p:cNvPr>
@@ -10363,7 +10363,7 @@
           <p:cNvPr id="16" name="">
             <a:extLst xmlns:a="http://schemas.openxmlformats.org/drawingml/2006/main">
               <a:ext uri="{FF2B5EF4-FFF2-40B4-BE49-F238E27FC236}">
-                <a16:creationId xmlns:a16="http://schemas.microsoft.com/office/drawing/2014/main" id="{4DDCE97D-816A-4839-B35A-0BEE42832FC8}"/>
+                <a16:creationId xmlns:a16="http://schemas.microsoft.com/office/drawing/2014/main" id="{E6CFD577-CEB7-4FDA-A460-04B16DCEFC2B}"/>
               </a:ext>
             </a:extLst>
           </p:cNvPr>
@@ -10395,7 +10395,7 @@
           <p:cNvPr id="17" name="">
             <a:extLst xmlns:a="http://schemas.openxmlformats.org/drawingml/2006/main">
               <a:ext uri="{FF2B5EF4-FFF2-40B4-BE49-F238E27FC236}">
-                <a16:creationId xmlns:a16="http://schemas.microsoft.com/office/drawing/2014/main" id="{45BF0263-66F6-49BB-AF5C-A887B672B986}"/>
+                <a16:creationId xmlns:a16="http://schemas.microsoft.com/office/drawing/2014/main" id="{3F097DC4-BB34-45BA-A120-24AE1B97FC8C}"/>
               </a:ext>
             </a:extLst>
           </p:cNvPr>
@@ -10458,7 +10458,7 @@
           <p:cNvPr id="18" name="">
             <a:extLst xmlns:a="http://schemas.openxmlformats.org/drawingml/2006/main">
               <a:ext uri="{FF2B5EF4-FFF2-40B4-BE49-F238E27FC236}">
-                <a16:creationId xmlns:a16="http://schemas.microsoft.com/office/drawing/2014/main" id="{9F2D55E7-D54D-4CED-929C-8635906AFC26}"/>
+                <a16:creationId xmlns:a16="http://schemas.microsoft.com/office/drawing/2014/main" id="{E6CDC870-5F6B-43E1-8ECB-776601D135D4}"/>
               </a:ext>
             </a:extLst>
           </p:cNvPr>
@@ -10521,7 +10521,7 @@
           <p:cNvPr id="19" name="">
             <a:extLst xmlns:a="http://schemas.openxmlformats.org/drawingml/2006/main">
               <a:ext uri="{FF2B5EF4-FFF2-40B4-BE49-F238E27FC236}">
-                <a16:creationId xmlns:a16="http://schemas.microsoft.com/office/drawing/2014/main" id="{D76880EA-CDE8-4714-A56A-935777C7B72E}"/>
+                <a16:creationId xmlns:a16="http://schemas.microsoft.com/office/drawing/2014/main" id="{85A28A16-5B6D-4D77-9339-F859EA61B1DD}"/>
               </a:ext>
             </a:extLst>
           </p:cNvPr>
@@ -10555,7 +10555,7 @@
           <p:cNvPr id="20" name="">
             <a:extLst xmlns:a="http://schemas.openxmlformats.org/drawingml/2006/main">
               <a:ext uri="{FF2B5EF4-FFF2-40B4-BE49-F238E27FC236}">
-                <a16:creationId xmlns:a16="http://schemas.microsoft.com/office/drawing/2014/main" id="{0E5270F1-533A-4DF5-81B0-ACC2F7461A4E}"/>
+                <a16:creationId xmlns:a16="http://schemas.microsoft.com/office/drawing/2014/main" id="{AB8F21BE-C7CF-42A1-8129-F22D682CB310}"/>
               </a:ext>
             </a:extLst>
           </p:cNvPr>
@@ -10587,7 +10587,7 @@
           <p:cNvPr id="21" name="">
             <a:extLst xmlns:a="http://schemas.openxmlformats.org/drawingml/2006/main">
               <a:ext uri="{FF2B5EF4-FFF2-40B4-BE49-F238E27FC236}">
-                <a16:creationId xmlns:a16="http://schemas.microsoft.com/office/drawing/2014/main" id="{1BE565EB-E443-4812-945F-CBF933C69304}"/>
+                <a16:creationId xmlns:a16="http://schemas.microsoft.com/office/drawing/2014/main" id="{1411FEAB-606C-40AD-9503-DD64798306D0}"/>
               </a:ext>
             </a:extLst>
           </p:cNvPr>
@@ -10650,7 +10650,7 @@
           <p:cNvPr id="22" name="">
             <a:extLst xmlns:a="http://schemas.openxmlformats.org/drawingml/2006/main">
               <a:ext uri="{FF2B5EF4-FFF2-40B4-BE49-F238E27FC236}">
-                <a16:creationId xmlns:a16="http://schemas.microsoft.com/office/drawing/2014/main" id="{8379827E-B5A5-4F23-8B14-B63C63BBC774}"/>
+                <a16:creationId xmlns:a16="http://schemas.microsoft.com/office/drawing/2014/main" id="{61B44175-8D31-4B41-91AD-9FAFE519E04D}"/>
               </a:ext>
             </a:extLst>
           </p:cNvPr>
@@ -10713,7 +10713,7 @@
           <p:cNvPr id="23" name="">
             <a:extLst xmlns:a="http://schemas.openxmlformats.org/drawingml/2006/main">
               <a:ext uri="{FF2B5EF4-FFF2-40B4-BE49-F238E27FC236}">
-                <a16:creationId xmlns:a16="http://schemas.microsoft.com/office/drawing/2014/main" id="{8A326871-974F-4483-BE3A-871EC5D521C2}"/>
+                <a16:creationId xmlns:a16="http://schemas.microsoft.com/office/drawing/2014/main" id="{572D3681-7323-4A40-9FEE-135FB7BFA891}"/>
               </a:ext>
             </a:extLst>
           </p:cNvPr>
@@ -10747,7 +10747,7 @@
           <p:cNvPr id="24" name="">
             <a:extLst xmlns:a="http://schemas.openxmlformats.org/drawingml/2006/main">
               <a:ext uri="{FF2B5EF4-FFF2-40B4-BE49-F238E27FC236}">
-                <a16:creationId xmlns:a16="http://schemas.microsoft.com/office/drawing/2014/main" id="{C2EB4001-9BB3-4B93-85FF-C77B3F7D75EF}"/>
+                <a16:creationId xmlns:a16="http://schemas.microsoft.com/office/drawing/2014/main" id="{67043DB0-D6D2-417C-9A44-66CEE2E00433}"/>
               </a:ext>
             </a:extLst>
           </p:cNvPr>
@@ -10779,7 +10779,7 @@
           <p:cNvPr id="25" name="">
             <a:extLst xmlns:a="http://schemas.openxmlformats.org/drawingml/2006/main">
               <a:ext uri="{FF2B5EF4-FFF2-40B4-BE49-F238E27FC236}">
-                <a16:creationId xmlns:a16="http://schemas.microsoft.com/office/drawing/2014/main" id="{4551FA2F-6E0C-4573-B2F8-B9AF350BBCF2}"/>
+                <a16:creationId xmlns:a16="http://schemas.microsoft.com/office/drawing/2014/main" id="{7FFA58A0-7E4F-482B-802A-64174D58DE6B}"/>
               </a:ext>
             </a:extLst>
           </p:cNvPr>
@@ -10842,7 +10842,7 @@
           <p:cNvPr id="26" name="">
             <a:extLst xmlns:a="http://schemas.openxmlformats.org/drawingml/2006/main">
               <a:ext uri="{FF2B5EF4-FFF2-40B4-BE49-F238E27FC236}">
-                <a16:creationId xmlns:a16="http://schemas.microsoft.com/office/drawing/2014/main" id="{E7D4C33F-0FFE-4CD0-9B29-C18197C425F9}"/>
+                <a16:creationId xmlns:a16="http://schemas.microsoft.com/office/drawing/2014/main" id="{ADBFB4E1-73C9-4E48-8612-55824874E7BF}"/>
               </a:ext>
             </a:extLst>
           </p:cNvPr>
@@ -10909,7 +10909,7 @@
           <p:cNvPr id="27" name="">
             <a:extLst xmlns:a="http://schemas.openxmlformats.org/drawingml/2006/main">
               <a:ext uri="{FF2B5EF4-FFF2-40B4-BE49-F238E27FC236}">
-                <a16:creationId xmlns:a16="http://schemas.microsoft.com/office/drawing/2014/main" id="{586095BC-403E-4447-AFA0-18B5ECEC2AD6}"/>
+                <a16:creationId xmlns:a16="http://schemas.microsoft.com/office/drawing/2014/main" id="{2BE93250-D8AA-4C14-8B6D-7C6F99C26819}"/>
               </a:ext>
             </a:extLst>
           </p:cNvPr>
@@ -10941,7 +10941,7 @@
           <p:cNvPr id="28" name="">
             <a:extLst xmlns:a="http://schemas.openxmlformats.org/drawingml/2006/main">
               <a:ext uri="{FF2B5EF4-FFF2-40B4-BE49-F238E27FC236}">
-                <a16:creationId xmlns:a16="http://schemas.microsoft.com/office/drawing/2014/main" id="{88A1F11C-7FF1-4729-8373-BD68304038B6}"/>
+                <a16:creationId xmlns:a16="http://schemas.microsoft.com/office/drawing/2014/main" id="{1C9B5923-66BD-4C5A-A03F-460568B5D451}"/>
               </a:ext>
             </a:extLst>
           </p:cNvPr>
@@ -10973,7 +10973,7 @@
           <p:cNvPr id="29" name="">
             <a:extLst xmlns:a="http://schemas.openxmlformats.org/drawingml/2006/main">
               <a:ext uri="{FF2B5EF4-FFF2-40B4-BE49-F238E27FC236}">
-                <a16:creationId xmlns:a16="http://schemas.microsoft.com/office/drawing/2014/main" id="{3554561B-8839-469B-A703-F870E7A212C7}"/>
+                <a16:creationId xmlns:a16="http://schemas.microsoft.com/office/drawing/2014/main" id="{0745FFC0-D812-4B1E-BF4A-409C6020F67A}"/>
               </a:ext>
             </a:extLst>
           </p:cNvPr>
@@ -11036,7 +11036,7 @@
           <p:cNvPr id="30" name="">
             <a:extLst xmlns:a="http://schemas.openxmlformats.org/drawingml/2006/main">
               <a:ext uri="{FF2B5EF4-FFF2-40B4-BE49-F238E27FC236}">
-                <a16:creationId xmlns:a16="http://schemas.microsoft.com/office/drawing/2014/main" id="{344410D7-DE51-4E4C-A55F-3E7473AD9DBA}"/>
+                <a16:creationId xmlns:a16="http://schemas.microsoft.com/office/drawing/2014/main" id="{90ECACF1-2E6A-4351-9035-2534C2ECF6C3}"/>
               </a:ext>
             </a:extLst>
           </p:cNvPr>
@@ -11103,7 +11103,7 @@
           <p:cNvPr id="31" name="">
             <a:extLst xmlns:a="http://schemas.openxmlformats.org/drawingml/2006/main">
               <a:ext uri="{FF2B5EF4-FFF2-40B4-BE49-F238E27FC236}">
-                <a16:creationId xmlns:a16="http://schemas.microsoft.com/office/drawing/2014/main" id="{C1FFAE24-5496-4AAC-8244-833765AAB1B6}"/>
+                <a16:creationId xmlns:a16="http://schemas.microsoft.com/office/drawing/2014/main" id="{B297D8A6-8FD6-48E7-893C-C8071FBC2E09}"/>
               </a:ext>
             </a:extLst>
           </p:cNvPr>
@@ -11135,7 +11135,7 @@
           <p:cNvPr id="32" name="">
             <a:extLst xmlns:a="http://schemas.openxmlformats.org/drawingml/2006/main">
               <a:ext uri="{FF2B5EF4-FFF2-40B4-BE49-F238E27FC236}">
-                <a16:creationId xmlns:a16="http://schemas.microsoft.com/office/drawing/2014/main" id="{896FB773-5C19-4055-9A3E-38730B8D56D3}"/>
+                <a16:creationId xmlns:a16="http://schemas.microsoft.com/office/drawing/2014/main" id="{44040E11-A322-4A5F-964C-971403052BE3}"/>
               </a:ext>
             </a:extLst>
           </p:cNvPr>
@@ -11167,7 +11167,7 @@
           <p:cNvPr id="33" name="">
             <a:extLst xmlns:a="http://schemas.openxmlformats.org/drawingml/2006/main">
               <a:ext uri="{FF2B5EF4-FFF2-40B4-BE49-F238E27FC236}">
-                <a16:creationId xmlns:a16="http://schemas.microsoft.com/office/drawing/2014/main" id="{088119C8-8D8F-4989-8753-688F4C4C2299}"/>
+                <a16:creationId xmlns:a16="http://schemas.microsoft.com/office/drawing/2014/main" id="{1965C8B0-E5BD-46E0-BB9B-2E6643376124}"/>
               </a:ext>
             </a:extLst>
           </p:cNvPr>
@@ -11230,7 +11230,7 @@
           <p:cNvPr id="34" name="">
             <a:extLst xmlns:a="http://schemas.openxmlformats.org/drawingml/2006/main">
               <a:ext uri="{FF2B5EF4-FFF2-40B4-BE49-F238E27FC236}">
-                <a16:creationId xmlns:a16="http://schemas.microsoft.com/office/drawing/2014/main" id="{14D53C25-17B5-453E-B7B7-9E8BA3E96490}"/>
+                <a16:creationId xmlns:a16="http://schemas.microsoft.com/office/drawing/2014/main" id="{12D7B1BE-5D65-4877-A136-5FF6C20F4F1D}"/>
               </a:ext>
             </a:extLst>
           </p:cNvPr>
@@ -11297,7 +11297,7 @@
           <p:cNvPr id="35" name="">
             <a:extLst xmlns:a="http://schemas.openxmlformats.org/drawingml/2006/main">
               <a:ext uri="{FF2B5EF4-FFF2-40B4-BE49-F238E27FC236}">
-                <a16:creationId xmlns:a16="http://schemas.microsoft.com/office/drawing/2014/main" id="{0ACF5CC0-F61B-474A-BE30-8651E8FCA7D2}"/>
+                <a16:creationId xmlns:a16="http://schemas.microsoft.com/office/drawing/2014/main" id="{AFCA9A72-6B12-4E24-855F-D5904CCD29DC}"/>
               </a:ext>
             </a:extLst>
           </p:cNvPr>
@@ -11360,7 +11360,7 @@
           <p:cNvPr id="36" name="">
             <a:extLst xmlns:a="http://schemas.openxmlformats.org/drawingml/2006/main">
               <a:ext uri="{FF2B5EF4-FFF2-40B4-BE49-F238E27FC236}">
-                <a16:creationId xmlns:a16="http://schemas.microsoft.com/office/drawing/2014/main" id="{F3325052-F709-4FEC-BA2E-39019A2E64E1}"/>
+                <a16:creationId xmlns:a16="http://schemas.microsoft.com/office/drawing/2014/main" id="{6DDBE073-EC88-44D8-93E0-F1B616350069}"/>
               </a:ext>
             </a:extLst>
           </p:cNvPr>
@@ -11392,7 +11392,7 @@
           <p:cNvPr id="37" name="">
             <a:extLst xmlns:a="http://schemas.openxmlformats.org/drawingml/2006/main">
               <a:ext uri="{FF2B5EF4-FFF2-40B4-BE49-F238E27FC236}">
-                <a16:creationId xmlns:a16="http://schemas.microsoft.com/office/drawing/2014/main" id="{741C172B-FF07-4B8B-B72A-4E7BEE303646}"/>
+                <a16:creationId xmlns:a16="http://schemas.microsoft.com/office/drawing/2014/main" id="{3C84F99C-88CD-4C72-9892-6D0B4389F564}"/>
               </a:ext>
             </a:extLst>
           </p:cNvPr>
@@ -11455,7 +11455,7 @@
           <p:cNvPr id="38" name="">
             <a:extLst xmlns:a="http://schemas.openxmlformats.org/drawingml/2006/main">
               <a:ext uri="{FF2B5EF4-FFF2-40B4-BE49-F238E27FC236}">
-                <a16:creationId xmlns:a16="http://schemas.microsoft.com/office/drawing/2014/main" id="{5794EA64-D3E6-4154-A9E0-A179BD2B03D2}"/>
+                <a16:creationId xmlns:a16="http://schemas.microsoft.com/office/drawing/2014/main" id="{14875F63-A4E6-42EA-A0ED-C1E41D604D40}"/>
               </a:ext>
             </a:extLst>
           </p:cNvPr>
@@ -11516,7 +11516,7 @@
     </p:spTree>
     <p:extLst>
       <p:ext uri="{BB962C8B-B14F-4D97-AF65-F5344CB8AC3E}">
-        <p14:creationId xmlns:p14="http://schemas.microsoft.com/office/powerpoint/2010/main" val="255013019"/>
+        <p14:creationId xmlns:p14="http://schemas.microsoft.com/office/powerpoint/2010/main" val="298017986"/>
       </p:ext>
     </p:extLst>
   </p:cSld>
@@ -11547,7 +11547,7 @@
           <p:cNvPr id="1" name="">
             <a:extLst xmlns:a="http://schemas.openxmlformats.org/drawingml/2006/main">
               <a:ext uri="{FF2B5EF4-FFF2-40B4-BE49-F238E27FC236}">
-                <a16:creationId xmlns:a16="http://schemas.microsoft.com/office/drawing/2014/main" id="{50722344-B976-40F1-9D4D-4C5A40E9BB1D}"/>
+                <a16:creationId xmlns:a16="http://schemas.microsoft.com/office/drawing/2014/main" id="{19614546-4F3B-4BF2-B02F-9F87EC52F393}"/>
               </a:ext>
             </a:extLst>
           </p:cNvPr>
@@ -11610,7 +11610,7 @@
           <p:cNvPr id="2" name="">
             <a:extLst xmlns:a="http://schemas.openxmlformats.org/drawingml/2006/main">
               <a:ext uri="{FF2B5EF4-FFF2-40B4-BE49-F238E27FC236}">
-                <a16:creationId xmlns:a16="http://schemas.microsoft.com/office/drawing/2014/main" id="{2014EA45-B985-471E-9DE0-BFF0DCE5F0BA}"/>
+                <a16:creationId xmlns:a16="http://schemas.microsoft.com/office/drawing/2014/main" id="{B183AAE4-A1A6-4327-AB78-E6BC83A3DCF3}"/>
               </a:ext>
             </a:extLst>
           </p:cNvPr>
@@ -11677,7 +11677,7 @@
           <p:cNvPr id="3" name="">
             <a:extLst xmlns:a="http://schemas.openxmlformats.org/drawingml/2006/main">
               <a:ext uri="{FF2B5EF4-FFF2-40B4-BE49-F238E27FC236}">
-                <a16:creationId xmlns:a16="http://schemas.microsoft.com/office/drawing/2014/main" id="{A170CFCF-AC38-4FDE-84BD-FF0F8FB49BB2}"/>
+                <a16:creationId xmlns:a16="http://schemas.microsoft.com/office/drawing/2014/main" id="{1D09D536-A700-415F-AEA6-0FFFAD81CFD5}"/>
               </a:ext>
             </a:extLst>
           </p:cNvPr>
@@ -11744,7 +11744,7 @@
           <p:cNvPr id="4" name="">
             <a:extLst xmlns:a="http://schemas.openxmlformats.org/drawingml/2006/main">
               <a:ext uri="{FF2B5EF4-FFF2-40B4-BE49-F238E27FC236}">
-                <a16:creationId xmlns:a16="http://schemas.microsoft.com/office/drawing/2014/main" id="{A0F884B3-5B47-4B3E-9D3F-485F8DD61396}"/>
+                <a16:creationId xmlns:a16="http://schemas.microsoft.com/office/drawing/2014/main" id="{8510C3D8-7638-464F-AB7B-B7CA9BE8E3CB}"/>
               </a:ext>
             </a:extLst>
           </p:cNvPr>
@@ -11776,7 +11776,7 @@
           <p:cNvPr id="5" name="">
             <a:extLst xmlns:a="http://schemas.openxmlformats.org/drawingml/2006/main">
               <a:ext uri="{FF2B5EF4-FFF2-40B4-BE49-F238E27FC236}">
-                <a16:creationId xmlns:a16="http://schemas.microsoft.com/office/drawing/2014/main" id="{3E1DB092-FC4C-422D-A3BA-7C7ED22F7DC1}"/>
+                <a16:creationId xmlns:a16="http://schemas.microsoft.com/office/drawing/2014/main" id="{E0344063-C224-4A28-80AA-B3AFEBF68E84}"/>
               </a:ext>
             </a:extLst>
           </p:cNvPr>
@@ -11839,7 +11839,7 @@
           <p:cNvPr id="6" name="">
             <a:extLst xmlns:a="http://schemas.openxmlformats.org/drawingml/2006/main">
               <a:ext uri="{FF2B5EF4-FFF2-40B4-BE49-F238E27FC236}">
-                <a16:creationId xmlns:a16="http://schemas.microsoft.com/office/drawing/2014/main" id="{5122018C-C274-4E4A-9DBB-F01BA54EDB67}"/>
+                <a16:creationId xmlns:a16="http://schemas.microsoft.com/office/drawing/2014/main" id="{38B9FF4D-A48A-4A77-8083-CC84B18E6AF0}"/>
               </a:ext>
             </a:extLst>
           </p:cNvPr>
@@ -11902,7 +11902,7 @@
           <p:cNvPr id="7" name="">
             <a:extLst xmlns:a="http://schemas.openxmlformats.org/drawingml/2006/main">
               <a:ext uri="{FF2B5EF4-FFF2-40B4-BE49-F238E27FC236}">
-                <a16:creationId xmlns:a16="http://schemas.microsoft.com/office/drawing/2014/main" id="{D949F5B9-0B47-4447-AF7F-73C4FA63E33B}"/>
+                <a16:creationId xmlns:a16="http://schemas.microsoft.com/office/drawing/2014/main" id="{F6ABAE73-BEB1-47CA-BDE0-E0879377CC27}"/>
               </a:ext>
             </a:extLst>
           </p:cNvPr>
@@ -11936,7 +11936,7 @@
           <p:cNvPr id="8" name="">
             <a:extLst xmlns:a="http://schemas.openxmlformats.org/drawingml/2006/main">
               <a:ext uri="{FF2B5EF4-FFF2-40B4-BE49-F238E27FC236}">
-                <a16:creationId xmlns:a16="http://schemas.microsoft.com/office/drawing/2014/main" id="{5B95BD44-B7B9-4AA7-9AEE-12BB98B1BF84}"/>
+                <a16:creationId xmlns:a16="http://schemas.microsoft.com/office/drawing/2014/main" id="{44D7D9F9-1557-48BA-BE8A-3207A67226A1}"/>
               </a:ext>
             </a:extLst>
           </p:cNvPr>
@@ -11968,7 +11968,7 @@
           <p:cNvPr id="9" name="">
             <a:extLst xmlns:a="http://schemas.openxmlformats.org/drawingml/2006/main">
               <a:ext uri="{FF2B5EF4-FFF2-40B4-BE49-F238E27FC236}">
-                <a16:creationId xmlns:a16="http://schemas.microsoft.com/office/drawing/2014/main" id="{B5D17EE7-CEC1-4524-8F80-99988963BDFA}"/>
+                <a16:creationId xmlns:a16="http://schemas.microsoft.com/office/drawing/2014/main" id="{43D1DAD4-15B7-4802-BB62-39228CC5508E}"/>
               </a:ext>
             </a:extLst>
           </p:cNvPr>
@@ -12031,7 +12031,7 @@
           <p:cNvPr id="10" name="">
             <a:extLst xmlns:a="http://schemas.openxmlformats.org/drawingml/2006/main">
               <a:ext uri="{FF2B5EF4-FFF2-40B4-BE49-F238E27FC236}">
-                <a16:creationId xmlns:a16="http://schemas.microsoft.com/office/drawing/2014/main" id="{99430139-18AB-4E78-AC38-32D49EDA8F33}"/>
+                <a16:creationId xmlns:a16="http://schemas.microsoft.com/office/drawing/2014/main" id="{BBABAB80-637A-490B-AAAC-B0775A2ED395}"/>
               </a:ext>
             </a:extLst>
           </p:cNvPr>
@@ -12094,7 +12094,7 @@
           <p:cNvPr id="11" name="">
             <a:extLst xmlns:a="http://schemas.openxmlformats.org/drawingml/2006/main">
               <a:ext uri="{FF2B5EF4-FFF2-40B4-BE49-F238E27FC236}">
-                <a16:creationId xmlns:a16="http://schemas.microsoft.com/office/drawing/2014/main" id="{66631484-7AB8-4BB4-9BE1-A2C3D215AD6E}"/>
+                <a16:creationId xmlns:a16="http://schemas.microsoft.com/office/drawing/2014/main" id="{A81F6EB4-8698-4661-95B2-C59F7D5CE114}"/>
               </a:ext>
             </a:extLst>
           </p:cNvPr>
@@ -12128,7 +12128,7 @@
           <p:cNvPr id="12" name="">
             <a:extLst xmlns:a="http://schemas.openxmlformats.org/drawingml/2006/main">
               <a:ext uri="{FF2B5EF4-FFF2-40B4-BE49-F238E27FC236}">
-                <a16:creationId xmlns:a16="http://schemas.microsoft.com/office/drawing/2014/main" id="{192AF1F0-6FB2-41BF-94BD-C2E387AB319A}"/>
+                <a16:creationId xmlns:a16="http://schemas.microsoft.com/office/drawing/2014/main" id="{37FB4EFE-D4F7-4C4F-A422-924F6601628D}"/>
               </a:ext>
             </a:extLst>
           </p:cNvPr>
@@ -12160,7 +12160,7 @@
           <p:cNvPr id="13" name="">
             <a:extLst xmlns:a="http://schemas.openxmlformats.org/drawingml/2006/main">
               <a:ext uri="{FF2B5EF4-FFF2-40B4-BE49-F238E27FC236}">
-                <a16:creationId xmlns:a16="http://schemas.microsoft.com/office/drawing/2014/main" id="{7FF6DFE2-E233-49BC-A642-5EF3356209F8}"/>
+                <a16:creationId xmlns:a16="http://schemas.microsoft.com/office/drawing/2014/main" id="{FAE7DDB6-34F7-4720-834B-B70DD488ED07}"/>
               </a:ext>
             </a:extLst>
           </p:cNvPr>
@@ -12223,7 +12223,7 @@
           <p:cNvPr id="14" name="">
             <a:extLst xmlns:a="http://schemas.openxmlformats.org/drawingml/2006/main">
               <a:ext uri="{FF2B5EF4-FFF2-40B4-BE49-F238E27FC236}">
-                <a16:creationId xmlns:a16="http://schemas.microsoft.com/office/drawing/2014/main" id="{FAEE2CB3-FB64-4AEC-854C-30D316D5FEF8}"/>
+                <a16:creationId xmlns:a16="http://schemas.microsoft.com/office/drawing/2014/main" id="{7C150046-A2C8-48BA-9F52-FE079999A8AB}"/>
               </a:ext>
             </a:extLst>
           </p:cNvPr>
@@ -12286,7 +12286,7 @@
           <p:cNvPr id="15" name="">
             <a:extLst xmlns:a="http://schemas.openxmlformats.org/drawingml/2006/main">
               <a:ext uri="{FF2B5EF4-FFF2-40B4-BE49-F238E27FC236}">
-                <a16:creationId xmlns:a16="http://schemas.microsoft.com/office/drawing/2014/main" id="{7E78A9B5-DFDA-435D-B477-6A2CC90DDA8E}"/>
+                <a16:creationId xmlns:a16="http://schemas.microsoft.com/office/drawing/2014/main" id="{5FAB9282-9424-418C-99A4-D4D5DFDDB674}"/>
               </a:ext>
             </a:extLst>
           </p:cNvPr>
@@ -12320,7 +12320,7 @@
           <p:cNvPr id="16" name="">
             <a:extLst xmlns:a="http://schemas.openxmlformats.org/drawingml/2006/main">
               <a:ext uri="{FF2B5EF4-FFF2-40B4-BE49-F238E27FC236}">
-                <a16:creationId xmlns:a16="http://schemas.microsoft.com/office/drawing/2014/main" id="{D1743DBC-70A0-4890-B353-F3174AF4D37A}"/>
+                <a16:creationId xmlns:a16="http://schemas.microsoft.com/office/drawing/2014/main" id="{E9BF7090-3C14-4A96-846A-F3A9116E7E40}"/>
               </a:ext>
             </a:extLst>
           </p:cNvPr>
@@ -12352,7 +12352,7 @@
           <p:cNvPr id="17" name="">
             <a:extLst xmlns:a="http://schemas.openxmlformats.org/drawingml/2006/main">
               <a:ext uri="{FF2B5EF4-FFF2-40B4-BE49-F238E27FC236}">
-                <a16:creationId xmlns:a16="http://schemas.microsoft.com/office/drawing/2014/main" id="{9F90DBC5-EBE1-4FC2-8580-3A2A93748D8F}"/>
+                <a16:creationId xmlns:a16="http://schemas.microsoft.com/office/drawing/2014/main" id="{80E90561-C4B9-486F-B744-12DF2BAC670D}"/>
               </a:ext>
             </a:extLst>
           </p:cNvPr>
@@ -12415,7 +12415,7 @@
           <p:cNvPr id="18" name="">
             <a:extLst xmlns:a="http://schemas.openxmlformats.org/drawingml/2006/main">
               <a:ext uri="{FF2B5EF4-FFF2-40B4-BE49-F238E27FC236}">
-                <a16:creationId xmlns:a16="http://schemas.microsoft.com/office/drawing/2014/main" id="{BF568D5F-7C7B-4D28-9E63-96D035A24218}"/>
+                <a16:creationId xmlns:a16="http://schemas.microsoft.com/office/drawing/2014/main" id="{5F9E3D81-56AE-486E-B31A-A1668F56F662}"/>
               </a:ext>
             </a:extLst>
           </p:cNvPr>
@@ -12478,7 +12478,7 @@
           <p:cNvPr id="19" name="">
             <a:extLst xmlns:a="http://schemas.openxmlformats.org/drawingml/2006/main">
               <a:ext uri="{FF2B5EF4-FFF2-40B4-BE49-F238E27FC236}">
-                <a16:creationId xmlns:a16="http://schemas.microsoft.com/office/drawing/2014/main" id="{84C1DB14-66A0-4042-B56C-03990FF35B07}"/>
+                <a16:creationId xmlns:a16="http://schemas.microsoft.com/office/drawing/2014/main" id="{E8A3F500-5776-450A-B8AC-A3927AC6BFE3}"/>
               </a:ext>
             </a:extLst>
           </p:cNvPr>
@@ -12512,7 +12512,7 @@
           <p:cNvPr id="20" name="">
             <a:extLst xmlns:a="http://schemas.openxmlformats.org/drawingml/2006/main">
               <a:ext uri="{FF2B5EF4-FFF2-40B4-BE49-F238E27FC236}">
-                <a16:creationId xmlns:a16="http://schemas.microsoft.com/office/drawing/2014/main" id="{B052C903-63EF-4A57-BCCF-16CDD5B59BF4}"/>
+                <a16:creationId xmlns:a16="http://schemas.microsoft.com/office/drawing/2014/main" id="{BA93DF9F-6857-4F3B-8AA9-027E1F9413AD}"/>
               </a:ext>
             </a:extLst>
           </p:cNvPr>
@@ -12544,7 +12544,7 @@
           <p:cNvPr id="21" name="">
             <a:extLst xmlns:a="http://schemas.openxmlformats.org/drawingml/2006/main">
               <a:ext uri="{FF2B5EF4-FFF2-40B4-BE49-F238E27FC236}">
-                <a16:creationId xmlns:a16="http://schemas.microsoft.com/office/drawing/2014/main" id="{F9E16F44-3001-46EF-8810-15F23C7CA62E}"/>
+                <a16:creationId xmlns:a16="http://schemas.microsoft.com/office/drawing/2014/main" id="{406358CB-8640-4220-B30C-13F7EE7B0A28}"/>
               </a:ext>
             </a:extLst>
           </p:cNvPr>
@@ -12607,7 +12607,7 @@
           <p:cNvPr id="22" name="">
             <a:extLst xmlns:a="http://schemas.openxmlformats.org/drawingml/2006/main">
               <a:ext uri="{FF2B5EF4-FFF2-40B4-BE49-F238E27FC236}">
-                <a16:creationId xmlns:a16="http://schemas.microsoft.com/office/drawing/2014/main" id="{189DDA1F-DFD4-480B-9F53-CA8CCF31B7C8}"/>
+                <a16:creationId xmlns:a16="http://schemas.microsoft.com/office/drawing/2014/main" id="{07551CE2-463C-4554-8ED1-3519E9706198}"/>
               </a:ext>
             </a:extLst>
           </p:cNvPr>
@@ -12639,7 +12639,7 @@
           <p:cNvPr id="23" name="">
             <a:extLst xmlns:a="http://schemas.openxmlformats.org/drawingml/2006/main">
               <a:ext uri="{FF2B5EF4-FFF2-40B4-BE49-F238E27FC236}">
-                <a16:creationId xmlns:a16="http://schemas.microsoft.com/office/drawing/2014/main" id="{DF89474C-1EFC-4962-8A6F-236C3B62FBB6}"/>
+                <a16:creationId xmlns:a16="http://schemas.microsoft.com/office/drawing/2014/main" id="{A113AB92-DEFD-4017-B871-DF2D6960488F}"/>
               </a:ext>
             </a:extLst>
           </p:cNvPr>
@@ -12702,7 +12702,7 @@
           <p:cNvPr id="24" name="">
             <a:extLst xmlns:a="http://schemas.openxmlformats.org/drawingml/2006/main">
               <a:ext uri="{FF2B5EF4-FFF2-40B4-BE49-F238E27FC236}">
-                <a16:creationId xmlns:a16="http://schemas.microsoft.com/office/drawing/2014/main" id="{4790CCD6-2720-4F9A-98DD-D105ED58D3B2}"/>
+                <a16:creationId xmlns:a16="http://schemas.microsoft.com/office/drawing/2014/main" id="{54168736-E707-4FA0-9E1E-93F35FA9EFAE}"/>
               </a:ext>
             </a:extLst>
           </p:cNvPr>
@@ -12714,7 +12714,7 @@
         <p:spPr>
           <a:xfrm xmlns:a="http://schemas.openxmlformats.org/drawingml/2006/main">
             <a:off x="6400800" y="3143250"/>
-            <a:ext cx="2000250" cy="495300"/>
+            <a:ext cx="1524000" cy="457200"/>
           </a:xfrm>
           <a:prstGeom xmlns:a="http://schemas.openxmlformats.org/drawingml/2006/main" prst="rect">
             <a:avLst/>
@@ -12737,7 +12737,7 @@
           <a:lstStyle xmlns:a="http://schemas.openxmlformats.org/drawingml/2006/main"/>
           <a:p xmlns:a="http://schemas.openxmlformats.org/drawingml/2006/main">
             <a:pPr algn="l">
-              <a:defRPr sz="2850" b="1">
+              <a:defRPr sz="2550" b="1">
                 <a:solidFill>
                   <a:srgbClr val="15936B"/>
                 </a:solidFill>
@@ -12747,7 +12747,7 @@
               </a:defRPr>
             </a:pPr>
             <a:r>
-              <a:rPr sz="2850" b="1">
+              <a:rPr sz="2550" b="1">
                 <a:solidFill>
                   <a:srgbClr val="15936B"/>
                 </a:solidFill>
@@ -12765,19 +12765,19 @@
           <p:cNvPr id="25" name="">
             <a:extLst xmlns:a="http://schemas.openxmlformats.org/drawingml/2006/main">
               <a:ext uri="{FF2B5EF4-FFF2-40B4-BE49-F238E27FC236}">
-                <a16:creationId xmlns:a16="http://schemas.microsoft.com/office/drawing/2014/main" id="{886C6898-2D6E-4D46-8456-2F04679B87EA}"/>
-              </a:ext>
-            </a:extLst>
-          </p:cNvPr>
-          <p:cNvSpPr>
-            <a:spLocks xmlns:a="http://schemas.openxmlformats.org/drawingml/2006/main" noGrp="1"/>
-          </p:cNvSpPr>
-          <p:nvPr/>
-        </p:nvSpPr>
-        <p:spPr>
-          <a:xfrm xmlns:a="http://schemas.openxmlformats.org/drawingml/2006/main">
-            <a:off x="6400800" y="3619500"/>
-            <a:ext cx="2000250" cy="419100"/>
+                <a16:creationId xmlns:a16="http://schemas.microsoft.com/office/drawing/2014/main" id="{42C3B3C7-10DE-4F24-92FE-7FFD507607C5}"/>
+              </a:ext>
+            </a:extLst>
+          </p:cNvPr>
+          <p:cNvSpPr>
+            <a:spLocks xmlns:a="http://schemas.openxmlformats.org/drawingml/2006/main" noGrp="1"/>
+          </p:cNvSpPr>
+          <p:nvPr/>
+        </p:nvSpPr>
+        <p:spPr>
+          <a:xfrm xmlns:a="http://schemas.openxmlformats.org/drawingml/2006/main">
+            <a:off x="6400800" y="3676650"/>
+            <a:ext cx="1524000" cy="342900"/>
           </a:xfrm>
           <a:prstGeom xmlns:a="http://schemas.openxmlformats.org/drawingml/2006/main" prst="rect">
             <a:avLst/>
@@ -12832,19 +12832,19 @@
           <p:cNvPr id="26" name="">
             <a:extLst xmlns:a="http://schemas.openxmlformats.org/drawingml/2006/main">
               <a:ext uri="{FF2B5EF4-FFF2-40B4-BE49-F238E27FC236}">
-                <a16:creationId xmlns:a16="http://schemas.microsoft.com/office/drawing/2014/main" id="{F6FA5B67-BE06-4013-9901-F94A59461CE6}"/>
-              </a:ext>
-            </a:extLst>
-          </p:cNvPr>
-          <p:cNvSpPr>
-            <a:spLocks xmlns:a="http://schemas.openxmlformats.org/drawingml/2006/main" noGrp="1"/>
-          </p:cNvSpPr>
-          <p:nvPr/>
-        </p:nvSpPr>
-        <p:spPr>
-          <a:xfrm xmlns:a="http://schemas.openxmlformats.org/drawingml/2006/main">
-            <a:off x="8305800" y="3143250"/>
-            <a:ext cx="2000250" cy="495300"/>
+                <a16:creationId xmlns:a16="http://schemas.microsoft.com/office/drawing/2014/main" id="{559DEE71-0DC8-4590-97C6-286CBD5DE0B8}"/>
+              </a:ext>
+            </a:extLst>
+          </p:cNvPr>
+          <p:cNvSpPr>
+            <a:spLocks xmlns:a="http://schemas.openxmlformats.org/drawingml/2006/main" noGrp="1"/>
+          </p:cNvSpPr>
+          <p:nvPr/>
+        </p:nvSpPr>
+        <p:spPr>
+          <a:xfrm xmlns:a="http://schemas.openxmlformats.org/drawingml/2006/main">
+            <a:off x="8172450" y="3143250"/>
+            <a:ext cx="1257300" cy="457200"/>
           </a:xfrm>
           <a:prstGeom xmlns:a="http://schemas.openxmlformats.org/drawingml/2006/main" prst="rect">
             <a:avLst/>
@@ -12867,7 +12867,7 @@
           <a:lstStyle xmlns:a="http://schemas.openxmlformats.org/drawingml/2006/main"/>
           <a:p xmlns:a="http://schemas.openxmlformats.org/drawingml/2006/main">
             <a:pPr algn="l">
-              <a:defRPr sz="2850" b="1">
+              <a:defRPr sz="2550" b="1">
                 <a:solidFill>
                   <a:srgbClr val="2C7FB8"/>
                 </a:solidFill>
@@ -12877,7 +12877,7 @@
               </a:defRPr>
             </a:pPr>
             <a:r>
-              <a:rPr sz="2850" b="1">
+              <a:rPr sz="2550" b="1">
                 <a:solidFill>
                   <a:srgbClr val="2C7FB8"/>
                 </a:solidFill>
@@ -12895,19 +12895,19 @@
           <p:cNvPr id="27" name="">
             <a:extLst xmlns:a="http://schemas.openxmlformats.org/drawingml/2006/main">
               <a:ext uri="{FF2B5EF4-FFF2-40B4-BE49-F238E27FC236}">
-                <a16:creationId xmlns:a16="http://schemas.microsoft.com/office/drawing/2014/main" id="{54659694-DD2F-48F9-9301-7D4D3D221B43}"/>
-              </a:ext>
-            </a:extLst>
-          </p:cNvPr>
-          <p:cNvSpPr>
-            <a:spLocks xmlns:a="http://schemas.openxmlformats.org/drawingml/2006/main" noGrp="1"/>
-          </p:cNvSpPr>
-          <p:nvPr/>
-        </p:nvSpPr>
-        <p:spPr>
-          <a:xfrm xmlns:a="http://schemas.openxmlformats.org/drawingml/2006/main">
-            <a:off x="8305800" y="3619500"/>
-            <a:ext cx="2000250" cy="419100"/>
+                <a16:creationId xmlns:a16="http://schemas.microsoft.com/office/drawing/2014/main" id="{5872B5DF-F74E-445C-8F16-B785F1A957A5}"/>
+              </a:ext>
+            </a:extLst>
+          </p:cNvPr>
+          <p:cNvSpPr>
+            <a:spLocks xmlns:a="http://schemas.openxmlformats.org/drawingml/2006/main" noGrp="1"/>
+          </p:cNvSpPr>
+          <p:nvPr/>
+        </p:nvSpPr>
+        <p:spPr>
+          <a:xfrm xmlns:a="http://schemas.openxmlformats.org/drawingml/2006/main">
+            <a:off x="8172450" y="3676650"/>
+            <a:ext cx="1257300" cy="342900"/>
           </a:xfrm>
           <a:prstGeom xmlns:a="http://schemas.openxmlformats.org/drawingml/2006/main" prst="rect">
             <a:avLst/>
@@ -12962,19 +12962,19 @@
           <p:cNvPr id="28" name="">
             <a:extLst xmlns:a="http://schemas.openxmlformats.org/drawingml/2006/main">
               <a:ext uri="{FF2B5EF4-FFF2-40B4-BE49-F238E27FC236}">
-                <a16:creationId xmlns:a16="http://schemas.microsoft.com/office/drawing/2014/main" id="{02157B68-36DA-4127-BD29-231977095534}"/>
-              </a:ext>
-            </a:extLst>
-          </p:cNvPr>
-          <p:cNvSpPr>
-            <a:spLocks xmlns:a="http://schemas.openxmlformats.org/drawingml/2006/main" noGrp="1"/>
-          </p:cNvSpPr>
-          <p:nvPr/>
-        </p:nvSpPr>
-        <p:spPr>
-          <a:xfrm xmlns:a="http://schemas.openxmlformats.org/drawingml/2006/main">
-            <a:off x="9829800" y="3143250"/>
-            <a:ext cx="2000250" cy="495300"/>
+                <a16:creationId xmlns:a16="http://schemas.microsoft.com/office/drawing/2014/main" id="{098B4196-38BD-418B-B5C9-1F6B3CBE8BE1}"/>
+              </a:ext>
+            </a:extLst>
+          </p:cNvPr>
+          <p:cNvSpPr>
+            <a:spLocks xmlns:a="http://schemas.openxmlformats.org/drawingml/2006/main" noGrp="1"/>
+          </p:cNvSpPr>
+          <p:nvPr/>
+        </p:nvSpPr>
+        <p:spPr>
+          <a:xfrm xmlns:a="http://schemas.openxmlformats.org/drawingml/2006/main">
+            <a:off x="9620250" y="3143250"/>
+            <a:ext cx="1143000" cy="457200"/>
           </a:xfrm>
           <a:prstGeom xmlns:a="http://schemas.openxmlformats.org/drawingml/2006/main" prst="rect">
             <a:avLst/>
@@ -12997,7 +12997,7 @@
           <a:lstStyle xmlns:a="http://schemas.openxmlformats.org/drawingml/2006/main"/>
           <a:p xmlns:a="http://schemas.openxmlformats.org/drawingml/2006/main">
             <a:pPr algn="l">
-              <a:defRPr sz="2850" b="1">
+              <a:defRPr sz="2550" b="1">
                 <a:solidFill>
                   <a:srgbClr val="D9942C"/>
                 </a:solidFill>
@@ -13007,7 +13007,7 @@
               </a:defRPr>
             </a:pPr>
             <a:r>
-              <a:rPr sz="2850" b="1">
+              <a:rPr sz="2550" b="1">
                 <a:solidFill>
                   <a:srgbClr val="D9942C"/>
                 </a:solidFill>
@@ -13025,19 +13025,19 @@
           <p:cNvPr id="29" name="">
             <a:extLst xmlns:a="http://schemas.openxmlformats.org/drawingml/2006/main">
               <a:ext uri="{FF2B5EF4-FFF2-40B4-BE49-F238E27FC236}">
-                <a16:creationId xmlns:a16="http://schemas.microsoft.com/office/drawing/2014/main" id="{6E577D2D-1F18-4ACC-B0DC-9697A264D48F}"/>
-              </a:ext>
-            </a:extLst>
-          </p:cNvPr>
-          <p:cNvSpPr>
-            <a:spLocks xmlns:a="http://schemas.openxmlformats.org/drawingml/2006/main" noGrp="1"/>
-          </p:cNvSpPr>
-          <p:nvPr/>
-        </p:nvSpPr>
-        <p:spPr>
-          <a:xfrm xmlns:a="http://schemas.openxmlformats.org/drawingml/2006/main">
-            <a:off x="9829800" y="3619500"/>
-            <a:ext cx="2000250" cy="419100"/>
+                <a16:creationId xmlns:a16="http://schemas.microsoft.com/office/drawing/2014/main" id="{4A6876B0-72EE-47EF-8054-D6DB36AC706B}"/>
+              </a:ext>
+            </a:extLst>
+          </p:cNvPr>
+          <p:cNvSpPr>
+            <a:spLocks xmlns:a="http://schemas.openxmlformats.org/drawingml/2006/main" noGrp="1"/>
+          </p:cNvSpPr>
+          <p:nvPr/>
+        </p:nvSpPr>
+        <p:spPr>
+          <a:xfrm xmlns:a="http://schemas.openxmlformats.org/drawingml/2006/main">
+            <a:off x="9620250" y="3676650"/>
+            <a:ext cx="1143000" cy="342900"/>
           </a:xfrm>
           <a:prstGeom xmlns:a="http://schemas.openxmlformats.org/drawingml/2006/main" prst="rect">
             <a:avLst/>
@@ -13092,7 +13092,7 @@
           <p:cNvPr id="30" name="">
             <a:extLst xmlns:a="http://schemas.openxmlformats.org/drawingml/2006/main">
               <a:ext uri="{FF2B5EF4-FFF2-40B4-BE49-F238E27FC236}">
-                <a16:creationId xmlns:a16="http://schemas.microsoft.com/office/drawing/2014/main" id="{1F04A6A1-196A-4485-945E-3D72F43A3673}"/>
+                <a16:creationId xmlns:a16="http://schemas.microsoft.com/office/drawing/2014/main" id="{C87E7585-B6CE-4C4C-9DB0-6F6338AFD209}"/>
               </a:ext>
             </a:extLst>
           </p:cNvPr>
@@ -13124,7 +13124,7 @@
           <p:cNvPr id="31" name="">
             <a:extLst xmlns:a="http://schemas.openxmlformats.org/drawingml/2006/main">
               <a:ext uri="{FF2B5EF4-FFF2-40B4-BE49-F238E27FC236}">
-                <a16:creationId xmlns:a16="http://schemas.microsoft.com/office/drawing/2014/main" id="{85208437-1157-4F6D-85B8-2B149A14F535}"/>
+                <a16:creationId xmlns:a16="http://schemas.microsoft.com/office/drawing/2014/main" id="{C8A5361E-F2EE-43F3-8DAF-51C06984A3BD}"/>
               </a:ext>
             </a:extLst>
           </p:cNvPr>
@@ -13156,7 +13156,7 @@
           <p:cNvPr id="32" name="">
             <a:extLst xmlns:a="http://schemas.openxmlformats.org/drawingml/2006/main">
               <a:ext uri="{FF2B5EF4-FFF2-40B4-BE49-F238E27FC236}">
-                <a16:creationId xmlns:a16="http://schemas.microsoft.com/office/drawing/2014/main" id="{37903784-8161-4EBD-A5AF-CA1B0C55C4B0}"/>
+                <a16:creationId xmlns:a16="http://schemas.microsoft.com/office/drawing/2014/main" id="{B3DA20E2-50AB-4DB4-B712-BC6907457E06}"/>
               </a:ext>
             </a:extLst>
           </p:cNvPr>
@@ -13223,7 +13223,7 @@
           <p:cNvPr id="33" name="">
             <a:extLst xmlns:a="http://schemas.openxmlformats.org/drawingml/2006/main">
               <a:ext uri="{FF2B5EF4-FFF2-40B4-BE49-F238E27FC236}">
-                <a16:creationId xmlns:a16="http://schemas.microsoft.com/office/drawing/2014/main" id="{CAA6E47F-70DD-4D68-9EEF-2ED747454636}"/>
+                <a16:creationId xmlns:a16="http://schemas.microsoft.com/office/drawing/2014/main" id="{832C5DC8-86D9-46CE-B7DB-C2EB7DC46ECA}"/>
               </a:ext>
             </a:extLst>
           </p:cNvPr>
@@ -13286,7 +13286,7 @@
           <p:cNvPr id="34" name="">
             <a:extLst xmlns:a="http://schemas.openxmlformats.org/drawingml/2006/main">
               <a:ext uri="{FF2B5EF4-FFF2-40B4-BE49-F238E27FC236}">
-                <a16:creationId xmlns:a16="http://schemas.microsoft.com/office/drawing/2014/main" id="{361AB778-4619-4B4E-8EE9-1BDF482901DA}"/>
+                <a16:creationId xmlns:a16="http://schemas.microsoft.com/office/drawing/2014/main" id="{2B81E5F4-9F71-43D3-8295-906FD72AC2C8}"/>
               </a:ext>
             </a:extLst>
           </p:cNvPr>
@@ -13318,7 +13318,7 @@
           <p:cNvPr id="35" name="">
             <a:extLst xmlns:a="http://schemas.openxmlformats.org/drawingml/2006/main">
               <a:ext uri="{FF2B5EF4-FFF2-40B4-BE49-F238E27FC236}">
-                <a16:creationId xmlns:a16="http://schemas.microsoft.com/office/drawing/2014/main" id="{984FE5CE-673F-465D-9C2E-4810EAD44205}"/>
+                <a16:creationId xmlns:a16="http://schemas.microsoft.com/office/drawing/2014/main" id="{572EE049-EFE8-4751-9D10-DFAFE4171BE9}"/>
               </a:ext>
             </a:extLst>
           </p:cNvPr>
@@ -13381,7 +13381,7 @@
           <p:cNvPr id="36" name="">
             <a:extLst xmlns:a="http://schemas.openxmlformats.org/drawingml/2006/main">
               <a:ext uri="{FF2B5EF4-FFF2-40B4-BE49-F238E27FC236}">
-                <a16:creationId xmlns:a16="http://schemas.microsoft.com/office/drawing/2014/main" id="{006E0808-9E2C-4AA2-BCB3-FB1262FBF07C}"/>
+                <a16:creationId xmlns:a16="http://schemas.microsoft.com/office/drawing/2014/main" id="{23DAD91E-8312-46B6-A032-ECB294F92A33}"/>
               </a:ext>
             </a:extLst>
           </p:cNvPr>
@@ -13442,7 +13442,7 @@
     </p:spTree>
     <p:extLst>
       <p:ext uri="{BB962C8B-B14F-4D97-AF65-F5344CB8AC3E}">
-        <p14:creationId xmlns:p14="http://schemas.microsoft.com/office/powerpoint/2010/main" val="1226466060"/>
+        <p14:creationId xmlns:p14="http://schemas.microsoft.com/office/powerpoint/2010/main" val="957789122"/>
       </p:ext>
     </p:extLst>
   </p:cSld>
@@ -13473,7 +13473,7 @@
           <p:cNvPr id="1" name="">
             <a:extLst xmlns:a="http://schemas.openxmlformats.org/drawingml/2006/main">
               <a:ext uri="{FF2B5EF4-FFF2-40B4-BE49-F238E27FC236}">
-                <a16:creationId xmlns:a16="http://schemas.microsoft.com/office/drawing/2014/main" id="{30B83682-41B7-4264-8413-372CBE984B4D}"/>
+                <a16:creationId xmlns:a16="http://schemas.microsoft.com/office/drawing/2014/main" id="{93963685-734F-43FE-9251-6945C17E9CB4}"/>
               </a:ext>
             </a:extLst>
           </p:cNvPr>
@@ -13536,7 +13536,7 @@
           <p:cNvPr id="2" name="">
             <a:extLst xmlns:a="http://schemas.openxmlformats.org/drawingml/2006/main">
               <a:ext uri="{FF2B5EF4-FFF2-40B4-BE49-F238E27FC236}">
-                <a16:creationId xmlns:a16="http://schemas.microsoft.com/office/drawing/2014/main" id="{B606A888-26D5-4E33-91C0-BCCAA8638EAD}"/>
+                <a16:creationId xmlns:a16="http://schemas.microsoft.com/office/drawing/2014/main" id="{F808F20D-8E16-49CE-A9FD-FA22D69B4F80}"/>
               </a:ext>
             </a:extLst>
           </p:cNvPr>
@@ -13603,7 +13603,7 @@
           <p:cNvPr id="3" name="">
             <a:extLst xmlns:a="http://schemas.openxmlformats.org/drawingml/2006/main">
               <a:ext uri="{FF2B5EF4-FFF2-40B4-BE49-F238E27FC236}">
-                <a16:creationId xmlns:a16="http://schemas.microsoft.com/office/drawing/2014/main" id="{299AB854-F798-47D1-8258-29EA0428F464}"/>
+                <a16:creationId xmlns:a16="http://schemas.microsoft.com/office/drawing/2014/main" id="{0AFC1B00-66DA-4958-BEBB-15ED077316C5}"/>
               </a:ext>
             </a:extLst>
           </p:cNvPr>
@@ -13670,7 +13670,7 @@
           <p:cNvPr id="4" name="">
             <a:extLst xmlns:a="http://schemas.openxmlformats.org/drawingml/2006/main">
               <a:ext uri="{FF2B5EF4-FFF2-40B4-BE49-F238E27FC236}">
-                <a16:creationId xmlns:a16="http://schemas.microsoft.com/office/drawing/2014/main" id="{4138E417-F73C-43AE-937C-D2BFA532A376}"/>
+                <a16:creationId xmlns:a16="http://schemas.microsoft.com/office/drawing/2014/main" id="{2387AE66-08FF-4511-A4E1-087D35E84CC3}"/>
               </a:ext>
             </a:extLst>
           </p:cNvPr>
@@ -13702,7 +13702,7 @@
           <p:cNvPr id="5" name="">
             <a:extLst xmlns:a="http://schemas.openxmlformats.org/drawingml/2006/main">
               <a:ext uri="{FF2B5EF4-FFF2-40B4-BE49-F238E27FC236}">
-                <a16:creationId xmlns:a16="http://schemas.microsoft.com/office/drawing/2014/main" id="{EE8B5F0F-F8F4-42B5-9627-CD4941C186D9}"/>
+                <a16:creationId xmlns:a16="http://schemas.microsoft.com/office/drawing/2014/main" id="{E66CA215-0836-412F-AA6E-0E200D16036D}"/>
               </a:ext>
             </a:extLst>
           </p:cNvPr>
@@ -13765,7 +13765,7 @@
           <p:cNvPr id="6" name="">
             <a:extLst xmlns:a="http://schemas.openxmlformats.org/drawingml/2006/main">
               <a:ext uri="{FF2B5EF4-FFF2-40B4-BE49-F238E27FC236}">
-                <a16:creationId xmlns:a16="http://schemas.microsoft.com/office/drawing/2014/main" id="{0F772E77-16D5-40F2-9E29-C94B325DB1A2}"/>
+                <a16:creationId xmlns:a16="http://schemas.microsoft.com/office/drawing/2014/main" id="{61CA546A-F8DF-4503-8B04-BB1AF70C126F}"/>
               </a:ext>
             </a:extLst>
           </p:cNvPr>
@@ -13797,7 +13797,7 @@
           <p:cNvPr id="7" name="">
             <a:extLst xmlns:a="http://schemas.openxmlformats.org/drawingml/2006/main">
               <a:ext uri="{FF2B5EF4-FFF2-40B4-BE49-F238E27FC236}">
-                <a16:creationId xmlns:a16="http://schemas.microsoft.com/office/drawing/2014/main" id="{C4CEEA44-A798-410A-8EC7-F6560E24AF28}"/>
+                <a16:creationId xmlns:a16="http://schemas.microsoft.com/office/drawing/2014/main" id="{94D93B69-2DD1-4E02-A6AF-F78298175DF8}"/>
               </a:ext>
             </a:extLst>
           </p:cNvPr>
@@ -13860,7 +13860,7 @@
           <p:cNvPr id="8" name="">
             <a:extLst xmlns:a="http://schemas.openxmlformats.org/drawingml/2006/main">
               <a:ext uri="{FF2B5EF4-FFF2-40B4-BE49-F238E27FC236}">
-                <a16:creationId xmlns:a16="http://schemas.microsoft.com/office/drawing/2014/main" id="{20862B60-4175-4AA4-B8E0-DF537B7D2E87}"/>
+                <a16:creationId xmlns:a16="http://schemas.microsoft.com/office/drawing/2014/main" id="{6171926F-61EA-466F-A505-3A101C0987B7}"/>
               </a:ext>
             </a:extLst>
           </p:cNvPr>
@@ -13923,7 +13923,7 @@
           <p:cNvPr id="9" name="">
             <a:extLst xmlns:a="http://schemas.openxmlformats.org/drawingml/2006/main">
               <a:ext uri="{FF2B5EF4-FFF2-40B4-BE49-F238E27FC236}">
-                <a16:creationId xmlns:a16="http://schemas.microsoft.com/office/drawing/2014/main" id="{9666DDC9-676E-40D3-A2BA-5C2A9D767FA4}"/>
+                <a16:creationId xmlns:a16="http://schemas.microsoft.com/office/drawing/2014/main" id="{AD057D6D-EBB8-44C6-B2B8-AB5B057DFC55}"/>
               </a:ext>
             </a:extLst>
           </p:cNvPr>
@@ -13955,7 +13955,7 @@
           <p:cNvPr id="10" name="">
             <a:extLst xmlns:a="http://schemas.openxmlformats.org/drawingml/2006/main">
               <a:ext uri="{FF2B5EF4-FFF2-40B4-BE49-F238E27FC236}">
-                <a16:creationId xmlns:a16="http://schemas.microsoft.com/office/drawing/2014/main" id="{A8F471FF-00AA-43D8-996E-5CF3B244726A}"/>
+                <a16:creationId xmlns:a16="http://schemas.microsoft.com/office/drawing/2014/main" id="{7F0E3B2B-B218-4230-8EE0-F5BEDA38CEBC}"/>
               </a:ext>
             </a:extLst>
           </p:cNvPr>
@@ -14018,7 +14018,7 @@
           <p:cNvPr id="11" name="">
             <a:extLst xmlns:a="http://schemas.openxmlformats.org/drawingml/2006/main">
               <a:ext uri="{FF2B5EF4-FFF2-40B4-BE49-F238E27FC236}">
-                <a16:creationId xmlns:a16="http://schemas.microsoft.com/office/drawing/2014/main" id="{7569FAEF-BE80-4352-B7FE-319BCFE97160}"/>
+                <a16:creationId xmlns:a16="http://schemas.microsoft.com/office/drawing/2014/main" id="{4A3C4D8D-83A5-4180-8DF6-63ECB55F1366}"/>
               </a:ext>
             </a:extLst>
           </p:cNvPr>
@@ -14081,7 +14081,7 @@
           <p:cNvPr id="12" name="">
             <a:extLst xmlns:a="http://schemas.openxmlformats.org/drawingml/2006/main">
               <a:ext uri="{FF2B5EF4-FFF2-40B4-BE49-F238E27FC236}">
-                <a16:creationId xmlns:a16="http://schemas.microsoft.com/office/drawing/2014/main" id="{B0B749A9-D4DE-4148-98B8-A42A647C6AB3}"/>
+                <a16:creationId xmlns:a16="http://schemas.microsoft.com/office/drawing/2014/main" id="{A22254D4-C0D8-424C-B3AB-8EE034E4B97C}"/>
               </a:ext>
             </a:extLst>
           </p:cNvPr>
@@ -14113,7 +14113,7 @@
           <p:cNvPr id="13" name="">
             <a:extLst xmlns:a="http://schemas.openxmlformats.org/drawingml/2006/main">
               <a:ext uri="{FF2B5EF4-FFF2-40B4-BE49-F238E27FC236}">
-                <a16:creationId xmlns:a16="http://schemas.microsoft.com/office/drawing/2014/main" id="{91E8C93B-3758-4A04-BADE-A1EECBF01EF0}"/>
+                <a16:creationId xmlns:a16="http://schemas.microsoft.com/office/drawing/2014/main" id="{F7872BE5-C925-45DC-9CEF-06BEDD95C409}"/>
               </a:ext>
             </a:extLst>
           </p:cNvPr>
@@ -14176,7 +14176,7 @@
           <p:cNvPr id="14" name="">
             <a:extLst xmlns:a="http://schemas.openxmlformats.org/drawingml/2006/main">
               <a:ext uri="{FF2B5EF4-FFF2-40B4-BE49-F238E27FC236}">
-                <a16:creationId xmlns:a16="http://schemas.microsoft.com/office/drawing/2014/main" id="{E1F8C13F-D037-49E8-A31E-63112C68563B}"/>
+                <a16:creationId xmlns:a16="http://schemas.microsoft.com/office/drawing/2014/main" id="{B08E854E-AE93-4596-8C09-CB3B5181DC57}"/>
               </a:ext>
             </a:extLst>
           </p:cNvPr>
@@ -14239,7 +14239,7 @@
           <p:cNvPr id="15" name="">
             <a:extLst xmlns:a="http://schemas.openxmlformats.org/drawingml/2006/main">
               <a:ext uri="{FF2B5EF4-FFF2-40B4-BE49-F238E27FC236}">
-                <a16:creationId xmlns:a16="http://schemas.microsoft.com/office/drawing/2014/main" id="{AF492165-C9E8-4E53-B046-DCCE0CE408BF}"/>
+                <a16:creationId xmlns:a16="http://schemas.microsoft.com/office/drawing/2014/main" id="{95284E28-0CAC-454B-925B-629E9499D26C}"/>
               </a:ext>
             </a:extLst>
           </p:cNvPr>
@@ -14271,7 +14271,7 @@
           <p:cNvPr id="16" name="">
             <a:extLst xmlns:a="http://schemas.openxmlformats.org/drawingml/2006/main">
               <a:ext uri="{FF2B5EF4-FFF2-40B4-BE49-F238E27FC236}">
-                <a16:creationId xmlns:a16="http://schemas.microsoft.com/office/drawing/2014/main" id="{AABEFB46-F433-416F-8F3A-5C70CECA5171}"/>
+                <a16:creationId xmlns:a16="http://schemas.microsoft.com/office/drawing/2014/main" id="{AD7A5E3E-78DE-49F9-BF15-972D6AD99483}"/>
               </a:ext>
             </a:extLst>
           </p:cNvPr>
@@ -14334,7 +14334,7 @@
           <p:cNvPr id="17" name="">
             <a:extLst xmlns:a="http://schemas.openxmlformats.org/drawingml/2006/main">
               <a:ext uri="{FF2B5EF4-FFF2-40B4-BE49-F238E27FC236}">
-                <a16:creationId xmlns:a16="http://schemas.microsoft.com/office/drawing/2014/main" id="{830E8488-A5D9-4C93-9B33-251707398963}"/>
+                <a16:creationId xmlns:a16="http://schemas.microsoft.com/office/drawing/2014/main" id="{F4F285FB-7F3B-412C-831D-BA10B8B4ADC4}"/>
               </a:ext>
             </a:extLst>
           </p:cNvPr>
@@ -14397,7 +14397,7 @@
           <p:cNvPr id="18" name="">
             <a:extLst xmlns:a="http://schemas.openxmlformats.org/drawingml/2006/main">
               <a:ext uri="{FF2B5EF4-FFF2-40B4-BE49-F238E27FC236}">
-                <a16:creationId xmlns:a16="http://schemas.microsoft.com/office/drawing/2014/main" id="{737AD6A1-A25B-44C6-8E31-1C490CB593E8}"/>
+                <a16:creationId xmlns:a16="http://schemas.microsoft.com/office/drawing/2014/main" id="{7C231352-D1A1-4C99-ADC2-7EE9AB00A01A}"/>
               </a:ext>
             </a:extLst>
           </p:cNvPr>
@@ -14429,7 +14429,7 @@
           <p:cNvPr id="19" name="">
             <a:extLst xmlns:a="http://schemas.openxmlformats.org/drawingml/2006/main">
               <a:ext uri="{FF2B5EF4-FFF2-40B4-BE49-F238E27FC236}">
-                <a16:creationId xmlns:a16="http://schemas.microsoft.com/office/drawing/2014/main" id="{253F16E2-E389-460C-8863-968470B09545}"/>
+                <a16:creationId xmlns:a16="http://schemas.microsoft.com/office/drawing/2014/main" id="{6913EB04-9C0D-4851-A4B1-2FA9440CB7E5}"/>
               </a:ext>
             </a:extLst>
           </p:cNvPr>
@@ -14492,7 +14492,7 @@
           <p:cNvPr id="20" name="">
             <a:extLst xmlns:a="http://schemas.openxmlformats.org/drawingml/2006/main">
               <a:ext uri="{FF2B5EF4-FFF2-40B4-BE49-F238E27FC236}">
-                <a16:creationId xmlns:a16="http://schemas.microsoft.com/office/drawing/2014/main" id="{913A8E35-5AD2-4A0C-8D2B-7AE15B8902CE}"/>
+                <a16:creationId xmlns:a16="http://schemas.microsoft.com/office/drawing/2014/main" id="{E351985B-8522-4308-9E77-CFBFA3567C22}"/>
               </a:ext>
             </a:extLst>
           </p:cNvPr>
@@ -14555,7 +14555,7 @@
           <p:cNvPr id="21" name="">
             <a:extLst xmlns:a="http://schemas.openxmlformats.org/drawingml/2006/main">
               <a:ext uri="{FF2B5EF4-FFF2-40B4-BE49-F238E27FC236}">
-                <a16:creationId xmlns:a16="http://schemas.microsoft.com/office/drawing/2014/main" id="{879BD98A-7B96-43B8-92DE-DBCC52DFAA6F}"/>
+                <a16:creationId xmlns:a16="http://schemas.microsoft.com/office/drawing/2014/main" id="{21AE1A09-2A80-44E2-A59B-C9436581974E}"/>
               </a:ext>
             </a:extLst>
           </p:cNvPr>
@@ -14587,7 +14587,7 @@
           <p:cNvPr id="22" name="">
             <a:extLst xmlns:a="http://schemas.openxmlformats.org/drawingml/2006/main">
               <a:ext uri="{FF2B5EF4-FFF2-40B4-BE49-F238E27FC236}">
-                <a16:creationId xmlns:a16="http://schemas.microsoft.com/office/drawing/2014/main" id="{119826F4-4907-47C1-8902-A5686EA19D87}"/>
+                <a16:creationId xmlns:a16="http://schemas.microsoft.com/office/drawing/2014/main" id="{755DEF49-9167-4724-AF10-B965880FF49E}"/>
               </a:ext>
             </a:extLst>
           </p:cNvPr>
@@ -14650,7 +14650,7 @@
           <p:cNvPr id="23" name="">
             <a:extLst xmlns:a="http://schemas.openxmlformats.org/drawingml/2006/main">
               <a:ext uri="{FF2B5EF4-FFF2-40B4-BE49-F238E27FC236}">
-                <a16:creationId xmlns:a16="http://schemas.microsoft.com/office/drawing/2014/main" id="{039172AE-EE20-4062-8723-3594206A7E08}"/>
+                <a16:creationId xmlns:a16="http://schemas.microsoft.com/office/drawing/2014/main" id="{7AC1A77E-37CF-45F8-8FCA-296C51DC37F5}"/>
               </a:ext>
             </a:extLst>
           </p:cNvPr>
@@ -14713,7 +14713,7 @@
           <p:cNvPr id="24" name="">
             <a:extLst xmlns:a="http://schemas.openxmlformats.org/drawingml/2006/main">
               <a:ext uri="{FF2B5EF4-FFF2-40B4-BE49-F238E27FC236}">
-                <a16:creationId xmlns:a16="http://schemas.microsoft.com/office/drawing/2014/main" id="{ADFF53F3-A797-41B8-96E4-61413892DF36}"/>
+                <a16:creationId xmlns:a16="http://schemas.microsoft.com/office/drawing/2014/main" id="{5B02441A-0689-471F-84A8-0F689A118E30}"/>
               </a:ext>
             </a:extLst>
           </p:cNvPr>
@@ -14745,7 +14745,7 @@
           <p:cNvPr id="25" name="">
             <a:extLst xmlns:a="http://schemas.openxmlformats.org/drawingml/2006/main">
               <a:ext uri="{FF2B5EF4-FFF2-40B4-BE49-F238E27FC236}">
-                <a16:creationId xmlns:a16="http://schemas.microsoft.com/office/drawing/2014/main" id="{127D625D-1266-41F9-8B07-39946E133657}"/>
+                <a16:creationId xmlns:a16="http://schemas.microsoft.com/office/drawing/2014/main" id="{66399B24-202C-4259-B19D-34D25C860C62}"/>
               </a:ext>
             </a:extLst>
           </p:cNvPr>
@@ -14808,7 +14808,7 @@
           <p:cNvPr id="26" name="">
             <a:extLst xmlns:a="http://schemas.openxmlformats.org/drawingml/2006/main">
               <a:ext uri="{FF2B5EF4-FFF2-40B4-BE49-F238E27FC236}">
-                <a16:creationId xmlns:a16="http://schemas.microsoft.com/office/drawing/2014/main" id="{A95CD9BB-737F-4737-9D8B-3CAA969898A4}"/>
+                <a16:creationId xmlns:a16="http://schemas.microsoft.com/office/drawing/2014/main" id="{E0470B3A-80A9-45C7-BC33-34A0F5C31959}"/>
               </a:ext>
             </a:extLst>
           </p:cNvPr>
@@ -14871,7 +14871,7 @@
           <p:cNvPr id="27" name="">
             <a:extLst xmlns:a="http://schemas.openxmlformats.org/drawingml/2006/main">
               <a:ext uri="{FF2B5EF4-FFF2-40B4-BE49-F238E27FC236}">
-                <a16:creationId xmlns:a16="http://schemas.microsoft.com/office/drawing/2014/main" id="{9331D46A-5E8A-4DC0-9939-CB2A95598BEB}"/>
+                <a16:creationId xmlns:a16="http://schemas.microsoft.com/office/drawing/2014/main" id="{726C9418-740E-45AA-9581-663769C10357}"/>
               </a:ext>
             </a:extLst>
           </p:cNvPr>
@@ -14903,7 +14903,7 @@
           <p:cNvPr id="28" name="">
             <a:extLst xmlns:a="http://schemas.openxmlformats.org/drawingml/2006/main">
               <a:ext uri="{FF2B5EF4-FFF2-40B4-BE49-F238E27FC236}">
-                <a16:creationId xmlns:a16="http://schemas.microsoft.com/office/drawing/2014/main" id="{A26F2186-73E2-4C7B-9293-AC22E2FFA7D5}"/>
+                <a16:creationId xmlns:a16="http://schemas.microsoft.com/office/drawing/2014/main" id="{8FCB1F7B-8586-42E5-A9D5-E84131951E49}"/>
               </a:ext>
             </a:extLst>
           </p:cNvPr>
@@ -14966,7 +14966,7 @@
           <p:cNvPr id="29" name="">
             <a:extLst xmlns:a="http://schemas.openxmlformats.org/drawingml/2006/main">
               <a:ext uri="{FF2B5EF4-FFF2-40B4-BE49-F238E27FC236}">
-                <a16:creationId xmlns:a16="http://schemas.microsoft.com/office/drawing/2014/main" id="{3F252646-6106-4568-A8B8-BB062F4C9B8D}"/>
+                <a16:creationId xmlns:a16="http://schemas.microsoft.com/office/drawing/2014/main" id="{0B7B18F5-8E0E-4062-A681-D69E36D8E8C6}"/>
               </a:ext>
             </a:extLst>
           </p:cNvPr>
@@ -15029,7 +15029,7 @@
           <p:cNvPr id="30" name="">
             <a:extLst xmlns:a="http://schemas.openxmlformats.org/drawingml/2006/main">
               <a:ext uri="{FF2B5EF4-FFF2-40B4-BE49-F238E27FC236}">
-                <a16:creationId xmlns:a16="http://schemas.microsoft.com/office/drawing/2014/main" id="{45FFEE00-7D2B-4482-B970-3B9E104286E9}"/>
+                <a16:creationId xmlns:a16="http://schemas.microsoft.com/office/drawing/2014/main" id="{488FE55F-B4B0-4B09-B615-042219A97355}"/>
               </a:ext>
             </a:extLst>
           </p:cNvPr>
@@ -15061,7 +15061,7 @@
           <p:cNvPr id="31" name="">
             <a:extLst xmlns:a="http://schemas.openxmlformats.org/drawingml/2006/main">
               <a:ext uri="{FF2B5EF4-FFF2-40B4-BE49-F238E27FC236}">
-                <a16:creationId xmlns:a16="http://schemas.microsoft.com/office/drawing/2014/main" id="{F83B3AFF-F6C9-4F39-853F-AE034C6FBDD1}"/>
+                <a16:creationId xmlns:a16="http://schemas.microsoft.com/office/drawing/2014/main" id="{F9813B4A-3084-41CE-B2A7-45883F385D36}"/>
               </a:ext>
             </a:extLst>
           </p:cNvPr>
@@ -15124,7 +15124,7 @@
           <p:cNvPr id="32" name="">
             <a:extLst xmlns:a="http://schemas.openxmlformats.org/drawingml/2006/main">
               <a:ext uri="{FF2B5EF4-FFF2-40B4-BE49-F238E27FC236}">
-                <a16:creationId xmlns:a16="http://schemas.microsoft.com/office/drawing/2014/main" id="{78BF5452-471B-4E71-985F-BA6C2CEE8299}"/>
+                <a16:creationId xmlns:a16="http://schemas.microsoft.com/office/drawing/2014/main" id="{0C1A89C5-641C-43FC-A676-9A079961C0D9}"/>
               </a:ext>
             </a:extLst>
           </p:cNvPr>
@@ -15187,7 +15187,7 @@
           <p:cNvPr id="33" name="">
             <a:extLst xmlns:a="http://schemas.openxmlformats.org/drawingml/2006/main">
               <a:ext uri="{FF2B5EF4-FFF2-40B4-BE49-F238E27FC236}">
-                <a16:creationId xmlns:a16="http://schemas.microsoft.com/office/drawing/2014/main" id="{39973831-B340-40DC-AB3D-89E9D0049B24}"/>
+                <a16:creationId xmlns:a16="http://schemas.microsoft.com/office/drawing/2014/main" id="{70F5A050-A999-457C-A9DD-260EDE1C9FBD}"/>
               </a:ext>
             </a:extLst>
           </p:cNvPr>
@@ -15219,7 +15219,7 @@
           <p:cNvPr id="34" name="">
             <a:extLst xmlns:a="http://schemas.openxmlformats.org/drawingml/2006/main">
               <a:ext uri="{FF2B5EF4-FFF2-40B4-BE49-F238E27FC236}">
-                <a16:creationId xmlns:a16="http://schemas.microsoft.com/office/drawing/2014/main" id="{A70152F0-956C-4D94-BED9-F7E7B834A12A}"/>
+                <a16:creationId xmlns:a16="http://schemas.microsoft.com/office/drawing/2014/main" id="{765B12F0-D03A-4515-819A-66FE3EB1FAEB}"/>
               </a:ext>
             </a:extLst>
           </p:cNvPr>
@@ -15282,7 +15282,7 @@
           <p:cNvPr id="35" name="">
             <a:extLst xmlns:a="http://schemas.openxmlformats.org/drawingml/2006/main">
               <a:ext uri="{FF2B5EF4-FFF2-40B4-BE49-F238E27FC236}">
-                <a16:creationId xmlns:a16="http://schemas.microsoft.com/office/drawing/2014/main" id="{B888558F-0923-4C28-B583-0C709B10DB53}"/>
+                <a16:creationId xmlns:a16="http://schemas.microsoft.com/office/drawing/2014/main" id="{DD02329E-F0D4-496D-889A-A6F3E3154AD2}"/>
               </a:ext>
             </a:extLst>
           </p:cNvPr>
@@ -15345,7 +15345,7 @@
           <p:cNvPr id="36" name="">
             <a:extLst xmlns:a="http://schemas.openxmlformats.org/drawingml/2006/main">
               <a:ext uri="{FF2B5EF4-FFF2-40B4-BE49-F238E27FC236}">
-                <a16:creationId xmlns:a16="http://schemas.microsoft.com/office/drawing/2014/main" id="{500F7BDA-954C-48C0-B42E-B35A0E29D9E6}"/>
+                <a16:creationId xmlns:a16="http://schemas.microsoft.com/office/drawing/2014/main" id="{5DF9B888-387E-46E1-A922-F0031201F94A}"/>
               </a:ext>
             </a:extLst>
           </p:cNvPr>
@@ -15377,7 +15377,7 @@
           <p:cNvPr id="37" name="">
             <a:extLst xmlns:a="http://schemas.openxmlformats.org/drawingml/2006/main">
               <a:ext uri="{FF2B5EF4-FFF2-40B4-BE49-F238E27FC236}">
-                <a16:creationId xmlns:a16="http://schemas.microsoft.com/office/drawing/2014/main" id="{9245D438-94F6-45E2-BD0D-F72869556E67}"/>
+                <a16:creationId xmlns:a16="http://schemas.microsoft.com/office/drawing/2014/main" id="{42E6BAD6-DDCB-4EE4-BE73-2ACA04CB72C0}"/>
               </a:ext>
             </a:extLst>
           </p:cNvPr>
@@ -15440,7 +15440,7 @@
           <p:cNvPr id="38" name="">
             <a:extLst xmlns:a="http://schemas.openxmlformats.org/drawingml/2006/main">
               <a:ext uri="{FF2B5EF4-FFF2-40B4-BE49-F238E27FC236}">
-                <a16:creationId xmlns:a16="http://schemas.microsoft.com/office/drawing/2014/main" id="{65F10F63-CB76-4006-A37F-DEBF7221DB6A}"/>
+                <a16:creationId xmlns:a16="http://schemas.microsoft.com/office/drawing/2014/main" id="{AE6E5D17-562A-46BB-9CEE-4F9AA170C4FA}"/>
               </a:ext>
             </a:extLst>
           </p:cNvPr>
@@ -15503,7 +15503,7 @@
           <p:cNvPr id="39" name="">
             <a:extLst xmlns:a="http://schemas.openxmlformats.org/drawingml/2006/main">
               <a:ext uri="{FF2B5EF4-FFF2-40B4-BE49-F238E27FC236}">
-                <a16:creationId xmlns:a16="http://schemas.microsoft.com/office/drawing/2014/main" id="{DF678264-52AA-4666-929A-3156A244A316}"/>
+                <a16:creationId xmlns:a16="http://schemas.microsoft.com/office/drawing/2014/main" id="{2B51A9B3-E1D1-468E-9523-4C7F144FA4D8}"/>
               </a:ext>
             </a:extLst>
           </p:cNvPr>
@@ -15535,7 +15535,7 @@
           <p:cNvPr id="40" name="">
             <a:extLst xmlns:a="http://schemas.openxmlformats.org/drawingml/2006/main">
               <a:ext uri="{FF2B5EF4-FFF2-40B4-BE49-F238E27FC236}">
-                <a16:creationId xmlns:a16="http://schemas.microsoft.com/office/drawing/2014/main" id="{0CFE92B0-5E44-4837-B923-A5FEBB741823}"/>
+                <a16:creationId xmlns:a16="http://schemas.microsoft.com/office/drawing/2014/main" id="{C72D1786-F7E5-44E1-B132-B358DF6FA4D2}"/>
               </a:ext>
             </a:extLst>
           </p:cNvPr>
@@ -15598,7 +15598,7 @@
           <p:cNvPr id="41" name="">
             <a:extLst xmlns:a="http://schemas.openxmlformats.org/drawingml/2006/main">
               <a:ext uri="{FF2B5EF4-FFF2-40B4-BE49-F238E27FC236}">
-                <a16:creationId xmlns:a16="http://schemas.microsoft.com/office/drawing/2014/main" id="{5E7783B2-8358-4BB1-AC64-2BF86C638049}"/>
+                <a16:creationId xmlns:a16="http://schemas.microsoft.com/office/drawing/2014/main" id="{E98F2E16-C8A0-4FEF-9C7A-6B43F5465E1F}"/>
               </a:ext>
             </a:extLst>
           </p:cNvPr>
@@ -15661,7 +15661,7 @@
           <p:cNvPr id="42" name="">
             <a:extLst xmlns:a="http://schemas.openxmlformats.org/drawingml/2006/main">
               <a:ext uri="{FF2B5EF4-FFF2-40B4-BE49-F238E27FC236}">
-                <a16:creationId xmlns:a16="http://schemas.microsoft.com/office/drawing/2014/main" id="{EDE6B86C-943E-4202-97D8-0708324E9B71}"/>
+                <a16:creationId xmlns:a16="http://schemas.microsoft.com/office/drawing/2014/main" id="{DE08A153-5C74-470A-BFEF-C1D1EB35C5DA}"/>
               </a:ext>
             </a:extLst>
           </p:cNvPr>
@@ -15693,7 +15693,7 @@
           <p:cNvPr id="43" name="">
             <a:extLst xmlns:a="http://schemas.openxmlformats.org/drawingml/2006/main">
               <a:ext uri="{FF2B5EF4-FFF2-40B4-BE49-F238E27FC236}">
-                <a16:creationId xmlns:a16="http://schemas.microsoft.com/office/drawing/2014/main" id="{1D9B6D1A-3C3A-4342-8A61-E52C18B59417}"/>
+                <a16:creationId xmlns:a16="http://schemas.microsoft.com/office/drawing/2014/main" id="{CAD19965-E954-4A3E-A5E2-C33B8A50D334}"/>
               </a:ext>
             </a:extLst>
           </p:cNvPr>
@@ -15756,7 +15756,7 @@
           <p:cNvPr id="44" name="">
             <a:extLst xmlns:a="http://schemas.openxmlformats.org/drawingml/2006/main">
               <a:ext uri="{FF2B5EF4-FFF2-40B4-BE49-F238E27FC236}">
-                <a16:creationId xmlns:a16="http://schemas.microsoft.com/office/drawing/2014/main" id="{ADAFD550-A437-4359-B28C-FDDACC1F5A6F}"/>
+                <a16:creationId xmlns:a16="http://schemas.microsoft.com/office/drawing/2014/main" id="{7A91F2BC-3482-41DC-A231-D5BCF87C0598}"/>
               </a:ext>
             </a:extLst>
           </p:cNvPr>
@@ -15819,7 +15819,7 @@
           <p:cNvPr id="45" name="">
             <a:extLst xmlns:a="http://schemas.openxmlformats.org/drawingml/2006/main">
               <a:ext uri="{FF2B5EF4-FFF2-40B4-BE49-F238E27FC236}">
-                <a16:creationId xmlns:a16="http://schemas.microsoft.com/office/drawing/2014/main" id="{2457844C-0313-47ED-B0DD-28EDF6C1854A}"/>
+                <a16:creationId xmlns:a16="http://schemas.microsoft.com/office/drawing/2014/main" id="{BAEC1C80-5EDE-459C-A093-DEBA8CC7A92E}"/>
               </a:ext>
             </a:extLst>
           </p:cNvPr>
@@ -15851,7 +15851,7 @@
           <p:cNvPr id="46" name="">
             <a:extLst xmlns:a="http://schemas.openxmlformats.org/drawingml/2006/main">
               <a:ext uri="{FF2B5EF4-FFF2-40B4-BE49-F238E27FC236}">
-                <a16:creationId xmlns:a16="http://schemas.microsoft.com/office/drawing/2014/main" id="{606C9B9A-772D-4666-8645-2F43F4A4112D}"/>
+                <a16:creationId xmlns:a16="http://schemas.microsoft.com/office/drawing/2014/main" id="{9F7BBCE1-33E5-41F7-9930-65B4541D1A97}"/>
               </a:ext>
             </a:extLst>
           </p:cNvPr>
@@ -15914,7 +15914,7 @@
           <p:cNvPr id="47" name="">
             <a:extLst xmlns:a="http://schemas.openxmlformats.org/drawingml/2006/main">
               <a:ext uri="{FF2B5EF4-FFF2-40B4-BE49-F238E27FC236}">
-                <a16:creationId xmlns:a16="http://schemas.microsoft.com/office/drawing/2014/main" id="{5A960454-B20B-4BFF-A202-A32D457C2AAC}"/>
+                <a16:creationId xmlns:a16="http://schemas.microsoft.com/office/drawing/2014/main" id="{7FE626A1-5513-424F-BDE5-17DA49DCA9FC}"/>
               </a:ext>
             </a:extLst>
           </p:cNvPr>
@@ -15977,7 +15977,7 @@
           <p:cNvPr id="48" name="">
             <a:extLst xmlns:a="http://schemas.openxmlformats.org/drawingml/2006/main">
               <a:ext uri="{FF2B5EF4-FFF2-40B4-BE49-F238E27FC236}">
-                <a16:creationId xmlns:a16="http://schemas.microsoft.com/office/drawing/2014/main" id="{5F2B6C46-EF6E-43A4-BAAE-435FAE74BF0A}"/>
+                <a16:creationId xmlns:a16="http://schemas.microsoft.com/office/drawing/2014/main" id="{E0FAD3A1-25F5-448A-95C8-584160ED3B50}"/>
               </a:ext>
             </a:extLst>
           </p:cNvPr>
@@ -16009,7 +16009,7 @@
           <p:cNvPr id="49" name="">
             <a:extLst xmlns:a="http://schemas.openxmlformats.org/drawingml/2006/main">
               <a:ext uri="{FF2B5EF4-FFF2-40B4-BE49-F238E27FC236}">
-                <a16:creationId xmlns:a16="http://schemas.microsoft.com/office/drawing/2014/main" id="{E927F704-B750-455F-AB51-50CEDF8251CF}"/>
+                <a16:creationId xmlns:a16="http://schemas.microsoft.com/office/drawing/2014/main" id="{D54E7DDB-3B53-496F-BCB9-08A6D7955F37}"/>
               </a:ext>
             </a:extLst>
           </p:cNvPr>
@@ -16072,7 +16072,7 @@
           <p:cNvPr id="50" name="">
             <a:extLst xmlns:a="http://schemas.openxmlformats.org/drawingml/2006/main">
               <a:ext uri="{FF2B5EF4-FFF2-40B4-BE49-F238E27FC236}">
-                <a16:creationId xmlns:a16="http://schemas.microsoft.com/office/drawing/2014/main" id="{64CC5159-93BB-44E5-8BCF-3A1CA83DDC94}"/>
+                <a16:creationId xmlns:a16="http://schemas.microsoft.com/office/drawing/2014/main" id="{52EBD074-0D3C-4043-984E-736BFACC84D5}"/>
               </a:ext>
             </a:extLst>
           </p:cNvPr>
@@ -16135,7 +16135,7 @@
           <p:cNvPr id="51" name="">
             <a:extLst xmlns:a="http://schemas.openxmlformats.org/drawingml/2006/main">
               <a:ext uri="{FF2B5EF4-FFF2-40B4-BE49-F238E27FC236}">
-                <a16:creationId xmlns:a16="http://schemas.microsoft.com/office/drawing/2014/main" id="{4E106983-BD97-4EA3-85DC-0F1633024601}"/>
+                <a16:creationId xmlns:a16="http://schemas.microsoft.com/office/drawing/2014/main" id="{D7639BEA-7470-45FE-B8DA-EF66357DAD15}"/>
               </a:ext>
             </a:extLst>
           </p:cNvPr>
@@ -16167,7 +16167,7 @@
           <p:cNvPr id="52" name="">
             <a:extLst xmlns:a="http://schemas.openxmlformats.org/drawingml/2006/main">
               <a:ext uri="{FF2B5EF4-FFF2-40B4-BE49-F238E27FC236}">
-                <a16:creationId xmlns:a16="http://schemas.microsoft.com/office/drawing/2014/main" id="{A0ECF009-55D4-4A0A-A1E3-E442CE51A735}"/>
+                <a16:creationId xmlns:a16="http://schemas.microsoft.com/office/drawing/2014/main" id="{9C737A4B-195B-4130-865F-27B14FDF5842}"/>
               </a:ext>
             </a:extLst>
           </p:cNvPr>
@@ -16230,7 +16230,7 @@
           <p:cNvPr id="53" name="">
             <a:extLst xmlns:a="http://schemas.openxmlformats.org/drawingml/2006/main">
               <a:ext uri="{FF2B5EF4-FFF2-40B4-BE49-F238E27FC236}">
-                <a16:creationId xmlns:a16="http://schemas.microsoft.com/office/drawing/2014/main" id="{1BE12676-9D1F-45EF-A514-AE74F66A5A01}"/>
+                <a16:creationId xmlns:a16="http://schemas.microsoft.com/office/drawing/2014/main" id="{EC3D0A03-770D-4A82-8AD1-77B4ACEC4D8B}"/>
               </a:ext>
             </a:extLst>
           </p:cNvPr>
@@ -16293,7 +16293,7 @@
           <p:cNvPr id="54" name="">
             <a:extLst xmlns:a="http://schemas.openxmlformats.org/drawingml/2006/main">
               <a:ext uri="{FF2B5EF4-FFF2-40B4-BE49-F238E27FC236}">
-                <a16:creationId xmlns:a16="http://schemas.microsoft.com/office/drawing/2014/main" id="{728303C2-8110-4D4B-8F47-5F7D3FAB8F77}"/>
+                <a16:creationId xmlns:a16="http://schemas.microsoft.com/office/drawing/2014/main" id="{E8E6AC72-0184-4CA8-AF30-5A68AEB1C49B}"/>
               </a:ext>
             </a:extLst>
           </p:cNvPr>
@@ -16325,7 +16325,7 @@
           <p:cNvPr id="55" name="">
             <a:extLst xmlns:a="http://schemas.openxmlformats.org/drawingml/2006/main">
               <a:ext uri="{FF2B5EF4-FFF2-40B4-BE49-F238E27FC236}">
-                <a16:creationId xmlns:a16="http://schemas.microsoft.com/office/drawing/2014/main" id="{519EE5E5-7614-4AF7-A079-B1CE3FE4BEAD}"/>
+                <a16:creationId xmlns:a16="http://schemas.microsoft.com/office/drawing/2014/main" id="{F9DE1E7A-1A87-4AF7-9B17-EA5B33F52174}"/>
               </a:ext>
             </a:extLst>
           </p:cNvPr>
@@ -16388,7 +16388,7 @@
           <p:cNvPr id="56" name="">
             <a:extLst xmlns:a="http://schemas.openxmlformats.org/drawingml/2006/main">
               <a:ext uri="{FF2B5EF4-FFF2-40B4-BE49-F238E27FC236}">
-                <a16:creationId xmlns:a16="http://schemas.microsoft.com/office/drawing/2014/main" id="{4002D0A3-F56C-44DF-A6E6-1D6C0FCE1A6C}"/>
+                <a16:creationId xmlns:a16="http://schemas.microsoft.com/office/drawing/2014/main" id="{19756C36-DF20-4781-9317-39FAB13E2319}"/>
               </a:ext>
             </a:extLst>
           </p:cNvPr>
@@ -16451,7 +16451,7 @@
           <p:cNvPr id="57" name="">
             <a:extLst xmlns:a="http://schemas.openxmlformats.org/drawingml/2006/main">
               <a:ext uri="{FF2B5EF4-FFF2-40B4-BE49-F238E27FC236}">
-                <a16:creationId xmlns:a16="http://schemas.microsoft.com/office/drawing/2014/main" id="{7625CE7E-C751-4F41-A4CB-295DB1BF678C}"/>
+                <a16:creationId xmlns:a16="http://schemas.microsoft.com/office/drawing/2014/main" id="{EA39BD3B-8933-4392-BE8E-4F4DD64E72B0}"/>
               </a:ext>
             </a:extLst>
           </p:cNvPr>
@@ -16483,7 +16483,7 @@
           <p:cNvPr id="58" name="">
             <a:extLst xmlns:a="http://schemas.openxmlformats.org/drawingml/2006/main">
               <a:ext uri="{FF2B5EF4-FFF2-40B4-BE49-F238E27FC236}">
-                <a16:creationId xmlns:a16="http://schemas.microsoft.com/office/drawing/2014/main" id="{E99EE062-60E9-4BB3-BEA0-8A36A7E66E53}"/>
+                <a16:creationId xmlns:a16="http://schemas.microsoft.com/office/drawing/2014/main" id="{EEB63067-1D25-450D-8747-F833ECFBD87F}"/>
               </a:ext>
             </a:extLst>
           </p:cNvPr>
@@ -16546,7 +16546,7 @@
           <p:cNvPr id="59" name="">
             <a:extLst xmlns:a="http://schemas.openxmlformats.org/drawingml/2006/main">
               <a:ext uri="{FF2B5EF4-FFF2-40B4-BE49-F238E27FC236}">
-                <a16:creationId xmlns:a16="http://schemas.microsoft.com/office/drawing/2014/main" id="{09D22FD6-6B54-4370-A9C9-A6F90FE9A2B3}"/>
+                <a16:creationId xmlns:a16="http://schemas.microsoft.com/office/drawing/2014/main" id="{60AFA002-6706-4975-8D27-69AAC2C57CBB}"/>
               </a:ext>
             </a:extLst>
           </p:cNvPr>
@@ -16609,7 +16609,7 @@
           <p:cNvPr id="60" name="">
             <a:extLst xmlns:a="http://schemas.openxmlformats.org/drawingml/2006/main">
               <a:ext uri="{FF2B5EF4-FFF2-40B4-BE49-F238E27FC236}">
-                <a16:creationId xmlns:a16="http://schemas.microsoft.com/office/drawing/2014/main" id="{8799939D-6B26-4920-9CCD-F4088C9C683A}"/>
+                <a16:creationId xmlns:a16="http://schemas.microsoft.com/office/drawing/2014/main" id="{A55E62A7-1CC4-443F-86C7-92421ADB789A}"/>
               </a:ext>
             </a:extLst>
           </p:cNvPr>
@@ -16641,7 +16641,7 @@
           <p:cNvPr id="61" name="">
             <a:extLst xmlns:a="http://schemas.openxmlformats.org/drawingml/2006/main">
               <a:ext uri="{FF2B5EF4-FFF2-40B4-BE49-F238E27FC236}">
-                <a16:creationId xmlns:a16="http://schemas.microsoft.com/office/drawing/2014/main" id="{D594A95A-0BA6-4598-AB67-273DA540E5B7}"/>
+                <a16:creationId xmlns:a16="http://schemas.microsoft.com/office/drawing/2014/main" id="{E0EF8BF8-AD71-469F-A30D-E1D4B75675BA}"/>
               </a:ext>
             </a:extLst>
           </p:cNvPr>
@@ -16704,7 +16704,7 @@
           <p:cNvPr id="62" name="">
             <a:extLst xmlns:a="http://schemas.openxmlformats.org/drawingml/2006/main">
               <a:ext uri="{FF2B5EF4-FFF2-40B4-BE49-F238E27FC236}">
-                <a16:creationId xmlns:a16="http://schemas.microsoft.com/office/drawing/2014/main" id="{B37BC3B8-8F45-49CF-AFCA-8F485BB7A866}"/>
+                <a16:creationId xmlns:a16="http://schemas.microsoft.com/office/drawing/2014/main" id="{45E11598-A4C0-4A8F-BE0F-72CE31A393C1}"/>
               </a:ext>
             </a:extLst>
           </p:cNvPr>
@@ -16767,7 +16767,7 @@
           <p:cNvPr id="63" name="">
             <a:extLst xmlns:a="http://schemas.openxmlformats.org/drawingml/2006/main">
               <a:ext uri="{FF2B5EF4-FFF2-40B4-BE49-F238E27FC236}">
-                <a16:creationId xmlns:a16="http://schemas.microsoft.com/office/drawing/2014/main" id="{C4784276-2815-4C3E-BB66-74271B05E7E6}"/>
+                <a16:creationId xmlns:a16="http://schemas.microsoft.com/office/drawing/2014/main" id="{15A5533B-724C-4D41-8F61-9F899884444B}"/>
               </a:ext>
             </a:extLst>
           </p:cNvPr>
@@ -16799,7 +16799,7 @@
           <p:cNvPr id="64" name="">
             <a:extLst xmlns:a="http://schemas.openxmlformats.org/drawingml/2006/main">
               <a:ext uri="{FF2B5EF4-FFF2-40B4-BE49-F238E27FC236}">
-                <a16:creationId xmlns:a16="http://schemas.microsoft.com/office/drawing/2014/main" id="{8052EE5C-FA71-49D8-9393-FA157E925B2A}"/>
+                <a16:creationId xmlns:a16="http://schemas.microsoft.com/office/drawing/2014/main" id="{E3EA05D4-0536-42C7-A468-E95CD0CB6CB5}"/>
               </a:ext>
             </a:extLst>
           </p:cNvPr>
@@ -16862,19 +16862,19 @@
           <p:cNvPr id="65" name="">
             <a:extLst xmlns:a="http://schemas.openxmlformats.org/drawingml/2006/main">
               <a:ext uri="{FF2B5EF4-FFF2-40B4-BE49-F238E27FC236}">
-                <a16:creationId xmlns:a16="http://schemas.microsoft.com/office/drawing/2014/main" id="{73330BA9-8F30-4A96-BC79-70E40DF418AB}"/>
-              </a:ext>
-            </a:extLst>
-          </p:cNvPr>
-          <p:cNvSpPr>
-            <a:spLocks xmlns:a="http://schemas.openxmlformats.org/drawingml/2006/main" noGrp="1"/>
-          </p:cNvSpPr>
-          <p:nvPr/>
-        </p:nvSpPr>
-        <p:spPr>
-          <a:xfrm xmlns:a="http://schemas.openxmlformats.org/drawingml/2006/main">
-            <a:off x="7658100" y="2800350"/>
-            <a:ext cx="2571750" cy="838200"/>
+                <a16:creationId xmlns:a16="http://schemas.microsoft.com/office/drawing/2014/main" id="{EFB266B1-B5FD-4A1D-86DA-E061BA045D69}"/>
+              </a:ext>
+            </a:extLst>
+          </p:cNvPr>
+          <p:cNvSpPr>
+            <a:spLocks xmlns:a="http://schemas.openxmlformats.org/drawingml/2006/main" noGrp="1"/>
+          </p:cNvSpPr>
+          <p:nvPr/>
+        </p:nvSpPr>
+        <p:spPr>
+          <a:xfrm xmlns:a="http://schemas.openxmlformats.org/drawingml/2006/main">
+            <a:off x="7658100" y="2743200"/>
+            <a:ext cx="2571750" cy="933450"/>
           </a:xfrm>
           <a:prstGeom xmlns:a="http://schemas.openxmlformats.org/drawingml/2006/main" prst="rect">
             <a:avLst/>
@@ -16894,19 +16894,19 @@
           <p:cNvPr id="66" name="">
             <a:extLst xmlns:a="http://schemas.openxmlformats.org/drawingml/2006/main">
               <a:ext uri="{FF2B5EF4-FFF2-40B4-BE49-F238E27FC236}">
-                <a16:creationId xmlns:a16="http://schemas.microsoft.com/office/drawing/2014/main" id="{A55CB807-601E-433F-955A-4BB859CF90B2}"/>
-              </a:ext>
-            </a:extLst>
-          </p:cNvPr>
-          <p:cNvSpPr>
-            <a:spLocks xmlns:a="http://schemas.openxmlformats.org/drawingml/2006/main" noGrp="1"/>
-          </p:cNvSpPr>
-          <p:nvPr/>
-        </p:nvSpPr>
-        <p:spPr>
-          <a:xfrm xmlns:a="http://schemas.openxmlformats.org/drawingml/2006/main">
-            <a:off x="7658100" y="2800350"/>
-            <a:ext cx="47625" cy="838200"/>
+                <a16:creationId xmlns:a16="http://schemas.microsoft.com/office/drawing/2014/main" id="{A83324D1-0F88-4844-81C2-6B42F8676E4D}"/>
+              </a:ext>
+            </a:extLst>
+          </p:cNvPr>
+          <p:cNvSpPr>
+            <a:spLocks xmlns:a="http://schemas.openxmlformats.org/drawingml/2006/main" noGrp="1"/>
+          </p:cNvSpPr>
+          <p:nvPr/>
+        </p:nvSpPr>
+        <p:spPr>
+          <a:xfrm xmlns:a="http://schemas.openxmlformats.org/drawingml/2006/main">
+            <a:off x="7658100" y="2743200"/>
+            <a:ext cx="47625" cy="933450"/>
           </a:xfrm>
           <a:prstGeom xmlns:a="http://schemas.openxmlformats.org/drawingml/2006/main" prst="rect">
             <a:avLst/>
@@ -16926,7 +16926,7 @@
           <p:cNvPr id="67" name="">
             <a:extLst xmlns:a="http://schemas.openxmlformats.org/drawingml/2006/main">
               <a:ext uri="{FF2B5EF4-FFF2-40B4-BE49-F238E27FC236}">
-                <a16:creationId xmlns:a16="http://schemas.microsoft.com/office/drawing/2014/main" id="{4EAB83EC-FB0B-4B81-A4A8-B7801BFA3007}"/>
+                <a16:creationId xmlns:a16="http://schemas.microsoft.com/office/drawing/2014/main" id="{6E972E1B-AA03-4337-8F08-8FA059E227D7}"/>
               </a:ext>
             </a:extLst>
           </p:cNvPr>
@@ -16989,7 +16989,7 @@
           <p:cNvPr id="68" name="">
             <a:extLst xmlns:a="http://schemas.openxmlformats.org/drawingml/2006/main">
               <a:ext uri="{FF2B5EF4-FFF2-40B4-BE49-F238E27FC236}">
-                <a16:creationId xmlns:a16="http://schemas.microsoft.com/office/drawing/2014/main" id="{62F0B85B-2560-442E-9DE9-E355C0A4AEDF}"/>
+                <a16:creationId xmlns:a16="http://schemas.microsoft.com/office/drawing/2014/main" id="{8A5B0ED5-F6B4-470B-99CC-AE66225BCFA6}"/>
               </a:ext>
             </a:extLst>
           </p:cNvPr>
@@ -17056,7 +17056,7 @@
           <p:cNvPr id="69" name="">
             <a:extLst xmlns:a="http://schemas.openxmlformats.org/drawingml/2006/main">
               <a:ext uri="{FF2B5EF4-FFF2-40B4-BE49-F238E27FC236}">
-                <a16:creationId xmlns:a16="http://schemas.microsoft.com/office/drawing/2014/main" id="{43FC03E6-7299-4231-B62A-2099F9BE1A41}"/>
+                <a16:creationId xmlns:a16="http://schemas.microsoft.com/office/drawing/2014/main" id="{43DFFA53-0E48-4962-ACD5-F02EC8C7DC35}"/>
               </a:ext>
             </a:extLst>
           </p:cNvPr>
@@ -17068,7 +17068,7 @@
         <p:spPr>
           <a:xfrm xmlns:a="http://schemas.openxmlformats.org/drawingml/2006/main">
             <a:off x="7658100" y="3905250"/>
-            <a:ext cx="2571750" cy="838200"/>
+            <a:ext cx="2571750" cy="933450"/>
           </a:xfrm>
           <a:prstGeom xmlns:a="http://schemas.openxmlformats.org/drawingml/2006/main" prst="rect">
             <a:avLst/>
@@ -17088,7 +17088,7 @@
           <p:cNvPr id="70" name="">
             <a:extLst xmlns:a="http://schemas.openxmlformats.org/drawingml/2006/main">
               <a:ext uri="{FF2B5EF4-FFF2-40B4-BE49-F238E27FC236}">
-                <a16:creationId xmlns:a16="http://schemas.microsoft.com/office/drawing/2014/main" id="{53CAA86D-0987-40F2-91DF-09ECC8506625}"/>
+                <a16:creationId xmlns:a16="http://schemas.microsoft.com/office/drawing/2014/main" id="{0DEFC833-9D3B-42CA-B3D8-78EBB9CE9EC7}"/>
               </a:ext>
             </a:extLst>
           </p:cNvPr>
@@ -17100,7 +17100,7 @@
         <p:spPr>
           <a:xfrm xmlns:a="http://schemas.openxmlformats.org/drawingml/2006/main">
             <a:off x="7658100" y="3905250"/>
-            <a:ext cx="47625" cy="838200"/>
+            <a:ext cx="47625" cy="933450"/>
           </a:xfrm>
           <a:prstGeom xmlns:a="http://schemas.openxmlformats.org/drawingml/2006/main" prst="rect">
             <a:avLst/>
@@ -17120,7 +17120,7 @@
           <p:cNvPr id="71" name="">
             <a:extLst xmlns:a="http://schemas.openxmlformats.org/drawingml/2006/main">
               <a:ext uri="{FF2B5EF4-FFF2-40B4-BE49-F238E27FC236}">
-                <a16:creationId xmlns:a16="http://schemas.microsoft.com/office/drawing/2014/main" id="{81A57CC2-4491-4019-BD1D-DBB529F8447F}"/>
+                <a16:creationId xmlns:a16="http://schemas.microsoft.com/office/drawing/2014/main" id="{49B61980-9E12-4CB1-ABDD-A6DCE27C723D}"/>
               </a:ext>
             </a:extLst>
           </p:cNvPr>
@@ -17183,7 +17183,7 @@
           <p:cNvPr id="72" name="">
             <a:extLst xmlns:a="http://schemas.openxmlformats.org/drawingml/2006/main">
               <a:ext uri="{FF2B5EF4-FFF2-40B4-BE49-F238E27FC236}">
-                <a16:creationId xmlns:a16="http://schemas.microsoft.com/office/drawing/2014/main" id="{4BA71FEA-FF0A-4D78-A958-C8A28E333F16}"/>
+                <a16:creationId xmlns:a16="http://schemas.microsoft.com/office/drawing/2014/main" id="{B2AC4E01-0DBE-4B74-8482-BBAEFC67A5EE}"/>
               </a:ext>
             </a:extLst>
           </p:cNvPr>
@@ -17250,7 +17250,7 @@
           <p:cNvPr id="73" name="">
             <a:extLst xmlns:a="http://schemas.openxmlformats.org/drawingml/2006/main">
               <a:ext uri="{FF2B5EF4-FFF2-40B4-BE49-F238E27FC236}">
-                <a16:creationId xmlns:a16="http://schemas.microsoft.com/office/drawing/2014/main" id="{94F7EF32-CD38-4DC8-96F4-F51734B61854}"/>
+                <a16:creationId xmlns:a16="http://schemas.microsoft.com/office/drawing/2014/main" id="{8FB627D5-5D18-4A87-B5E0-8AC9BD7CB188}"/>
               </a:ext>
             </a:extLst>
           </p:cNvPr>
@@ -17313,7 +17313,7 @@
           <p:cNvPr id="74" name="">
             <a:extLst xmlns:a="http://schemas.openxmlformats.org/drawingml/2006/main">
               <a:ext uri="{FF2B5EF4-FFF2-40B4-BE49-F238E27FC236}">
-                <a16:creationId xmlns:a16="http://schemas.microsoft.com/office/drawing/2014/main" id="{97108FC0-E548-4BF1-97BB-7CF524E31654}"/>
+                <a16:creationId xmlns:a16="http://schemas.microsoft.com/office/drawing/2014/main" id="{722C8480-23B7-410E-9E9B-B9A0CDF8F0B9}"/>
               </a:ext>
             </a:extLst>
           </p:cNvPr>
@@ -17345,7 +17345,7 @@
           <p:cNvPr id="75" name="">
             <a:extLst xmlns:a="http://schemas.openxmlformats.org/drawingml/2006/main">
               <a:ext uri="{FF2B5EF4-FFF2-40B4-BE49-F238E27FC236}">
-                <a16:creationId xmlns:a16="http://schemas.microsoft.com/office/drawing/2014/main" id="{74031AF1-2087-4FAD-9EAA-BA7F7C662090}"/>
+                <a16:creationId xmlns:a16="http://schemas.microsoft.com/office/drawing/2014/main" id="{FE03839E-0F05-4AEC-99CF-3BCBCB670A4A}"/>
               </a:ext>
             </a:extLst>
           </p:cNvPr>
@@ -17408,7 +17408,7 @@
           <p:cNvPr id="76" name="">
             <a:extLst xmlns:a="http://schemas.openxmlformats.org/drawingml/2006/main">
               <a:ext uri="{FF2B5EF4-FFF2-40B4-BE49-F238E27FC236}">
-                <a16:creationId xmlns:a16="http://schemas.microsoft.com/office/drawing/2014/main" id="{A53C5819-989C-410B-A52B-0342D513E41B}"/>
+                <a16:creationId xmlns:a16="http://schemas.microsoft.com/office/drawing/2014/main" id="{20F9FA45-A85B-4710-BB98-0A11C07CC652}"/>
               </a:ext>
             </a:extLst>
           </p:cNvPr>
@@ -17469,7 +17469,7 @@
     </p:spTree>
     <p:extLst>
       <p:ext uri="{BB962C8B-B14F-4D97-AF65-F5344CB8AC3E}">
-        <p14:creationId xmlns:p14="http://schemas.microsoft.com/office/powerpoint/2010/main" val="995318522"/>
+        <p14:creationId xmlns:p14="http://schemas.microsoft.com/office/powerpoint/2010/main" val="1698211995"/>
       </p:ext>
     </p:extLst>
   </p:cSld>
@@ -17500,7 +17500,7 @@
           <p:cNvPr id="1" name="">
             <a:extLst xmlns:a="http://schemas.openxmlformats.org/drawingml/2006/main">
               <a:ext uri="{FF2B5EF4-FFF2-40B4-BE49-F238E27FC236}">
-                <a16:creationId xmlns:a16="http://schemas.microsoft.com/office/drawing/2014/main" id="{D3D738D4-1C1B-4082-AC5A-62095560D8EC}"/>
+                <a16:creationId xmlns:a16="http://schemas.microsoft.com/office/drawing/2014/main" id="{C8546646-38BA-4C6F-9718-A7F8EDF288A2}"/>
               </a:ext>
             </a:extLst>
           </p:cNvPr>
@@ -17563,7 +17563,7 @@
           <p:cNvPr id="2" name="">
             <a:extLst xmlns:a="http://schemas.openxmlformats.org/drawingml/2006/main">
               <a:ext uri="{FF2B5EF4-FFF2-40B4-BE49-F238E27FC236}">
-                <a16:creationId xmlns:a16="http://schemas.microsoft.com/office/drawing/2014/main" id="{2F352C8E-CBD3-4FE2-8453-FCC42FF7DE8D}"/>
+                <a16:creationId xmlns:a16="http://schemas.microsoft.com/office/drawing/2014/main" id="{B56E821C-0F37-4E8A-98D7-A1314B4D8DA3}"/>
               </a:ext>
             </a:extLst>
           </p:cNvPr>
@@ -17630,7 +17630,7 @@
           <p:cNvPr id="3" name="">
             <a:extLst xmlns:a="http://schemas.openxmlformats.org/drawingml/2006/main">
               <a:ext uri="{FF2B5EF4-FFF2-40B4-BE49-F238E27FC236}">
-                <a16:creationId xmlns:a16="http://schemas.microsoft.com/office/drawing/2014/main" id="{6D73D1EE-AA47-4CA3-AEBD-068693E6CF90}"/>
+                <a16:creationId xmlns:a16="http://schemas.microsoft.com/office/drawing/2014/main" id="{06EF9644-7BD6-41A6-832D-A16B35BAE82C}"/>
               </a:ext>
             </a:extLst>
           </p:cNvPr>
@@ -17697,7 +17697,7 @@
           <p:cNvPr id="4" name="">
             <a:extLst xmlns:a="http://schemas.openxmlformats.org/drawingml/2006/main">
               <a:ext uri="{FF2B5EF4-FFF2-40B4-BE49-F238E27FC236}">
-                <a16:creationId xmlns:a16="http://schemas.microsoft.com/office/drawing/2014/main" id="{8BA441C5-623C-4666-A64C-922834F48843}"/>
+                <a16:creationId xmlns:a16="http://schemas.microsoft.com/office/drawing/2014/main" id="{6227ED15-C768-4129-B741-32C496027B39}"/>
               </a:ext>
             </a:extLst>
           </p:cNvPr>
@@ -17729,7 +17729,7 @@
           <p:cNvPr id="5" name="">
             <a:extLst xmlns:a="http://schemas.openxmlformats.org/drawingml/2006/main">
               <a:ext uri="{FF2B5EF4-FFF2-40B4-BE49-F238E27FC236}">
-                <a16:creationId xmlns:a16="http://schemas.microsoft.com/office/drawing/2014/main" id="{16D72792-960A-495B-B821-AB58FAEE3D9B}"/>
+                <a16:creationId xmlns:a16="http://schemas.microsoft.com/office/drawing/2014/main" id="{7E3CB31C-D7D5-4E48-983A-8AEB36A47893}"/>
               </a:ext>
             </a:extLst>
           </p:cNvPr>
@@ -17761,7 +17761,7 @@
           <p:cNvPr id="6" name="">
             <a:extLst xmlns:a="http://schemas.openxmlformats.org/drawingml/2006/main">
               <a:ext uri="{FF2B5EF4-FFF2-40B4-BE49-F238E27FC236}">
-                <a16:creationId xmlns:a16="http://schemas.microsoft.com/office/drawing/2014/main" id="{B021291A-F8C3-4152-BE7E-F77172BBCC8B}"/>
+                <a16:creationId xmlns:a16="http://schemas.microsoft.com/office/drawing/2014/main" id="{75740F7C-DC5D-4088-ABA5-37896AB69774}"/>
               </a:ext>
             </a:extLst>
           </p:cNvPr>
@@ -17824,7 +17824,7 @@
           <p:cNvPr id="7" name="">
             <a:extLst xmlns:a="http://schemas.openxmlformats.org/drawingml/2006/main">
               <a:ext uri="{FF2B5EF4-FFF2-40B4-BE49-F238E27FC236}">
-                <a16:creationId xmlns:a16="http://schemas.microsoft.com/office/drawing/2014/main" id="{F346C671-7BD5-4157-A630-801FD9876403}"/>
+                <a16:creationId xmlns:a16="http://schemas.microsoft.com/office/drawing/2014/main" id="{4E58CEF2-6093-4B74-A26A-7BFA528F4991}"/>
               </a:ext>
             </a:extLst>
           </p:cNvPr>
@@ -17891,7 +17891,7 @@
           <p:cNvPr id="8" name="">
             <a:extLst xmlns:a="http://schemas.openxmlformats.org/drawingml/2006/main">
               <a:ext uri="{FF2B5EF4-FFF2-40B4-BE49-F238E27FC236}">
-                <a16:creationId xmlns:a16="http://schemas.microsoft.com/office/drawing/2014/main" id="{898DAC09-F184-4427-9D06-59276671AA71}"/>
+                <a16:creationId xmlns:a16="http://schemas.microsoft.com/office/drawing/2014/main" id="{5C1665BC-9F01-4499-9F4C-884EB95D2C48}"/>
               </a:ext>
             </a:extLst>
           </p:cNvPr>
@@ -17925,7 +17925,7 @@
           <p:cNvPr id="9" name="">
             <a:extLst xmlns:a="http://schemas.openxmlformats.org/drawingml/2006/main">
               <a:ext uri="{FF2B5EF4-FFF2-40B4-BE49-F238E27FC236}">
-                <a16:creationId xmlns:a16="http://schemas.microsoft.com/office/drawing/2014/main" id="{F3759540-8EBF-416E-93FF-9A3EB5333D12}"/>
+                <a16:creationId xmlns:a16="http://schemas.microsoft.com/office/drawing/2014/main" id="{08A91D40-E614-407B-AA92-65504E054261}"/>
               </a:ext>
             </a:extLst>
           </p:cNvPr>
@@ -17957,7 +17957,7 @@
           <p:cNvPr id="10" name="">
             <a:extLst xmlns:a="http://schemas.openxmlformats.org/drawingml/2006/main">
               <a:ext uri="{FF2B5EF4-FFF2-40B4-BE49-F238E27FC236}">
-                <a16:creationId xmlns:a16="http://schemas.microsoft.com/office/drawing/2014/main" id="{75B556A7-A7DC-4EA1-828C-25148D1EEC2E}"/>
+                <a16:creationId xmlns:a16="http://schemas.microsoft.com/office/drawing/2014/main" id="{45ADE4C9-4201-419B-8587-77F455DE0A00}"/>
               </a:ext>
             </a:extLst>
           </p:cNvPr>
@@ -17989,7 +17989,7 @@
           <p:cNvPr id="11" name="">
             <a:extLst xmlns:a="http://schemas.openxmlformats.org/drawingml/2006/main">
               <a:ext uri="{FF2B5EF4-FFF2-40B4-BE49-F238E27FC236}">
-                <a16:creationId xmlns:a16="http://schemas.microsoft.com/office/drawing/2014/main" id="{2150C7DE-0BC8-42EB-B8EA-86826D346905}"/>
+                <a16:creationId xmlns:a16="http://schemas.microsoft.com/office/drawing/2014/main" id="{0B660CDC-0585-406B-A68E-712CF07C9A13}"/>
               </a:ext>
             </a:extLst>
           </p:cNvPr>
@@ -18021,7 +18021,7 @@
           <p:cNvPr id="12" name="">
             <a:extLst xmlns:a="http://schemas.openxmlformats.org/drawingml/2006/main">
               <a:ext uri="{FF2B5EF4-FFF2-40B4-BE49-F238E27FC236}">
-                <a16:creationId xmlns:a16="http://schemas.microsoft.com/office/drawing/2014/main" id="{D7EF082A-FD06-49BC-B95C-6B60DF0360DC}"/>
+                <a16:creationId xmlns:a16="http://schemas.microsoft.com/office/drawing/2014/main" id="{19103B88-8419-4D3D-A5BF-2044575AEBB5}"/>
               </a:ext>
             </a:extLst>
           </p:cNvPr>
@@ -18084,7 +18084,7 @@
           <p:cNvPr id="13" name="">
             <a:extLst xmlns:a="http://schemas.openxmlformats.org/drawingml/2006/main">
               <a:ext uri="{FF2B5EF4-FFF2-40B4-BE49-F238E27FC236}">
-                <a16:creationId xmlns:a16="http://schemas.microsoft.com/office/drawing/2014/main" id="{2E4F4BE0-4803-44CC-87AD-BFC8FE080BFF}"/>
+                <a16:creationId xmlns:a16="http://schemas.microsoft.com/office/drawing/2014/main" id="{C77F77F5-6AA1-4203-ADE2-7E28403F667D}"/>
               </a:ext>
             </a:extLst>
           </p:cNvPr>
@@ -18151,7 +18151,7 @@
           <p:cNvPr id="14" name="">
             <a:extLst xmlns:a="http://schemas.openxmlformats.org/drawingml/2006/main">
               <a:ext uri="{FF2B5EF4-FFF2-40B4-BE49-F238E27FC236}">
-                <a16:creationId xmlns:a16="http://schemas.microsoft.com/office/drawing/2014/main" id="{DF6559A3-C4E9-4040-AEF8-BA3E6E49510E}"/>
+                <a16:creationId xmlns:a16="http://schemas.microsoft.com/office/drawing/2014/main" id="{FE299326-ADD8-42FB-AC79-2B6038801C58}"/>
               </a:ext>
             </a:extLst>
           </p:cNvPr>
@@ -18185,7 +18185,7 @@
           <p:cNvPr id="15" name="">
             <a:extLst xmlns:a="http://schemas.openxmlformats.org/drawingml/2006/main">
               <a:ext uri="{FF2B5EF4-FFF2-40B4-BE49-F238E27FC236}">
-                <a16:creationId xmlns:a16="http://schemas.microsoft.com/office/drawing/2014/main" id="{059D16C8-EBC1-4408-A484-0259EC1ACCA2}"/>
+                <a16:creationId xmlns:a16="http://schemas.microsoft.com/office/drawing/2014/main" id="{EA5986AB-4612-43CF-BEAB-B1AB58068F12}"/>
               </a:ext>
             </a:extLst>
           </p:cNvPr>
@@ -18217,7 +18217,7 @@
           <p:cNvPr id="16" name="">
             <a:extLst xmlns:a="http://schemas.openxmlformats.org/drawingml/2006/main">
               <a:ext uri="{FF2B5EF4-FFF2-40B4-BE49-F238E27FC236}">
-                <a16:creationId xmlns:a16="http://schemas.microsoft.com/office/drawing/2014/main" id="{80DE65D0-2661-41F0-A24E-BDDDE706E685}"/>
+                <a16:creationId xmlns:a16="http://schemas.microsoft.com/office/drawing/2014/main" id="{A91796D7-8EF3-4F17-AA90-3A5316B464C1}"/>
               </a:ext>
             </a:extLst>
           </p:cNvPr>
@@ -18249,7 +18249,7 @@
           <p:cNvPr id="17" name="">
             <a:extLst xmlns:a="http://schemas.openxmlformats.org/drawingml/2006/main">
               <a:ext uri="{FF2B5EF4-FFF2-40B4-BE49-F238E27FC236}">
-                <a16:creationId xmlns:a16="http://schemas.microsoft.com/office/drawing/2014/main" id="{6ADB968B-A8B3-44FB-9A7C-6ACBCC6CF7EE}"/>
+                <a16:creationId xmlns:a16="http://schemas.microsoft.com/office/drawing/2014/main" id="{5670B550-C93A-4195-ADFF-BE734F84C32A}"/>
               </a:ext>
             </a:extLst>
           </p:cNvPr>
@@ -18281,7 +18281,7 @@
           <p:cNvPr id="18" name="">
             <a:extLst xmlns:a="http://schemas.openxmlformats.org/drawingml/2006/main">
               <a:ext uri="{FF2B5EF4-FFF2-40B4-BE49-F238E27FC236}">
-                <a16:creationId xmlns:a16="http://schemas.microsoft.com/office/drawing/2014/main" id="{57624637-A074-4A19-BB46-857B58322386}"/>
+                <a16:creationId xmlns:a16="http://schemas.microsoft.com/office/drawing/2014/main" id="{44D74520-9DD8-41DC-9C69-08F7C2C6B318}"/>
               </a:ext>
             </a:extLst>
           </p:cNvPr>
@@ -18344,7 +18344,7 @@
           <p:cNvPr id="19" name="">
             <a:extLst xmlns:a="http://schemas.openxmlformats.org/drawingml/2006/main">
               <a:ext uri="{FF2B5EF4-FFF2-40B4-BE49-F238E27FC236}">
-                <a16:creationId xmlns:a16="http://schemas.microsoft.com/office/drawing/2014/main" id="{3FABCE0B-63BD-4D82-9812-D7687799A626}"/>
+                <a16:creationId xmlns:a16="http://schemas.microsoft.com/office/drawing/2014/main" id="{FB20FF55-0864-4A2B-BE9A-C5E49577E4BF}"/>
               </a:ext>
             </a:extLst>
           </p:cNvPr>
@@ -18411,7 +18411,7 @@
           <p:cNvPr id="20" name="">
             <a:extLst xmlns:a="http://schemas.openxmlformats.org/drawingml/2006/main">
               <a:ext uri="{FF2B5EF4-FFF2-40B4-BE49-F238E27FC236}">
-                <a16:creationId xmlns:a16="http://schemas.microsoft.com/office/drawing/2014/main" id="{1F83C52C-0820-470E-976F-3DA1713B785E}"/>
+                <a16:creationId xmlns:a16="http://schemas.microsoft.com/office/drawing/2014/main" id="{33529C6D-8189-4A4E-A611-1402749A426E}"/>
               </a:ext>
             </a:extLst>
           </p:cNvPr>
@@ -18445,7 +18445,7 @@
           <p:cNvPr id="21" name="">
             <a:extLst xmlns:a="http://schemas.openxmlformats.org/drawingml/2006/main">
               <a:ext uri="{FF2B5EF4-FFF2-40B4-BE49-F238E27FC236}">
-                <a16:creationId xmlns:a16="http://schemas.microsoft.com/office/drawing/2014/main" id="{71811D9F-7FBA-4E56-ADCD-03CAAFB4132B}"/>
+                <a16:creationId xmlns:a16="http://schemas.microsoft.com/office/drawing/2014/main" id="{463697BC-1C48-4FF7-A563-339EFDC2E4DD}"/>
               </a:ext>
             </a:extLst>
           </p:cNvPr>
@@ -18477,7 +18477,7 @@
           <p:cNvPr id="22" name="">
             <a:extLst xmlns:a="http://schemas.openxmlformats.org/drawingml/2006/main">
               <a:ext uri="{FF2B5EF4-FFF2-40B4-BE49-F238E27FC236}">
-                <a16:creationId xmlns:a16="http://schemas.microsoft.com/office/drawing/2014/main" id="{F23D22ED-0D2B-4A70-A048-3CB454AEB1E5}"/>
+                <a16:creationId xmlns:a16="http://schemas.microsoft.com/office/drawing/2014/main" id="{EAF1E5F6-CB4E-4FD1-85BB-3D6CA12E864C}"/>
               </a:ext>
             </a:extLst>
           </p:cNvPr>
@@ -18540,7 +18540,7 @@
           <p:cNvPr id="23" name="">
             <a:extLst xmlns:a="http://schemas.openxmlformats.org/drawingml/2006/main">
               <a:ext uri="{FF2B5EF4-FFF2-40B4-BE49-F238E27FC236}">
-                <a16:creationId xmlns:a16="http://schemas.microsoft.com/office/drawing/2014/main" id="{5703300D-FB9C-48AA-806E-C3F243825827}"/>
+                <a16:creationId xmlns:a16="http://schemas.microsoft.com/office/drawing/2014/main" id="{DE8C5CAE-2E70-4F92-B1EF-0DC60733F13E}"/>
               </a:ext>
             </a:extLst>
           </p:cNvPr>
@@ -18572,7 +18572,7 @@
           <p:cNvPr id="24" name="">
             <a:extLst xmlns:a="http://schemas.openxmlformats.org/drawingml/2006/main">
               <a:ext uri="{FF2B5EF4-FFF2-40B4-BE49-F238E27FC236}">
-                <a16:creationId xmlns:a16="http://schemas.microsoft.com/office/drawing/2014/main" id="{9EB913B9-A6F4-44BE-AFCE-A2D846E8DD60}"/>
+                <a16:creationId xmlns:a16="http://schemas.microsoft.com/office/drawing/2014/main" id="{1C0FCF70-B94F-4E8A-A928-9DCC2F0E3A16}"/>
               </a:ext>
             </a:extLst>
           </p:cNvPr>
@@ -18635,7 +18635,7 @@
           <p:cNvPr id="25" name="">
             <a:extLst xmlns:a="http://schemas.openxmlformats.org/drawingml/2006/main">
               <a:ext uri="{FF2B5EF4-FFF2-40B4-BE49-F238E27FC236}">
-                <a16:creationId xmlns:a16="http://schemas.microsoft.com/office/drawing/2014/main" id="{F725F2E2-E3A8-4331-B632-5F3792ABAB5E}"/>
+                <a16:creationId xmlns:a16="http://schemas.microsoft.com/office/drawing/2014/main" id="{C2A2487B-28E4-4EC2-B760-CFCB010C52B2}"/>
               </a:ext>
             </a:extLst>
           </p:cNvPr>
@@ -18696,7 +18696,7 @@
     </p:spTree>
     <p:extLst>
       <p:ext uri="{BB962C8B-B14F-4D97-AF65-F5344CB8AC3E}">
-        <p14:creationId xmlns:p14="http://schemas.microsoft.com/office/powerpoint/2010/main" val="124041450"/>
+        <p14:creationId xmlns:p14="http://schemas.microsoft.com/office/powerpoint/2010/main" val="1595433733"/>
       </p:ext>
     </p:extLst>
   </p:cSld>
@@ -18727,7 +18727,7 @@
           <p:cNvPr id="1" name="">
             <a:extLst xmlns:a="http://schemas.openxmlformats.org/drawingml/2006/main">
               <a:ext uri="{FF2B5EF4-FFF2-40B4-BE49-F238E27FC236}">
-                <a16:creationId xmlns:a16="http://schemas.microsoft.com/office/drawing/2014/main" id="{93F0FF78-24DA-4C37-B6C2-EC6EC51CC94E}"/>
+                <a16:creationId xmlns:a16="http://schemas.microsoft.com/office/drawing/2014/main" id="{79861933-7FEB-432E-BC63-730E97C7D2A5}"/>
               </a:ext>
             </a:extLst>
           </p:cNvPr>
@@ -18790,7 +18790,7 @@
           <p:cNvPr id="2" name="">
             <a:extLst xmlns:a="http://schemas.openxmlformats.org/drawingml/2006/main">
               <a:ext uri="{FF2B5EF4-FFF2-40B4-BE49-F238E27FC236}">
-                <a16:creationId xmlns:a16="http://schemas.microsoft.com/office/drawing/2014/main" id="{08B76F4B-1534-40A0-A858-3FD910B84AD3}"/>
+                <a16:creationId xmlns:a16="http://schemas.microsoft.com/office/drawing/2014/main" id="{4D779104-B77E-4ABC-BACE-C723E2DF1710}"/>
               </a:ext>
             </a:extLst>
           </p:cNvPr>
@@ -18857,7 +18857,7 @@
           <p:cNvPr id="3" name="">
             <a:extLst xmlns:a="http://schemas.openxmlformats.org/drawingml/2006/main">
               <a:ext uri="{FF2B5EF4-FFF2-40B4-BE49-F238E27FC236}">
-                <a16:creationId xmlns:a16="http://schemas.microsoft.com/office/drawing/2014/main" id="{2D03D82B-D14F-4CEA-9518-DA3BF0AC6E00}"/>
+                <a16:creationId xmlns:a16="http://schemas.microsoft.com/office/drawing/2014/main" id="{52BDEBEB-DE6F-4887-AE6F-15DD5E05EBE3}"/>
               </a:ext>
             </a:extLst>
           </p:cNvPr>
@@ -18924,7 +18924,7 @@
           <p:cNvPr id="4" name="">
             <a:extLst xmlns:a="http://schemas.openxmlformats.org/drawingml/2006/main">
               <a:ext uri="{FF2B5EF4-FFF2-40B4-BE49-F238E27FC236}">
-                <a16:creationId xmlns:a16="http://schemas.microsoft.com/office/drawing/2014/main" id="{EC820CF7-875E-4D85-80A8-FEF648776C99}"/>
+                <a16:creationId xmlns:a16="http://schemas.microsoft.com/office/drawing/2014/main" id="{B7758E0C-836C-46B5-AF47-65C50A175198}"/>
               </a:ext>
             </a:extLst>
           </p:cNvPr>
@@ -18956,7 +18956,7 @@
           <p:cNvPr id="5" name="">
             <a:extLst xmlns:a="http://schemas.openxmlformats.org/drawingml/2006/main">
               <a:ext uri="{FF2B5EF4-FFF2-40B4-BE49-F238E27FC236}">
-                <a16:creationId xmlns:a16="http://schemas.microsoft.com/office/drawing/2014/main" id="{41075DEF-0383-440D-A10B-A7476D349BC9}"/>
+                <a16:creationId xmlns:a16="http://schemas.microsoft.com/office/drawing/2014/main" id="{F8B6F62D-C2D1-494B-A1E9-0F729C6C1E06}"/>
               </a:ext>
             </a:extLst>
           </p:cNvPr>
@@ -18988,7 +18988,7 @@
           <p:cNvPr id="6" name="">
             <a:extLst xmlns:a="http://schemas.openxmlformats.org/drawingml/2006/main">
               <a:ext uri="{FF2B5EF4-FFF2-40B4-BE49-F238E27FC236}">
-                <a16:creationId xmlns:a16="http://schemas.microsoft.com/office/drawing/2014/main" id="{7947BCC5-6C65-4B97-8DEF-EB92349BF045}"/>
+                <a16:creationId xmlns:a16="http://schemas.microsoft.com/office/drawing/2014/main" id="{10653A14-62E9-49F6-9C28-C79F95B9441C}"/>
               </a:ext>
             </a:extLst>
           </p:cNvPr>
@@ -19051,7 +19051,7 @@
           <p:cNvPr id="7" name="">
             <a:extLst xmlns:a="http://schemas.openxmlformats.org/drawingml/2006/main">
               <a:ext uri="{FF2B5EF4-FFF2-40B4-BE49-F238E27FC236}">
-                <a16:creationId xmlns:a16="http://schemas.microsoft.com/office/drawing/2014/main" id="{5399B584-7678-461C-9138-4197FD564BBC}"/>
+                <a16:creationId xmlns:a16="http://schemas.microsoft.com/office/drawing/2014/main" id="{F0574502-F761-4333-8430-2BB0BE4C4D5E}"/>
               </a:ext>
             </a:extLst>
           </p:cNvPr>
@@ -19118,7 +19118,7 @@
           <p:cNvPr id="8" name="">
             <a:extLst xmlns:a="http://schemas.openxmlformats.org/drawingml/2006/main">
               <a:ext uri="{FF2B5EF4-FFF2-40B4-BE49-F238E27FC236}">
-                <a16:creationId xmlns:a16="http://schemas.microsoft.com/office/drawing/2014/main" id="{590B00B2-41C8-463E-886D-35590FE5B291}"/>
+                <a16:creationId xmlns:a16="http://schemas.microsoft.com/office/drawing/2014/main" id="{72E5E16E-567B-4744-AF0A-11BF29368CC4}"/>
               </a:ext>
             </a:extLst>
           </p:cNvPr>
@@ -19150,7 +19150,7 @@
           <p:cNvPr id="9" name="">
             <a:extLst xmlns:a="http://schemas.openxmlformats.org/drawingml/2006/main">
               <a:ext uri="{FF2B5EF4-FFF2-40B4-BE49-F238E27FC236}">
-                <a16:creationId xmlns:a16="http://schemas.microsoft.com/office/drawing/2014/main" id="{3321C56E-11ED-4EC1-95F5-127BFEE52066}"/>
+                <a16:creationId xmlns:a16="http://schemas.microsoft.com/office/drawing/2014/main" id="{80A288B7-1F81-4D82-AAB6-36B14C782067}"/>
               </a:ext>
             </a:extLst>
           </p:cNvPr>
@@ -19182,7 +19182,7 @@
           <p:cNvPr id="10" name="">
             <a:extLst xmlns:a="http://schemas.openxmlformats.org/drawingml/2006/main">
               <a:ext uri="{FF2B5EF4-FFF2-40B4-BE49-F238E27FC236}">
-                <a16:creationId xmlns:a16="http://schemas.microsoft.com/office/drawing/2014/main" id="{09FCE60F-2A48-4000-B347-D7DBF2918C56}"/>
+                <a16:creationId xmlns:a16="http://schemas.microsoft.com/office/drawing/2014/main" id="{A3AFBCF8-47A0-43D4-A127-786448F95D0C}"/>
               </a:ext>
             </a:extLst>
           </p:cNvPr>
@@ -19245,7 +19245,7 @@
           <p:cNvPr id="11" name="">
             <a:extLst xmlns:a="http://schemas.openxmlformats.org/drawingml/2006/main">
               <a:ext uri="{FF2B5EF4-FFF2-40B4-BE49-F238E27FC236}">
-                <a16:creationId xmlns:a16="http://schemas.microsoft.com/office/drawing/2014/main" id="{8651C157-9CA2-41EE-B359-F8CAE511AF3D}"/>
+                <a16:creationId xmlns:a16="http://schemas.microsoft.com/office/drawing/2014/main" id="{90AC5E1D-ABBA-4DE5-98DA-2A9145122D90}"/>
               </a:ext>
             </a:extLst>
           </p:cNvPr>
@@ -19312,7 +19312,7 @@
           <p:cNvPr id="12" name="">
             <a:extLst xmlns:a="http://schemas.openxmlformats.org/drawingml/2006/main">
               <a:ext uri="{FF2B5EF4-FFF2-40B4-BE49-F238E27FC236}">
-                <a16:creationId xmlns:a16="http://schemas.microsoft.com/office/drawing/2014/main" id="{AB0A29D2-2524-4F44-A937-23C0064E0DED}"/>
+                <a16:creationId xmlns:a16="http://schemas.microsoft.com/office/drawing/2014/main" id="{76638BB7-596E-4AA5-8425-CBF801540B5C}"/>
               </a:ext>
             </a:extLst>
           </p:cNvPr>
@@ -19344,7 +19344,7 @@
           <p:cNvPr id="13" name="">
             <a:extLst xmlns:a="http://schemas.openxmlformats.org/drawingml/2006/main">
               <a:ext uri="{FF2B5EF4-FFF2-40B4-BE49-F238E27FC236}">
-                <a16:creationId xmlns:a16="http://schemas.microsoft.com/office/drawing/2014/main" id="{B6618D0A-6F55-469E-B96B-988506752356}"/>
+                <a16:creationId xmlns:a16="http://schemas.microsoft.com/office/drawing/2014/main" id="{A679F6C0-6F1E-435C-BF08-AEEF10A7A953}"/>
               </a:ext>
             </a:extLst>
           </p:cNvPr>
@@ -19376,7 +19376,7 @@
           <p:cNvPr id="14" name="">
             <a:extLst xmlns:a="http://schemas.openxmlformats.org/drawingml/2006/main">
               <a:ext uri="{FF2B5EF4-FFF2-40B4-BE49-F238E27FC236}">
-                <a16:creationId xmlns:a16="http://schemas.microsoft.com/office/drawing/2014/main" id="{13838AF5-63B0-4841-8576-320E216D8DA7}"/>
+                <a16:creationId xmlns:a16="http://schemas.microsoft.com/office/drawing/2014/main" id="{78853DB5-268D-43A9-BDEE-0B3ECC6C95F1}"/>
               </a:ext>
             </a:extLst>
           </p:cNvPr>
@@ -19439,7 +19439,7 @@
           <p:cNvPr id="15" name="">
             <a:extLst xmlns:a="http://schemas.openxmlformats.org/drawingml/2006/main">
               <a:ext uri="{FF2B5EF4-FFF2-40B4-BE49-F238E27FC236}">
-                <a16:creationId xmlns:a16="http://schemas.microsoft.com/office/drawing/2014/main" id="{68B8C6E8-FFA7-4170-8411-F3854ED0F654}"/>
+                <a16:creationId xmlns:a16="http://schemas.microsoft.com/office/drawing/2014/main" id="{2DD5CE14-48D8-4EEE-99DA-505F056EA296}"/>
               </a:ext>
             </a:extLst>
           </p:cNvPr>
@@ -19506,7 +19506,7 @@
           <p:cNvPr id="16" name="">
             <a:extLst xmlns:a="http://schemas.openxmlformats.org/drawingml/2006/main">
               <a:ext uri="{FF2B5EF4-FFF2-40B4-BE49-F238E27FC236}">
-                <a16:creationId xmlns:a16="http://schemas.microsoft.com/office/drawing/2014/main" id="{D89FAECF-596B-4F37-AF20-1D39B9BBDA49}"/>
+                <a16:creationId xmlns:a16="http://schemas.microsoft.com/office/drawing/2014/main" id="{CD86AEC2-97B3-4902-87DA-725117777EF8}"/>
               </a:ext>
             </a:extLst>
           </p:cNvPr>
@@ -19538,7 +19538,7 @@
           <p:cNvPr id="17" name="">
             <a:extLst xmlns:a="http://schemas.openxmlformats.org/drawingml/2006/main">
               <a:ext uri="{FF2B5EF4-FFF2-40B4-BE49-F238E27FC236}">
-                <a16:creationId xmlns:a16="http://schemas.microsoft.com/office/drawing/2014/main" id="{48F961AF-A327-4BB2-B1DC-55A0C4B16BF2}"/>
+                <a16:creationId xmlns:a16="http://schemas.microsoft.com/office/drawing/2014/main" id="{BA9896B8-FAF3-4C7A-8B45-D7D018384586}"/>
               </a:ext>
             </a:extLst>
           </p:cNvPr>
@@ -19570,7 +19570,7 @@
           <p:cNvPr id="18" name="">
             <a:extLst xmlns:a="http://schemas.openxmlformats.org/drawingml/2006/main">
               <a:ext uri="{FF2B5EF4-FFF2-40B4-BE49-F238E27FC236}">
-                <a16:creationId xmlns:a16="http://schemas.microsoft.com/office/drawing/2014/main" id="{B2379B50-FBFC-41A9-9B36-14F9E0CA06F2}"/>
+                <a16:creationId xmlns:a16="http://schemas.microsoft.com/office/drawing/2014/main" id="{CCACFE5E-679E-47CB-AD70-B4425C34EF54}"/>
               </a:ext>
             </a:extLst>
           </p:cNvPr>
@@ -19633,7 +19633,7 @@
           <p:cNvPr id="19" name="">
             <a:extLst xmlns:a="http://schemas.openxmlformats.org/drawingml/2006/main">
               <a:ext uri="{FF2B5EF4-FFF2-40B4-BE49-F238E27FC236}">
-                <a16:creationId xmlns:a16="http://schemas.microsoft.com/office/drawing/2014/main" id="{DD802F91-4AC7-40D7-B3AC-1E11CB6EFFE0}"/>
+                <a16:creationId xmlns:a16="http://schemas.microsoft.com/office/drawing/2014/main" id="{BF5DF09B-CE56-40F8-891D-4CCB7E91B4A1}"/>
               </a:ext>
             </a:extLst>
           </p:cNvPr>
@@ -19700,7 +19700,7 @@
           <p:cNvPr id="20" name="">
             <a:extLst xmlns:a="http://schemas.openxmlformats.org/drawingml/2006/main">
               <a:ext uri="{FF2B5EF4-FFF2-40B4-BE49-F238E27FC236}">
-                <a16:creationId xmlns:a16="http://schemas.microsoft.com/office/drawing/2014/main" id="{7F9C61EF-CC0F-4C08-BB82-0A72B4ADE960}"/>
+                <a16:creationId xmlns:a16="http://schemas.microsoft.com/office/drawing/2014/main" id="{70FE0D39-34F3-4F92-A305-DE99EF88309C}"/>
               </a:ext>
             </a:extLst>
           </p:cNvPr>
@@ -19732,7 +19732,7 @@
           <p:cNvPr id="21" name="">
             <a:extLst xmlns:a="http://schemas.openxmlformats.org/drawingml/2006/main">
               <a:ext uri="{FF2B5EF4-FFF2-40B4-BE49-F238E27FC236}">
-                <a16:creationId xmlns:a16="http://schemas.microsoft.com/office/drawing/2014/main" id="{61AA0AFC-6E77-4911-9B2C-BA74E741EC8C}"/>
+                <a16:creationId xmlns:a16="http://schemas.microsoft.com/office/drawing/2014/main" id="{60D4DFE4-5702-490A-B10D-C21BF4367639}"/>
               </a:ext>
             </a:extLst>
           </p:cNvPr>
@@ -19799,7 +19799,7 @@
           <p:cNvPr id="22" name="">
             <a:extLst xmlns:a="http://schemas.openxmlformats.org/drawingml/2006/main">
               <a:ext uri="{FF2B5EF4-FFF2-40B4-BE49-F238E27FC236}">
-                <a16:creationId xmlns:a16="http://schemas.microsoft.com/office/drawing/2014/main" id="{43F9012A-6C5D-49BE-BFB2-522231792C22}"/>
+                <a16:creationId xmlns:a16="http://schemas.microsoft.com/office/drawing/2014/main" id="{D17A5F4E-DE29-4343-A6D7-19CC43E94EC0}"/>
               </a:ext>
             </a:extLst>
           </p:cNvPr>
@@ -19831,7 +19831,7 @@
           <p:cNvPr id="23" name="">
             <a:extLst xmlns:a="http://schemas.openxmlformats.org/drawingml/2006/main">
               <a:ext uri="{FF2B5EF4-FFF2-40B4-BE49-F238E27FC236}">
-                <a16:creationId xmlns:a16="http://schemas.microsoft.com/office/drawing/2014/main" id="{3B6D71DB-D400-40C0-87F0-C84DAB5307C9}"/>
+                <a16:creationId xmlns:a16="http://schemas.microsoft.com/office/drawing/2014/main" id="{18832697-42B6-4BEB-B25C-609EFA2084B0}"/>
               </a:ext>
             </a:extLst>
           </p:cNvPr>
@@ -19894,7 +19894,7 @@
           <p:cNvPr id="24" name="">
             <a:extLst xmlns:a="http://schemas.openxmlformats.org/drawingml/2006/main">
               <a:ext uri="{FF2B5EF4-FFF2-40B4-BE49-F238E27FC236}">
-                <a16:creationId xmlns:a16="http://schemas.microsoft.com/office/drawing/2014/main" id="{58DAF718-1841-4142-8AD7-B07A4AC19C62}"/>
+                <a16:creationId xmlns:a16="http://schemas.microsoft.com/office/drawing/2014/main" id="{4FE4BF6C-61D7-40BF-8BB4-F3708BBD41D4}"/>
               </a:ext>
             </a:extLst>
           </p:cNvPr>
@@ -19955,7 +19955,7 @@
     </p:spTree>
     <p:extLst>
       <p:ext uri="{BB962C8B-B14F-4D97-AF65-F5344CB8AC3E}">
-        <p14:creationId xmlns:p14="http://schemas.microsoft.com/office/powerpoint/2010/main" val="1216330727"/>
+        <p14:creationId xmlns:p14="http://schemas.microsoft.com/office/powerpoint/2010/main" val="1395982801"/>
       </p:ext>
     </p:extLst>
   </p:cSld>

</xml_diff>